<commit_message>
Incorporate Finance partner feedback into prototype and deck.
Name missing seats and as-of dates, add not-backfilling and pivot dispositions, drop contractors, and lead with the variance story for Finance and HR.
</commit_message>
<xml_diff>
--- a/deck/Headcount_Control_Tower_Case_Study.pptx
+++ b/deck/Headcount_Control_Tower_Case_Study.pptx
@@ -584,7 +584,7 @@
           <a:lstStyle/>
           <a:p>
             <a:r>
-              <a:t>Key cuts: quotes off product UI; waterfall → bridge; working filters; history ranges; real logo; export preview.</a:t>
+              <a:t>Key cuts from Finance review: contractors out for simplicity; Marketing −2 named (Events not backfilling + Lifecycle closed); pivots; July close vs viewing date; story before grids.</a:t>
             </a:r>
           </a:p>
         </p:txBody>
@@ -4802,7 +4802,7 @@
                 </a:solidFill>
                 <a:latin typeface="Arial"/>
               </a:rPr>
-              <a:t>Outlook  ·  Story + timeline + history ranges</a:t>
+              <a:t>Story first  ·  Named missing seats + July close as-of</a:t>
             </a:r>
           </a:p>
         </p:txBody>
@@ -4906,7 +4906,7 @@
                 </a:solidFill>
                 <a:latin typeface="Arial"/>
               </a:rPr>
-              <a:t>Bridge  ·  Readable gap explanation</a:t>
+              <a:t>Bridge  ·  Backfill · not backfilling · pivot</a:t>
             </a:r>
           </a:p>
         </p:txBody>
@@ -5010,7 +5010,7 @@
                 </a:solidFill>
                 <a:latin typeface="Arial"/>
               </a:rPr>
-              <a:t>Approvals  ·  Manager → HR → Finance</a:t>
+              <a:t>Simple inputs  ·  HR dispositions Finance can track</a:t>
             </a:r>
           </a:p>
         </p:txBody>
@@ -5488,7 +5488,7 @@
                 </a:solidFill>
                 <a:latin typeface="Arial"/>
               </a:rPr>
-              <a:t>Time to understand HC @ date</a:t>
+              <a:t>Time to understand HC @ close date</a:t>
             </a:r>
           </a:p>
         </p:txBody>
@@ -5878,7 +5878,7 @@
                 </a:solidFill>
                 <a:latin typeface="Arial"/>
               </a:rPr>
-              <a:t>Backfill decision SLA</a:t>
+              <a:t>Disposition logged on attrition</a:t>
             </a:r>
           </a:p>
         </p:txBody>
@@ -5913,7 +5913,7 @@
                 </a:solidFill>
                 <a:latin typeface="Arial"/>
               </a:rPr>
-              <a:t>Median days ↓</a:t>
+              <a:t>% of exits tagged</a:t>
             </a:r>
           </a:p>
         </p:txBody>
@@ -6073,7 +6073,7 @@
                 </a:solidFill>
                 <a:latin typeface="Arial"/>
               </a:rPr>
-              <a:t>Spreadsheet steps removed</a:t>
+              <a:t>Unexplained dept gaps</a:t>
             </a:r>
           </a:p>
         </p:txBody>
@@ -6108,7 +6108,7 @@
                 </a:solidFill>
                 <a:latin typeface="Arial"/>
               </a:rPr>
-              <a:t>Checklist shrinks</a:t>
+              <a:t>→ 0 at close</a:t>
             </a:r>
           </a:p>
         </p:txBody>
@@ -6143,7 +6143,7 @@
                 </a:solidFill>
                 <a:latin typeface="Arial"/>
               </a:rPr>
-              <a:t>Ops cost</a:t>
+              <a:t>Named seats</a:t>
             </a:r>
           </a:p>
         </p:txBody>
@@ -7478,7 +7478,7 @@
                 </a:solidFill>
                 <a:latin typeface="Arial"/>
               </a:rPr>
-              <a:t>Problem: comprehension. Why: finance trust + HR decisions + BambooHR GTM.</a:t>
+              <a:t>Tell the story: as-of date · named missing seats · dispositions Finance and HR share.</a:t>
             </a:r>
           </a:p>
           <a:p>
@@ -7494,7 +7494,7 @@
                 </a:solidFill>
                 <a:latin typeface="Arial"/>
               </a:rPr>
-              <a:t>Evidence → hypotheses → cross-functional build → iterate → measure.</a:t>
+              <a:t>Evidence → hypotheses → cross-functional build → iterate with Finance → measure.</a:t>
             </a:r>
           </a:p>
           <a:p>
@@ -7510,7 +7510,7 @@
                 </a:solidFill>
                 <a:latin typeface="Arial"/>
               </a:rPr>
-              <a:t>AI accelerated discovery. Judgment drove the product calls.</a:t>
+              <a:t>AI accelerated discovery. Judgment — and partner review — drove the product calls.</a:t>
             </a:r>
           </a:p>
         </p:txBody>
@@ -8004,7 +8004,7 @@
                 </a:solidFill>
                 <a:latin typeface="Arial"/>
               </a:rPr>
-              <a:t>Backfill, net-new, contractor, and “approved” mean different things to Finance and HR.</a:t>
+              <a:t>Backfill, not backfilling, pivot, and net-new mean different things — so −2 looks unexplained.</a:t>
             </a:r>
           </a:p>
         </p:txBody>
@@ -8156,7 +8156,7 @@
                 </a:solidFill>
                 <a:latin typeface="Arial"/>
               </a:rPr>
-              <a:t>Leaders cannot answer headcount at a date without a rebuild — so trust erodes every close.</a:t>
+              <a:t>Leaders cannot tell if the number is as of today or as of month-end close — trust erodes every recon.</a:t>
             </a:r>
           </a:p>
         </p:txBody>
@@ -9182,7 +9182,7 @@
                 </a:solidFill>
                 <a:latin typeface="Arial"/>
               </a:rPr>
-              <a:t>One explained variance story at close</a:t>
+              <a:t>One explained variance story at a clear as-of date</a:t>
             </a:r>
           </a:p>
         </p:txBody>
@@ -9217,7 +9217,7 @@
                 </a:solidFill>
                 <a:latin typeface="Arial"/>
               </a:rPr>
-              <a:t>Fewer recon threads · faster board answers</a:t>
+              <a:t>Named missing seats · faster board answers</a:t>
             </a:r>
           </a:p>
         </p:txBody>
@@ -9334,7 +9334,7 @@
                 </a:solidFill>
                 <a:latin typeface="Arial"/>
               </a:rPr>
-              <a:t>Clear ticket types and approval path</a:t>
+              <a:t>Easy dispositions: backfill / not backfilling / pivot</a:t>
             </a:r>
           </a:p>
         </p:txBody>
@@ -9369,7 +9369,7 @@
                 </a:solidFill>
                 <a:latin typeface="Arial"/>
               </a:rPr>
-              <a:t>Backfills don’t masquerade as net-new</a:t>
+              <a:t>Inputs Finance can trust without a rebuild</a:t>
             </a:r>
           </a:p>
         </p:txBody>
@@ -11186,7 +11186,7 @@
                 </a:solidFill>
                 <a:latin typeface="Arial"/>
               </a:rPr>
-              <a:t>Story + one control tower</a:t>
+              <a:t>Story + named missing seats</a:t>
             </a:r>
           </a:p>
         </p:txBody>
@@ -11336,7 +11336,7 @@
                 </a:solidFill>
                 <a:latin typeface="Arial"/>
               </a:rPr>
-              <a:t>Backfill / new / contractor undefined</a:t>
+              <a:t>Backfill / not backfilling / pivot undefined</a:t>
             </a:r>
           </a:p>
         </p:txBody>
@@ -11371,7 +11371,7 @@
                 </a:solidFill>
                 <a:latin typeface="Arial"/>
               </a:rPr>
-              <a:t>Type tags + shared glossary</a:t>
+              <a:t>Disposition tags HR can set</a:t>
             </a:r>
           </a:p>
         </p:txBody>
@@ -11556,7 +11556,7 @@
                 </a:solidFill>
                 <a:latin typeface="Arial"/>
               </a:rPr>
-              <a:t>Ticket queue in-product</a:t>
+              <a:t>Simple Finance + HR inputs</a:t>
             </a:r>
           </a:p>
         </p:txBody>
@@ -11706,7 +11706,7 @@
                 </a:solidFill>
                 <a:latin typeface="Arial"/>
               </a:rPr>
-              <a:t>No history or as-of snapshots</a:t>
+              <a:t>Today vs close date confused</a:t>
             </a:r>
           </a:p>
         </p:txBody>
@@ -11741,7 +11741,7 @@
                 </a:solidFill>
                 <a:latin typeface="Arial"/>
               </a:rPr>
-              <a:t>Ranges + audit trail</a:t>
+              <a:t>Explicit July close as-of</a:t>
             </a:r>
           </a:p>
         </p:txBody>
@@ -11926,7 +11926,7 @@
                 </a:solidFill>
                 <a:latin typeface="Arial"/>
               </a:rPr>
-              <a:t>Bridge &gt; Sankey</a:t>
+              <a:t>Bridge tells the story first</a:t>
             </a:r>
           </a:p>
         </p:txBody>
@@ -12294,13 +12294,13 @@
               </a:spcBef>
             </a:pPr>
             <a:r>
-              <a:rPr sz="1500" b="0">
+              <a:rPr sz="1400" b="0">
                 <a:solidFill>
                   <a:srgbClr val="1B1F17"/>
                 </a:solidFill>
                 <a:latin typeface="Arial"/>
               </a:rPr>
-              <a:t>Observed friction: definitions, as-of, approvals, unexplained variance</a:t>
+              <a:t>Follow-up review: name what’s missing, clear as-of, not backfilling + pivots, drop contractors, tell the story</a:t>
             </a:r>
           </a:p>
         </p:txBody>

</xml_diff>

<commit_message>
Add Finance bus-factor quote and key-person risk through the deck.
Keep existing slide structure while framing recon as institutional knowledge risk, not only time saved.
</commit_message>
<xml_diff>
--- a/deck/Headcount_Control_Tower_Case_Study.pptx
+++ b/deck/Headcount_Control_Tower_Case_Study.pptx
@@ -4,23 +4,26 @@
   <p:sldMasterIdLst>
     <p:sldMasterId id="2147483648" r:id="rId1"/>
   </p:sldMasterIdLst>
+  <p:notesMasterIdLst>
+    <p:notesMasterId r:id="rId16"/>
+  </p:notesMasterIdLst>
   <p:sldIdLst>
-    <p:sldId id="256" r:id="rId7"/>
-    <p:sldId id="257" r:id="rId9"/>
-    <p:sldId id="258" r:id="rId10"/>
-    <p:sldId id="259" r:id="rId11"/>
-    <p:sldId id="260" r:id="rId12"/>
-    <p:sldId id="261" r:id="rId13"/>
-    <p:sldId id="262" r:id="rId14"/>
-    <p:sldId id="263" r:id="rId15"/>
-    <p:sldId id="264" r:id="rId16"/>
-    <p:sldId id="265" r:id="rId17"/>
-    <p:sldId id="266" r:id="rId18"/>
-    <p:sldId id="267" r:id="rId19"/>
-    <p:sldId id="268" r:id="rId20"/>
-    <p:sldId id="269" r:id="rId21"/>
+    <p:sldId id="256" r:id="rId2"/>
+    <p:sldId id="257" r:id="rId3"/>
+    <p:sldId id="258" r:id="rId4"/>
+    <p:sldId id="259" r:id="rId5"/>
+    <p:sldId id="260" r:id="rId6"/>
+    <p:sldId id="261" r:id="rId7"/>
+    <p:sldId id="262" r:id="rId8"/>
+    <p:sldId id="263" r:id="rId9"/>
+    <p:sldId id="264" r:id="rId10"/>
+    <p:sldId id="265" r:id="rId11"/>
+    <p:sldId id="266" r:id="rId12"/>
+    <p:sldId id="267" r:id="rId13"/>
+    <p:sldId id="268" r:id="rId14"/>
+    <p:sldId id="269" r:id="rId15"/>
   </p:sldIdLst>
-  <p:sldSz cx="12191695" cy="6858000" type="screen4x3"/>
+  <p:sldSz cx="12192000" cy="6858000"/>
   <p:notesSz cx="6858000" cy="9144000"/>
   <p:defaultTextStyle>
     <a:defPPr>
@@ -117,11 +120,27 @@
       </a:defRPr>
     </a:lvl9pPr>
   </p:defaultTextStyle>
+  <p:extLst>
+    <p:ext uri="{EFAFB233-063F-42B5-8137-9DF3F51BA10A}">
+      <p15:sldGuideLst xmlns:p15="http://schemas.microsoft.com/office/powerpoint/2012/main">
+        <p15:guide id="1" orient="horz" pos="2160">
+          <p15:clr>
+            <a:srgbClr val="A4A3A4"/>
+          </p15:clr>
+        </p15:guide>
+        <p15:guide id="2" pos="2880">
+          <p15:clr>
+            <a:srgbClr val="A4A3A4"/>
+          </p15:clr>
+        </p15:guide>
+      </p15:sldGuideLst>
+    </p:ext>
+  </p:extLst>
 </p:presentation>
 </file>
 
 <file path=ppt/notesMasters/notesMaster1.xml><?xml version="1.0" encoding="utf-8"?>
-<p:notesMaster xmlns:a="http://schemas.openxmlformats.org/drawingml/2006/main" xmlns:p="http://schemas.openxmlformats.org/presentationml/2006/main" xmlns:r="http://schemas.openxmlformats.org/officeDocument/2006/relationships">
+<p:notesMaster xmlns:a="http://schemas.openxmlformats.org/drawingml/2006/main" xmlns:r="http://schemas.openxmlformats.org/officeDocument/2006/relationships" xmlns:p="http://schemas.openxmlformats.org/presentationml/2006/main">
   <p:cSld>
     <p:bg>
       <p:bgRef idx="1001">
@@ -142,241 +161,16 @@
           <a:chExt cx="0" cy="0"/>
         </a:xfrm>
       </p:grpSpPr>
-      <p:sp>
-        <p:nvSpPr>
-          <p:cNvPr id="2" name="Header Placeholder 1"/>
-          <p:cNvSpPr>
-            <a:spLocks noGrp="1"/>
-          </p:cNvSpPr>
-          <p:nvPr>
-            <p:ph type="hdr" sz="quarter"/>
-          </p:nvPr>
-        </p:nvSpPr>
-        <p:spPr>
-          <a:xfrm>
-            <a:off x="0" y="0"/>
-            <a:ext cx="2971800" cy="457200"/>
-          </a:xfrm>
-          <a:prstGeom prst="rect">
-            <a:avLst/>
-          </a:prstGeom>
-        </p:spPr>
-        <p:txBody>
-          <a:bodyPr vert="horz" lIns="91440" tIns="45720" rIns="91440" bIns="45720" rtlCol="0"/>
-          <a:lstStyle>
-            <a:lvl1pPr algn="l">
-              <a:defRPr sz="1200"/>
-            </a:lvl1pPr>
-          </a:lstStyle>
-          <a:p>
-            <a:endParaRPr lang="en-US"/>
-          </a:p>
-        </p:txBody>
-      </p:sp>
-      <p:sp>
-        <p:nvSpPr>
-          <p:cNvPr id="3" name="Date Placeholder 2"/>
-          <p:cNvSpPr>
-            <a:spLocks noGrp="1"/>
-          </p:cNvSpPr>
-          <p:nvPr>
-            <p:ph type="dt" idx="1"/>
-          </p:nvPr>
-        </p:nvSpPr>
-        <p:spPr>
-          <a:xfrm>
-            <a:off x="3884613" y="0"/>
-            <a:ext cx="2971800" cy="457200"/>
-          </a:xfrm>
-          <a:prstGeom prst="rect">
-            <a:avLst/>
-          </a:prstGeom>
-        </p:spPr>
-        <p:txBody>
-          <a:bodyPr vert="horz" lIns="91440" tIns="45720" rIns="91440" bIns="45720" rtlCol="0"/>
-          <a:lstStyle>
-            <a:lvl1pPr algn="r">
-              <a:defRPr sz="1200"/>
-            </a:lvl1pPr>
-          </a:lstStyle>
-          <a:p>
-            <a:fld id="{0F89C1C7-3DCD-1040-A9CF-14679D8B5DDD}" type="datetimeFigureOut">
-              <a:rPr lang="en-US" smtClean="0"/>
-              <a:t>10/17/16</a:t>
-            </a:fld>
-            <a:endParaRPr lang="en-US"/>
-          </a:p>
-        </p:txBody>
-      </p:sp>
-      <p:sp>
-        <p:nvSpPr>
-          <p:cNvPr id="4" name="Slide Image Placeholder 3"/>
-          <p:cNvSpPr>
-            <a:spLocks noGrp="1" noRot="1" noChangeAspect="1"/>
-          </p:cNvSpPr>
-          <p:nvPr>
-            <p:ph type="sldImg" idx="2"/>
-          </p:nvPr>
-        </p:nvSpPr>
-        <p:spPr>
-          <a:xfrm>
-            <a:off x="1143000" y="685800"/>
-            <a:ext cx="4572000" cy="3429000"/>
-          </a:xfrm>
-          <a:prstGeom prst="rect">
-            <a:avLst/>
-          </a:prstGeom>
-          <a:noFill/>
-          <a:ln w="12700">
-            <a:solidFill>
-              <a:prstClr val="black"/>
-            </a:solidFill>
-          </a:ln>
-        </p:spPr>
-        <p:txBody>
-          <a:bodyPr vert="horz" lIns="91440" tIns="45720" rIns="91440" bIns="45720" rtlCol="0" anchor="ctr"/>
-          <a:lstStyle/>
-          <a:p>
-            <a:endParaRPr lang="en-US"/>
-          </a:p>
-        </p:txBody>
-      </p:sp>
-      <p:sp>
-        <p:nvSpPr>
-          <p:cNvPr id="5" name="Notes Placeholder 4"/>
-          <p:cNvSpPr>
-            <a:spLocks noGrp="1"/>
-          </p:cNvSpPr>
-          <p:nvPr>
-            <p:ph type="body" sz="quarter" idx="3"/>
-          </p:nvPr>
-        </p:nvSpPr>
-        <p:spPr>
-          <a:xfrm>
-            <a:off x="685800" y="4343400"/>
-            <a:ext cx="5486400" cy="4114800"/>
-          </a:xfrm>
-          <a:prstGeom prst="rect">
-            <a:avLst/>
-          </a:prstGeom>
-        </p:spPr>
-        <p:txBody>
-          <a:bodyPr vert="horz" lIns="91440" tIns="45720" rIns="91440" bIns="45720" rtlCol="0"/>
-          <a:lstStyle/>
-          <a:p>
-            <a:pPr lvl="0"/>
-            <a:r>
-              <a:rPr lang="en-US" smtClean="0"/>
-              <a:t>Click to edit Master text styles</a:t>
-            </a:r>
-          </a:p>
-          <a:p>
-            <a:pPr lvl="1"/>
-            <a:r>
-              <a:rPr lang="en-US" smtClean="0"/>
-              <a:t>Second level</a:t>
-            </a:r>
-          </a:p>
-          <a:p>
-            <a:pPr lvl="2"/>
-            <a:r>
-              <a:rPr lang="en-US" smtClean="0"/>
-              <a:t>Third level</a:t>
-            </a:r>
-          </a:p>
-          <a:p>
-            <a:pPr lvl="3"/>
-            <a:r>
-              <a:rPr lang="en-US" smtClean="0"/>
-              <a:t>Fourth level</a:t>
-            </a:r>
-          </a:p>
-          <a:p>
-            <a:pPr lvl="4"/>
-            <a:r>
-              <a:rPr lang="en-US" smtClean="0"/>
-              <a:t>Fifth level</a:t>
-            </a:r>
-            <a:endParaRPr lang="en-US"/>
-          </a:p>
-        </p:txBody>
-      </p:sp>
-      <p:sp>
-        <p:nvSpPr>
-          <p:cNvPr id="6" name="Footer Placeholder 5"/>
-          <p:cNvSpPr>
-            <a:spLocks noGrp="1"/>
-          </p:cNvSpPr>
-          <p:nvPr>
-            <p:ph type="ftr" sz="quarter" idx="4"/>
-          </p:nvPr>
-        </p:nvSpPr>
-        <p:spPr>
-          <a:xfrm>
-            <a:off x="0" y="8685213"/>
-            <a:ext cx="2971800" cy="457200"/>
-          </a:xfrm>
-          <a:prstGeom prst="rect">
-            <a:avLst/>
-          </a:prstGeom>
-        </p:spPr>
-        <p:txBody>
-          <a:bodyPr vert="horz" lIns="91440" tIns="45720" rIns="91440" bIns="45720" rtlCol="0" anchor="b"/>
-          <a:lstStyle>
-            <a:lvl1pPr algn="l">
-              <a:defRPr sz="1200"/>
-            </a:lvl1pPr>
-          </a:lstStyle>
-          <a:p>
-            <a:endParaRPr lang="en-US"/>
-          </a:p>
-        </p:txBody>
-      </p:sp>
-      <p:sp>
-        <p:nvSpPr>
-          <p:cNvPr id="7" name="Slide Number Placeholder 6"/>
-          <p:cNvSpPr>
-            <a:spLocks noGrp="1"/>
-          </p:cNvSpPr>
-          <p:nvPr>
-            <p:ph type="sldNum" sz="quarter" idx="5"/>
-          </p:nvPr>
-        </p:nvSpPr>
-        <p:spPr>
-          <a:xfrm>
-            <a:off x="3884613" y="8685213"/>
-            <a:ext cx="2971800" cy="457200"/>
-          </a:xfrm>
-          <a:prstGeom prst="rect">
-            <a:avLst/>
-          </a:prstGeom>
-        </p:spPr>
-        <p:txBody>
-          <a:bodyPr vert="horz" lIns="91440" tIns="45720" rIns="91440" bIns="45720" rtlCol="0" anchor="b"/>
-          <a:lstStyle>
-            <a:lvl1pPr algn="r">
-              <a:defRPr sz="1200"/>
-            </a:lvl1pPr>
-          </a:lstStyle>
-          <a:p>
-            <a:fld id="{BB5E49A5-4136-284D-997B-48E1D791AD67}" type="slidenum">
-              <a:rPr lang="en-US" smtClean="0"/>
-              <a:t>‹#›</a:t>
-            </a:fld>
-            <a:endParaRPr lang="en-US"/>
-          </a:p>
-        </p:txBody>
-      </p:sp>
     </p:spTree>
     <p:extLst>
       <p:ext uri="{BB962C8B-B14F-4D97-AF65-F5344CB8AC3E}">
-        <p14:creationId xmlns:p14="http://schemas.microsoft.com/office/powerpoint/2010/main" val="2623252185"/>
+        <p14:creationId xmlns:p14="http://schemas.microsoft.com/office/powerpoint/2010/main" val="2432464146"/>
       </p:ext>
     </p:extLst>
   </p:cSld>
   <p:clrMap bg1="lt1" tx1="dk1" bg2="lt2" tx2="dk2" accent1="accent1" accent2="accent2" accent3="accent3" accent4="accent4" accent5="accent5" accent6="accent6" hlink="hlink" folHlink="folHlink"/>
   <p:notesStyle>
-    <a:lvl1pPr marL="0" algn="l" defTabSz="457200" rtl="0" eaLnBrk="1" latinLnBrk="0" hangingPunct="1">
+    <a:lvl1pPr marL="0" algn="l" defTabSz="914400" rtl="0" eaLnBrk="1" latinLnBrk="0" hangingPunct="1">
       <a:defRPr sz="1200" kern="1200">
         <a:solidFill>
           <a:schemeClr val="tx1"/>
@@ -386,7 +180,7 @@
         <a:cs typeface="+mn-cs"/>
       </a:defRPr>
     </a:lvl1pPr>
-    <a:lvl2pPr marL="457200" algn="l" defTabSz="457200" rtl="0" eaLnBrk="1" latinLnBrk="0" hangingPunct="1">
+    <a:lvl2pPr marL="457200" algn="l" defTabSz="914400" rtl="0" eaLnBrk="1" latinLnBrk="0" hangingPunct="1">
       <a:defRPr sz="1200" kern="1200">
         <a:solidFill>
           <a:schemeClr val="tx1"/>
@@ -396,7 +190,7 @@
         <a:cs typeface="+mn-cs"/>
       </a:defRPr>
     </a:lvl2pPr>
-    <a:lvl3pPr marL="914400" algn="l" defTabSz="457200" rtl="0" eaLnBrk="1" latinLnBrk="0" hangingPunct="1">
+    <a:lvl3pPr marL="914400" algn="l" defTabSz="914400" rtl="0" eaLnBrk="1" latinLnBrk="0" hangingPunct="1">
       <a:defRPr sz="1200" kern="1200">
         <a:solidFill>
           <a:schemeClr val="tx1"/>
@@ -406,7 +200,7 @@
         <a:cs typeface="+mn-cs"/>
       </a:defRPr>
     </a:lvl3pPr>
-    <a:lvl4pPr marL="1371600" algn="l" defTabSz="457200" rtl="0" eaLnBrk="1" latinLnBrk="0" hangingPunct="1">
+    <a:lvl4pPr marL="1371600" algn="l" defTabSz="914400" rtl="0" eaLnBrk="1" latinLnBrk="0" hangingPunct="1">
       <a:defRPr sz="1200" kern="1200">
         <a:solidFill>
           <a:schemeClr val="tx1"/>
@@ -416,7 +210,7 @@
         <a:cs typeface="+mn-cs"/>
       </a:defRPr>
     </a:lvl4pPr>
-    <a:lvl5pPr marL="1828800" algn="l" defTabSz="457200" rtl="0" eaLnBrk="1" latinLnBrk="0" hangingPunct="1">
+    <a:lvl5pPr marL="1828800" algn="l" defTabSz="914400" rtl="0" eaLnBrk="1" latinLnBrk="0" hangingPunct="1">
       <a:defRPr sz="1200" kern="1200">
         <a:solidFill>
           <a:schemeClr val="tx1"/>
@@ -426,7 +220,7 @@
         <a:cs typeface="+mn-cs"/>
       </a:defRPr>
     </a:lvl5pPr>
-    <a:lvl6pPr marL="2286000" algn="l" defTabSz="457200" rtl="0" eaLnBrk="1" latinLnBrk="0" hangingPunct="1">
+    <a:lvl6pPr marL="2286000" algn="l" defTabSz="914400" rtl="0" eaLnBrk="1" latinLnBrk="0" hangingPunct="1">
       <a:defRPr sz="1200" kern="1200">
         <a:solidFill>
           <a:schemeClr val="tx1"/>
@@ -436,7 +230,7 @@
         <a:cs typeface="+mn-cs"/>
       </a:defRPr>
     </a:lvl6pPr>
-    <a:lvl7pPr marL="2743200" algn="l" defTabSz="457200" rtl="0" eaLnBrk="1" latinLnBrk="0" hangingPunct="1">
+    <a:lvl7pPr marL="2743200" algn="l" defTabSz="914400" rtl="0" eaLnBrk="1" latinLnBrk="0" hangingPunct="1">
       <a:defRPr sz="1200" kern="1200">
         <a:solidFill>
           <a:schemeClr val="tx1"/>
@@ -446,7 +240,7 @@
         <a:cs typeface="+mn-cs"/>
       </a:defRPr>
     </a:lvl7pPr>
-    <a:lvl8pPr marL="3200400" algn="l" defTabSz="457200" rtl="0" eaLnBrk="1" latinLnBrk="0" hangingPunct="1">
+    <a:lvl8pPr marL="3200400" algn="l" defTabSz="914400" rtl="0" eaLnBrk="1" latinLnBrk="0" hangingPunct="1">
       <a:defRPr sz="1200" kern="1200">
         <a:solidFill>
           <a:schemeClr val="tx1"/>
@@ -456,7 +250,7 @@
         <a:cs typeface="+mn-cs"/>
       </a:defRPr>
     </a:lvl8pPr>
-    <a:lvl9pPr marL="3657600" algn="l" defTabSz="457200" rtl="0" eaLnBrk="1" latinLnBrk="0" hangingPunct="1">
+    <a:lvl9pPr marL="3657600" algn="l" defTabSz="914400" rtl="0" eaLnBrk="1" latinLnBrk="0" hangingPunct="1">
       <a:defRPr sz="1200" kern="1200">
         <a:solidFill>
           <a:schemeClr val="tx1"/>
@@ -471,7 +265,7 @@
 </file>
 
 <file path=ppt/notesSlides/notesSlide1.xml><?xml version="1.0" encoding="utf-8"?>
-<p:notes xmlns:a="http://schemas.openxmlformats.org/drawingml/2006/main" xmlns:p="http://schemas.openxmlformats.org/presentationml/2006/main" xmlns:r="http://schemas.openxmlformats.org/officeDocument/2006/relationships">
+<p:notes xmlns:a="http://schemas.openxmlformats.org/drawingml/2006/main" xmlns:r="http://schemas.openxmlformats.org/officeDocument/2006/relationships" xmlns:p="http://schemas.openxmlformats.org/presentationml/2006/main">
   <p:cSld>
     <p:spTree>
       <p:nvGrpSpPr>
@@ -491,7 +285,7 @@
         <p:nvSpPr>
           <p:cNvPr id="2" name="Slide Image Placeholder 1"/>
           <p:cNvSpPr>
-            <a:spLocks noGrp="1"/>
+            <a:spLocks noGrp="1" noRot="1" noChangeAspect="1"/>
           </p:cNvSpPr>
           <p:nvPr>
             <p:ph type="sldImg" idx="2"/>
@@ -506,7 +300,7 @@
             <a:spLocks noGrp="1"/>
           </p:cNvSpPr>
           <p:nvPr>
-            <p:ph type="body" idx="3" sz="quarter"/>
+            <p:ph type="body" sz="quarter" idx="3"/>
           </p:nvPr>
         </p:nvSpPr>
         <p:spPr/>
@@ -527,7 +321,7 @@
             <a:spLocks noGrp="1"/>
           </p:cNvSpPr>
           <p:nvPr>
-            <p:ph type="sldNum" idx="5" sz="quarter"/>
+            <p:ph type="sldNum" sz="quarter" idx="5"/>
           </p:nvPr>
         </p:nvSpPr>
         <p:spPr/>
@@ -541,7 +335,7 @@
 </file>
 
 <file path=ppt/notesSlides/notesSlide10.xml><?xml version="1.0" encoding="utf-8"?>
-<p:notes xmlns:a="http://schemas.openxmlformats.org/drawingml/2006/main" xmlns:p="http://schemas.openxmlformats.org/presentationml/2006/main" xmlns:r="http://schemas.openxmlformats.org/officeDocument/2006/relationships">
+<p:notes xmlns:a="http://schemas.openxmlformats.org/drawingml/2006/main" xmlns:r="http://schemas.openxmlformats.org/officeDocument/2006/relationships" xmlns:p="http://schemas.openxmlformats.org/presentationml/2006/main">
   <p:cSld>
     <p:spTree>
       <p:nvGrpSpPr>
@@ -561,7 +355,7 @@
         <p:nvSpPr>
           <p:cNvPr id="2" name="Slide Image Placeholder 1"/>
           <p:cNvSpPr>
-            <a:spLocks noGrp="1"/>
+            <a:spLocks noGrp="1" noRot="1" noChangeAspect="1"/>
           </p:cNvSpPr>
           <p:nvPr>
             <p:ph type="sldImg" idx="2"/>
@@ -576,7 +370,7 @@
             <a:spLocks noGrp="1"/>
           </p:cNvSpPr>
           <p:nvPr>
-            <p:ph type="body" idx="3" sz="quarter"/>
+            <p:ph type="body" sz="quarter" idx="3"/>
           </p:nvPr>
         </p:nvSpPr>
         <p:spPr/>
@@ -597,7 +391,7 @@
             <a:spLocks noGrp="1"/>
           </p:cNvSpPr>
           <p:nvPr>
-            <p:ph type="sldNum" idx="5" sz="quarter"/>
+            <p:ph type="sldNum" sz="quarter" idx="5"/>
           </p:nvPr>
         </p:nvSpPr>
         <p:spPr/>
@@ -611,7 +405,7 @@
 </file>
 
 <file path=ppt/notesSlides/notesSlide11.xml><?xml version="1.0" encoding="utf-8"?>
-<p:notes xmlns:a="http://schemas.openxmlformats.org/drawingml/2006/main" xmlns:p="http://schemas.openxmlformats.org/presentationml/2006/main" xmlns:r="http://schemas.openxmlformats.org/officeDocument/2006/relationships">
+<p:notes xmlns:a="http://schemas.openxmlformats.org/drawingml/2006/main" xmlns:r="http://schemas.openxmlformats.org/officeDocument/2006/relationships" xmlns:p="http://schemas.openxmlformats.org/presentationml/2006/main">
   <p:cSld>
     <p:spTree>
       <p:nvGrpSpPr>
@@ -631,7 +425,7 @@
         <p:nvSpPr>
           <p:cNvPr id="2" name="Slide Image Placeholder 1"/>
           <p:cNvSpPr>
-            <a:spLocks noGrp="1"/>
+            <a:spLocks noGrp="1" noRot="1" noChangeAspect="1"/>
           </p:cNvSpPr>
           <p:nvPr>
             <p:ph type="sldImg" idx="2"/>
@@ -646,7 +440,7 @@
             <a:spLocks noGrp="1"/>
           </p:cNvSpPr>
           <p:nvPr>
-            <p:ph type="body" idx="3" sz="quarter"/>
+            <p:ph type="body" sz="quarter" idx="3"/>
           </p:nvPr>
         </p:nvSpPr>
         <p:spPr/>
@@ -667,7 +461,7 @@
             <a:spLocks noGrp="1"/>
           </p:cNvSpPr>
           <p:nvPr>
-            <p:ph type="sldNum" idx="5" sz="quarter"/>
+            <p:ph type="sldNum" sz="quarter" idx="5"/>
           </p:nvPr>
         </p:nvSpPr>
         <p:spPr/>
@@ -681,7 +475,7 @@
 </file>
 
 <file path=ppt/notesSlides/notesSlide12.xml><?xml version="1.0" encoding="utf-8"?>
-<p:notes xmlns:a="http://schemas.openxmlformats.org/drawingml/2006/main" xmlns:p="http://schemas.openxmlformats.org/presentationml/2006/main" xmlns:r="http://schemas.openxmlformats.org/officeDocument/2006/relationships">
+<p:notes xmlns:a="http://schemas.openxmlformats.org/drawingml/2006/main" xmlns:r="http://schemas.openxmlformats.org/officeDocument/2006/relationships" xmlns:p="http://schemas.openxmlformats.org/presentationml/2006/main">
   <p:cSld>
     <p:spTree>
       <p:nvGrpSpPr>
@@ -701,7 +495,7 @@
         <p:nvSpPr>
           <p:cNvPr id="2" name="Slide Image Placeholder 1"/>
           <p:cNvSpPr>
-            <a:spLocks noGrp="1"/>
+            <a:spLocks noGrp="1" noRot="1" noChangeAspect="1"/>
           </p:cNvSpPr>
           <p:nvPr>
             <p:ph type="sldImg" idx="2"/>
@@ -716,7 +510,7 @@
             <a:spLocks noGrp="1"/>
           </p:cNvSpPr>
           <p:nvPr>
-            <p:ph type="body" idx="3" sz="quarter"/>
+            <p:ph type="body" sz="quarter" idx="3"/>
           </p:nvPr>
         </p:nvSpPr>
         <p:spPr/>
@@ -737,7 +531,7 @@
             <a:spLocks noGrp="1"/>
           </p:cNvSpPr>
           <p:nvPr>
-            <p:ph type="sldNum" idx="5" sz="quarter"/>
+            <p:ph type="sldNum" sz="quarter" idx="5"/>
           </p:nvPr>
         </p:nvSpPr>
         <p:spPr/>
@@ -751,7 +545,7 @@
 </file>
 
 <file path=ppt/notesSlides/notesSlide13.xml><?xml version="1.0" encoding="utf-8"?>
-<p:notes xmlns:a="http://schemas.openxmlformats.org/drawingml/2006/main" xmlns:p="http://schemas.openxmlformats.org/presentationml/2006/main" xmlns:r="http://schemas.openxmlformats.org/officeDocument/2006/relationships">
+<p:notes xmlns:a="http://schemas.openxmlformats.org/drawingml/2006/main" xmlns:r="http://schemas.openxmlformats.org/officeDocument/2006/relationships" xmlns:p="http://schemas.openxmlformats.org/presentationml/2006/main">
   <p:cSld>
     <p:spTree>
       <p:nvGrpSpPr>
@@ -771,7 +565,7 @@
         <p:nvSpPr>
           <p:cNvPr id="2" name="Slide Image Placeholder 1"/>
           <p:cNvSpPr>
-            <a:spLocks noGrp="1"/>
+            <a:spLocks noGrp="1" noRot="1" noChangeAspect="1"/>
           </p:cNvSpPr>
           <p:nvPr>
             <p:ph type="sldImg" idx="2"/>
@@ -786,7 +580,7 @@
             <a:spLocks noGrp="1"/>
           </p:cNvSpPr>
           <p:nvPr>
-            <p:ph type="body" idx="3" sz="quarter"/>
+            <p:ph type="body" sz="quarter" idx="3"/>
           </p:nvPr>
         </p:nvSpPr>
         <p:spPr/>
@@ -807,7 +601,7 @@
             <a:spLocks noGrp="1"/>
           </p:cNvSpPr>
           <p:nvPr>
-            <p:ph type="sldNum" idx="5" sz="quarter"/>
+            <p:ph type="sldNum" sz="quarter" idx="5"/>
           </p:nvPr>
         </p:nvSpPr>
         <p:spPr/>
@@ -821,7 +615,7 @@
 </file>
 
 <file path=ppt/notesSlides/notesSlide14.xml><?xml version="1.0" encoding="utf-8"?>
-<p:notes xmlns:a="http://schemas.openxmlformats.org/drawingml/2006/main" xmlns:p="http://schemas.openxmlformats.org/presentationml/2006/main" xmlns:r="http://schemas.openxmlformats.org/officeDocument/2006/relationships">
+<p:notes xmlns:a="http://schemas.openxmlformats.org/drawingml/2006/main" xmlns:r="http://schemas.openxmlformats.org/officeDocument/2006/relationships" xmlns:p="http://schemas.openxmlformats.org/presentationml/2006/main">
   <p:cSld>
     <p:spTree>
       <p:nvGrpSpPr>
@@ -841,7 +635,7 @@
         <p:nvSpPr>
           <p:cNvPr id="2" name="Slide Image Placeholder 1"/>
           <p:cNvSpPr>
-            <a:spLocks noGrp="1"/>
+            <a:spLocks noGrp="1" noRot="1" noChangeAspect="1"/>
           </p:cNvSpPr>
           <p:nvPr>
             <p:ph type="sldImg" idx="2"/>
@@ -856,7 +650,7 @@
             <a:spLocks noGrp="1"/>
           </p:cNvSpPr>
           <p:nvPr>
-            <p:ph type="body" idx="3" sz="quarter"/>
+            <p:ph type="body" sz="quarter" idx="3"/>
           </p:nvPr>
         </p:nvSpPr>
         <p:spPr/>
@@ -877,7 +671,7 @@
             <a:spLocks noGrp="1"/>
           </p:cNvSpPr>
           <p:nvPr>
-            <p:ph type="sldNum" idx="5" sz="quarter"/>
+            <p:ph type="sldNum" sz="quarter" idx="5"/>
           </p:nvPr>
         </p:nvSpPr>
         <p:spPr/>
@@ -891,7 +685,7 @@
 </file>
 
 <file path=ppt/notesSlides/notesSlide2.xml><?xml version="1.0" encoding="utf-8"?>
-<p:notes xmlns:a="http://schemas.openxmlformats.org/drawingml/2006/main" xmlns:p="http://schemas.openxmlformats.org/presentationml/2006/main" xmlns:r="http://schemas.openxmlformats.org/officeDocument/2006/relationships">
+<p:notes xmlns:a="http://schemas.openxmlformats.org/drawingml/2006/main" xmlns:r="http://schemas.openxmlformats.org/officeDocument/2006/relationships" xmlns:p="http://schemas.openxmlformats.org/presentationml/2006/main">
   <p:cSld>
     <p:spTree>
       <p:nvGrpSpPr>
@@ -911,7 +705,7 @@
         <p:nvSpPr>
           <p:cNvPr id="2" name="Slide Image Placeholder 1"/>
           <p:cNvSpPr>
-            <a:spLocks noGrp="1"/>
+            <a:spLocks noGrp="1" noRot="1" noChangeAspect="1"/>
           </p:cNvSpPr>
           <p:nvPr>
             <p:ph type="sldImg" idx="2"/>
@@ -926,7 +720,7 @@
             <a:spLocks noGrp="1"/>
           </p:cNvSpPr>
           <p:nvPr>
-            <p:ph type="body" idx="3" sz="quarter"/>
+            <p:ph type="body" sz="quarter" idx="3"/>
           </p:nvPr>
         </p:nvSpPr>
         <p:spPr/>
@@ -947,7 +741,7 @@
             <a:spLocks noGrp="1"/>
           </p:cNvSpPr>
           <p:nvPr>
-            <p:ph type="sldNum" idx="5" sz="quarter"/>
+            <p:ph type="sldNum" sz="quarter" idx="5"/>
           </p:nvPr>
         </p:nvSpPr>
         <p:spPr/>
@@ -961,7 +755,7 @@
 </file>
 
 <file path=ppt/notesSlides/notesSlide3.xml><?xml version="1.0" encoding="utf-8"?>
-<p:notes xmlns:a="http://schemas.openxmlformats.org/drawingml/2006/main" xmlns:p="http://schemas.openxmlformats.org/presentationml/2006/main" xmlns:r="http://schemas.openxmlformats.org/officeDocument/2006/relationships">
+<p:notes xmlns:a="http://schemas.openxmlformats.org/drawingml/2006/main" xmlns:r="http://schemas.openxmlformats.org/officeDocument/2006/relationships" xmlns:p="http://schemas.openxmlformats.org/presentationml/2006/main">
   <p:cSld>
     <p:spTree>
       <p:nvGrpSpPr>
@@ -981,7 +775,7 @@
         <p:nvSpPr>
           <p:cNvPr id="2" name="Slide Image Placeholder 1"/>
           <p:cNvSpPr>
-            <a:spLocks noGrp="1"/>
+            <a:spLocks noGrp="1" noRot="1" noChangeAspect="1"/>
           </p:cNvSpPr>
           <p:nvPr>
             <p:ph type="sldImg" idx="2"/>
@@ -996,7 +790,7 @@
             <a:spLocks noGrp="1"/>
           </p:cNvSpPr>
           <p:nvPr>
-            <p:ph type="body" idx="3" sz="quarter"/>
+            <p:ph type="body" sz="quarter" idx="3"/>
           </p:nvPr>
         </p:nvSpPr>
         <p:spPr/>
@@ -1017,7 +811,7 @@
             <a:spLocks noGrp="1"/>
           </p:cNvSpPr>
           <p:nvPr>
-            <p:ph type="sldNum" idx="5" sz="quarter"/>
+            <p:ph type="sldNum" sz="quarter" idx="5"/>
           </p:nvPr>
         </p:nvSpPr>
         <p:spPr/>
@@ -1031,7 +825,7 @@
 </file>
 
 <file path=ppt/notesSlides/notesSlide4.xml><?xml version="1.0" encoding="utf-8"?>
-<p:notes xmlns:a="http://schemas.openxmlformats.org/drawingml/2006/main" xmlns:p="http://schemas.openxmlformats.org/presentationml/2006/main" xmlns:r="http://schemas.openxmlformats.org/officeDocument/2006/relationships">
+<p:notes xmlns:a="http://schemas.openxmlformats.org/drawingml/2006/main" xmlns:r="http://schemas.openxmlformats.org/officeDocument/2006/relationships" xmlns:p="http://schemas.openxmlformats.org/presentationml/2006/main">
   <p:cSld>
     <p:spTree>
       <p:nvGrpSpPr>
@@ -1051,7 +845,7 @@
         <p:nvSpPr>
           <p:cNvPr id="2" name="Slide Image Placeholder 1"/>
           <p:cNvSpPr>
-            <a:spLocks noGrp="1"/>
+            <a:spLocks noGrp="1" noRot="1" noChangeAspect="1"/>
           </p:cNvSpPr>
           <p:nvPr>
             <p:ph type="sldImg" idx="2"/>
@@ -1066,7 +860,7 @@
             <a:spLocks noGrp="1"/>
           </p:cNvSpPr>
           <p:nvPr>
-            <p:ph type="body" idx="3" sz="quarter"/>
+            <p:ph type="body" sz="quarter" idx="3"/>
           </p:nvPr>
         </p:nvSpPr>
         <p:spPr/>
@@ -1087,7 +881,7 @@
             <a:spLocks noGrp="1"/>
           </p:cNvSpPr>
           <p:nvPr>
-            <p:ph type="sldNum" idx="5" sz="quarter"/>
+            <p:ph type="sldNum" sz="quarter" idx="5"/>
           </p:nvPr>
         </p:nvSpPr>
         <p:spPr/>
@@ -1101,7 +895,7 @@
 </file>
 
 <file path=ppt/notesSlides/notesSlide5.xml><?xml version="1.0" encoding="utf-8"?>
-<p:notes xmlns:a="http://schemas.openxmlformats.org/drawingml/2006/main" xmlns:p="http://schemas.openxmlformats.org/presentationml/2006/main" xmlns:r="http://schemas.openxmlformats.org/officeDocument/2006/relationships">
+<p:notes xmlns:a="http://schemas.openxmlformats.org/drawingml/2006/main" xmlns:r="http://schemas.openxmlformats.org/officeDocument/2006/relationships" xmlns:p="http://schemas.openxmlformats.org/presentationml/2006/main">
   <p:cSld>
     <p:spTree>
       <p:nvGrpSpPr>
@@ -1121,7 +915,7 @@
         <p:nvSpPr>
           <p:cNvPr id="2" name="Slide Image Placeholder 1"/>
           <p:cNvSpPr>
-            <a:spLocks noGrp="1"/>
+            <a:spLocks noGrp="1" noRot="1" noChangeAspect="1"/>
           </p:cNvSpPr>
           <p:nvPr>
             <p:ph type="sldImg" idx="2"/>
@@ -1136,7 +930,7 @@
             <a:spLocks noGrp="1"/>
           </p:cNvSpPr>
           <p:nvPr>
-            <p:ph type="body" idx="3" sz="quarter"/>
+            <p:ph type="body" sz="quarter" idx="3"/>
           </p:nvPr>
         </p:nvSpPr>
         <p:spPr/>
@@ -1157,7 +951,7 @@
             <a:spLocks noGrp="1"/>
           </p:cNvSpPr>
           <p:nvPr>
-            <p:ph type="sldNum" idx="5" sz="quarter"/>
+            <p:ph type="sldNum" sz="quarter" idx="5"/>
           </p:nvPr>
         </p:nvSpPr>
         <p:spPr/>
@@ -1171,7 +965,7 @@
 </file>
 
 <file path=ppt/notesSlides/notesSlide6.xml><?xml version="1.0" encoding="utf-8"?>
-<p:notes xmlns:a="http://schemas.openxmlformats.org/drawingml/2006/main" xmlns:p="http://schemas.openxmlformats.org/presentationml/2006/main" xmlns:r="http://schemas.openxmlformats.org/officeDocument/2006/relationships">
+<p:notes xmlns:a="http://schemas.openxmlformats.org/drawingml/2006/main" xmlns:r="http://schemas.openxmlformats.org/officeDocument/2006/relationships" xmlns:p="http://schemas.openxmlformats.org/presentationml/2006/main">
   <p:cSld>
     <p:spTree>
       <p:nvGrpSpPr>
@@ -1191,7 +985,7 @@
         <p:nvSpPr>
           <p:cNvPr id="2" name="Slide Image Placeholder 1"/>
           <p:cNvSpPr>
-            <a:spLocks noGrp="1"/>
+            <a:spLocks noGrp="1" noRot="1" noChangeAspect="1"/>
           </p:cNvSpPr>
           <p:nvPr>
             <p:ph type="sldImg" idx="2"/>
@@ -1206,7 +1000,7 @@
             <a:spLocks noGrp="1"/>
           </p:cNvSpPr>
           <p:nvPr>
-            <p:ph type="body" idx="3" sz="quarter"/>
+            <p:ph type="body" sz="quarter" idx="3"/>
           </p:nvPr>
         </p:nvSpPr>
         <p:spPr/>
@@ -1215,7 +1009,7 @@
           <a:lstStyle/>
           <a:p>
             <a:r>
-              <a:t>Pain = presentation failure. Opportunity = finance buying motion.</a:t>
+              <a:t>Lead with the bus-factor quote after the comprehension quote. Problem is not only time — institutional knowledge concentrated in one FP&amp;A owner. Product value = shared story so the company is not doomed if that person is out.</a:t>
             </a:r>
           </a:p>
         </p:txBody>
@@ -1227,7 +1021,7 @@
             <a:spLocks noGrp="1"/>
           </p:cNvSpPr>
           <p:nvPr>
-            <p:ph type="sldNum" idx="5" sz="quarter"/>
+            <p:ph type="sldNum" sz="quarter" idx="5"/>
           </p:nvPr>
         </p:nvSpPr>
         <p:spPr/>
@@ -1241,7 +1035,7 @@
 </file>
 
 <file path=ppt/notesSlides/notesSlide7.xml><?xml version="1.0" encoding="utf-8"?>
-<p:notes xmlns:a="http://schemas.openxmlformats.org/drawingml/2006/main" xmlns:p="http://schemas.openxmlformats.org/presentationml/2006/main" xmlns:r="http://schemas.openxmlformats.org/officeDocument/2006/relationships">
+<p:notes xmlns:a="http://schemas.openxmlformats.org/drawingml/2006/main" xmlns:r="http://schemas.openxmlformats.org/officeDocument/2006/relationships" xmlns:p="http://schemas.openxmlformats.org/presentationml/2006/main">
   <p:cSld>
     <p:spTree>
       <p:nvGrpSpPr>
@@ -1261,7 +1055,7 @@
         <p:nvSpPr>
           <p:cNvPr id="2" name="Slide Image Placeholder 1"/>
           <p:cNvSpPr>
-            <a:spLocks noGrp="1"/>
+            <a:spLocks noGrp="1" noRot="1" noChangeAspect="1"/>
           </p:cNvSpPr>
           <p:nvPr>
             <p:ph type="sldImg" idx="2"/>
@@ -1276,7 +1070,7 @@
             <a:spLocks noGrp="1"/>
           </p:cNvSpPr>
           <p:nvPr>
-            <p:ph type="body" idx="3" sz="quarter"/>
+            <p:ph type="body" sz="quarter" idx="3"/>
           </p:nvPr>
         </p:nvSpPr>
         <p:spPr/>
@@ -1297,7 +1091,7 @@
             <a:spLocks noGrp="1"/>
           </p:cNvSpPr>
           <p:nvPr>
-            <p:ph type="sldNum" idx="5" sz="quarter"/>
+            <p:ph type="sldNum" sz="quarter" idx="5"/>
           </p:nvPr>
         </p:nvSpPr>
         <p:spPr/>
@@ -1311,7 +1105,7 @@
 </file>
 
 <file path=ppt/notesSlides/notesSlide8.xml><?xml version="1.0" encoding="utf-8"?>
-<p:notes xmlns:a="http://schemas.openxmlformats.org/drawingml/2006/main" xmlns:p="http://schemas.openxmlformats.org/presentationml/2006/main" xmlns:r="http://schemas.openxmlformats.org/officeDocument/2006/relationships">
+<p:notes xmlns:a="http://schemas.openxmlformats.org/drawingml/2006/main" xmlns:r="http://schemas.openxmlformats.org/officeDocument/2006/relationships" xmlns:p="http://schemas.openxmlformats.org/presentationml/2006/main">
   <p:cSld>
     <p:spTree>
       <p:nvGrpSpPr>
@@ -1331,7 +1125,7 @@
         <p:nvSpPr>
           <p:cNvPr id="2" name="Slide Image Placeholder 1"/>
           <p:cNvSpPr>
-            <a:spLocks noGrp="1"/>
+            <a:spLocks noGrp="1" noRot="1" noChangeAspect="1"/>
           </p:cNvSpPr>
           <p:nvPr>
             <p:ph type="sldImg" idx="2"/>
@@ -1346,7 +1140,7 @@
             <a:spLocks noGrp="1"/>
           </p:cNvSpPr>
           <p:nvPr>
-            <p:ph type="body" idx="3" sz="quarter"/>
+            <p:ph type="body" sz="quarter" idx="3"/>
           </p:nvPr>
         </p:nvSpPr>
         <p:spPr/>
@@ -1367,7 +1161,7 @@
             <a:spLocks noGrp="1"/>
           </p:cNvSpPr>
           <p:nvPr>
-            <p:ph type="sldNum" idx="5" sz="quarter"/>
+            <p:ph type="sldNum" sz="quarter" idx="5"/>
           </p:nvPr>
         </p:nvSpPr>
         <p:spPr/>
@@ -1381,7 +1175,7 @@
 </file>
 
 <file path=ppt/notesSlides/notesSlide9.xml><?xml version="1.0" encoding="utf-8"?>
-<p:notes xmlns:a="http://schemas.openxmlformats.org/drawingml/2006/main" xmlns:p="http://schemas.openxmlformats.org/presentationml/2006/main" xmlns:r="http://schemas.openxmlformats.org/officeDocument/2006/relationships">
+<p:notes xmlns:a="http://schemas.openxmlformats.org/drawingml/2006/main" xmlns:r="http://schemas.openxmlformats.org/officeDocument/2006/relationships" xmlns:p="http://schemas.openxmlformats.org/presentationml/2006/main">
   <p:cSld>
     <p:spTree>
       <p:nvGrpSpPr>
@@ -1401,7 +1195,7 @@
         <p:nvSpPr>
           <p:cNvPr id="2" name="Slide Image Placeholder 1"/>
           <p:cNvSpPr>
-            <a:spLocks noGrp="1"/>
+            <a:spLocks noGrp="1" noRot="1" noChangeAspect="1"/>
           </p:cNvSpPr>
           <p:nvPr>
             <p:ph type="sldImg" idx="2"/>
@@ -1416,7 +1210,7 @@
             <a:spLocks noGrp="1"/>
           </p:cNvSpPr>
           <p:nvPr>
-            <p:ph type="body" idx="3" sz="quarter"/>
+            <p:ph type="body" sz="quarter" idx="3"/>
           </p:nvPr>
         </p:nvSpPr>
         <p:spPr/>
@@ -1437,7 +1231,7 @@
             <a:spLocks noGrp="1"/>
           </p:cNvSpPr>
           <p:nvPr>
-            <p:ph type="sldNum" idx="5" sz="quarter"/>
+            <p:ph type="sldNum" sz="quarter" idx="5"/>
           </p:nvPr>
         </p:nvSpPr>
         <p:spPr/>
@@ -1488,10 +1282,9 @@
           <a:lstStyle/>
           <a:p>
             <a:r>
-              <a:rPr lang="en-US" smtClean="0"/>
+              <a:rPr lang="en-US"/>
               <a:t>Click to edit Master title style</a:t>
             </a:r>
-            <a:endParaRPr lang="en-US"/>
           </a:p>
         </p:txBody>
       </p:sp>
@@ -1607,10 +1400,9 @@
           </a:lstStyle>
           <a:p>
             <a:r>
-              <a:rPr lang="en-US" smtClean="0"/>
+              <a:rPr lang="en-US"/>
               <a:t>Click to edit Master subtitle style</a:t>
             </a:r>
-            <a:endParaRPr lang="en-US"/>
           </a:p>
         </p:txBody>
       </p:sp>
@@ -1631,7 +1423,7 @@
           <a:p>
             <a:fld id="{5BCAD085-E8A6-8845-BD4E-CB4CCA059FC4}" type="datetimeFigureOut">
               <a:rPr lang="en-US" smtClean="0"/>
-              <a:t>1/27/13</a:t>
+              <a:t>8/3/26</a:t>
             </a:fld>
             <a:endParaRPr lang="en-US"/>
           </a:p>
@@ -1725,10 +1517,9 @@
           <a:lstStyle/>
           <a:p>
             <a:r>
-              <a:rPr lang="en-US" smtClean="0"/>
+              <a:rPr lang="en-US"/>
               <a:t>Click to edit Master title style</a:t>
             </a:r>
-            <a:endParaRPr lang="en-US"/>
           </a:p>
         </p:txBody>
       </p:sp>
@@ -1749,38 +1540,37 @@
           <a:p>
             <a:pPr lvl="0"/>
             <a:r>
-              <a:rPr lang="en-US" smtClean="0"/>
+              <a:rPr lang="en-US"/>
               <a:t>Click to edit Master text styles</a:t>
             </a:r>
           </a:p>
           <a:p>
             <a:pPr lvl="1"/>
             <a:r>
-              <a:rPr lang="en-US" smtClean="0"/>
+              <a:rPr lang="en-US"/>
               <a:t>Second level</a:t>
             </a:r>
           </a:p>
           <a:p>
             <a:pPr lvl="2"/>
             <a:r>
-              <a:rPr lang="en-US" smtClean="0"/>
+              <a:rPr lang="en-US"/>
               <a:t>Third level</a:t>
             </a:r>
           </a:p>
           <a:p>
             <a:pPr lvl="3"/>
             <a:r>
-              <a:rPr lang="en-US" smtClean="0"/>
+              <a:rPr lang="en-US"/>
               <a:t>Fourth level</a:t>
             </a:r>
           </a:p>
           <a:p>
             <a:pPr lvl="4"/>
             <a:r>
-              <a:rPr lang="en-US" smtClean="0"/>
+              <a:rPr lang="en-US"/>
               <a:t>Fifth level</a:t>
             </a:r>
-            <a:endParaRPr lang="en-US"/>
           </a:p>
         </p:txBody>
       </p:sp>
@@ -1801,7 +1591,7 @@
           <a:p>
             <a:fld id="{5BCAD085-E8A6-8845-BD4E-CB4CCA059FC4}" type="datetimeFigureOut">
               <a:rPr lang="en-US" smtClean="0"/>
-              <a:t>1/27/13</a:t>
+              <a:t>8/3/26</a:t>
             </a:fld>
             <a:endParaRPr lang="en-US"/>
           </a:p>
@@ -1900,10 +1690,9 @@
           <a:lstStyle/>
           <a:p>
             <a:r>
-              <a:rPr lang="en-US" smtClean="0"/>
+              <a:rPr lang="en-US"/>
               <a:t>Click to edit Master title style</a:t>
             </a:r>
-            <a:endParaRPr lang="en-US"/>
           </a:p>
         </p:txBody>
       </p:sp>
@@ -1929,38 +1718,37 @@
           <a:p>
             <a:pPr lvl="0"/>
             <a:r>
-              <a:rPr lang="en-US" smtClean="0"/>
+              <a:rPr lang="en-US"/>
               <a:t>Click to edit Master text styles</a:t>
             </a:r>
           </a:p>
           <a:p>
             <a:pPr lvl="1"/>
             <a:r>
-              <a:rPr lang="en-US" smtClean="0"/>
+              <a:rPr lang="en-US"/>
               <a:t>Second level</a:t>
             </a:r>
           </a:p>
           <a:p>
             <a:pPr lvl="2"/>
             <a:r>
-              <a:rPr lang="en-US" smtClean="0"/>
+              <a:rPr lang="en-US"/>
               <a:t>Third level</a:t>
             </a:r>
           </a:p>
           <a:p>
             <a:pPr lvl="3"/>
             <a:r>
-              <a:rPr lang="en-US" smtClean="0"/>
+              <a:rPr lang="en-US"/>
               <a:t>Fourth level</a:t>
             </a:r>
           </a:p>
           <a:p>
             <a:pPr lvl="4"/>
             <a:r>
-              <a:rPr lang="en-US" smtClean="0"/>
+              <a:rPr lang="en-US"/>
               <a:t>Fifth level</a:t>
             </a:r>
-            <a:endParaRPr lang="en-US"/>
           </a:p>
         </p:txBody>
       </p:sp>
@@ -1981,7 +1769,7 @@
           <a:p>
             <a:fld id="{5BCAD085-E8A6-8845-BD4E-CB4CCA059FC4}" type="datetimeFigureOut">
               <a:rPr lang="en-US" smtClean="0"/>
-              <a:t>1/27/13</a:t>
+              <a:t>8/3/26</a:t>
             </a:fld>
             <a:endParaRPr lang="en-US"/>
           </a:p>
@@ -2075,10 +1863,9 @@
           <a:lstStyle/>
           <a:p>
             <a:r>
-              <a:rPr lang="en-US" smtClean="0"/>
+              <a:rPr lang="en-US"/>
               <a:t>Click to edit Master title style</a:t>
             </a:r>
-            <a:endParaRPr lang="en-US"/>
           </a:p>
         </p:txBody>
       </p:sp>
@@ -2099,38 +1886,37 @@
           <a:p>
             <a:pPr lvl="0"/>
             <a:r>
-              <a:rPr lang="en-US" smtClean="0"/>
+              <a:rPr lang="en-US"/>
               <a:t>Click to edit Master text styles</a:t>
             </a:r>
           </a:p>
           <a:p>
             <a:pPr lvl="1"/>
             <a:r>
-              <a:rPr lang="en-US" smtClean="0"/>
+              <a:rPr lang="en-US"/>
               <a:t>Second level</a:t>
             </a:r>
           </a:p>
           <a:p>
             <a:pPr lvl="2"/>
             <a:r>
-              <a:rPr lang="en-US" smtClean="0"/>
+              <a:rPr lang="en-US"/>
               <a:t>Third level</a:t>
             </a:r>
           </a:p>
           <a:p>
             <a:pPr lvl="3"/>
             <a:r>
-              <a:rPr lang="en-US" smtClean="0"/>
+              <a:rPr lang="en-US"/>
               <a:t>Fourth level</a:t>
             </a:r>
           </a:p>
           <a:p>
             <a:pPr lvl="4"/>
             <a:r>
-              <a:rPr lang="en-US" smtClean="0"/>
+              <a:rPr lang="en-US"/>
               <a:t>Fifth level</a:t>
             </a:r>
-            <a:endParaRPr lang="en-US"/>
           </a:p>
         </p:txBody>
       </p:sp>
@@ -2151,7 +1937,7 @@
           <a:p>
             <a:fld id="{5BCAD085-E8A6-8845-BD4E-CB4CCA059FC4}" type="datetimeFigureOut">
               <a:rPr lang="en-US" smtClean="0"/>
-              <a:t>1/27/13</a:t>
+              <a:t>8/3/26</a:t>
             </a:fld>
             <a:endParaRPr lang="en-US"/>
           </a:p>
@@ -2254,10 +2040,9 @@
           </a:lstStyle>
           <a:p>
             <a:r>
-              <a:rPr lang="en-US" smtClean="0"/>
+              <a:rPr lang="en-US"/>
               <a:t>Click to edit Master title style</a:t>
             </a:r>
-            <a:endParaRPr lang="en-US"/>
           </a:p>
         </p:txBody>
       </p:sp>
@@ -2374,7 +2159,7 @@
           <a:p>
             <a:pPr lvl="0"/>
             <a:r>
-              <a:rPr lang="en-US" smtClean="0"/>
+              <a:rPr lang="en-US"/>
               <a:t>Click to edit Master text styles</a:t>
             </a:r>
           </a:p>
@@ -2397,7 +2182,7 @@
           <a:p>
             <a:fld id="{5BCAD085-E8A6-8845-BD4E-CB4CCA059FC4}" type="datetimeFigureOut">
               <a:rPr lang="en-US" smtClean="0"/>
-              <a:t>1/27/13</a:t>
+              <a:t>8/3/26</a:t>
             </a:fld>
             <a:endParaRPr lang="en-US"/>
           </a:p>
@@ -2491,10 +2276,9 @@
           <a:lstStyle/>
           <a:p>
             <a:r>
-              <a:rPr lang="en-US" smtClean="0"/>
+              <a:rPr lang="en-US"/>
               <a:t>Click to edit Master title style</a:t>
             </a:r>
-            <a:endParaRPr lang="en-US"/>
           </a:p>
         </p:txBody>
       </p:sp>
@@ -2548,38 +2332,37 @@
           <a:p>
             <a:pPr lvl="0"/>
             <a:r>
-              <a:rPr lang="en-US" smtClean="0"/>
+              <a:rPr lang="en-US"/>
               <a:t>Click to edit Master text styles</a:t>
             </a:r>
           </a:p>
           <a:p>
             <a:pPr lvl="1"/>
             <a:r>
-              <a:rPr lang="en-US" smtClean="0"/>
+              <a:rPr lang="en-US"/>
               <a:t>Second level</a:t>
             </a:r>
           </a:p>
           <a:p>
             <a:pPr lvl="2"/>
             <a:r>
-              <a:rPr lang="en-US" smtClean="0"/>
+              <a:rPr lang="en-US"/>
               <a:t>Third level</a:t>
             </a:r>
           </a:p>
           <a:p>
             <a:pPr lvl="3"/>
             <a:r>
-              <a:rPr lang="en-US" smtClean="0"/>
+              <a:rPr lang="en-US"/>
               <a:t>Fourth level</a:t>
             </a:r>
           </a:p>
           <a:p>
             <a:pPr lvl="4"/>
             <a:r>
-              <a:rPr lang="en-US" smtClean="0"/>
+              <a:rPr lang="en-US"/>
               <a:t>Fifth level</a:t>
             </a:r>
-            <a:endParaRPr lang="en-US"/>
           </a:p>
         </p:txBody>
       </p:sp>
@@ -2633,38 +2416,37 @@
           <a:p>
             <a:pPr lvl="0"/>
             <a:r>
-              <a:rPr lang="en-US" smtClean="0"/>
+              <a:rPr lang="en-US"/>
               <a:t>Click to edit Master text styles</a:t>
             </a:r>
           </a:p>
           <a:p>
             <a:pPr lvl="1"/>
             <a:r>
-              <a:rPr lang="en-US" smtClean="0"/>
+              <a:rPr lang="en-US"/>
               <a:t>Second level</a:t>
             </a:r>
           </a:p>
           <a:p>
             <a:pPr lvl="2"/>
             <a:r>
-              <a:rPr lang="en-US" smtClean="0"/>
+              <a:rPr lang="en-US"/>
               <a:t>Third level</a:t>
             </a:r>
           </a:p>
           <a:p>
             <a:pPr lvl="3"/>
             <a:r>
-              <a:rPr lang="en-US" smtClean="0"/>
+              <a:rPr lang="en-US"/>
               <a:t>Fourth level</a:t>
             </a:r>
           </a:p>
           <a:p>
             <a:pPr lvl="4"/>
             <a:r>
-              <a:rPr lang="en-US" smtClean="0"/>
+              <a:rPr lang="en-US"/>
               <a:t>Fifth level</a:t>
             </a:r>
-            <a:endParaRPr lang="en-US"/>
           </a:p>
         </p:txBody>
       </p:sp>
@@ -2685,7 +2467,7 @@
           <a:p>
             <a:fld id="{5BCAD085-E8A6-8845-BD4E-CB4CCA059FC4}" type="datetimeFigureOut">
               <a:rPr lang="en-US" smtClean="0"/>
-              <a:t>1/27/13</a:t>
+              <a:t>8/3/26</a:t>
             </a:fld>
             <a:endParaRPr lang="en-US"/>
           </a:p>
@@ -2783,10 +2565,9 @@
           </a:lstStyle>
           <a:p>
             <a:r>
-              <a:rPr lang="en-US" smtClean="0"/>
+              <a:rPr lang="en-US"/>
               <a:t>Click to edit Master title style</a:t>
             </a:r>
-            <a:endParaRPr lang="en-US"/>
           </a:p>
         </p:txBody>
       </p:sp>
@@ -2849,7 +2630,7 @@
           <a:p>
             <a:pPr lvl="0"/>
             <a:r>
-              <a:rPr lang="en-US" smtClean="0"/>
+              <a:rPr lang="en-US"/>
               <a:t>Click to edit Master text styles</a:t>
             </a:r>
           </a:p>
@@ -2905,38 +2686,37 @@
           <a:p>
             <a:pPr lvl="0"/>
             <a:r>
-              <a:rPr lang="en-US" smtClean="0"/>
+              <a:rPr lang="en-US"/>
               <a:t>Click to edit Master text styles</a:t>
             </a:r>
           </a:p>
           <a:p>
             <a:pPr lvl="1"/>
             <a:r>
-              <a:rPr lang="en-US" smtClean="0"/>
+              <a:rPr lang="en-US"/>
               <a:t>Second level</a:t>
             </a:r>
           </a:p>
           <a:p>
             <a:pPr lvl="2"/>
             <a:r>
-              <a:rPr lang="en-US" smtClean="0"/>
+              <a:rPr lang="en-US"/>
               <a:t>Third level</a:t>
             </a:r>
           </a:p>
           <a:p>
             <a:pPr lvl="3"/>
             <a:r>
-              <a:rPr lang="en-US" smtClean="0"/>
+              <a:rPr lang="en-US"/>
               <a:t>Fourth level</a:t>
             </a:r>
           </a:p>
           <a:p>
             <a:pPr lvl="4"/>
             <a:r>
-              <a:rPr lang="en-US" smtClean="0"/>
+              <a:rPr lang="en-US"/>
               <a:t>Fifth level</a:t>
             </a:r>
-            <a:endParaRPr lang="en-US"/>
           </a:p>
         </p:txBody>
       </p:sp>
@@ -2999,7 +2779,7 @@
           <a:p>
             <a:pPr lvl="0"/>
             <a:r>
-              <a:rPr lang="en-US" smtClean="0"/>
+              <a:rPr lang="en-US"/>
               <a:t>Click to edit Master text styles</a:t>
             </a:r>
           </a:p>
@@ -3055,38 +2835,37 @@
           <a:p>
             <a:pPr lvl="0"/>
             <a:r>
-              <a:rPr lang="en-US" smtClean="0"/>
+              <a:rPr lang="en-US"/>
               <a:t>Click to edit Master text styles</a:t>
             </a:r>
           </a:p>
           <a:p>
             <a:pPr lvl="1"/>
             <a:r>
-              <a:rPr lang="en-US" smtClean="0"/>
+              <a:rPr lang="en-US"/>
               <a:t>Second level</a:t>
             </a:r>
           </a:p>
           <a:p>
             <a:pPr lvl="2"/>
             <a:r>
-              <a:rPr lang="en-US" smtClean="0"/>
+              <a:rPr lang="en-US"/>
               <a:t>Third level</a:t>
             </a:r>
           </a:p>
           <a:p>
             <a:pPr lvl="3"/>
             <a:r>
-              <a:rPr lang="en-US" smtClean="0"/>
+              <a:rPr lang="en-US"/>
               <a:t>Fourth level</a:t>
             </a:r>
           </a:p>
           <a:p>
             <a:pPr lvl="4"/>
             <a:r>
-              <a:rPr lang="en-US" smtClean="0"/>
+              <a:rPr lang="en-US"/>
               <a:t>Fifth level</a:t>
             </a:r>
-            <a:endParaRPr lang="en-US"/>
           </a:p>
         </p:txBody>
       </p:sp>
@@ -3107,7 +2886,7 @@
           <a:p>
             <a:fld id="{5BCAD085-E8A6-8845-BD4E-CB4CCA059FC4}" type="datetimeFigureOut">
               <a:rPr lang="en-US" smtClean="0"/>
-              <a:t>1/27/13</a:t>
+              <a:t>8/3/26</a:t>
             </a:fld>
             <a:endParaRPr lang="en-US"/>
           </a:p>
@@ -3201,10 +2980,9 @@
           <a:lstStyle/>
           <a:p>
             <a:r>
-              <a:rPr lang="en-US" smtClean="0"/>
+              <a:rPr lang="en-US"/>
               <a:t>Click to edit Master title style</a:t>
             </a:r>
-            <a:endParaRPr lang="en-US"/>
           </a:p>
         </p:txBody>
       </p:sp>
@@ -3225,7 +3003,7 @@
           <a:p>
             <a:fld id="{5BCAD085-E8A6-8845-BD4E-CB4CCA059FC4}" type="datetimeFigureOut">
               <a:rPr lang="en-US" smtClean="0"/>
-              <a:t>1/27/13</a:t>
+              <a:t>8/3/26</a:t>
             </a:fld>
             <a:endParaRPr lang="en-US"/>
           </a:p>
@@ -3320,7 +3098,7 @@
           <a:p>
             <a:fld id="{5BCAD085-E8A6-8845-BD4E-CB4CCA059FC4}" type="datetimeFigureOut">
               <a:rPr lang="en-US" smtClean="0"/>
-              <a:t>1/27/13</a:t>
+              <a:t>8/3/26</a:t>
             </a:fld>
             <a:endParaRPr lang="en-US"/>
           </a:p>
@@ -3423,10 +3201,9 @@
           </a:lstStyle>
           <a:p>
             <a:r>
-              <a:rPr lang="en-US" smtClean="0"/>
+              <a:rPr lang="en-US"/>
               <a:t>Click to edit Master title style</a:t>
             </a:r>
-            <a:endParaRPr lang="en-US"/>
           </a:p>
         </p:txBody>
       </p:sp>
@@ -3480,38 +3257,37 @@
           <a:p>
             <a:pPr lvl="0"/>
             <a:r>
-              <a:rPr lang="en-US" smtClean="0"/>
+              <a:rPr lang="en-US"/>
               <a:t>Click to edit Master text styles</a:t>
             </a:r>
           </a:p>
           <a:p>
             <a:pPr lvl="1"/>
             <a:r>
-              <a:rPr lang="en-US" smtClean="0"/>
+              <a:rPr lang="en-US"/>
               <a:t>Second level</a:t>
             </a:r>
           </a:p>
           <a:p>
             <a:pPr lvl="2"/>
             <a:r>
-              <a:rPr lang="en-US" smtClean="0"/>
+              <a:rPr lang="en-US"/>
               <a:t>Third level</a:t>
             </a:r>
           </a:p>
           <a:p>
             <a:pPr lvl="3"/>
             <a:r>
-              <a:rPr lang="en-US" smtClean="0"/>
+              <a:rPr lang="en-US"/>
               <a:t>Fourth level</a:t>
             </a:r>
           </a:p>
           <a:p>
             <a:pPr lvl="4"/>
             <a:r>
-              <a:rPr lang="en-US" smtClean="0"/>
+              <a:rPr lang="en-US"/>
               <a:t>Fifth level</a:t>
             </a:r>
-            <a:endParaRPr lang="en-US"/>
           </a:p>
         </p:txBody>
       </p:sp>
@@ -3574,7 +3350,7 @@
           <a:p>
             <a:pPr lvl="0"/>
             <a:r>
-              <a:rPr lang="en-US" smtClean="0"/>
+              <a:rPr lang="en-US"/>
               <a:t>Click to edit Master text styles</a:t>
             </a:r>
           </a:p>
@@ -3597,7 +3373,7 @@
           <a:p>
             <a:fld id="{5BCAD085-E8A6-8845-BD4E-CB4CCA059FC4}" type="datetimeFigureOut">
               <a:rPr lang="en-US" smtClean="0"/>
-              <a:t>1/27/13</a:t>
+              <a:t>8/3/26</a:t>
             </a:fld>
             <a:endParaRPr lang="en-US"/>
           </a:p>
@@ -3700,10 +3476,9 @@
           </a:lstStyle>
           <a:p>
             <a:r>
-              <a:rPr lang="en-US" smtClean="0"/>
+              <a:rPr lang="en-US"/>
               <a:t>Click to edit Master title style</a:t>
             </a:r>
-            <a:endParaRPr lang="en-US"/>
           </a:p>
         </p:txBody>
       </p:sp>
@@ -3827,7 +3602,7 @@
           <a:p>
             <a:pPr lvl="0"/>
             <a:r>
-              <a:rPr lang="en-US" smtClean="0"/>
+              <a:rPr lang="en-US"/>
               <a:t>Click to edit Master text styles</a:t>
             </a:r>
           </a:p>
@@ -3850,7 +3625,7 @@
           <a:p>
             <a:fld id="{5BCAD085-E8A6-8845-BD4E-CB4CCA059FC4}" type="datetimeFigureOut">
               <a:rPr lang="en-US" smtClean="0"/>
-              <a:t>1/27/13</a:t>
+              <a:t>8/3/26</a:t>
             </a:fld>
             <a:endParaRPr lang="en-US"/>
           </a:p>
@@ -3959,10 +3734,9 @@
           <a:lstStyle/>
           <a:p>
             <a:r>
-              <a:rPr lang="en-US" smtClean="0"/>
+              <a:rPr lang="en-US"/>
               <a:t>Click to edit Master title style</a:t>
             </a:r>
-            <a:endParaRPr lang="en-US"/>
           </a:p>
         </p:txBody>
       </p:sp>
@@ -3993,38 +3767,37 @@
           <a:p>
             <a:pPr lvl="0"/>
             <a:r>
-              <a:rPr lang="en-US" smtClean="0"/>
+              <a:rPr lang="en-US"/>
               <a:t>Click to edit Master text styles</a:t>
             </a:r>
           </a:p>
           <a:p>
             <a:pPr lvl="1"/>
             <a:r>
-              <a:rPr lang="en-US" smtClean="0"/>
+              <a:rPr lang="en-US"/>
               <a:t>Second level</a:t>
             </a:r>
           </a:p>
           <a:p>
             <a:pPr lvl="2"/>
             <a:r>
-              <a:rPr lang="en-US" smtClean="0"/>
+              <a:rPr lang="en-US"/>
               <a:t>Third level</a:t>
             </a:r>
           </a:p>
           <a:p>
             <a:pPr lvl="3"/>
             <a:r>
-              <a:rPr lang="en-US" smtClean="0"/>
+              <a:rPr lang="en-US"/>
               <a:t>Fourth level</a:t>
             </a:r>
           </a:p>
           <a:p>
             <a:pPr lvl="4"/>
             <a:r>
-              <a:rPr lang="en-US" smtClean="0"/>
+              <a:rPr lang="en-US"/>
               <a:t>Fifth level</a:t>
             </a:r>
-            <a:endParaRPr lang="en-US"/>
           </a:p>
         </p:txBody>
       </p:sp>
@@ -4063,7 +3836,7 @@
           <a:p>
             <a:fld id="{5BCAD085-E8A6-8845-BD4E-CB4CCA059FC4}" type="datetimeFigureOut">
               <a:rPr lang="en-US" smtClean="0"/>
-              <a:t>1/27/13</a:t>
+              <a:t>8/3/26</a:t>
             </a:fld>
             <a:endParaRPr lang="en-US"/>
           </a:p>
@@ -4422,7 +4195,7 @@
 </file>
 
 <file path=ppt/slides/slide1.xml><?xml version="1.0" encoding="utf-8"?>
-<p:sld xmlns:a="http://schemas.openxmlformats.org/drawingml/2006/main" xmlns:p="http://schemas.openxmlformats.org/presentationml/2006/main" xmlns:r="http://schemas.openxmlformats.org/officeDocument/2006/relationships">
+<p:sld xmlns:a="http://schemas.openxmlformats.org/drawingml/2006/main" xmlns:r="http://schemas.openxmlformats.org/officeDocument/2006/relationships" xmlns:p="http://schemas.openxmlformats.org/presentationml/2006/main">
   <p:cSld>
     <p:spTree>
       <p:nvGrpSpPr>
@@ -4430,7 +4203,14 @@
         <p:cNvGrpSpPr/>
         <p:nvPr/>
       </p:nvGrpSpPr>
-      <p:grpSpPr/>
+      <p:grpSpPr>
+        <a:xfrm>
+          <a:off x="0" y="0"/>
+          <a:ext cx="0" cy="0"/>
+          <a:chOff x="0" y="0"/>
+          <a:chExt cx="0" cy="0"/>
+        </a:xfrm>
+      </p:grpSpPr>
       <p:sp>
         <p:nvSpPr>
           <p:cNvPr id="2" name="Rectangle 1"/>
@@ -4471,6 +4251,7 @@
           <a:lstStyle/>
           <a:p>
             <a:pPr algn="ctr"/>
+            <a:endParaRPr/>
           </a:p>
         </p:txBody>
       </p:sp>
@@ -4514,6 +4295,7 @@
           <a:lstStyle/>
           <a:p>
             <a:pPr algn="ctr"/>
+            <a:endParaRPr/>
           </a:p>
         </p:txBody>
       </p:sp>
@@ -4526,7 +4308,7 @@
           <p:nvPr/>
         </p:nvPicPr>
         <p:blipFill>
-          <a:blip r:embed="rId2"/>
+          <a:blip r:embed="rId3"/>
           <a:stretch>
             <a:fillRect/>
           </a:stretch>
@@ -4601,7 +4383,7 @@
         <p:spPr>
           <a:xfrm>
             <a:off x="822960" y="4023360"/>
-            <a:ext cx="10058400" cy="1280160"/>
+            <a:ext cx="10058400" cy="774571"/>
           </a:xfrm>
           <a:prstGeom prst="rect">
             <a:avLst/>
@@ -4616,7 +4398,7 @@
           <a:p>
             <a:pPr algn="l"/>
             <a:r>
-              <a:rPr sz="1800" b="0">
+              <a:rPr sz="1800" b="0" dirty="0">
                 <a:solidFill>
                   <a:srgbClr val="1B1F17"/>
                 </a:solidFill>
@@ -4632,29 +4414,49 @@
               </a:spcBef>
             </a:pPr>
             <a:r>
-              <a:rPr sz="1800" b="0">
+              <a:rPr sz="1800" b="0" dirty="0">
                 <a:solidFill>
                   <a:srgbClr val="1B1F17"/>
                 </a:solidFill>
                 <a:latin typeface="Arial"/>
               </a:rPr>
-              <a:t>The bet: make that story clear in 30 seconds — for Finance, HR, and BambooHR.</a:t>
-            </a:r>
-          </a:p>
-          <a:p>
-            <a:pPr algn="l">
-              <a:spcBef>
-                <a:spcPts val="1200"/>
-              </a:spcBef>
-            </a:pPr>
-            <a:r>
-              <a:rPr sz="1400" b="0">
-                <a:solidFill>
-                  <a:srgbClr val="6A7264"/>
-                </a:solidFill>
-                <a:latin typeface="Arial"/>
-              </a:rPr>
-              <a:t>AI-augmented discovery  ·  Interactive prototype  ·  Partner review with Head of Finance</a:t>
+              <a:t>The bet: make that story clear in 30 seconds</a:t>
+            </a:r>
+            <a:r>
+              <a:rPr lang="en-US" sz="1800" b="0" dirty="0">
+                <a:solidFill>
+                  <a:srgbClr val="1B1F17"/>
+                </a:solidFill>
+                <a:latin typeface="Arial"/>
+              </a:rPr>
+              <a:t>, </a:t>
+            </a:r>
+            <a:r>
+              <a:rPr sz="1800" b="0" dirty="0">
+                <a:solidFill>
+                  <a:srgbClr val="1B1F17"/>
+                </a:solidFill>
+                <a:latin typeface="Arial"/>
+              </a:rPr>
+              <a:t>for Finance,</a:t>
+            </a:r>
+            <a:r>
+              <a:rPr lang="en-US" dirty="0">
+                <a:solidFill>
+                  <a:srgbClr val="1B1F17"/>
+                </a:solidFill>
+                <a:latin typeface="Arial"/>
+              </a:rPr>
+              <a:t> and HR</a:t>
+            </a:r>
+            <a:r>
+              <a:rPr sz="1800" b="0" dirty="0">
+                <a:solidFill>
+                  <a:srgbClr val="1B1F17"/>
+                </a:solidFill>
+                <a:latin typeface="Arial"/>
+              </a:rPr>
+              <a:t>.</a:t>
             </a:r>
           </a:p>
         </p:txBody>
@@ -4668,7 +4470,7 @@
 </file>
 
 <file path=ppt/slides/slide10.xml><?xml version="1.0" encoding="utf-8"?>
-<p:sld xmlns:a="http://schemas.openxmlformats.org/drawingml/2006/main" xmlns:p="http://schemas.openxmlformats.org/presentationml/2006/main" xmlns:r="http://schemas.openxmlformats.org/officeDocument/2006/relationships">
+<p:sld xmlns:a="http://schemas.openxmlformats.org/drawingml/2006/main" xmlns:r="http://schemas.openxmlformats.org/officeDocument/2006/relationships" xmlns:p="http://schemas.openxmlformats.org/presentationml/2006/main">
   <p:cSld>
     <p:spTree>
       <p:nvGrpSpPr>
@@ -4676,7 +4478,14 @@
         <p:cNvGrpSpPr/>
         <p:nvPr/>
       </p:nvGrpSpPr>
-      <p:grpSpPr/>
+      <p:grpSpPr>
+        <a:xfrm>
+          <a:off x="0" y="0"/>
+          <a:ext cx="0" cy="0"/>
+          <a:chOff x="0" y="0"/>
+          <a:chExt cx="0" cy="0"/>
+        </a:xfrm>
+      </p:grpSpPr>
       <p:sp>
         <p:nvSpPr>
           <p:cNvPr id="2" name="Rectangle 1"/>
@@ -4717,6 +4526,7 @@
           <a:lstStyle/>
           <a:p>
             <a:pPr algn="ctr"/>
+            <a:endParaRPr/>
           </a:p>
         </p:txBody>
       </p:sp>
@@ -4729,7 +4539,7 @@
           <p:nvPr/>
         </p:nvPicPr>
         <p:blipFill>
-          <a:blip r:embed="rId2"/>
+          <a:blip r:embed="rId3"/>
           <a:stretch>
             <a:fillRect/>
           </a:stretch>
@@ -4803,14 +4613,29 @@
           <a:p>
             <a:pPr algn="l"/>
             <a:r>
-              <a:rPr sz="2600" b="1">
+              <a:rPr sz="2600" b="1" dirty="0">
                 <a:solidFill>
                   <a:srgbClr val="1B1F17"/>
                 </a:solidFill>
                 <a:latin typeface="Arial"/>
               </a:rPr>
-              <a:t>What we have — and what we would learn next</a:t>
-            </a:r>
+              <a:t>What we have</a:t>
+            </a:r>
+            <a:r>
+              <a:rPr lang="en-US" sz="2600" b="1" dirty="0">
+                <a:solidFill>
+                  <a:srgbClr val="1B1F17"/>
+                </a:solidFill>
+                <a:latin typeface="Arial"/>
+              </a:rPr>
+              <a:t>, where I would continue</a:t>
+            </a:r>
+            <a:endParaRPr sz="2600" b="1" dirty="0">
+              <a:solidFill>
+                <a:srgbClr val="1B1F17"/>
+              </a:solidFill>
+              <a:latin typeface="Arial"/>
+            </a:endParaRPr>
           </a:p>
         </p:txBody>
       </p:sp>
@@ -4858,6 +4683,7 @@
           <a:lstStyle/>
           <a:p>
             <a:pPr algn="ctr"/>
+            <a:endParaRPr/>
           </a:p>
         </p:txBody>
       </p:sp>
@@ -5005,6 +4831,7 @@
           <a:lstStyle/>
           <a:p>
             <a:pPr algn="ctr"/>
+            <a:endParaRPr/>
           </a:p>
         </p:txBody>
       </p:sp>
@@ -5221,7 +5048,7 @@
 </file>
 
 <file path=ppt/slides/slide11.xml><?xml version="1.0" encoding="utf-8"?>
-<p:sld xmlns:a="http://schemas.openxmlformats.org/drawingml/2006/main" xmlns:p="http://schemas.openxmlformats.org/presentationml/2006/main" xmlns:r="http://schemas.openxmlformats.org/officeDocument/2006/relationships">
+<p:sld xmlns:a="http://schemas.openxmlformats.org/drawingml/2006/main" xmlns:r="http://schemas.openxmlformats.org/officeDocument/2006/relationships" xmlns:p="http://schemas.openxmlformats.org/presentationml/2006/main">
   <p:cSld>
     <p:spTree>
       <p:nvGrpSpPr>
@@ -5229,7 +5056,14 @@
         <p:cNvGrpSpPr/>
         <p:nvPr/>
       </p:nvGrpSpPr>
-      <p:grpSpPr/>
+      <p:grpSpPr>
+        <a:xfrm>
+          <a:off x="0" y="0"/>
+          <a:ext cx="0" cy="0"/>
+          <a:chOff x="0" y="0"/>
+          <a:chExt cx="0" cy="0"/>
+        </a:xfrm>
+      </p:grpSpPr>
       <p:sp>
         <p:nvSpPr>
           <p:cNvPr id="2" name="Rectangle 1"/>
@@ -5270,186 +5104,13 @@
           <a:lstStyle/>
           <a:p>
             <a:pPr algn="ctr"/>
+            <a:endParaRPr/>
           </a:p>
         </p:txBody>
       </p:sp>
       <p:pic>
         <p:nvPicPr>
           <p:cNvPr id="3" name="Picture 2" descr="bamboohr-logo.png"/>
-          <p:cNvPicPr>
-            <a:picLocks noChangeAspect="1"/>
-          </p:cNvPicPr>
-          <p:nvPr/>
-        </p:nvPicPr>
-        <p:blipFill>
-          <a:blip r:embed="rId2"/>
-          <a:stretch>
-            <a:fillRect/>
-          </a:stretch>
-        </p:blipFill>
-        <p:spPr>
-          <a:xfrm>
-            <a:off x="685800" y="256032"/>
-            <a:ext cx="1417320" cy="304174"/>
-          </a:xfrm>
-          <a:prstGeom prst="rect">
-            <a:avLst/>
-          </a:prstGeom>
-        </p:spPr>
-      </p:pic>
-      <p:sp>
-        <p:nvSpPr>
-          <p:cNvPr id="4" name="TextBox 3"/>
-          <p:cNvSpPr txBox="1"/>
-          <p:nvPr/>
-        </p:nvSpPr>
-        <p:spPr>
-          <a:xfrm>
-            <a:off x="2331720" y="228600"/>
-            <a:ext cx="9144000" cy="228600"/>
-          </a:xfrm>
-          <a:prstGeom prst="rect">
-            <a:avLst/>
-          </a:prstGeom>
-          <a:noFill/>
-        </p:spPr>
-        <p:txBody>
-          <a:bodyPr wrap="square">
-            <a:spAutoFit/>
-          </a:bodyPr>
-          <a:lstStyle/>
-          <a:p>
-            <a:pPr algn="l"/>
-            <a:r>
-              <a:rPr sz="1100" b="1">
-                <a:solidFill>
-                  <a:srgbClr val="4F8F12"/>
-                </a:solidFill>
-                <a:latin typeface="Arial"/>
-              </a:rPr>
-              <a:t>ITERATIONS</a:t>
-            </a:r>
-          </a:p>
-        </p:txBody>
-      </p:sp>
-      <p:sp>
-        <p:nvSpPr>
-          <p:cNvPr id="5" name="TextBox 4"/>
-          <p:cNvSpPr txBox="1"/>
-          <p:nvPr/>
-        </p:nvSpPr>
-        <p:spPr>
-          <a:xfrm>
-            <a:off x="2331720" y="457200"/>
-            <a:ext cx="9326880" cy="502920"/>
-          </a:xfrm>
-          <a:prstGeom prst="rect">
-            <a:avLst/>
-          </a:prstGeom>
-          <a:noFill/>
-        </p:spPr>
-        <p:txBody>
-          <a:bodyPr wrap="square">
-            <a:spAutoFit/>
-          </a:bodyPr>
-          <a:lstStyle/>
-          <a:p>
-            <a:pPr algn="l"/>
-            <a:r>
-              <a:rPr sz="2600" b="1">
-                <a:solidFill>
-                  <a:srgbClr val="1B1F17"/>
-                </a:solidFill>
-                <a:latin typeface="Arial"/>
-              </a:rPr>
-              <a:t>Ship → show Finance → simplify</a:t>
-            </a:r>
-          </a:p>
-        </p:txBody>
-      </p:sp>
-      <p:sp>
-        <p:nvSpPr>
-          <p:cNvPr id="6" name="Rounded Rectangle 5"/>
-          <p:cNvSpPr/>
-          <p:nvPr/>
-        </p:nvSpPr>
-        <p:spPr>
-          <a:xfrm>
-            <a:off x="548640" y="1371600"/>
-            <a:ext cx="5577840" cy="365760"/>
-          </a:xfrm>
-          <a:prstGeom prst="roundRect">
-            <a:avLst>
-              <a:gd name="adj" fmla="val 6000"/>
-            </a:avLst>
-          </a:prstGeom>
-          <a:solidFill>
-            <a:srgbClr val="F3F8EA"/>
-          </a:solidFill>
-          <a:ln>
-            <a:noFill/>
-          </a:ln>
-        </p:spPr>
-        <p:style>
-          <a:lnRef idx="1">
-            <a:schemeClr val="accent1"/>
-          </a:lnRef>
-          <a:fillRef idx="3">
-            <a:schemeClr val="accent1"/>
-          </a:fillRef>
-          <a:effectRef idx="2">
-            <a:schemeClr val="accent1"/>
-          </a:effectRef>
-          <a:fontRef idx="minor">
-            <a:schemeClr val="lt1"/>
-          </a:fontRef>
-        </p:style>
-        <p:txBody>
-          <a:bodyPr rtlCol="0" anchor="ctr"/>
-          <a:lstStyle/>
-          <a:p>
-            <a:pPr algn="ctr"/>
-          </a:p>
-        </p:txBody>
-      </p:sp>
-      <p:sp>
-        <p:nvSpPr>
-          <p:cNvPr id="7" name="TextBox 6"/>
-          <p:cNvSpPr txBox="1"/>
-          <p:nvPr/>
-        </p:nvSpPr>
-        <p:spPr>
-          <a:xfrm>
-            <a:off x="731520" y="1417320"/>
-            <a:ext cx="5212080" cy="274320"/>
-          </a:xfrm>
-          <a:prstGeom prst="rect">
-            <a:avLst/>
-          </a:prstGeom>
-          <a:noFill/>
-        </p:spPr>
-        <p:txBody>
-          <a:bodyPr wrap="square">
-            <a:spAutoFit/>
-          </a:bodyPr>
-          <a:lstStyle/>
-          <a:p>
-            <a:pPr algn="l"/>
-            <a:r>
-              <a:rPr sz="1200" b="1">
-                <a:solidFill>
-                  <a:srgbClr val="1B1F17"/>
-                </a:solidFill>
-                <a:latin typeface="Arial"/>
-              </a:rPr>
-              <a:t>Story first  ·  Approved plan · filled · named gap</a:t>
-            </a:r>
-          </a:p>
-        </p:txBody>
-      </p:sp>
-      <p:pic>
-        <p:nvPicPr>
-          <p:cNvPr id="8" name="Picture 7" descr="01-home-outlook-tile.png"/>
           <p:cNvPicPr>
             <a:picLocks noChangeAspect="1"/>
           </p:cNvPicPr>
@@ -5463,8 +5124,8 @@
         </p:blipFill>
         <p:spPr>
           <a:xfrm>
-            <a:off x="594360" y="1783080"/>
-            <a:ext cx="4535126" cy="1874519"/>
+            <a:off x="685800" y="256032"/>
+            <a:ext cx="1417320" cy="304174"/>
           </a:xfrm>
           <a:prstGeom prst="rect">
             <a:avLst/>
@@ -5473,13 +5134,89 @@
       </p:pic>
       <p:sp>
         <p:nvSpPr>
-          <p:cNvPr id="9" name="Rounded Rectangle 8"/>
+          <p:cNvPr id="4" name="TextBox 3"/>
+          <p:cNvSpPr txBox="1"/>
+          <p:nvPr/>
+        </p:nvSpPr>
+        <p:spPr>
+          <a:xfrm>
+            <a:off x="2331720" y="228600"/>
+            <a:ext cx="9144000" cy="228600"/>
+          </a:xfrm>
+          <a:prstGeom prst="rect">
+            <a:avLst/>
+          </a:prstGeom>
+          <a:noFill/>
+        </p:spPr>
+        <p:txBody>
+          <a:bodyPr wrap="square">
+            <a:spAutoFit/>
+          </a:bodyPr>
+          <a:lstStyle/>
+          <a:p>
+            <a:pPr algn="l"/>
+            <a:r>
+              <a:rPr sz="1100" b="1">
+                <a:solidFill>
+                  <a:srgbClr val="4F8F12"/>
+                </a:solidFill>
+                <a:latin typeface="Arial"/>
+              </a:rPr>
+              <a:t>ITERATIONS</a:t>
+            </a:r>
+          </a:p>
+        </p:txBody>
+      </p:sp>
+      <p:sp>
+        <p:nvSpPr>
+          <p:cNvPr id="5" name="TextBox 4"/>
+          <p:cNvSpPr txBox="1"/>
+          <p:nvPr/>
+        </p:nvSpPr>
+        <p:spPr>
+          <a:xfrm>
+            <a:off x="2331720" y="457200"/>
+            <a:ext cx="9326880" cy="502920"/>
+          </a:xfrm>
+          <a:prstGeom prst="rect">
+            <a:avLst/>
+          </a:prstGeom>
+          <a:noFill/>
+        </p:spPr>
+        <p:txBody>
+          <a:bodyPr wrap="square">
+            <a:spAutoFit/>
+          </a:bodyPr>
+          <a:lstStyle/>
+          <a:p>
+            <a:pPr algn="l"/>
+            <a:r>
+              <a:rPr lang="en-US" sz="2600" b="1" dirty="0">
+                <a:solidFill>
+                  <a:srgbClr val="1B1F17"/>
+                </a:solidFill>
+                <a:latin typeface="Arial"/>
+              </a:rPr>
+              <a:t>Build, Iterate, Launch</a:t>
+            </a:r>
+            <a:endParaRPr sz="2600" b="1" dirty="0">
+              <a:solidFill>
+                <a:srgbClr val="1B1F17"/>
+              </a:solidFill>
+              <a:latin typeface="Arial"/>
+            </a:endParaRPr>
+          </a:p>
+        </p:txBody>
+      </p:sp>
+      <p:sp>
+        <p:nvSpPr>
+          <p:cNvPr id="6" name="Rounded Rectangle 5"/>
           <p:cNvSpPr/>
           <p:nvPr/>
         </p:nvSpPr>
         <p:spPr>
           <a:xfrm>
-            <a:off x="6355079" y="1371600"/>
+            <a:off x="548640" y="1371600"/>
             <a:ext cx="5577840" cy="365760"/>
           </a:xfrm>
           <a:prstGeom prst="roundRect">
@@ -5513,18 +5250,19 @@
           <a:lstStyle/>
           <a:p>
             <a:pPr algn="ctr"/>
-          </a:p>
-        </p:txBody>
-      </p:sp>
-      <p:sp>
-        <p:nvSpPr>
-          <p:cNvPr id="10" name="TextBox 9"/>
-          <p:cNvSpPr txBox="1"/>
-          <p:nvPr/>
-        </p:nvSpPr>
-        <p:spPr>
-          <a:xfrm>
-            <a:off x="6537959" y="1417320"/>
+            <a:endParaRPr/>
+          </a:p>
+        </p:txBody>
+      </p:sp>
+      <p:sp>
+        <p:nvSpPr>
+          <p:cNvPr id="7" name="TextBox 6"/>
+          <p:cNvSpPr txBox="1"/>
+          <p:nvPr/>
+        </p:nvSpPr>
+        <p:spPr>
+          <a:xfrm>
+            <a:off x="731520" y="1417320"/>
             <a:ext cx="5212080" cy="274320"/>
           </a:xfrm>
           <a:prstGeom prst="rect">
@@ -5546,14 +5284,14 @@
                 </a:solidFill>
                 <a:latin typeface="Arial"/>
               </a:rPr>
-              <a:t>Bridge  ·  Backfill · not backfilling · pivot</a:t>
+              <a:t>Story first  ·  Approved plan · filled · named gap</a:t>
             </a:r>
           </a:p>
         </p:txBody>
       </p:sp>
       <p:pic>
         <p:nvPicPr>
-          <p:cNvPr id="11" name="Picture 10" descr="02-bridge-tile.png"/>
+          <p:cNvPr id="8" name="Picture 7" descr="01-home-outlook-tile.png"/>
           <p:cNvPicPr>
             <a:picLocks noChangeAspect="1"/>
           </p:cNvPicPr>
@@ -5567,7 +5305,7 @@
         </p:blipFill>
         <p:spPr>
           <a:xfrm>
-            <a:off x="6400799" y="1783080"/>
+            <a:off x="594360" y="1783080"/>
             <a:ext cx="4535126" cy="1874519"/>
           </a:xfrm>
           <a:prstGeom prst="rect">
@@ -5577,13 +5315,13 @@
       </p:pic>
       <p:sp>
         <p:nvSpPr>
-          <p:cNvPr id="12" name="Rounded Rectangle 11"/>
+          <p:cNvPr id="9" name="Rounded Rectangle 8"/>
           <p:cNvSpPr/>
           <p:nvPr/>
         </p:nvSpPr>
         <p:spPr>
           <a:xfrm>
-            <a:off x="548640" y="3840480"/>
+            <a:off x="6355079" y="1371600"/>
             <a:ext cx="5577840" cy="365760"/>
           </a:xfrm>
           <a:prstGeom prst="roundRect">
@@ -5617,18 +5355,19 @@
           <a:lstStyle/>
           <a:p>
             <a:pPr algn="ctr"/>
-          </a:p>
-        </p:txBody>
-      </p:sp>
-      <p:sp>
-        <p:nvSpPr>
-          <p:cNvPr id="13" name="TextBox 12"/>
-          <p:cNvSpPr txBox="1"/>
-          <p:nvPr/>
-        </p:nvSpPr>
-        <p:spPr>
-          <a:xfrm>
-            <a:off x="731520" y="3886200"/>
+            <a:endParaRPr/>
+          </a:p>
+        </p:txBody>
+      </p:sp>
+      <p:sp>
+        <p:nvSpPr>
+          <p:cNvPr id="10" name="TextBox 9"/>
+          <p:cNvSpPr txBox="1"/>
+          <p:nvPr/>
+        </p:nvSpPr>
+        <p:spPr>
+          <a:xfrm>
+            <a:off x="6537959" y="1417320"/>
             <a:ext cx="5212080" cy="274320"/>
           </a:xfrm>
           <a:prstGeom prst="rect">
@@ -5650,14 +5389,14 @@
                 </a:solidFill>
                 <a:latin typeface="Arial"/>
               </a:rPr>
-              <a:t>Manual update  ·  Mid-cycle edits systems miss</a:t>
+              <a:t>Bridge  ·  Backfill · not backfilling · pivot</a:t>
             </a:r>
           </a:p>
         </p:txBody>
       </p:sp>
       <p:pic>
         <p:nvPicPr>
-          <p:cNvPr id="14" name="Picture 13" descr="03-approvals-tile.png"/>
+          <p:cNvPr id="11" name="Picture 10" descr="02-bridge-tile.png"/>
           <p:cNvPicPr>
             <a:picLocks noChangeAspect="1"/>
           </p:cNvPicPr>
@@ -5671,7 +5410,7 @@
         </p:blipFill>
         <p:spPr>
           <a:xfrm>
-            <a:off x="594360" y="4251960"/>
+            <a:off x="6400799" y="1783080"/>
             <a:ext cx="4535126" cy="1874519"/>
           </a:xfrm>
           <a:prstGeom prst="rect">
@@ -5681,13 +5420,13 @@
       </p:pic>
       <p:sp>
         <p:nvSpPr>
-          <p:cNvPr id="15" name="Rounded Rectangle 14"/>
+          <p:cNvPr id="12" name="Rounded Rectangle 11"/>
           <p:cNvSpPr/>
           <p:nvPr/>
         </p:nvSpPr>
         <p:spPr>
           <a:xfrm>
-            <a:off x="6355079" y="3840480"/>
+            <a:off x="548640" y="3840480"/>
             <a:ext cx="5577840" cy="365760"/>
           </a:xfrm>
           <a:prstGeom prst="roundRect">
@@ -5721,6 +5460,112 @@
           <a:lstStyle/>
           <a:p>
             <a:pPr algn="ctr"/>
+            <a:endParaRPr/>
+          </a:p>
+        </p:txBody>
+      </p:sp>
+      <p:sp>
+        <p:nvSpPr>
+          <p:cNvPr id="13" name="TextBox 12"/>
+          <p:cNvSpPr txBox="1"/>
+          <p:nvPr/>
+        </p:nvSpPr>
+        <p:spPr>
+          <a:xfrm>
+            <a:off x="731520" y="3886200"/>
+            <a:ext cx="5212080" cy="274320"/>
+          </a:xfrm>
+          <a:prstGeom prst="rect">
+            <a:avLst/>
+          </a:prstGeom>
+          <a:noFill/>
+        </p:spPr>
+        <p:txBody>
+          <a:bodyPr wrap="square">
+            <a:spAutoFit/>
+          </a:bodyPr>
+          <a:lstStyle/>
+          <a:p>
+            <a:pPr algn="l"/>
+            <a:r>
+              <a:rPr sz="1200" b="1">
+                <a:solidFill>
+                  <a:srgbClr val="1B1F17"/>
+                </a:solidFill>
+                <a:latin typeface="Arial"/>
+              </a:rPr>
+              <a:t>Manual update  ·  Mid-cycle edits systems miss</a:t>
+            </a:r>
+          </a:p>
+        </p:txBody>
+      </p:sp>
+      <p:pic>
+        <p:nvPicPr>
+          <p:cNvPr id="14" name="Picture 13" descr="03-approvals-tile.png"/>
+          <p:cNvPicPr>
+            <a:picLocks noChangeAspect="1"/>
+          </p:cNvPicPr>
+          <p:nvPr/>
+        </p:nvPicPr>
+        <p:blipFill>
+          <a:blip r:embed="rId6"/>
+          <a:stretch>
+            <a:fillRect/>
+          </a:stretch>
+        </p:blipFill>
+        <p:spPr>
+          <a:xfrm>
+            <a:off x="594360" y="4251960"/>
+            <a:ext cx="4535126" cy="1874519"/>
+          </a:xfrm>
+          <a:prstGeom prst="rect">
+            <a:avLst/>
+          </a:prstGeom>
+        </p:spPr>
+      </p:pic>
+      <p:sp>
+        <p:nvSpPr>
+          <p:cNvPr id="15" name="Rounded Rectangle 14"/>
+          <p:cNvSpPr/>
+          <p:nvPr/>
+        </p:nvSpPr>
+        <p:spPr>
+          <a:xfrm>
+            <a:off x="6355079" y="3840480"/>
+            <a:ext cx="5577840" cy="365760"/>
+          </a:xfrm>
+          <a:prstGeom prst="roundRect">
+            <a:avLst>
+              <a:gd name="adj" fmla="val 6000"/>
+            </a:avLst>
+          </a:prstGeom>
+          <a:solidFill>
+            <a:srgbClr val="F3F8EA"/>
+          </a:solidFill>
+          <a:ln>
+            <a:noFill/>
+          </a:ln>
+        </p:spPr>
+        <p:style>
+          <a:lnRef idx="1">
+            <a:schemeClr val="accent1"/>
+          </a:lnRef>
+          <a:fillRef idx="3">
+            <a:schemeClr val="accent1"/>
+          </a:fillRef>
+          <a:effectRef idx="2">
+            <a:schemeClr val="accent1"/>
+          </a:effectRef>
+          <a:fontRef idx="minor">
+            <a:schemeClr val="lt1"/>
+          </a:fontRef>
+        </p:style>
+        <p:txBody>
+          <a:bodyPr rtlCol="0" anchor="ctr"/>
+          <a:lstStyle/>
+          <a:p>
+            <a:pPr algn="ctr"/>
+            <a:endParaRPr/>
           </a:p>
         </p:txBody>
       </p:sp>
@@ -5768,7 +5613,7 @@
           <p:nvPr/>
         </p:nvPicPr>
         <p:blipFill>
-          <a:blip r:embed="rId6"/>
+          <a:blip r:embed="rId7"/>
           <a:stretch>
             <a:fillRect/>
           </a:stretch>
@@ -5862,7 +5707,7 @@
 </file>
 
 <file path=ppt/slides/slide12.xml><?xml version="1.0" encoding="utf-8"?>
-<p:sld xmlns:a="http://schemas.openxmlformats.org/drawingml/2006/main" xmlns:p="http://schemas.openxmlformats.org/presentationml/2006/main" xmlns:r="http://schemas.openxmlformats.org/officeDocument/2006/relationships">
+<p:sld xmlns:a="http://schemas.openxmlformats.org/drawingml/2006/main" xmlns:r="http://schemas.openxmlformats.org/officeDocument/2006/relationships" xmlns:p="http://schemas.openxmlformats.org/presentationml/2006/main">
   <p:cSld>
     <p:spTree>
       <p:nvGrpSpPr>
@@ -5870,7 +5715,14 @@
         <p:cNvGrpSpPr/>
         <p:nvPr/>
       </p:nvGrpSpPr>
-      <p:grpSpPr/>
+      <p:grpSpPr>
+        <a:xfrm>
+          <a:off x="0" y="0"/>
+          <a:ext cx="0" cy="0"/>
+          <a:chOff x="0" y="0"/>
+          <a:chExt cx="0" cy="0"/>
+        </a:xfrm>
+      </p:grpSpPr>
       <p:sp>
         <p:nvSpPr>
           <p:cNvPr id="2" name="Rectangle 1"/>
@@ -5911,6 +5763,7 @@
           <a:lstStyle/>
           <a:p>
             <a:pPr algn="ctr"/>
+            <a:endParaRPr/>
           </a:p>
         </p:txBody>
       </p:sp>
@@ -5923,7 +5776,7 @@
           <p:nvPr/>
         </p:nvPicPr>
         <p:blipFill>
-          <a:blip r:embed="rId2"/>
+          <a:blip r:embed="rId3"/>
           <a:stretch>
             <a:fillRect/>
           </a:stretch>
@@ -5997,14 +5850,29 @@
           <a:p>
             <a:pPr algn="l"/>
             <a:r>
-              <a:rPr sz="2600" b="1">
+              <a:rPr sz="2600" b="1" dirty="0">
                 <a:solidFill>
                   <a:srgbClr val="1B1F17"/>
                 </a:solidFill>
                 <a:latin typeface="Arial"/>
               </a:rPr>
-              <a:t>Measure understanding — tie every metric to the problem</a:t>
-            </a:r>
+              <a:t>Measure understanding</a:t>
+            </a:r>
+            <a:r>
+              <a:rPr lang="en-US" sz="2600" b="1" dirty="0">
+                <a:solidFill>
+                  <a:srgbClr val="1B1F17"/>
+                </a:solidFill>
+                <a:latin typeface="Arial"/>
+              </a:rPr>
+              <a:t>. Did this work? </a:t>
+            </a:r>
+            <a:endParaRPr sz="2600" b="1" dirty="0">
+              <a:solidFill>
+                <a:srgbClr val="1B1F17"/>
+              </a:solidFill>
+              <a:latin typeface="Arial"/>
+            </a:endParaRPr>
           </a:p>
         </p:txBody>
       </p:sp>
@@ -6052,6 +5920,7 @@
           <a:lstStyle/>
           <a:p>
             <a:pPr algn="ctr"/>
+            <a:endParaRPr/>
           </a:p>
         </p:txBody>
       </p:sp>
@@ -6095,6 +5964,7 @@
           <a:lstStyle/>
           <a:p>
             <a:pPr algn="ctr"/>
+            <a:endParaRPr/>
           </a:p>
         </p:txBody>
       </p:sp>
@@ -6247,6 +6117,7 @@
           <a:lstStyle/>
           <a:p>
             <a:pPr algn="ctr"/>
+            <a:endParaRPr/>
           </a:p>
         </p:txBody>
       </p:sp>
@@ -6290,6 +6161,7 @@
           <a:lstStyle/>
           <a:p>
             <a:pPr algn="ctr"/>
+            <a:endParaRPr/>
           </a:p>
         </p:txBody>
       </p:sp>
@@ -6393,7 +6265,7 @@
                 </a:solidFill>
                 <a:latin typeface="Arial"/>
               </a:rPr>
-              <a:t>Finance speed</a:t>
+              <a:t>Speed + resilience</a:t>
             </a:r>
           </a:p>
         </p:txBody>
@@ -6442,6 +6314,7 @@
           <a:lstStyle/>
           <a:p>
             <a:pPr algn="ctr"/>
+            <a:endParaRPr/>
           </a:p>
         </p:txBody>
       </p:sp>
@@ -6485,6 +6358,7 @@
           <a:lstStyle/>
           <a:p>
             <a:pPr algn="ctr"/>
+            <a:endParaRPr/>
           </a:p>
         </p:txBody>
       </p:sp>
@@ -6637,6 +6511,7 @@
           <a:lstStyle/>
           <a:p>
             <a:pPr algn="ctr"/>
+            <a:endParaRPr/>
           </a:p>
         </p:txBody>
       </p:sp>
@@ -6680,6 +6555,7 @@
           <a:lstStyle/>
           <a:p>
             <a:pPr algn="ctr"/>
+            <a:endParaRPr/>
           </a:p>
         </p:txBody>
       </p:sp>
@@ -6832,6 +6708,7 @@
           <a:lstStyle/>
           <a:p>
             <a:pPr algn="ctr"/>
+            <a:endParaRPr/>
           </a:p>
         </p:txBody>
       </p:sp>
@@ -6875,6 +6752,7 @@
           <a:lstStyle/>
           <a:p>
             <a:pPr algn="ctr"/>
+            <a:endParaRPr/>
           </a:p>
         </p:txBody>
       </p:sp>
@@ -7027,6 +6905,7 @@
           <a:lstStyle/>
           <a:p>
             <a:pPr algn="ctr"/>
+            <a:endParaRPr/>
           </a:p>
         </p:txBody>
       </p:sp>
@@ -7070,6 +6949,7 @@
           <a:lstStyle/>
           <a:p>
             <a:pPr algn="ctr"/>
+            <a:endParaRPr/>
           </a:p>
         </p:txBody>
       </p:sp>
@@ -7257,7 +7137,7 @@
 </file>
 
 <file path=ppt/slides/slide13.xml><?xml version="1.0" encoding="utf-8"?>
-<p:sld xmlns:a="http://schemas.openxmlformats.org/drawingml/2006/main" xmlns:p="http://schemas.openxmlformats.org/presentationml/2006/main" xmlns:r="http://schemas.openxmlformats.org/officeDocument/2006/relationships">
+<p:sld xmlns:a="http://schemas.openxmlformats.org/drawingml/2006/main" xmlns:r="http://schemas.openxmlformats.org/officeDocument/2006/relationships" xmlns:p="http://schemas.openxmlformats.org/presentationml/2006/main">
   <p:cSld>
     <p:spTree>
       <p:nvGrpSpPr>
@@ -7265,7 +7145,14 @@
         <p:cNvGrpSpPr/>
         <p:nvPr/>
       </p:nvGrpSpPr>
-      <p:grpSpPr/>
+      <p:grpSpPr>
+        <a:xfrm>
+          <a:off x="0" y="0"/>
+          <a:ext cx="0" cy="0"/>
+          <a:chOff x="0" y="0"/>
+          <a:chExt cx="0" cy="0"/>
+        </a:xfrm>
+      </p:grpSpPr>
       <p:sp>
         <p:nvSpPr>
           <p:cNvPr id="2" name="Rectangle 1"/>
@@ -7306,6 +7193,7 @@
           <a:lstStyle/>
           <a:p>
             <a:pPr algn="ctr"/>
+            <a:endParaRPr/>
           </a:p>
         </p:txBody>
       </p:sp>
@@ -7318,7 +7206,7 @@
           <p:nvPr/>
         </p:nvPicPr>
         <p:blipFill>
-          <a:blip r:embed="rId2"/>
+          <a:blip r:embed="rId3"/>
           <a:stretch>
             <a:fillRect/>
           </a:stretch>
@@ -7377,7 +7265,7 @@
         <p:spPr>
           <a:xfrm>
             <a:off x="2331720" y="457200"/>
-            <a:ext cx="9326880" cy="502920"/>
+            <a:ext cx="9326880" cy="492443"/>
           </a:xfrm>
           <a:prstGeom prst="rect">
             <a:avLst/>
@@ -7392,13 +7280,13 @@
           <a:p>
             <a:pPr algn="l"/>
             <a:r>
-              <a:rPr sz="2600" b="1">
+              <a:rPr lang="en-US" sz="2600" b="1" dirty="0">
                 <a:solidFill>
                   <a:srgbClr val="1B1F17"/>
                 </a:solidFill>
                 <a:latin typeface="Arial"/>
               </a:rPr>
-              <a:t>Modeled for a ~300-person company — labeled assumptions</a:t>
+              <a:t>Potential Impact</a:t>
             </a:r>
           </a:p>
         </p:txBody>
@@ -7412,7 +7300,7 @@
         <p:spPr>
           <a:xfrm>
             <a:off x="685800" y="1371600"/>
-            <a:ext cx="10972800" cy="365760"/>
+            <a:ext cx="10972800" cy="292388"/>
           </a:xfrm>
           <a:prstGeom prst="rect">
             <a:avLst/>
@@ -7427,14 +7315,20 @@
           <a:p>
             <a:pPr algn="l"/>
             <a:r>
-              <a:rPr sz="1300" b="1">
+              <a:rPr lang="en-US" sz="1300" b="1" dirty="0">
                 <a:solidFill>
                   <a:srgbClr val="6A7264"/>
                 </a:solidFill>
                 <a:latin typeface="Arial"/>
               </a:rPr>
-              <a:t>Not a customer ROI claim — a planning model for interview discussion. Validate hours in the next interviews.</a:t>
-            </a:r>
+              <a:t>Modeled for a ~ 300 Employee company</a:t>
+            </a:r>
+            <a:endParaRPr sz="1300" b="1" dirty="0">
+              <a:solidFill>
+                <a:srgbClr val="6A7264"/>
+              </a:solidFill>
+              <a:latin typeface="Arial"/>
+            </a:endParaRPr>
           </a:p>
         </p:txBody>
       </p:sp>
@@ -7482,6 +7376,7 @@
           <a:lstStyle/>
           <a:p>
             <a:pPr algn="ctr"/>
+            <a:endParaRPr/>
           </a:p>
         </p:txBody>
       </p:sp>
@@ -7494,7 +7389,7 @@
         <p:spPr>
           <a:xfrm>
             <a:off x="960120" y="2286000"/>
-            <a:ext cx="2971800" cy="731520"/>
+            <a:ext cx="2971800" cy="830997"/>
           </a:xfrm>
           <a:prstGeom prst="rect">
             <a:avLst/>
@@ -7509,14 +7404,20 @@
           <a:p>
             <a:pPr algn="l"/>
             <a:r>
-              <a:rPr sz="3600" b="1">
+              <a:rPr lang="en-US" sz="2400" b="1" dirty="0">
                 <a:solidFill>
                   <a:srgbClr val="4F8F12"/>
                 </a:solidFill>
                 <a:latin typeface="Arial"/>
               </a:rPr>
-              <a:t>8–12 hrs</a:t>
-            </a:r>
+              <a:t>Redundancy in place </a:t>
+            </a:r>
+            <a:endParaRPr sz="2400" b="1" dirty="0">
+              <a:solidFill>
+                <a:srgbClr val="4F8F12"/>
+              </a:solidFill>
+              <a:latin typeface="Arial"/>
+            </a:endParaRPr>
           </a:p>
         </p:txBody>
       </p:sp>
@@ -7529,7 +7430,7 @@
         <p:spPr>
           <a:xfrm>
             <a:off x="960120" y="3200400"/>
-            <a:ext cx="2971800" cy="1188720"/>
+            <a:ext cx="2971800" cy="784830"/>
           </a:xfrm>
           <a:prstGeom prst="rect">
             <a:avLst/>
@@ -7544,14 +7445,22 @@
           <a:p>
             <a:pPr algn="l"/>
             <a:r>
-              <a:rPr sz="1500" b="0">
+              <a:rPr lang="en-US" sz="1500" b="0" dirty="0">
                 <a:solidFill>
                   <a:srgbClr val="1B1F17"/>
                 </a:solidFill>
                 <a:latin typeface="Arial"/>
               </a:rPr>
-              <a:t>FP&amp;A time / month on recon
-before (assumption)</a:t>
+              <a:t>More than one person can explain the gap — so recon isn’t a single point of failure</a:t>
+            </a:r>
+            <a:r>
+              <a:rPr sz="1500" b="0" dirty="0">
+                <a:solidFill>
+                  <a:srgbClr val="1B1F17"/>
+                </a:solidFill>
+                <a:latin typeface="Arial"/>
+              </a:rPr>
+              <a:t/>
             </a:r>
           </a:p>
         </p:txBody>
@@ -7586,7 +7495,7 @@
                 </a:solidFill>
                 <a:latin typeface="Arial"/>
               </a:rPr>
-              <a:t>Matches multi-tab close ritual</a:t>
+              <a:t>Answers the “hit by a bus” risk from Finance</a:t>
             </a:r>
           </a:p>
         </p:txBody>
@@ -7635,6 +7544,7 @@
           <a:lstStyle/>
           <a:p>
             <a:pPr algn="ctr"/>
+            <a:endParaRPr/>
           </a:p>
         </p:txBody>
       </p:sp>
@@ -7647,7 +7557,7 @@
         <p:spPr>
           <a:xfrm>
             <a:off x="4709160" y="2286000"/>
-            <a:ext cx="2971800" cy="731520"/>
+            <a:ext cx="2971800" cy="461665"/>
           </a:xfrm>
           <a:prstGeom prst="rect">
             <a:avLst/>
@@ -7662,7 +7572,7 @@
           <a:p>
             <a:pPr algn="l"/>
             <a:r>
-              <a:rPr sz="3600" b="1">
+              <a:rPr sz="2400" b="1" dirty="0">
                 <a:solidFill>
                   <a:srgbClr val="4F8F12"/>
                 </a:solidFill>
@@ -7682,7 +7592,7 @@
         <p:spPr>
           <a:xfrm>
             <a:off x="4709160" y="3200400"/>
-            <a:ext cx="2971800" cy="1188720"/>
+            <a:ext cx="2971800" cy="553998"/>
           </a:xfrm>
           <a:prstGeom prst="rect">
             <a:avLst/>
@@ -7697,14 +7607,14 @@
           <a:p>
             <a:pPr algn="l"/>
             <a:r>
-              <a:rPr sz="1500" b="0">
+              <a:rPr sz="1500" b="0" dirty="0">
                 <a:solidFill>
                   <a:srgbClr val="1B1F17"/>
                 </a:solidFill>
                 <a:latin typeface="Arial"/>
               </a:rPr>
               <a:t>Target time to a trusted view
-with Control Tower</a:t>
+</a:t>
             </a:r>
           </a:p>
         </p:txBody>
@@ -7788,6 +7698,7 @@
           <a:lstStyle/>
           <a:p>
             <a:pPr algn="ctr"/>
+            <a:endParaRPr/>
           </a:p>
         </p:txBody>
       </p:sp>
@@ -7800,7 +7711,7 @@
         <p:spPr>
           <a:xfrm>
             <a:off x="8458199" y="2286000"/>
-            <a:ext cx="2971800" cy="731520"/>
+            <a:ext cx="2971800" cy="461665"/>
           </a:xfrm>
           <a:prstGeom prst="rect">
             <a:avLst/>
@@ -7815,7 +7726,7 @@
           <a:p>
             <a:pPr algn="l"/>
             <a:r>
-              <a:rPr sz="3600" b="1">
+              <a:rPr sz="2400" b="1" dirty="0">
                 <a:solidFill>
                   <a:srgbClr val="4F8F12"/>
                 </a:solidFill>
@@ -7976,7 +7887,7 @@
 </file>
 
 <file path=ppt/slides/slide14.xml><?xml version="1.0" encoding="utf-8"?>
-<p:sld xmlns:a="http://schemas.openxmlformats.org/drawingml/2006/main" xmlns:p="http://schemas.openxmlformats.org/presentationml/2006/main" xmlns:r="http://schemas.openxmlformats.org/officeDocument/2006/relationships">
+<p:sld xmlns:a="http://schemas.openxmlformats.org/drawingml/2006/main" xmlns:r="http://schemas.openxmlformats.org/officeDocument/2006/relationships" xmlns:p="http://schemas.openxmlformats.org/presentationml/2006/main">
   <p:cSld>
     <p:spTree>
       <p:nvGrpSpPr>
@@ -7984,7 +7895,14 @@
         <p:cNvGrpSpPr/>
         <p:nvPr/>
       </p:nvGrpSpPr>
-      <p:grpSpPr/>
+      <p:grpSpPr>
+        <a:xfrm>
+          <a:off x="0" y="0"/>
+          <a:ext cx="0" cy="0"/>
+          <a:chOff x="0" y="0"/>
+          <a:chExt cx="0" cy="0"/>
+        </a:xfrm>
+      </p:grpSpPr>
       <p:sp>
         <p:nvSpPr>
           <p:cNvPr id="2" name="Rectangle 1"/>
@@ -8025,6 +7943,7 @@
           <a:lstStyle/>
           <a:p>
             <a:pPr algn="ctr"/>
+            <a:endParaRPr/>
           </a:p>
         </p:txBody>
       </p:sp>
@@ -8037,7 +7956,7 @@
           <p:nvPr/>
         </p:nvPicPr>
         <p:blipFill>
-          <a:blip r:embed="rId2"/>
+          <a:blip r:embed="rId3"/>
           <a:stretch>
             <a:fillRect/>
           </a:stretch>
@@ -8076,7 +7995,7 @@
           <a:p>
             <a:pPr algn="l"/>
             <a:r>
-              <a:rPr sz="2800" b="1">
+              <a:rPr sz="2800" b="1" dirty="0">
                 <a:solidFill>
                   <a:srgbClr val="1B1F17"/>
                 </a:solidFill>
@@ -8199,7 +8118,7 @@
 </file>
 
 <file path=ppt/slides/slide2.xml><?xml version="1.0" encoding="utf-8"?>
-<p:sld xmlns:a="http://schemas.openxmlformats.org/drawingml/2006/main" xmlns:p="http://schemas.openxmlformats.org/presentationml/2006/main" xmlns:r="http://schemas.openxmlformats.org/officeDocument/2006/relationships">
+<p:sld xmlns:a="http://schemas.openxmlformats.org/drawingml/2006/main" xmlns:r="http://schemas.openxmlformats.org/officeDocument/2006/relationships" xmlns:p="http://schemas.openxmlformats.org/presentationml/2006/main">
   <p:cSld>
     <p:spTree>
       <p:nvGrpSpPr>
@@ -8207,7 +8126,14 @@
         <p:cNvGrpSpPr/>
         <p:nvPr/>
       </p:nvGrpSpPr>
-      <p:grpSpPr/>
+      <p:grpSpPr>
+        <a:xfrm>
+          <a:off x="0" y="0"/>
+          <a:ext cx="0" cy="0"/>
+          <a:chOff x="0" y="0"/>
+          <a:chExt cx="0" cy="0"/>
+        </a:xfrm>
+      </p:grpSpPr>
       <p:sp>
         <p:nvSpPr>
           <p:cNvPr id="2" name="Rectangle 1"/>
@@ -8248,6 +8174,7 @@
           <a:lstStyle/>
           <a:p>
             <a:pPr algn="ctr"/>
+            <a:endParaRPr/>
           </a:p>
         </p:txBody>
       </p:sp>
@@ -8260,7 +8187,7 @@
           <p:nvPr/>
         </p:nvPicPr>
         <p:blipFill>
-          <a:blip r:embed="rId2"/>
+          <a:blip r:embed="rId3"/>
           <a:stretch>
             <a:fillRect/>
           </a:stretch>
@@ -8284,7 +8211,7 @@
         <p:spPr>
           <a:xfrm>
             <a:off x="2331720" y="228600"/>
-            <a:ext cx="9144000" cy="228600"/>
+            <a:ext cx="9144000" cy="261610"/>
           </a:xfrm>
           <a:prstGeom prst="rect">
             <a:avLst/>
@@ -8299,13 +8226,13 @@
           <a:p>
             <a:pPr algn="l"/>
             <a:r>
-              <a:rPr sz="1100" b="1">
+              <a:rPr sz="1100" b="1" dirty="0">
                 <a:solidFill>
                   <a:srgbClr val="4F8F12"/>
                 </a:solidFill>
                 <a:latin typeface="Arial"/>
               </a:rPr>
-              <a:t>THE PROBLEM WE SOLVE</a:t>
+              <a:t>THE PROBLEM </a:t>
             </a:r>
           </a:p>
         </p:txBody>
@@ -8318,8 +8245,8 @@
         </p:nvSpPr>
         <p:spPr>
           <a:xfrm>
-            <a:off x="2331720" y="457200"/>
-            <a:ext cx="9326880" cy="502920"/>
+            <a:off x="2103120" y="457200"/>
+            <a:ext cx="9555480" cy="892552"/>
           </a:xfrm>
           <a:prstGeom prst="rect">
             <a:avLst/>
@@ -8334,48 +8261,40 @@
           <a:p>
             <a:pPr algn="l"/>
             <a:r>
-              <a:rPr sz="2600" b="1">
+              <a:rPr lang="en-US" sz="2600" b="1" dirty="0">
                 <a:solidFill>
                   <a:srgbClr val="1B1F17"/>
                 </a:solidFill>
                 <a:latin typeface="Arial"/>
               </a:rPr>
-              <a:t>Reconciliation is critical — but nobody can follow the story.</a:t>
-            </a:r>
-          </a:p>
-        </p:txBody>
-      </p:sp>
-      <p:sp>
-        <p:nvSpPr>
-          <p:cNvPr id="6" name="TextBox 5"/>
-          <p:cNvSpPr txBox="1"/>
-          <p:nvPr/>
-        </p:nvSpPr>
-        <p:spPr>
-          <a:xfrm>
-            <a:off x="2331720" y="960120"/>
-            <a:ext cx="9326880" cy="320040"/>
-          </a:xfrm>
-          <a:prstGeom prst="rect">
-            <a:avLst/>
-          </a:prstGeom>
-          <a:noFill/>
-        </p:spPr>
-        <p:txBody>
-          <a:bodyPr wrap="square">
-            <a:spAutoFit/>
-          </a:bodyPr>
-          <a:lstStyle/>
-          <a:p>
-            <a:pPr algn="l"/>
-            <a:r>
-              <a:rPr sz="1500" b="0">
-                <a:solidFill>
-                  <a:srgbClr val="6A7264"/>
-                </a:solidFill>
-                <a:latin typeface="Arial"/>
-              </a:rPr>
-              <a:t>Not a missing-data problem. A comprehension and alignment problem.</a:t>
+              <a:t>Headcount r</a:t>
+            </a:r>
+            <a:r>
+              <a:rPr sz="2600" b="1" dirty="0">
+                <a:solidFill>
+                  <a:srgbClr val="1B1F17"/>
+                </a:solidFill>
+                <a:latin typeface="Arial"/>
+              </a:rPr>
+              <a:t>econciliation is critical</a:t>
+            </a:r>
+            <a:r>
+              <a:rPr lang="en-US" sz="2600" b="1" dirty="0">
+                <a:solidFill>
+                  <a:srgbClr val="1B1F17"/>
+                </a:solidFill>
+                <a:latin typeface="Arial"/>
+              </a:rPr>
+              <a:t>,</a:t>
+            </a:r>
+            <a:r>
+              <a:rPr sz="2600" b="1" dirty="0">
+                <a:solidFill>
+                  <a:srgbClr val="1B1F17"/>
+                </a:solidFill>
+                <a:latin typeface="Arial"/>
+              </a:rPr>
+              <a:t> but nobody can follow the story.</a:t>
             </a:r>
           </a:p>
         </p:txBody>
@@ -8424,6 +8343,7 @@
           <a:lstStyle/>
           <a:p>
             <a:pPr algn="ctr"/>
+            <a:endParaRPr/>
           </a:p>
         </p:txBody>
       </p:sp>
@@ -8521,13 +8441,13 @@
           <a:p>
             <a:pPr algn="l"/>
             <a:r>
-              <a:rPr sz="1500" b="0">
+              <a:rPr sz="1500" b="0" dirty="0">
                 <a:solidFill>
                   <a:srgbClr val="6A7264"/>
                 </a:solidFill>
                 <a:latin typeface="Arial"/>
               </a:rPr>
-              <a:t>Approved plan, working plan, and filled headcount live in different tabs and systems. Leaders argue whose number is right.</a:t>
+              <a:t>Approved plan, working plan, and filled headcount live in different tabs — often only one Finance owner can rebuild the story.</a:t>
             </a:r>
           </a:p>
         </p:txBody>
@@ -8576,6 +8496,7 @@
           <a:lstStyle/>
           <a:p>
             <a:pPr algn="ctr"/>
+            <a:endParaRPr/>
           </a:p>
         </p:txBody>
       </p:sp>
@@ -8673,7 +8594,7 @@
           <a:p>
             <a:pPr algn="l"/>
             <a:r>
-              <a:rPr sz="1500" b="0">
+              <a:rPr sz="1500" b="0" dirty="0">
                 <a:solidFill>
                   <a:srgbClr val="6A7264"/>
                 </a:solidFill>
@@ -8728,6 +8649,7 @@
           <a:lstStyle/>
           <a:p>
             <a:pPr algn="ctr"/>
+            <a:endParaRPr/>
           </a:p>
         </p:txBody>
       </p:sp>
@@ -8915,7 +8837,7 @@
 </file>
 
 <file path=ppt/slides/slide3.xml><?xml version="1.0" encoding="utf-8"?>
-<p:sld xmlns:a="http://schemas.openxmlformats.org/drawingml/2006/main" xmlns:p="http://schemas.openxmlformats.org/presentationml/2006/main" xmlns:r="http://schemas.openxmlformats.org/officeDocument/2006/relationships">
+<p:sld xmlns:a="http://schemas.openxmlformats.org/drawingml/2006/main" xmlns:r="http://schemas.openxmlformats.org/officeDocument/2006/relationships" xmlns:p="http://schemas.openxmlformats.org/presentationml/2006/main">
   <p:cSld>
     <p:spTree>
       <p:nvGrpSpPr>
@@ -8923,7 +8845,14 @@
         <p:cNvGrpSpPr/>
         <p:nvPr/>
       </p:nvGrpSpPr>
-      <p:grpSpPr/>
+      <p:grpSpPr>
+        <a:xfrm>
+          <a:off x="0" y="0"/>
+          <a:ext cx="0" cy="0"/>
+          <a:chOff x="0" y="0"/>
+          <a:chExt cx="0" cy="0"/>
+        </a:xfrm>
+      </p:grpSpPr>
       <p:sp>
         <p:nvSpPr>
           <p:cNvPr id="2" name="Rectangle 1"/>
@@ -8964,6 +8893,7 @@
           <a:lstStyle/>
           <a:p>
             <a:pPr algn="ctr"/>
+            <a:endParaRPr/>
           </a:p>
         </p:txBody>
       </p:sp>
@@ -8976,7 +8906,7 @@
           <p:nvPr/>
         </p:nvPicPr>
         <p:blipFill>
-          <a:blip r:embed="rId2"/>
+          <a:blip r:embed="rId3"/>
           <a:stretch>
             <a:fillRect/>
           </a:stretch>
@@ -9105,6 +9035,7 @@
           <a:lstStyle/>
           <a:p>
             <a:pPr algn="ctr"/>
+            <a:endParaRPr/>
           </a:p>
         </p:txBody>
       </p:sp>
@@ -9208,7 +9139,7 @@
                 </a:solidFill>
                 <a:latin typeface="Arial"/>
               </a:rPr>
-              <a:t>Fewer recon threads · faster close · board-ready variance</a:t>
+              <a:t>Fewer recon threads · board-ready variance · knowledge not trapped in one person</a:t>
             </a:r>
           </a:p>
         </p:txBody>
@@ -9257,6 +9188,7 @@
           <a:lstStyle/>
           <a:p>
             <a:pPr algn="ctr"/>
+            <a:endParaRPr/>
           </a:p>
         </p:txBody>
       </p:sp>
@@ -9304,7 +9236,7 @@
         <p:spPr>
           <a:xfrm>
             <a:off x="3200400" y="2743200"/>
-            <a:ext cx="4846320" cy="640080"/>
+            <a:ext cx="4846320" cy="553998"/>
           </a:xfrm>
           <a:prstGeom prst="rect">
             <a:avLst/>
@@ -9319,13 +9251,31 @@
           <a:p>
             <a:pPr algn="l"/>
             <a:r>
-              <a:rPr sz="1500" b="0">
+              <a:rPr sz="1500" b="0" dirty="0">
                 <a:solidFill>
                   <a:srgbClr val="1B1F17"/>
                 </a:solidFill>
                 <a:latin typeface="Arial"/>
               </a:rPr>
-              <a:t>Log backfill / not backfilling / pivot once — Finance sees it instantly</a:t>
+              <a:t>Log backfill / not backfilling / pivot once</a:t>
+            </a:r>
+            <a:r>
+              <a:rPr lang="en-US" sz="1500" b="0" dirty="0">
+                <a:solidFill>
+                  <a:srgbClr val="1B1F17"/>
+                </a:solidFill>
+                <a:latin typeface="Arial"/>
+              </a:rPr>
+              <a:t>,</a:t>
+            </a:r>
+            <a:r>
+              <a:rPr sz="1500" b="0" dirty="0">
+                <a:solidFill>
+                  <a:srgbClr val="1B1F17"/>
+                </a:solidFill>
+                <a:latin typeface="Arial"/>
+              </a:rPr>
+              <a:t> Finance sees it instantly</a:t>
             </a:r>
           </a:p>
         </p:txBody>
@@ -9409,6 +9359,7 @@
           <a:lstStyle/>
           <a:p>
             <a:pPr algn="ctr"/>
+            <a:endParaRPr/>
           </a:p>
         </p:txBody>
       </p:sp>
@@ -9491,7 +9442,7 @@
         <p:spPr>
           <a:xfrm>
             <a:off x="8138160" y="3840480"/>
-            <a:ext cx="3383280" cy="640080"/>
+            <a:ext cx="3383280" cy="523220"/>
           </a:xfrm>
           <a:prstGeom prst="rect">
             <a:avLst/>
@@ -9506,13 +9457,31 @@
           <a:p>
             <a:pPr algn="l"/>
             <a:r>
-              <a:rPr sz="1400" b="1">
+              <a:rPr sz="1400" b="1" dirty="0">
                 <a:solidFill>
                   <a:srgbClr val="4F8F12"/>
                 </a:solidFill>
                 <a:latin typeface="Arial"/>
               </a:rPr>
-              <a:t>Less tribal knowledge · fewer stalled reqs</a:t>
+              <a:t>Less tribal knowledge · fewer stalled req</a:t>
+            </a:r>
+            <a:r>
+              <a:rPr lang="en-US" sz="1400" b="1" dirty="0">
+                <a:solidFill>
+                  <a:srgbClr val="4F8F12"/>
+                </a:solidFill>
+                <a:latin typeface="Arial"/>
+              </a:rPr>
+              <a:t>uirement</a:t>
+            </a:r>
+            <a:r>
+              <a:rPr sz="1400" b="1" dirty="0">
+                <a:solidFill>
+                  <a:srgbClr val="4F8F12"/>
+                </a:solidFill>
+                <a:latin typeface="Arial"/>
+              </a:rPr>
+              <a:t>s</a:t>
             </a:r>
           </a:p>
         </p:txBody>
@@ -9561,6 +9530,7 @@
           <a:lstStyle/>
           <a:p>
             <a:pPr algn="ctr"/>
+            <a:endParaRPr/>
           </a:p>
         </p:txBody>
       </p:sp>
@@ -9629,7 +9599,7 @@
                 </a:solidFill>
                 <a:latin typeface="Arial"/>
               </a:rPr>
-              <a:t>Trust the as-of date and the named drivers behind every gap</a:t>
+              <a:t>Trust the as-of date and named drivers — even if the FP&amp;A owner is out</a:t>
             </a:r>
           </a:p>
         </p:txBody>
@@ -9643,7 +9613,7 @@
         <p:spPr>
           <a:xfrm>
             <a:off x="8138160" y="4937759"/>
-            <a:ext cx="3383280" cy="640080"/>
+            <a:ext cx="3383280" cy="523220"/>
           </a:xfrm>
           <a:prstGeom prst="rect">
             <a:avLst/>
@@ -9658,13 +9628,31 @@
           <a:p>
             <a:pPr algn="l"/>
             <a:r>
-              <a:rPr sz="1400" b="1">
+              <a:rPr sz="1400" b="1" dirty="0">
                 <a:solidFill>
                   <a:srgbClr val="4F8F12"/>
                 </a:solidFill>
                 <a:latin typeface="Arial"/>
               </a:rPr>
-              <a:t>Decisions on people cost — not debates about the math</a:t>
+              <a:t>Business continuity · decisions on people cost, not one person’s spreadsheet</a:t>
+            </a:r>
+            <a:r>
+              <a:rPr lang="en-US" sz="1400" b="1" dirty="0">
+                <a:solidFill>
+                  <a:srgbClr val="4F8F12"/>
+                </a:solidFill>
+                <a:latin typeface="Arial"/>
+              </a:rPr>
+              <a:t/>
+            </a:r>
+            <a:r>
+              <a:rPr sz="1400" b="1" dirty="0">
+                <a:solidFill>
+                  <a:srgbClr val="4F8F12"/>
+                </a:solidFill>
+                <a:latin typeface="Arial"/>
+              </a:rPr>
+              <a:t/>
             </a:r>
           </a:p>
         </p:txBody>
@@ -9748,7 +9736,7 @@
 </file>
 
 <file path=ppt/slides/slide4.xml><?xml version="1.0" encoding="utf-8"?>
-<p:sld xmlns:a="http://schemas.openxmlformats.org/drawingml/2006/main" xmlns:p="http://schemas.openxmlformats.org/presentationml/2006/main" xmlns:r="http://schemas.openxmlformats.org/officeDocument/2006/relationships">
+<p:sld xmlns:a="http://schemas.openxmlformats.org/drawingml/2006/main" xmlns:r="http://schemas.openxmlformats.org/officeDocument/2006/relationships" xmlns:p="http://schemas.openxmlformats.org/presentationml/2006/main">
   <p:cSld>
     <p:spTree>
       <p:nvGrpSpPr>
@@ -9756,7 +9744,14 @@
         <p:cNvGrpSpPr/>
         <p:nvPr/>
       </p:nvGrpSpPr>
-      <p:grpSpPr/>
+      <p:grpSpPr>
+        <a:xfrm>
+          <a:off x="0" y="0"/>
+          <a:ext cx="0" cy="0"/>
+          <a:chOff x="0" y="0"/>
+          <a:chExt cx="0" cy="0"/>
+        </a:xfrm>
+      </p:grpSpPr>
       <p:sp>
         <p:nvSpPr>
           <p:cNvPr id="2" name="Rectangle 1"/>
@@ -9797,6 +9792,7 @@
           <a:lstStyle/>
           <a:p>
             <a:pPr algn="ctr"/>
+            <a:endParaRPr/>
           </a:p>
         </p:txBody>
       </p:sp>
@@ -9809,7 +9805,7 @@
           <p:nvPr/>
         </p:nvPicPr>
         <p:blipFill>
-          <a:blip r:embed="rId2"/>
+          <a:blip r:embed="rId3"/>
           <a:stretch>
             <a:fillRect/>
           </a:stretch>
@@ -9883,13 +9879,31 @@
           <a:p>
             <a:pPr algn="l"/>
             <a:r>
-              <a:rPr sz="2600" b="1">
+              <a:rPr sz="2600" b="1" dirty="0">
                 <a:solidFill>
                   <a:srgbClr val="1B1F17"/>
                 </a:solidFill>
                 <a:latin typeface="Arial"/>
               </a:rPr>
-              <a:t>A product Finance will fight for — not only HR.</a:t>
+              <a:t>A product Finance will fight for</a:t>
+            </a:r>
+            <a:r>
+              <a:rPr lang="en-US" sz="2600" b="1" dirty="0">
+                <a:solidFill>
+                  <a:srgbClr val="1B1F17"/>
+                </a:solidFill>
+                <a:latin typeface="Arial"/>
+              </a:rPr>
+              <a:t>,</a:t>
+            </a:r>
+            <a:r>
+              <a:rPr sz="2600" b="1" dirty="0">
+                <a:solidFill>
+                  <a:srgbClr val="1B1F17"/>
+                </a:solidFill>
+                <a:latin typeface="Arial"/>
+              </a:rPr>
+              <a:t> not only HR.</a:t>
             </a:r>
           </a:p>
         </p:txBody>
@@ -9938,6 +9952,7 @@
           <a:lstStyle/>
           <a:p>
             <a:pPr algn="ctr"/>
+            <a:endParaRPr/>
           </a:p>
         </p:txBody>
       </p:sp>
@@ -10055,6 +10070,7 @@
           <a:lstStyle/>
           <a:p>
             <a:pPr algn="ctr"/>
+            <a:endParaRPr/>
           </a:p>
         </p:txBody>
       </p:sp>
@@ -10102,7 +10118,7 @@
         <p:spPr>
           <a:xfrm>
             <a:off x="6675120" y="2377440"/>
-            <a:ext cx="4800600" cy="914400"/>
+            <a:ext cx="4800600" cy="738664"/>
           </a:xfrm>
           <a:prstGeom prst="rect">
             <a:avLst/>
@@ -10117,13 +10133,31 @@
           <a:p>
             <a:pPr algn="l"/>
             <a:r>
-              <a:rPr sz="1400" b="0">
+              <a:rPr sz="1400" b="0" dirty="0">
                 <a:solidFill>
                   <a:srgbClr val="6A7264"/>
                 </a:solidFill>
                 <a:latin typeface="Arial"/>
               </a:rPr>
-              <a:t>Headcount recon sits on BambooHR’s source-of-truth. Makes the HRIS the system Finance opens at close — not a spreadsheet export.</a:t>
+              <a:t>Headcount recon sits on BambooHR’s source-of-truth. Makes the HRIS the system Finance opens at close</a:t>
+            </a:r>
+            <a:r>
+              <a:rPr lang="en-US" sz="1400" b="0" dirty="0">
+                <a:solidFill>
+                  <a:srgbClr val="6A7264"/>
+                </a:solidFill>
+                <a:latin typeface="Arial"/>
+              </a:rPr>
+              <a:t>,</a:t>
+            </a:r>
+            <a:r>
+              <a:rPr sz="1400" b="0" dirty="0">
+                <a:solidFill>
+                  <a:srgbClr val="6A7264"/>
+                </a:solidFill>
+                <a:latin typeface="Arial"/>
+              </a:rPr>
+              <a:t> not a spreadsheet export.</a:t>
             </a:r>
           </a:p>
         </p:txBody>
@@ -10172,6 +10206,7 @@
           <a:lstStyle/>
           <a:p>
             <a:pPr algn="ctr"/>
+            <a:endParaRPr/>
           </a:p>
         </p:txBody>
       </p:sp>
@@ -10184,7 +10219,7 @@
         <p:spPr>
           <a:xfrm>
             <a:off x="1005840" y="4114800"/>
-            <a:ext cx="4800600" cy="411480"/>
+            <a:ext cx="4800600" cy="369332"/>
           </a:xfrm>
           <a:prstGeom prst="rect">
             <a:avLst/>
@@ -10199,13 +10234,13 @@
           <a:p>
             <a:pPr algn="l"/>
             <a:r>
-              <a:rPr sz="1800" b="1">
+              <a:rPr sz="1800" b="1" dirty="0">
                 <a:solidFill>
                   <a:srgbClr val="1B1F17"/>
                 </a:solidFill>
                 <a:latin typeface="Arial"/>
               </a:rPr>
-              <a:t>Differentiate on trust</a:t>
+              <a:t>Differentiate</a:t>
             </a:r>
           </a:p>
         </p:txBody>
@@ -10219,7 +10254,7 @@
         <p:spPr>
           <a:xfrm>
             <a:off x="1005840" y="4663440"/>
-            <a:ext cx="4800600" cy="914400"/>
+            <a:ext cx="4800600" cy="738664"/>
           </a:xfrm>
           <a:prstGeom prst="rect">
             <a:avLst/>
@@ -10234,14 +10269,20 @@
           <a:p>
             <a:pPr algn="l"/>
             <a:r>
-              <a:rPr sz="1400" b="0">
+              <a:rPr lang="en-US" sz="1400" b="0" dirty="0">
                 <a:solidFill>
                   <a:srgbClr val="6A7264"/>
                 </a:solidFill>
                 <a:latin typeface="Arial"/>
               </a:rPr>
-              <a:t>Competitors ship workforce charts. The gap is explained variance + shared dispositions + a clear as-of — hard to copy without HR+Finance design.</a:t>
-            </a:r>
+              <a:t>Companies like ADP who have large clients do not have this type of product even though it is a major time commitment for current finance leaders.</a:t>
+            </a:r>
+            <a:endParaRPr sz="1400" b="0" dirty="0">
+              <a:solidFill>
+                <a:srgbClr val="6A7264"/>
+              </a:solidFill>
+              <a:latin typeface="Arial"/>
+            </a:endParaRPr>
           </a:p>
         </p:txBody>
       </p:sp>
@@ -10289,6 +10330,7 @@
           <a:lstStyle/>
           <a:p>
             <a:pPr algn="ctr"/>
+            <a:endParaRPr/>
           </a:p>
         </p:txBody>
       </p:sp>
@@ -10441,7 +10483,7 @@
 </file>
 
 <file path=ppt/slides/slide5.xml><?xml version="1.0" encoding="utf-8"?>
-<p:sld xmlns:a="http://schemas.openxmlformats.org/drawingml/2006/main" xmlns:p="http://schemas.openxmlformats.org/presentationml/2006/main" xmlns:r="http://schemas.openxmlformats.org/officeDocument/2006/relationships">
+<p:sld xmlns:a="http://schemas.openxmlformats.org/drawingml/2006/main" xmlns:r="http://schemas.openxmlformats.org/officeDocument/2006/relationships" xmlns:p="http://schemas.openxmlformats.org/presentationml/2006/main">
   <p:cSld>
     <p:spTree>
       <p:nvGrpSpPr>
@@ -10449,7 +10491,14 @@
         <p:cNvGrpSpPr/>
         <p:nvPr/>
       </p:nvGrpSpPr>
-      <p:grpSpPr/>
+      <p:grpSpPr>
+        <a:xfrm>
+          <a:off x="0" y="0"/>
+          <a:ext cx="0" cy="0"/>
+          <a:chOff x="0" y="0"/>
+          <a:chExt cx="0" cy="0"/>
+        </a:xfrm>
+      </p:grpSpPr>
       <p:sp>
         <p:nvSpPr>
           <p:cNvPr id="2" name="Rectangle 1"/>
@@ -10490,6 +10539,7 @@
           <a:lstStyle/>
           <a:p>
             <a:pPr algn="ctr"/>
+            <a:endParaRPr/>
           </a:p>
         </p:txBody>
       </p:sp>
@@ -10502,7 +10552,7 @@
           <p:nvPr/>
         </p:nvPicPr>
         <p:blipFill>
-          <a:blip r:embed="rId2"/>
+          <a:blip r:embed="rId3"/>
           <a:stretch>
             <a:fillRect/>
           </a:stretch>
@@ -10582,7 +10632,7 @@
                 </a:solidFill>
                 <a:latin typeface="Arial"/>
               </a:rPr>
-              <a:t>A multi-tab workbook nobody outside FP&amp;A can navigate.</a:t>
+              <a:t>A multi-tab workbook only one Finance owner can truly navigate</a:t>
             </a:r>
           </a:p>
         </p:txBody>
@@ -10595,8 +10645,8 @@
         </p:nvSpPr>
         <p:spPr>
           <a:xfrm>
-            <a:off x="2331720" y="960120"/>
-            <a:ext cx="9326880" cy="320040"/>
+            <a:off x="2331720" y="866001"/>
+            <a:ext cx="9726930" cy="553998"/>
           </a:xfrm>
           <a:prstGeom prst="rect">
             <a:avLst/>
@@ -10611,14 +10661,29 @@
           <a:p>
             <a:pPr algn="l"/>
             <a:r>
-              <a:rPr sz="1500" b="0">
+              <a:rPr sz="1500" b="0" dirty="0">
                 <a:solidFill>
                   <a:srgbClr val="6A7264"/>
                 </a:solidFill>
                 <a:latin typeface="Arial"/>
               </a:rPr>
-              <a:t>Fictional Northline data — same structure as a real recon (approved plan · roll-forward · HC recon · net-new).</a:t>
-            </a:r>
+              <a:t>Fictional Northline data — </a:t>
+            </a:r>
+            <a:r>
+              <a:rPr lang="en-US" sz="1500" b="0" dirty="0">
+                <a:solidFill>
+                  <a:srgbClr val="6A7264"/>
+                </a:solidFill>
+                <a:latin typeface="Arial"/>
+              </a:rPr>
+              <a:t>This is a real spreadsheet from a Head of Finance but with numbers and roles changed to protect confidentiality </a:t>
+            </a:r>
+            <a:endParaRPr sz="1500" b="0" dirty="0">
+              <a:solidFill>
+                <a:srgbClr val="6A7264"/>
+              </a:solidFill>
+              <a:latin typeface="Arial"/>
+            </a:endParaRPr>
           </a:p>
         </p:txBody>
       </p:sp>
@@ -10631,7 +10696,7 @@
           <p:nvPr/>
         </p:nvPicPr>
         <p:blipFill>
-          <a:blip r:embed="rId3"/>
+          <a:blip r:embed="rId4"/>
           <a:stretch>
             <a:fillRect/>
           </a:stretch>
@@ -10725,7 +10790,7 @@
 </file>
 
 <file path=ppt/slides/slide6.xml><?xml version="1.0" encoding="utf-8"?>
-<p:sld xmlns:a="http://schemas.openxmlformats.org/drawingml/2006/main" xmlns:p="http://schemas.openxmlformats.org/presentationml/2006/main" xmlns:r="http://schemas.openxmlformats.org/officeDocument/2006/relationships">
+<p:sld xmlns:a="http://schemas.openxmlformats.org/drawingml/2006/main" xmlns:r="http://schemas.openxmlformats.org/officeDocument/2006/relationships" xmlns:p="http://schemas.openxmlformats.org/presentationml/2006/main">
   <p:cSld>
     <p:spTree>
       <p:nvGrpSpPr>
@@ -10733,7 +10798,14 @@
         <p:cNvGrpSpPr/>
         <p:nvPr/>
       </p:nvGrpSpPr>
-      <p:grpSpPr/>
+      <p:grpSpPr>
+        <a:xfrm>
+          <a:off x="0" y="0"/>
+          <a:ext cx="0" cy="0"/>
+          <a:chOff x="0" y="0"/>
+          <a:chExt cx="0" cy="0"/>
+        </a:xfrm>
+      </p:grpSpPr>
       <p:sp>
         <p:nvSpPr>
           <p:cNvPr id="2" name="Rectangle 1"/>
@@ -10774,6 +10846,7 @@
           <a:lstStyle/>
           <a:p>
             <a:pPr algn="ctr"/>
+            <a:endParaRPr/>
           </a:p>
         </p:txBody>
       </p:sp>
@@ -10786,7 +10859,7 @@
           <p:nvPr/>
         </p:nvPicPr>
         <p:blipFill>
-          <a:blip r:embed="rId2"/>
+          <a:blip r:embed="rId3"/>
           <a:stretch>
             <a:fillRect/>
           </a:stretch>
@@ -10860,14 +10933,38 @@
           <a:p>
             <a:pPr algn="l"/>
             <a:r>
-              <a:rPr sz="2600" b="1">
+              <a:rPr lang="en-US" sz="2600" b="1" dirty="0">
                 <a:solidFill>
                   <a:srgbClr val="1B1F17"/>
                 </a:solidFill>
                 <a:latin typeface="Arial"/>
               </a:rPr>
-              <a:t>Primary research — Head of Finance</a:t>
-            </a:r>
+              <a:t>Interview with</a:t>
+            </a:r>
+            <a:r>
+              <a:rPr sz="2600" b="1" dirty="0">
+                <a:solidFill>
+                  <a:srgbClr val="1B1F17"/>
+                </a:solidFill>
+                <a:latin typeface="Arial"/>
+              </a:rPr>
+              <a:t> Head of Finance</a:t>
+            </a:r>
+            <a:r>
+              <a:rPr lang="en-US" sz="2600" b="1" dirty="0">
+                <a:solidFill>
+                  <a:srgbClr val="1B1F17"/>
+                </a:solidFill>
+                <a:latin typeface="Arial"/>
+              </a:rPr>
+              <a:t> at 300 employee company</a:t>
+            </a:r>
+            <a:endParaRPr sz="2600" b="1" dirty="0">
+              <a:solidFill>
+                <a:srgbClr val="1B1F17"/>
+              </a:solidFill>
+              <a:latin typeface="Arial"/>
+            </a:endParaRPr>
           </a:p>
         </p:txBody>
       </p:sp>
@@ -10879,8 +10976,8 @@
         </p:nvSpPr>
         <p:spPr>
           <a:xfrm>
-            <a:off x="685800" y="1554480"/>
-            <a:ext cx="10972800" cy="2011680"/>
+            <a:off x="685800" y="1417320"/>
+            <a:ext cx="10972800" cy="1417320"/>
           </a:xfrm>
           <a:prstGeom prst="roundRect">
             <a:avLst>
@@ -10913,6 +11010,7 @@
           <a:lstStyle/>
           <a:p>
             <a:pPr algn="ctr"/>
+            <a:endParaRPr/>
           </a:p>
         </p:txBody>
       </p:sp>
@@ -10924,8 +11022,8 @@
         </p:nvSpPr>
         <p:spPr>
           <a:xfrm>
-            <a:off x="1051560" y="1783080"/>
-            <a:ext cx="10241280" cy="1554480"/>
+            <a:off x="1051560" y="1600200"/>
+            <a:ext cx="10241280" cy="1143000"/>
           </a:xfrm>
           <a:prstGeom prst="rect">
             <a:avLst/>
@@ -10975,8 +11073,8 @@
         </p:nvSpPr>
         <p:spPr>
           <a:xfrm>
-            <a:off x="685800" y="3840480"/>
-            <a:ext cx="10972800" cy="2011680"/>
+            <a:off x="685800" y="4526280"/>
+            <a:ext cx="10972800" cy="1417320"/>
           </a:xfrm>
           <a:prstGeom prst="roundRect">
             <a:avLst>
@@ -10984,7 +11082,7 @@
             </a:avLst>
           </a:prstGeom>
           <a:solidFill>
-            <a:srgbClr val="FFFFFF"/>
+            <a:srgbClr val="F3F8EA"/>
           </a:solidFill>
           <a:ln>
             <a:solidFill>
@@ -11011,6 +11109,7 @@
           <a:lstStyle/>
           <a:p>
             <a:pPr algn="ctr"/>
+            <a:endParaRPr/>
           </a:p>
         </p:txBody>
       </p:sp>
@@ -11022,8 +11121,8 @@
         </p:nvSpPr>
         <p:spPr>
           <a:xfrm>
-            <a:off x="1051560" y="4069080"/>
-            <a:ext cx="10241280" cy="1554480"/>
+            <a:off x="1051560" y="4709160"/>
+            <a:ext cx="10241280" cy="1143000"/>
           </a:xfrm>
           <a:prstGeom prst="rect">
             <a:avLst/>
@@ -11131,6 +11230,101 @@
                 <a:latin typeface="Arial"/>
               </a:rPr>
               <a:t>6/14</a:t>
+            </a:r>
+          </a:p>
+        </p:txBody>
+      </p:sp>
+      <p:sp>
+        <p:nvSpPr>
+          <p:cNvPr id="12" name="Rounded Rectangle 11"/>
+          <p:cNvSpPr/>
+          <p:nvPr/>
+        </p:nvSpPr>
+        <p:spPr>
+          <a:xfrm>
+            <a:off x="685800" y="2971800"/>
+            <a:ext cx="10972800" cy="1417320"/>
+          </a:xfrm>
+          <a:prstGeom prst="roundRect">
+            <a:avLst>
+              <a:gd name="adj" fmla="val 6000"/>
+            </a:avLst>
+          </a:prstGeom>
+          <a:solidFill>
+            <a:srgbClr val="FFFFFF"/>
+          </a:solidFill>
+          <a:ln>
+            <a:noFill/>
+          </a:ln>
+        </p:spPr>
+        <p:style>
+          <a:lnRef idx="1">
+            <a:schemeClr val="accent1"/>
+          </a:lnRef>
+          <a:fillRef idx="3">
+            <a:schemeClr val="accent1"/>
+          </a:fillRef>
+          <a:effectRef idx="2">
+            <a:schemeClr val="accent1"/>
+          </a:effectRef>
+          <a:fontRef idx="minor">
+            <a:schemeClr val="lt1"/>
+          </a:fontRef>
+        </p:style>
+        <p:txBody>
+          <a:bodyPr rtlCol="0" anchor="ctr"/>
+          <a:lstStyle/>
+          <a:p>
+            <a:pPr algn="ctr"/>
+          </a:p>
+        </p:txBody>
+      </p:sp>
+      <p:sp>
+        <p:nvSpPr>
+          <p:cNvPr id="13" name="TextBox 12"/>
+          <p:cNvSpPr txBox="1"/>
+          <p:nvPr/>
+        </p:nvSpPr>
+        <p:spPr>
+          <a:xfrm>
+            <a:off x="1051560" y="3172968"/>
+            <a:ext cx="10241280" cy="1097280"/>
+          </a:xfrm>
+          <a:prstGeom prst="rect">
+            <a:avLst/>
+          </a:prstGeom>
+          <a:noFill/>
+        </p:spPr>
+        <p:txBody>
+          <a:bodyPr wrap="square">
+            <a:spAutoFit/>
+          </a:bodyPr>
+          <a:lstStyle/>
+          <a:p>
+            <a:r>
+              <a:rPr sz="1700" b="0">
+                <a:solidFill>
+                  <a:srgbClr val="1B1F17"/>
+                </a:solidFill>
+                <a:latin typeface="Arial"/>
+              </a:rPr>
+              <a:t>“The problem is I’m the only one that reconciliation relies on. If I got hit by a bus, we’d be doomed”</a:t>
+            </a:r>
+          </a:p>
+          <a:p>
+            <a:pPr>
+              <a:spcBef>
+                <a:spcPts val="1000"/>
+              </a:spcBef>
+            </a:pPr>
+            <a:r>
+              <a:rPr sz="1300" b="1">
+                <a:solidFill>
+                  <a:srgbClr val="4F8F12"/>
+                </a:solidFill>
+                <a:latin typeface="Arial"/>
+              </a:rPr>
+              <a:t>— Head of Finance  ·  Key-person / bus-factor risk</a:t>
             </a:r>
           </a:p>
         </p:txBody>
@@ -11144,7 +11338,7 @@
 </file>
 
 <file path=ppt/slides/slide7.xml><?xml version="1.0" encoding="utf-8"?>
-<p:sld xmlns:a="http://schemas.openxmlformats.org/drawingml/2006/main" xmlns:p="http://schemas.openxmlformats.org/presentationml/2006/main" xmlns:r="http://schemas.openxmlformats.org/officeDocument/2006/relationships">
+<p:sld xmlns:a="http://schemas.openxmlformats.org/drawingml/2006/main" xmlns:r="http://schemas.openxmlformats.org/officeDocument/2006/relationships" xmlns:p="http://schemas.openxmlformats.org/presentationml/2006/main">
   <p:cSld>
     <p:spTree>
       <p:nvGrpSpPr>
@@ -11152,7 +11346,14 @@
         <p:cNvGrpSpPr/>
         <p:nvPr/>
       </p:nvGrpSpPr>
-      <p:grpSpPr/>
+      <p:grpSpPr>
+        <a:xfrm>
+          <a:off x="0" y="0"/>
+          <a:ext cx="0" cy="0"/>
+          <a:chOff x="0" y="0"/>
+          <a:chExt cx="0" cy="0"/>
+        </a:xfrm>
+      </p:grpSpPr>
       <p:sp>
         <p:nvSpPr>
           <p:cNvPr id="2" name="Rectangle 1"/>
@@ -11193,6 +11394,7 @@
           <a:lstStyle/>
           <a:p>
             <a:pPr algn="ctr"/>
+            <a:endParaRPr/>
           </a:p>
         </p:txBody>
       </p:sp>
@@ -11205,7 +11407,7 @@
           <p:nvPr/>
         </p:nvPicPr>
         <p:blipFill>
-          <a:blip r:embed="rId2"/>
+          <a:blip r:embed="rId3"/>
           <a:stretch>
             <a:fillRect/>
           </a:stretch>
@@ -11264,7 +11466,7 @@
         <p:spPr>
           <a:xfrm>
             <a:off x="2331720" y="457200"/>
-            <a:ext cx="9326880" cy="502920"/>
+            <a:ext cx="9326880" cy="892552"/>
           </a:xfrm>
           <a:prstGeom prst="rect">
             <a:avLst/>
@@ -11279,13 +11481,31 @@
           <a:p>
             <a:pPr algn="l"/>
             <a:r>
-              <a:rPr sz="2600" b="1">
+              <a:rPr sz="2600" b="1" dirty="0">
                 <a:solidFill>
                   <a:srgbClr val="1B1F17"/>
                 </a:solidFill>
                 <a:latin typeface="Arial"/>
               </a:rPr>
-              <a:t>Market pattern — HR and Finance still don’t share one headcount system</a:t>
+              <a:t>Market </a:t>
+            </a:r>
+            <a:r>
+              <a:rPr lang="en-US" sz="2600" b="1" dirty="0">
+                <a:solidFill>
+                  <a:srgbClr val="1B1F17"/>
+                </a:solidFill>
+                <a:latin typeface="Arial"/>
+              </a:rPr>
+              <a:t>Research</a:t>
+            </a:r>
+            <a:r>
+              <a:rPr sz="2600" b="1" dirty="0">
+                <a:solidFill>
+                  <a:srgbClr val="1B1F17"/>
+                </a:solidFill>
+                <a:latin typeface="Arial"/>
+              </a:rPr>
+              <a:t> — HR and Finance still don’t share one headcount system</a:t>
             </a:r>
           </a:p>
         </p:txBody>
@@ -11334,6 +11554,7 @@
           <a:lstStyle/>
           <a:p>
             <a:pPr algn="ctr"/>
+            <a:endParaRPr/>
           </a:p>
         </p:txBody>
       </p:sp>
@@ -11486,6 +11707,7 @@
           <a:lstStyle/>
           <a:p>
             <a:pPr algn="ctr"/>
+            <a:endParaRPr/>
           </a:p>
         </p:txBody>
       </p:sp>
@@ -11533,7 +11755,7 @@
         <p:spPr>
           <a:xfrm>
             <a:off x="4663440" y="2926080"/>
-            <a:ext cx="3063240" cy="1645920"/>
+            <a:ext cx="3063240" cy="1708160"/>
           </a:xfrm>
           <a:prstGeom prst="rect">
             <a:avLst/>
@@ -11548,14 +11770,29 @@
           <a:p>
             <a:pPr algn="l"/>
             <a:r>
-              <a:rPr sz="1500" b="0">
+              <a:rPr lang="en-US" sz="1500" b="0" dirty="0">
                 <a:solidFill>
                   <a:srgbClr val="1B1F17"/>
                 </a:solidFill>
                 <a:latin typeface="Arial"/>
               </a:rPr>
-              <a:t>monthly HR–Finance headcount reconciliation after HRIS–FP&amp;A integration (−43%)</a:t>
-            </a:r>
+              <a:t>Without a connected system between HR and Finance </a:t>
+            </a:r>
+            <a:r>
+              <a:rPr lang="en-US" sz="1500" dirty="0">
+                <a:solidFill>
+                  <a:srgbClr val="1B1F17"/>
+                </a:solidFill>
+                <a:latin typeface="Arial"/>
+              </a:rPr>
+              <a:t>headcount reconciliation takes 14 days. With a connected system it takes 8. This is without a product that actively monitors reconciliation </a:t>
+            </a:r>
+            <a:endParaRPr sz="1500" b="0" dirty="0">
+              <a:solidFill>
+                <a:srgbClr val="1B1F17"/>
+              </a:solidFill>
+              <a:latin typeface="Arial"/>
+            </a:endParaRPr>
           </a:p>
         </p:txBody>
       </p:sp>
@@ -11638,6 +11875,7 @@
           <a:lstStyle/>
           <a:p>
             <a:pPr algn="ctr"/>
+            <a:endParaRPr/>
           </a:p>
         </p:txBody>
       </p:sp>
@@ -11685,7 +11923,7 @@
         <p:spPr>
           <a:xfrm>
             <a:off x="8412479" y="2926080"/>
-            <a:ext cx="3063240" cy="1645920"/>
+            <a:ext cx="3063240" cy="553998"/>
           </a:xfrm>
           <a:prstGeom prst="rect">
             <a:avLst/>
@@ -11700,13 +11938,13 @@
           <a:p>
             <a:pPr algn="l"/>
             <a:r>
-              <a:rPr sz="1500" b="0">
+              <a:rPr sz="1500" b="0" dirty="0">
                 <a:solidFill>
                   <a:srgbClr val="1B1F17"/>
                 </a:solidFill>
                 <a:latin typeface="Arial"/>
               </a:rPr>
-              <a:t>average discrepancy between HR and Finance headcount reports without a unified structure</a:t>
+              <a:t>average discrepancy between HR and Finance headcount reports</a:t>
             </a:r>
           </a:p>
         </p:txBody>
@@ -11825,7 +12063,7 @@
 </file>
 
 <file path=ppt/slides/slide8.xml><?xml version="1.0" encoding="utf-8"?>
-<p:sld xmlns:a="http://schemas.openxmlformats.org/drawingml/2006/main" xmlns:p="http://schemas.openxmlformats.org/presentationml/2006/main" xmlns:r="http://schemas.openxmlformats.org/officeDocument/2006/relationships">
+<p:sld xmlns:a="http://schemas.openxmlformats.org/drawingml/2006/main" xmlns:r="http://schemas.openxmlformats.org/officeDocument/2006/relationships" xmlns:p="http://schemas.openxmlformats.org/presentationml/2006/main">
   <p:cSld>
     <p:spTree>
       <p:nvGrpSpPr>
@@ -11833,7 +12071,14 @@
         <p:cNvGrpSpPr/>
         <p:nvPr/>
       </p:nvGrpSpPr>
-      <p:grpSpPr/>
+      <p:grpSpPr>
+        <a:xfrm>
+          <a:off x="0" y="0"/>
+          <a:ext cx="0" cy="0"/>
+          <a:chOff x="0" y="0"/>
+          <a:chExt cx="0" cy="0"/>
+        </a:xfrm>
+      </p:grpSpPr>
       <p:sp>
         <p:nvSpPr>
           <p:cNvPr id="2" name="Rectangle 1"/>
@@ -11874,6 +12119,7 @@
           <a:lstStyle/>
           <a:p>
             <a:pPr algn="ctr"/>
+            <a:endParaRPr/>
           </a:p>
         </p:txBody>
       </p:sp>
@@ -11886,7 +12132,7 @@
           <p:nvPr/>
         </p:nvPicPr>
         <p:blipFill>
-          <a:blip r:embed="rId2"/>
+          <a:blip r:embed="rId3"/>
           <a:stretch>
             <a:fillRect/>
           </a:stretch>
@@ -11960,14 +12206,20 @@
           <a:p>
             <a:pPr algn="l"/>
             <a:r>
-              <a:rPr sz="2600" b="1">
+              <a:rPr lang="en-US" sz="2600" b="1" dirty="0">
                 <a:solidFill>
                   <a:srgbClr val="1B1F17"/>
                 </a:solidFill>
                 <a:latin typeface="Arial"/>
               </a:rPr>
-              <a:t>Five beliefs we designed the prototype to test</a:t>
-            </a:r>
+              <a:t>Five initial hypotheses</a:t>
+            </a:r>
+            <a:endParaRPr sz="2600" b="1" dirty="0">
+              <a:solidFill>
+                <a:srgbClr val="1B1F17"/>
+              </a:solidFill>
+              <a:latin typeface="Arial"/>
+            </a:endParaRPr>
           </a:p>
         </p:txBody>
       </p:sp>
@@ -12013,6 +12265,7 @@
           <a:lstStyle/>
           <a:p>
             <a:pPr algn="ctr"/>
+            <a:endParaRPr/>
           </a:p>
         </p:txBody>
       </p:sp>
@@ -12198,6 +12451,7 @@
           <a:lstStyle/>
           <a:p>
             <a:pPr algn="ctr"/>
+            <a:endParaRPr/>
           </a:p>
         </p:txBody>
       </p:sp>
@@ -12383,6 +12637,7 @@
           <a:lstStyle/>
           <a:p>
             <a:pPr algn="ctr"/>
+            <a:endParaRPr/>
           </a:p>
         </p:txBody>
       </p:sp>
@@ -12465,7 +12720,7 @@
         <p:spPr>
           <a:xfrm>
             <a:off x="5120640" y="3246120"/>
-            <a:ext cx="3474720" cy="548640"/>
+            <a:ext cx="3474720" cy="523220"/>
           </a:xfrm>
           <a:prstGeom prst="rect">
             <a:avLst/>
@@ -12480,7 +12735,7 @@
           <a:p>
             <a:pPr algn="l"/>
             <a:r>
-              <a:rPr sz="1400" b="0">
+              <a:rPr sz="1400" b="0" dirty="0">
                 <a:solidFill>
                   <a:srgbClr val="6A7264"/>
                 </a:solidFill>
@@ -12488,6 +12743,21 @@
               </a:rPr>
               <a:t>Mid-cycle changes live only in spreadsheets</a:t>
             </a:r>
+            <a:r>
+              <a:rPr lang="en-US" sz="1400" b="0" dirty="0">
+                <a:solidFill>
+                  <a:srgbClr val="6A7264"/>
+                </a:solidFill>
+                <a:latin typeface="Arial"/>
+              </a:rPr>
+              <a:t> an not accessible </a:t>
+            </a:r>
+            <a:endParaRPr sz="1400" b="0" dirty="0">
+              <a:solidFill>
+                <a:srgbClr val="6A7264"/>
+              </a:solidFill>
+              <a:latin typeface="Arial"/>
+            </a:endParaRPr>
           </a:p>
         </p:txBody>
       </p:sp>
@@ -12500,7 +12770,7 @@
         <p:spPr>
           <a:xfrm>
             <a:off x="8686800" y="3246120"/>
-            <a:ext cx="2926080" cy="548640"/>
+            <a:ext cx="2926080" cy="307777"/>
           </a:xfrm>
           <a:prstGeom prst="rect">
             <a:avLst/>
@@ -12515,14 +12785,29 @@
           <a:p>
             <a:pPr algn="l"/>
             <a:r>
-              <a:rPr sz="1400" b="1">
+              <a:rPr sz="1400" b="1" dirty="0">
                 <a:solidFill>
                   <a:srgbClr val="4F8F12"/>
                 </a:solidFill>
                 <a:latin typeface="Arial"/>
               </a:rPr>
-              <a:t>Manual update in-product</a:t>
-            </a:r>
+              <a:t>Manual update</a:t>
+            </a:r>
+            <a:r>
+              <a:rPr lang="en-US" sz="1400" b="1" dirty="0">
+                <a:solidFill>
+                  <a:srgbClr val="4F8F12"/>
+                </a:solidFill>
+                <a:latin typeface="Arial"/>
+              </a:rPr>
+              <a:t>s required</a:t>
+            </a:r>
+            <a:endParaRPr sz="1400" b="1" dirty="0">
+              <a:solidFill>
+                <a:srgbClr val="4F8F12"/>
+              </a:solidFill>
+              <a:latin typeface="Arial"/>
+            </a:endParaRPr>
           </a:p>
         </p:txBody>
       </p:sp>
@@ -12568,6 +12853,7 @@
           <a:lstStyle/>
           <a:p>
             <a:pPr algn="ctr"/>
+            <a:endParaRPr/>
           </a:p>
         </p:txBody>
       </p:sp>
@@ -12685,7 +12971,7 @@
         <p:spPr>
           <a:xfrm>
             <a:off x="8686800" y="4114799"/>
-            <a:ext cx="2926080" cy="548640"/>
+            <a:ext cx="2926080" cy="523220"/>
           </a:xfrm>
           <a:prstGeom prst="rect">
             <a:avLst/>
@@ -12700,14 +12986,29 @@
           <a:p>
             <a:pPr algn="l"/>
             <a:r>
-              <a:rPr sz="1400" b="1">
+              <a:rPr sz="1400" b="1" dirty="0">
                 <a:solidFill>
                   <a:srgbClr val="4F8F12"/>
                 </a:solidFill>
                 <a:latin typeface="Arial"/>
               </a:rPr>
-              <a:t>Explicit July close as-of</a:t>
-            </a:r>
+              <a:t>Explicit </a:t>
+            </a:r>
+            <a:r>
+              <a:rPr lang="en-US" sz="1400" b="1" dirty="0">
+                <a:solidFill>
+                  <a:srgbClr val="4F8F12"/>
+                </a:solidFill>
+                <a:latin typeface="Arial"/>
+              </a:rPr>
+              <a:t>as-of dates / real time data</a:t>
+            </a:r>
+            <a:endParaRPr sz="1400" b="1" dirty="0">
+              <a:solidFill>
+                <a:srgbClr val="4F8F12"/>
+              </a:solidFill>
+              <a:latin typeface="Arial"/>
+            </a:endParaRPr>
           </a:p>
         </p:txBody>
       </p:sp>
@@ -12753,6 +13054,7 @@
           <a:lstStyle/>
           <a:p>
             <a:pPr algn="ctr"/>
+            <a:endParaRPr/>
           </a:p>
         </p:txBody>
       </p:sp>
@@ -12800,7 +13102,7 @@
         <p:spPr>
           <a:xfrm>
             <a:off x="1828800" y="4983480"/>
-            <a:ext cx="3200400" cy="548640"/>
+            <a:ext cx="3200400" cy="338554"/>
           </a:xfrm>
           <a:prstGeom prst="rect">
             <a:avLst/>
@@ -12815,14 +13117,38 @@
           <a:p>
             <a:pPr algn="l"/>
             <a:r>
-              <a:rPr sz="1600" b="1">
+              <a:rPr sz="1600" b="1" dirty="0">
                 <a:solidFill>
                   <a:srgbClr val="1B1F17"/>
                 </a:solidFill>
                 <a:latin typeface="Arial"/>
               </a:rPr>
-              <a:t>Wrong default viz</a:t>
-            </a:r>
+              <a:t>Wrong default </a:t>
+            </a:r>
+            <a:r>
+              <a:rPr sz="1600" b="1" dirty="0" err="1">
+                <a:solidFill>
+                  <a:srgbClr val="1B1F17"/>
+                </a:solidFill>
+                <a:latin typeface="Arial"/>
+              </a:rPr>
+              <a:t>viz</a:t>
+            </a:r>
+            <a:r>
+              <a:rPr lang="en-US" sz="1600" b="1" dirty="0" err="1">
+                <a:solidFill>
+                  <a:srgbClr val="1B1F17"/>
+                </a:solidFill>
+                <a:latin typeface="Arial"/>
+              </a:rPr>
+              <a:t>ualization</a:t>
+            </a:r>
+            <a:endParaRPr sz="1600" b="1" dirty="0">
+              <a:solidFill>
+                <a:srgbClr val="1B1F17"/>
+              </a:solidFill>
+              <a:latin typeface="Arial"/>
+            </a:endParaRPr>
           </a:p>
         </p:txBody>
       </p:sp>
@@ -12975,7 +13301,7 @@
 </file>
 
 <file path=ppt/slides/slide9.xml><?xml version="1.0" encoding="utf-8"?>
-<p:sld xmlns:a="http://schemas.openxmlformats.org/drawingml/2006/main" xmlns:p="http://schemas.openxmlformats.org/presentationml/2006/main" xmlns:r="http://schemas.openxmlformats.org/officeDocument/2006/relationships">
+<p:sld xmlns:a="http://schemas.openxmlformats.org/drawingml/2006/main" xmlns:r="http://schemas.openxmlformats.org/officeDocument/2006/relationships" xmlns:p="http://schemas.openxmlformats.org/presentationml/2006/main">
   <p:cSld>
     <p:spTree>
       <p:nvGrpSpPr>
@@ -12983,7 +13309,14 @@
         <p:cNvGrpSpPr/>
         <p:nvPr/>
       </p:nvGrpSpPr>
-      <p:grpSpPr/>
+      <p:grpSpPr>
+        <a:xfrm>
+          <a:off x="0" y="0"/>
+          <a:ext cx="0" cy="0"/>
+          <a:chOff x="0" y="0"/>
+          <a:chExt cx="0" cy="0"/>
+        </a:xfrm>
+      </p:grpSpPr>
       <p:sp>
         <p:nvSpPr>
           <p:cNvPr id="2" name="Rectangle 1"/>
@@ -13024,6 +13357,7 @@
           <a:lstStyle/>
           <a:p>
             <a:pPr algn="ctr"/>
+            <a:endParaRPr/>
           </a:p>
         </p:txBody>
       </p:sp>
@@ -13036,7 +13370,7 @@
           <p:nvPr/>
         </p:nvPicPr>
         <p:blipFill>
-          <a:blip r:embed="rId2"/>
+          <a:blip r:embed="rId3"/>
           <a:stretch>
             <a:fillRect/>
           </a:stretch>
@@ -13060,7 +13394,7 @@
         <p:spPr>
           <a:xfrm>
             <a:off x="2331720" y="228600"/>
-            <a:ext cx="9144000" cy="228600"/>
+            <a:ext cx="9144000" cy="261610"/>
           </a:xfrm>
           <a:prstGeom prst="rect">
             <a:avLst/>
@@ -13075,14 +13409,20 @@
           <a:p>
             <a:pPr algn="l"/>
             <a:r>
-              <a:rPr sz="1100" b="1">
+              <a:rPr lang="en-US" sz="1100" b="1" dirty="0">
                 <a:solidFill>
                   <a:srgbClr val="4F8F12"/>
                 </a:solidFill>
                 <a:latin typeface="Arial"/>
               </a:rPr>
-              <a:t>HOW I WORK WITH THE COMPANY</a:t>
-            </a:r>
+              <a:t>Product Process</a:t>
+            </a:r>
+            <a:endParaRPr sz="1100" b="1" dirty="0">
+              <a:solidFill>
+                <a:srgbClr val="4F8F12"/>
+              </a:solidFill>
+              <a:latin typeface="Arial"/>
+            </a:endParaRPr>
           </a:p>
         </p:txBody>
       </p:sp>
@@ -13110,14 +13450,20 @@
           <a:p>
             <a:pPr algn="l"/>
             <a:r>
-              <a:rPr sz="2600" b="1">
+              <a:rPr lang="en-US" sz="2600" b="1" dirty="0">
                 <a:solidFill>
                   <a:srgbClr val="1B1F17"/>
                 </a:solidFill>
                 <a:latin typeface="Arial"/>
               </a:rPr>
-              <a:t>Product owns the problem. Partners own the constraints.</a:t>
-            </a:r>
+              <a:t>Cross-Functional Collaboration is a must</a:t>
+            </a:r>
+            <a:endParaRPr sz="2600" b="1" dirty="0">
+              <a:solidFill>
+                <a:srgbClr val="1B1F17"/>
+              </a:solidFill>
+              <a:latin typeface="Arial"/>
+            </a:endParaRPr>
           </a:p>
         </p:txBody>
       </p:sp>
@@ -13145,14 +13491,20 @@
           <a:p>
             <a:pPr algn="l"/>
             <a:r>
-              <a:rPr sz="1500" b="0">
+              <a:rPr lang="en-US" sz="1500" b="0" dirty="0">
                 <a:solidFill>
                   <a:srgbClr val="6A7264"/>
                 </a:solidFill>
                 <a:latin typeface="Arial"/>
               </a:rPr>
-              <a:t>How I’d pull Engineering, Implementation, Design, Finance, and HR into one build — not a handoff chain.</a:t>
-            </a:r>
+              <a:t>We support one another in all areas</a:t>
+            </a:r>
+            <a:endParaRPr sz="1500" b="0" dirty="0">
+              <a:solidFill>
+                <a:srgbClr val="6A7264"/>
+              </a:solidFill>
+              <a:latin typeface="Arial"/>
+            </a:endParaRPr>
           </a:p>
         </p:txBody>
       </p:sp>
@@ -13200,6 +13552,7 @@
           <a:lstStyle/>
           <a:p>
             <a:pPr algn="ctr"/>
+            <a:endParaRPr/>
           </a:p>
         </p:txBody>
       </p:sp>
@@ -13317,6 +13670,7 @@
           <a:lstStyle/>
           <a:p>
             <a:pPr algn="ctr"/>
+            <a:endParaRPr/>
           </a:p>
         </p:txBody>
       </p:sp>
@@ -13434,6 +13788,7 @@
           <a:lstStyle/>
           <a:p>
             <a:pPr algn="ctr"/>
+            <a:endParaRPr/>
           </a:p>
         </p:txBody>
       </p:sp>
@@ -13551,6 +13906,7 @@
           <a:lstStyle/>
           <a:p>
             <a:pPr algn="ctr"/>
+            <a:endParaRPr/>
           </a:p>
         </p:txBody>
       </p:sp>
@@ -13668,6 +14024,7 @@
           <a:lstStyle/>
           <a:p>
             <a:pPr algn="ctr"/>
+            <a:endParaRPr/>
           </a:p>
         </p:txBody>
       </p:sp>
@@ -13785,6 +14142,7 @@
           <a:lstStyle/>
           <a:p>
             <a:pPr algn="ctr"/>
+            <a:endParaRPr/>
           </a:p>
         </p:txBody>
       </p:sp>
@@ -14267,44 +14625,44 @@
         <a:sysClr val="window" lastClr="FFFFFF"/>
       </a:lt1>
       <a:dk2>
-        <a:srgbClr val="1F497D"/>
+        <a:srgbClr val="0E2841"/>
       </a:dk2>
       <a:lt2>
-        <a:srgbClr val="EEECE1"/>
+        <a:srgbClr val="E8E8E8"/>
       </a:lt2>
       <a:accent1>
-        <a:srgbClr val="4F81BD"/>
+        <a:srgbClr val="156082"/>
       </a:accent1>
       <a:accent2>
-        <a:srgbClr val="C0504D"/>
+        <a:srgbClr val="E97132"/>
       </a:accent2>
       <a:accent3>
-        <a:srgbClr val="9BBB59"/>
+        <a:srgbClr val="196B24"/>
       </a:accent3>
       <a:accent4>
-        <a:srgbClr val="8064A2"/>
+        <a:srgbClr val="0F9ED5"/>
       </a:accent4>
       <a:accent5>
-        <a:srgbClr val="4BACC6"/>
+        <a:srgbClr val="A02B93"/>
       </a:accent5>
       <a:accent6>
-        <a:srgbClr val="F79646"/>
+        <a:srgbClr val="4EA72E"/>
       </a:accent6>
       <a:hlink>
-        <a:srgbClr val="0000FF"/>
+        <a:srgbClr val="467886"/>
       </a:hlink>
       <a:folHlink>
-        <a:srgbClr val="800080"/>
+        <a:srgbClr val="96607D"/>
       </a:folHlink>
     </a:clrScheme>
     <a:fontScheme name="Office">
       <a:majorFont>
-        <a:latin typeface="Calibri"/>
+        <a:latin typeface="Aptos Display" panose="02110004020202020204"/>
         <a:ea typeface=""/>
         <a:cs typeface=""/>
-        <a:font script="Jpan" typeface="ＭＳ Ｐゴシック"/>
+        <a:font script="Jpan" typeface="游ゴシック Light"/>
         <a:font script="Hang" typeface="맑은 고딕"/>
-        <a:font script="Hans" typeface="宋体"/>
+        <a:font script="Hans" typeface="等线 Light"/>
         <a:font script="Hant" typeface="新細明體"/>
         <a:font script="Arab" typeface="Times New Roman"/>
         <a:font script="Hebr" typeface="Times New Roman"/>
@@ -14332,14 +14690,31 @@
         <a:font script="Viet" typeface="Times New Roman"/>
         <a:font script="Uigh" typeface="Microsoft Uighur"/>
         <a:font script="Geor" typeface="Sylfaen"/>
+        <a:font script="Armn" typeface="Arial"/>
+        <a:font script="Bugi" typeface="Leelawadee UI"/>
+        <a:font script="Bopo" typeface="Microsoft JhengHei"/>
+        <a:font script="Java" typeface="Javanese Text"/>
+        <a:font script="Lisu" typeface="Segoe UI"/>
+        <a:font script="Mymr" typeface="Myanmar Text"/>
+        <a:font script="Nkoo" typeface="Ebrima"/>
+        <a:font script="Olck" typeface="Nirmala UI"/>
+        <a:font script="Osma" typeface="Ebrima"/>
+        <a:font script="Phag" typeface="Phagspa"/>
+        <a:font script="Syrn" typeface="Estrangelo Edessa"/>
+        <a:font script="Syrj" typeface="Estrangelo Edessa"/>
+        <a:font script="Syre" typeface="Estrangelo Edessa"/>
+        <a:font script="Sora" typeface="Nirmala UI"/>
+        <a:font script="Tale" typeface="Microsoft Tai Le"/>
+        <a:font script="Talu" typeface="Microsoft New Tai Lue"/>
+        <a:font script="Tfng" typeface="Ebrima"/>
       </a:majorFont>
       <a:minorFont>
-        <a:latin typeface="Calibri"/>
+        <a:latin typeface="Aptos" panose="02110004020202020204"/>
         <a:ea typeface=""/>
         <a:cs typeface=""/>
-        <a:font script="Jpan" typeface="ＭＳ Ｐゴシック"/>
+        <a:font script="Jpan" typeface="游ゴシック"/>
         <a:font script="Hang" typeface="맑은 고딕"/>
-        <a:font script="Hans" typeface="宋体"/>
+        <a:font script="Hans" typeface="等线"/>
         <a:font script="Hant" typeface="新細明體"/>
         <a:font script="Arab" typeface="Arial"/>
         <a:font script="Hebr" typeface="Arial"/>
@@ -14367,6 +14742,23 @@
         <a:font script="Viet" typeface="Arial"/>
         <a:font script="Uigh" typeface="Microsoft Uighur"/>
         <a:font script="Geor" typeface="Sylfaen"/>
+        <a:font script="Armn" typeface="Arial"/>
+        <a:font script="Bugi" typeface="Leelawadee UI"/>
+        <a:font script="Bopo" typeface="Microsoft JhengHei"/>
+        <a:font script="Java" typeface="Javanese Text"/>
+        <a:font script="Lisu" typeface="Segoe UI"/>
+        <a:font script="Mymr" typeface="Myanmar Text"/>
+        <a:font script="Nkoo" typeface="Ebrima"/>
+        <a:font script="Olck" typeface="Nirmala UI"/>
+        <a:font script="Osma" typeface="Ebrima"/>
+        <a:font script="Phag" typeface="Phagspa"/>
+        <a:font script="Syrn" typeface="Estrangelo Edessa"/>
+        <a:font script="Syrj" typeface="Estrangelo Edessa"/>
+        <a:font script="Syre" typeface="Estrangelo Edessa"/>
+        <a:font script="Sora" typeface="Nirmala UI"/>
+        <a:font script="Tale" typeface="Microsoft Tai Le"/>
+        <a:font script="Talu" typeface="Microsoft New Tai Lue"/>
+        <a:font script="Tfng" typeface="Ebrima"/>
       </a:minorFont>
     </a:fontScheme>
     <a:fmtScheme name="Office">
@@ -14378,180 +14770,136 @@
           <a:gsLst>
             <a:gs pos="0">
               <a:schemeClr val="phClr">
-                <a:tint val="50000"/>
-                <a:satMod val="300000"/>
+                <a:lumMod val="110000"/>
+                <a:satMod val="105000"/>
+                <a:tint val="67000"/>
               </a:schemeClr>
             </a:gs>
-            <a:gs pos="35000">
+            <a:gs pos="50000">
               <a:schemeClr val="phClr">
-                <a:tint val="37000"/>
-                <a:satMod val="300000"/>
+                <a:lumMod val="105000"/>
+                <a:satMod val="103000"/>
+                <a:tint val="73000"/>
               </a:schemeClr>
             </a:gs>
             <a:gs pos="100000">
               <a:schemeClr val="phClr">
-                <a:tint val="15000"/>
-                <a:satMod val="350000"/>
+                <a:lumMod val="105000"/>
+                <a:satMod val="109000"/>
+                <a:tint val="81000"/>
               </a:schemeClr>
             </a:gs>
           </a:gsLst>
-          <a:lin ang="16200000" scaled="1"/>
+          <a:lin ang="5400000" scaled="0"/>
         </a:gradFill>
         <a:gradFill rotWithShape="1">
           <a:gsLst>
             <a:gs pos="0">
               <a:schemeClr val="phClr">
-                <a:tint val="100000"/>
+                <a:satMod val="103000"/>
+                <a:lumMod val="102000"/>
+                <a:tint val="94000"/>
+              </a:schemeClr>
+            </a:gs>
+            <a:gs pos="50000">
+              <a:schemeClr val="phClr">
+                <a:satMod val="110000"/>
+                <a:lumMod val="100000"/>
                 <a:shade val="100000"/>
-                <a:satMod val="130000"/>
               </a:schemeClr>
             </a:gs>
             <a:gs pos="100000">
               <a:schemeClr val="phClr">
-                <a:tint val="50000"/>
-                <a:shade val="100000"/>
-                <a:satMod val="350000"/>
+                <a:lumMod val="99000"/>
+                <a:satMod val="120000"/>
+                <a:shade val="78000"/>
               </a:schemeClr>
             </a:gs>
           </a:gsLst>
-          <a:lin ang="16200000" scaled="0"/>
+          <a:lin ang="5400000" scaled="0"/>
         </a:gradFill>
       </a:fillStyleLst>
       <a:lnStyleLst>
-        <a:ln w="9525" cap="flat" cmpd="sng" algn="ctr">
+        <a:ln w="12700" cap="flat" cmpd="sng" algn="ctr">
           <a:solidFill>
-            <a:schemeClr val="phClr">
-              <a:shade val="95000"/>
-              <a:satMod val="105000"/>
-            </a:schemeClr>
+            <a:schemeClr val="phClr"/>
           </a:solidFill>
           <a:prstDash val="solid"/>
+          <a:miter lim="800000"/>
+        </a:ln>
+        <a:ln w="19050" cap="flat" cmpd="sng" algn="ctr">
+          <a:solidFill>
+            <a:schemeClr val="phClr"/>
+          </a:solidFill>
+          <a:prstDash val="solid"/>
+          <a:miter lim="800000"/>
         </a:ln>
         <a:ln w="25400" cap="flat" cmpd="sng" algn="ctr">
           <a:solidFill>
             <a:schemeClr val="phClr"/>
           </a:solidFill>
           <a:prstDash val="solid"/>
-        </a:ln>
-        <a:ln w="38100" cap="flat" cmpd="sng" algn="ctr">
-          <a:solidFill>
-            <a:schemeClr val="phClr"/>
-          </a:solidFill>
-          <a:prstDash val="solid"/>
+          <a:miter lim="800000"/>
         </a:ln>
       </a:lnStyleLst>
       <a:effectStyleLst>
         <a:effectStyle>
+          <a:effectLst/>
+        </a:effectStyle>
+        <a:effectStyle>
+          <a:effectLst/>
+        </a:effectStyle>
+        <a:effectStyle>
           <a:effectLst>
-            <a:outerShdw blurRad="40000" dist="20000" dir="5400000" rotWithShape="0">
+            <a:outerShdw blurRad="57150" dist="19050" dir="5400000" algn="ctr" rotWithShape="0">
               <a:srgbClr val="000000">
-                <a:alpha val="38000"/>
+                <a:alpha val="63000"/>
               </a:srgbClr>
             </a:outerShdw>
           </a:effectLst>
-        </a:effectStyle>
-        <a:effectStyle>
-          <a:effectLst>
-            <a:outerShdw blurRad="40000" dist="23000" dir="5400000" rotWithShape="0">
-              <a:srgbClr val="000000">
-                <a:alpha val="35000"/>
-              </a:srgbClr>
-            </a:outerShdw>
-          </a:effectLst>
-        </a:effectStyle>
-        <a:effectStyle>
-          <a:effectLst>
-            <a:outerShdw blurRad="40000" dist="23000" dir="5400000" rotWithShape="0">
-              <a:srgbClr val="000000">
-                <a:alpha val="35000"/>
-              </a:srgbClr>
-            </a:outerShdw>
-          </a:effectLst>
-          <a:scene3d>
-            <a:camera prst="orthographicFront">
-              <a:rot lat="0" lon="0" rev="0"/>
-            </a:camera>
-            <a:lightRig rig="threePt" dir="t">
-              <a:rot lat="0" lon="0" rev="1200000"/>
-            </a:lightRig>
-          </a:scene3d>
-          <a:sp3d>
-            <a:bevelT w="63500" h="25400"/>
-          </a:sp3d>
         </a:effectStyle>
       </a:effectStyleLst>
       <a:bgFillStyleLst>
         <a:solidFill>
           <a:schemeClr val="phClr"/>
         </a:solidFill>
+        <a:solidFill>
+          <a:schemeClr val="phClr">
+            <a:tint val="95000"/>
+            <a:satMod val="170000"/>
+          </a:schemeClr>
+        </a:solidFill>
         <a:gradFill rotWithShape="1">
           <a:gsLst>
             <a:gs pos="0">
               <a:schemeClr val="phClr">
-                <a:tint val="40000"/>
-                <a:satMod val="350000"/>
+                <a:tint val="93000"/>
+                <a:satMod val="150000"/>
+                <a:shade val="98000"/>
+                <a:lumMod val="102000"/>
               </a:schemeClr>
             </a:gs>
-            <a:gs pos="40000">
+            <a:gs pos="50000">
               <a:schemeClr val="phClr">
-                <a:tint val="45000"/>
-                <a:shade val="99000"/>
-                <a:satMod val="350000"/>
+                <a:tint val="98000"/>
+                <a:satMod val="130000"/>
+                <a:shade val="90000"/>
+                <a:lumMod val="103000"/>
               </a:schemeClr>
             </a:gs>
             <a:gs pos="100000">
               <a:schemeClr val="phClr">
-                <a:shade val="20000"/>
-                <a:satMod val="255000"/>
+                <a:shade val="63000"/>
+                <a:satMod val="120000"/>
               </a:schemeClr>
             </a:gs>
           </a:gsLst>
-          <a:path path="circle">
-            <a:fillToRect l="50000" t="-80000" r="50000" b="180000"/>
-          </a:path>
-        </a:gradFill>
-        <a:gradFill rotWithShape="1">
-          <a:gsLst>
-            <a:gs pos="0">
-              <a:schemeClr val="phClr">
-                <a:tint val="80000"/>
-                <a:satMod val="300000"/>
-              </a:schemeClr>
-            </a:gs>
-            <a:gs pos="100000">
-              <a:schemeClr val="phClr">
-                <a:shade val="30000"/>
-                <a:satMod val="200000"/>
-              </a:schemeClr>
-            </a:gs>
-          </a:gsLst>
-          <a:path path="circle">
-            <a:fillToRect l="50000" t="50000" r="50000" b="50000"/>
-          </a:path>
+          <a:lin ang="5400000" scaled="0"/>
         </a:gradFill>
       </a:bgFillStyleLst>
     </a:fmtScheme>
   </a:themeElements>
   <a:objectDefaults>
-    <a:spDef>
-      <a:spPr/>
-      <a:bodyPr/>
-      <a:lstStyle/>
-      <a:style>
-        <a:lnRef idx="1">
-          <a:schemeClr val="accent1"/>
-        </a:lnRef>
-        <a:fillRef idx="3">
-          <a:schemeClr val="accent1"/>
-        </a:fillRef>
-        <a:effectRef idx="2">
-          <a:schemeClr val="accent1"/>
-        </a:effectRef>
-        <a:fontRef idx="minor">
-          <a:schemeClr val="lt1"/>
-        </a:fontRef>
-      </a:style>
-    </a:spDef>
     <a:lnDef>
       <a:spPr/>
       <a:bodyPr/>
@@ -14573,5 +14921,10 @@
     </a:lnDef>
   </a:objectDefaults>
   <a:extraClrSchemeLst/>
+  <a:extLst>
+    <a:ext uri="{05A4C25C-085E-4340-85A3-A5531E510DB2}">
+      <thm15:themeFamily xmlns:thm15="http://schemas.microsoft.com/office/thememl/2012/main" name="Office Theme" id="{2E142A2C-CD16-42D6-873A-C26D2A0506FA}" vid="{1BDDFF52-6CD6-40A5-AB3C-68EB2F1E4D0A}"/>
+    </a:ext>
+  </a:extLst>
 </a:theme>
 </file>
</xml_diff>

<commit_message>
Reframe slide 9 as PM partnership and close on the bus-factor takeaway.
</commit_message>
<xml_diff>
--- a/deck/Headcount_Control_Tower_Case_Study.pptx
+++ b/deck/Headcount_Control_Tower_Case_Study.pptx
@@ -659,7 +659,7 @@
           <a:lstStyle/>
           <a:p>
             <a:r>
-              <a:t>End on the problem we solve + who wins. Offer the demo.</a:t>
+              <a:t>End on the bus-factor quote. Takeaway: resilience and shared understanding, not only speed. Offer the live prototype.</a:t>
             </a:r>
           </a:p>
         </p:txBody>
@@ -1219,7 +1219,7 @@
           <a:lstStyle/>
           <a:p>
             <a:r>
-              <a:t>Speak to collaboration style: weekly triad (Product + Eng + Design), office hours with Finance/HR for glossary, Implementation in before GA so spreadsheet migration is a product requirement — not a support surprise.</a:t>
+              <a:t>Speak as a PM operating model: sit with Finance, co-design with HR, pair with Design on comprehension, negotiate with Eng on automation boundaries, and bring Implementation in before GA.</a:t>
             </a:r>
           </a:p>
         </p:txBody>
@@ -4332,7 +4332,7 @@
         <p:spPr>
           <a:xfrm>
             <a:off x="822960" y="2286000"/>
-            <a:ext cx="10058400" cy="1463040"/>
+            <a:ext cx="10058400" cy="1225977"/>
           </a:xfrm>
           <a:prstGeom prst="rect">
             <a:avLst/>
@@ -4347,14 +4347,29 @@
           <a:p>
             <a:pPr algn="l"/>
             <a:r>
-              <a:rPr sz="4200" b="1">
+              <a:rPr sz="4200" b="1" dirty="0">
                 <a:solidFill>
                   <a:srgbClr val="1B1F17"/>
                 </a:solidFill>
                 <a:latin typeface="Arial"/>
               </a:rPr>
-              <a:t>Headcount Control Tower</a:t>
-            </a:r>
+              <a:t>Headcount </a:t>
+            </a:r>
+            <a:r>
+              <a:rPr lang="en-US" sz="4200" b="1" dirty="0">
+                <a:solidFill>
+                  <a:srgbClr val="1B1F17"/>
+                </a:solidFill>
+                <a:latin typeface="Arial"/>
+              </a:rPr>
+              <a:t>Reconciliation</a:t>
+            </a:r>
+            <a:endParaRPr sz="4200" b="1" dirty="0">
+              <a:solidFill>
+                <a:srgbClr val="1B1F17"/>
+              </a:solidFill>
+              <a:latin typeface="Arial"/>
+            </a:endParaRPr>
           </a:p>
           <a:p>
             <a:pPr algn="l">
@@ -4363,7 +4378,7 @@
               </a:spcBef>
             </a:pPr>
             <a:r>
-              <a:rPr sz="2000" b="0">
+              <a:rPr sz="2000" b="0" dirty="0">
                 <a:solidFill>
                   <a:srgbClr val="6A7264"/>
                 </a:solidFill>
@@ -4731,54 +4746,112 @@
         <p:spPr>
           <a:xfrm>
             <a:off x="1005840" y="2286000"/>
-            <a:ext cx="4754880" cy="3200400"/>
-          </a:xfrm>
-          <a:prstGeom prst="rect">
-            <a:avLst/>
-          </a:prstGeom>
-          <a:noFill/>
-        </p:spPr>
-        <p:txBody>
-          <a:bodyPr wrap="square">
-            <a:spAutoFit/>
-          </a:bodyPr>
-          <a:lstStyle/>
+            <a:ext cx="4754880" cy="2354491"/>
+          </a:xfrm>
+          <a:prstGeom prst="rect">
+            <a:avLst/>
+          </a:prstGeom>
+          <a:noFill/>
+        </p:spPr>
+        <p:txBody>
+          <a:bodyPr wrap="square">
+            <a:spAutoFit/>
+          </a:bodyPr>
+          <a:lstStyle/>
+          <a:p>
+            <a:pPr marL="285750" indent="-285750" algn="l">
+              <a:buFont typeface="Arial" panose="020B0604020202020204" pitchFamily="34" charset="0"/>
+              <a:buChar char="•"/>
+            </a:pPr>
+            <a:r>
+              <a:rPr sz="1500" b="0" dirty="0">
+                <a:solidFill>
+                  <a:srgbClr val="1B1F17"/>
+                </a:solidFill>
+                <a:latin typeface="Arial"/>
+              </a:rPr>
+              <a:t>Head of Finance conversation (exact quotes)</a:t>
+            </a:r>
+            <a:endParaRPr lang="en-US" sz="1500" b="0" dirty="0">
+              <a:solidFill>
+                <a:srgbClr val="1B1F17"/>
+              </a:solidFill>
+              <a:latin typeface="Arial"/>
+            </a:endParaRPr>
+          </a:p>
+          <a:p>
+            <a:pPr marL="285750" indent="-285750" algn="l">
+              <a:buFont typeface="Arial" panose="020B0604020202020204" pitchFamily="34" charset="0"/>
+              <a:buChar char="•"/>
+            </a:pPr>
+            <a:endParaRPr lang="en-US" sz="1500" dirty="0">
+              <a:solidFill>
+                <a:srgbClr val="1B1F17"/>
+              </a:solidFill>
+              <a:latin typeface="Arial"/>
+            </a:endParaRPr>
+          </a:p>
           <a:p>
             <a:pPr algn="l"/>
-            <a:r>
-              <a:rPr sz="1500" b="0">
+            <a:endParaRPr lang="en-US" sz="1500" b="0" dirty="0">
+              <a:solidFill>
+                <a:srgbClr val="1B1F17"/>
+              </a:solidFill>
+              <a:latin typeface="Arial"/>
+            </a:endParaRPr>
+          </a:p>
+          <a:p>
+            <a:pPr marL="285750" indent="-285750" algn="l">
+              <a:buFont typeface="Arial" panose="020B0604020202020204" pitchFamily="34" charset="0"/>
+              <a:buChar char="•"/>
+            </a:pPr>
+            <a:r>
+              <a:rPr sz="1500" b="0" dirty="0">
                 <a:solidFill>
                   <a:srgbClr val="1B1F17"/>
                 </a:solidFill>
                 <a:latin typeface="Arial"/>
               </a:rPr>
-              <a:t>Head of Finance conversation (exact quotes)</a:t>
-            </a:r>
-          </a:p>
-          <a:p>
-            <a:pPr algn="l">
-              <a:spcBef>
-                <a:spcPts val="1200"/>
-              </a:spcBef>
+              <a:t>Live multi-tab workbook: approved plan / roll-forward / HC recon / net-new</a:t>
+            </a:r>
+            <a:endParaRPr lang="en-US" sz="1500" b="0" dirty="0">
+              <a:solidFill>
+                <a:srgbClr val="1B1F17"/>
+              </a:solidFill>
+              <a:latin typeface="Arial"/>
+            </a:endParaRPr>
+          </a:p>
+          <a:p>
+            <a:pPr marL="285750" indent="-285750" algn="l">
+              <a:buFont typeface="Arial" panose="020B0604020202020204" pitchFamily="34" charset="0"/>
+              <a:buChar char="•"/>
             </a:pPr>
-            <a:r>
-              <a:rPr sz="1500" b="0">
-                <a:solidFill>
-                  <a:srgbClr val="1B1F17"/>
-                </a:solidFill>
-                <a:latin typeface="Arial"/>
-              </a:rPr>
-              <a:t>Live multi-tab workbook: approved plan / roll-forward / HC recon / net-new</a:t>
-            </a:r>
-          </a:p>
-          <a:p>
-            <a:pPr algn="l">
-              <a:spcBef>
-                <a:spcPts val="1200"/>
-              </a:spcBef>
+            <a:endParaRPr lang="en-US" sz="1500" dirty="0">
+              <a:solidFill>
+                <a:srgbClr val="1B1F17"/>
+              </a:solidFill>
+              <a:latin typeface="Arial"/>
+            </a:endParaRPr>
+          </a:p>
+          <a:p>
+            <a:pPr marL="285750" indent="-285750" algn="l">
+              <a:buFont typeface="Arial" panose="020B0604020202020204" pitchFamily="34" charset="0"/>
+              <a:buChar char="•"/>
             </a:pPr>
-            <a:r>
-              <a:rPr sz="1400" b="0">
+            <a:endParaRPr lang="en-US" sz="1500" dirty="0">
+              <a:solidFill>
+                <a:srgbClr val="1B1F17"/>
+              </a:solidFill>
+              <a:latin typeface="Arial"/>
+            </a:endParaRPr>
+          </a:p>
+          <a:p>
+            <a:pPr marL="285750" indent="-285750" algn="l">
+              <a:buFont typeface="Arial" panose="020B0604020202020204" pitchFamily="34" charset="0"/>
+              <a:buChar char="•"/>
+            </a:pPr>
+            <a:r>
+              <a:rPr sz="1400" b="0" dirty="0">
                 <a:solidFill>
                   <a:srgbClr val="1B1F17"/>
                 </a:solidFill>
@@ -4879,22 +4952,25 @@
         <p:spPr>
           <a:xfrm>
             <a:off x="6629400" y="2286000"/>
-            <a:ext cx="4663440" cy="3200400"/>
-          </a:xfrm>
-          <a:prstGeom prst="rect">
-            <a:avLst/>
-          </a:prstGeom>
-          <a:noFill/>
-        </p:spPr>
-        <p:txBody>
-          <a:bodyPr wrap="square">
-            <a:spAutoFit/>
-          </a:bodyPr>
-          <a:lstStyle/>
-          <a:p>
-            <a:pPr algn="l"/>
-            <a:r>
-              <a:rPr sz="1500" b="0">
+            <a:ext cx="4663440" cy="3323987"/>
+          </a:xfrm>
+          <a:prstGeom prst="rect">
+            <a:avLst/>
+          </a:prstGeom>
+          <a:noFill/>
+        </p:spPr>
+        <p:txBody>
+          <a:bodyPr wrap="square">
+            <a:spAutoFit/>
+          </a:bodyPr>
+          <a:lstStyle/>
+          <a:p>
+            <a:pPr marL="285750" indent="-285750" algn="l">
+              <a:buFont typeface="Arial" panose="020B0604020202020204" pitchFamily="34" charset="0"/>
+              <a:buChar char="•"/>
+            </a:pPr>
+            <a:r>
+              <a:rPr sz="1500" b="0" dirty="0">
                 <a:solidFill>
                   <a:srgbClr val="1B1F17"/>
                 </a:solidFill>
@@ -4902,15 +4978,44 @@
               </a:rPr>
               <a:t>FP&amp;A lead — close ritual &amp; recon hours</a:t>
             </a:r>
-          </a:p>
-          <a:p>
-            <a:pPr algn="l">
-              <a:spcBef>
-                <a:spcPts val="1200"/>
-              </a:spcBef>
+            <a:endParaRPr lang="en-US" sz="1500" b="0" dirty="0">
+              <a:solidFill>
+                <a:srgbClr val="1B1F17"/>
+              </a:solidFill>
+              <a:latin typeface="Arial"/>
+            </a:endParaRPr>
+          </a:p>
+          <a:p>
+            <a:pPr marL="285750" indent="-285750" algn="l">
+              <a:buFont typeface="Arial" panose="020B0604020202020204" pitchFamily="34" charset="0"/>
+              <a:buChar char="•"/>
             </a:pPr>
-            <a:r>
-              <a:rPr sz="1500" b="0">
+            <a:endParaRPr lang="en-US" sz="1500" dirty="0">
+              <a:solidFill>
+                <a:srgbClr val="1B1F17"/>
+              </a:solidFill>
+              <a:latin typeface="Arial"/>
+            </a:endParaRPr>
+          </a:p>
+          <a:p>
+            <a:pPr marL="285750" indent="-285750" algn="l">
+              <a:buFont typeface="Arial" panose="020B0604020202020204" pitchFamily="34" charset="0"/>
+              <a:buChar char="•"/>
+            </a:pPr>
+            <a:endParaRPr lang="en-US" sz="1500" b="0" dirty="0">
+              <a:solidFill>
+                <a:srgbClr val="1B1F17"/>
+              </a:solidFill>
+              <a:latin typeface="Arial"/>
+            </a:endParaRPr>
+          </a:p>
+          <a:p>
+            <a:pPr marL="285750" indent="-285750" algn="l">
+              <a:buFont typeface="Arial" panose="020B0604020202020204" pitchFamily="34" charset="0"/>
+              <a:buChar char="•"/>
+            </a:pPr>
+            <a:r>
+              <a:rPr sz="1500" b="0" dirty="0">
                 <a:solidFill>
                   <a:srgbClr val="1B1F17"/>
                 </a:solidFill>
@@ -4918,47 +5023,137 @@
               </a:rPr>
               <a:t>HR ops — disposition SLA &amp; ticket path</a:t>
             </a:r>
-          </a:p>
-          <a:p>
-            <a:pPr algn="l">
-              <a:spcBef>
-                <a:spcPts val="1200"/>
-              </a:spcBef>
+            <a:endParaRPr lang="en-US" sz="1500" b="0" dirty="0">
+              <a:solidFill>
+                <a:srgbClr val="1B1F17"/>
+              </a:solidFill>
+              <a:latin typeface="Arial"/>
+            </a:endParaRPr>
+          </a:p>
+          <a:p>
+            <a:pPr marL="285750" indent="-285750" algn="l">
+              <a:buFont typeface="Arial" panose="020B0604020202020204" pitchFamily="34" charset="0"/>
+              <a:buChar char="•"/>
             </a:pPr>
-            <a:r>
-              <a:rPr sz="1500" b="0">
+            <a:endParaRPr lang="en-US" sz="1500" dirty="0">
+              <a:solidFill>
+                <a:srgbClr val="1B1F17"/>
+              </a:solidFill>
+              <a:latin typeface="Arial"/>
+            </a:endParaRPr>
+          </a:p>
+          <a:p>
+            <a:pPr marL="285750" indent="-285750" algn="l">
+              <a:buFont typeface="Arial" panose="020B0604020202020204" pitchFamily="34" charset="0"/>
+              <a:buChar char="•"/>
+            </a:pPr>
+            <a:endParaRPr lang="en-US" sz="1500" b="0" dirty="0">
+              <a:solidFill>
+                <a:srgbClr val="1B1F17"/>
+              </a:solidFill>
+              <a:latin typeface="Arial"/>
+            </a:endParaRPr>
+          </a:p>
+          <a:p>
+            <a:pPr marL="285750" indent="-285750" algn="l">
+              <a:buFont typeface="Arial" panose="020B0604020202020204" pitchFamily="34" charset="0"/>
+              <a:buChar char="•"/>
+            </a:pPr>
+            <a:r>
+              <a:rPr sz="1500" b="0" dirty="0">
                 <a:solidFill>
                   <a:srgbClr val="1B1F17"/>
                 </a:solidFill>
                 <a:latin typeface="Arial"/>
               </a:rPr>
-              <a:t>Hiring manager — request status needs</a:t>
-            </a:r>
-          </a:p>
-          <a:p>
-            <a:pPr algn="l">
-              <a:spcBef>
-                <a:spcPts val="1200"/>
-              </a:spcBef>
+              <a:t>Hiring manager — request status need</a:t>
+            </a:r>
+            <a:endParaRPr lang="en-US" sz="1500" b="0" dirty="0">
+              <a:solidFill>
+                <a:srgbClr val="1B1F17"/>
+              </a:solidFill>
+              <a:latin typeface="Arial"/>
+            </a:endParaRPr>
+          </a:p>
+          <a:p>
+            <a:pPr marL="285750" indent="-285750" algn="l">
+              <a:buFont typeface="Arial" panose="020B0604020202020204" pitchFamily="34" charset="0"/>
+              <a:buChar char="•"/>
             </a:pPr>
-            <a:r>
-              <a:rPr sz="1500" b="0">
+            <a:endParaRPr lang="en-US" sz="1500" dirty="0">
+              <a:solidFill>
+                <a:srgbClr val="1B1F17"/>
+              </a:solidFill>
+              <a:latin typeface="Arial"/>
+            </a:endParaRPr>
+          </a:p>
+          <a:p>
+            <a:pPr marL="285750" indent="-285750" algn="l">
+              <a:buFont typeface="Arial" panose="020B0604020202020204" pitchFamily="34" charset="0"/>
+              <a:buChar char="•"/>
+            </a:pPr>
+            <a:endParaRPr lang="en-US" sz="1500" b="0" dirty="0">
+              <a:solidFill>
+                <a:srgbClr val="1B1F17"/>
+              </a:solidFill>
+              <a:latin typeface="Arial"/>
+            </a:endParaRPr>
+          </a:p>
+          <a:p>
+            <a:pPr marL="285750" indent="-285750" algn="l">
+              <a:buFont typeface="Arial" panose="020B0604020202020204" pitchFamily="34" charset="0"/>
+              <a:buChar char="•"/>
+            </a:pPr>
+            <a:r>
+              <a:rPr sz="1500" b="0" dirty="0">
                 <a:solidFill>
                   <a:srgbClr val="1B1F17"/>
                 </a:solidFill>
                 <a:latin typeface="Arial"/>
               </a:rPr>
-              <a:t>Controller / CFO — board report bar</a:t>
-            </a:r>
-          </a:p>
-          <a:p>
-            <a:pPr algn="l">
-              <a:spcBef>
-                <a:spcPts val="1200"/>
-              </a:spcBef>
+              <a:t>Controller / CFO — board report b</a:t>
+            </a:r>
+            <a:r>
+              <a:rPr lang="en-US" sz="1500" b="0" dirty="0">
+                <a:solidFill>
+                  <a:srgbClr val="1B1F17"/>
+                </a:solidFill>
+                <a:latin typeface="Arial"/>
+              </a:rPr>
+              <a:t>ar</a:t>
+            </a:r>
+          </a:p>
+          <a:p>
+            <a:pPr marL="285750" indent="-285750" algn="l">
+              <a:buFont typeface="Arial" panose="020B0604020202020204" pitchFamily="34" charset="0"/>
+              <a:buChar char="•"/>
             </a:pPr>
-            <a:r>
-              <a:rPr sz="1500" b="0">
+            <a:endParaRPr lang="en-US" sz="1500" dirty="0">
+              <a:solidFill>
+                <a:srgbClr val="1B1F17"/>
+              </a:solidFill>
+              <a:latin typeface="Arial"/>
+            </a:endParaRPr>
+          </a:p>
+          <a:p>
+            <a:pPr marL="285750" indent="-285750" algn="l">
+              <a:buFont typeface="Arial" panose="020B0604020202020204" pitchFamily="34" charset="0"/>
+              <a:buChar char="•"/>
+            </a:pPr>
+            <a:endParaRPr lang="en-US" sz="1500" b="0" dirty="0">
+              <a:solidFill>
+                <a:srgbClr val="1B1F17"/>
+              </a:solidFill>
+              <a:latin typeface="Arial"/>
+            </a:endParaRPr>
+          </a:p>
+          <a:p>
+            <a:pPr marL="285750" indent="-285750" algn="l">
+              <a:buFont typeface="Arial" panose="020B0604020202020204" pitchFamily="34" charset="0"/>
+              <a:buChar char="•"/>
+            </a:pPr>
+            <a:r>
+              <a:rPr lang="en-US" sz="1500" b="0" dirty="0">
                 <a:solidFill>
                   <a:srgbClr val="1B1F17"/>
                 </a:solidFill>
@@ -7453,15 +7648,6 @@
               </a:rPr>
               <a:t>More than one person can explain the gap — so recon isn’t a single point of failure</a:t>
             </a:r>
-            <a:r>
-              <a:rPr sz="1500" b="0" dirty="0">
-                <a:solidFill>
-                  <a:srgbClr val="1B1F17"/>
-                </a:solidFill>
-                <a:latin typeface="Arial"/>
-              </a:rPr>
-              <a:t/>
-            </a:r>
           </a:p>
         </p:txBody>
       </p:sp>
@@ -8001,8 +8187,23 @@
                 </a:solidFill>
                 <a:latin typeface="Arial"/>
               </a:rPr>
-              <a:t>Solve the story gap.
-Make headcount recon understandable in 30 seconds.</a:t>
+              <a:t>“The problem is I’m the only one that reconciliation relies on. If I got hit by a bus, we’d be doomed.”</a:t>
+            </a:r>
+          </a:p>
+          <a:p>
+            <a:pPr>
+              <a:spcBef>
+                <a:spcPts val="1600"/>
+              </a:spcBef>
+            </a:pPr>
+            <a:r>
+              <a:rPr sz="1600" b="1">
+                <a:solidFill>
+                  <a:srgbClr val="4F8F12"/>
+                </a:solidFill>
+                <a:latin typeface="Arial"/>
+              </a:rPr>
+              <a:t>— Head of Finance</a:t>
             </a:r>
           </a:p>
         </p:txBody>
@@ -8031,13 +8232,13 @@
           <a:p>
             <a:pPr algn="l"/>
             <a:r>
-              <a:rPr sz="1600" b="0">
-                <a:solidFill>
-                  <a:srgbClr val="1B1F17"/>
-                </a:solidFill>
-                <a:latin typeface="Arial"/>
-              </a:rPr>
-              <a:t>Clients get trust and speed. BambooHR gets a Finance buyer who needs the HRIS at close.</a:t>
+              <a:rPr sz="1400" b="1">
+                <a:solidFill>
+                  <a:srgbClr val="4F8F12"/>
+                </a:solidFill>
+                <a:latin typeface="Arial"/>
+              </a:rPr>
+              <a:t>Key takeaway</a:t>
             </a:r>
           </a:p>
           <a:p>
@@ -8053,7 +8254,7 @@
                 </a:solidFill>
                 <a:latin typeface="Arial"/>
               </a:rPr>
-              <a:t>Problem → client why → BambooHR why → evidence → build with partners → measure.</a:t>
+              <a:t/>
             </a:r>
           </a:p>
           <a:p>
@@ -8069,7 +8270,39 @@
                 </a:solidFill>
                 <a:latin typeface="Arial"/>
               </a:rPr>
-              <a:t>AI accelerated discovery. Judgment — and Finance partner review — drove the calls.</a:t>
+              <a:t/>
+            </a:r>
+          </a:p>
+          <a:p>
+            <a:pPr>
+              <a:spcBef>
+                <a:spcPts val="1000"/>
+              </a:spcBef>
+            </a:pPr>
+            <a:r>
+              <a:rPr sz="2200" b="1">
+                <a:solidFill>
+                  <a:srgbClr val="1B1F17"/>
+                </a:solidFill>
+                <a:latin typeface="Arial"/>
+              </a:rPr>
+              <a:t>Headcount recon shouldn’t live in one person’s head — or one spreadsheet.</a:t>
+            </a:r>
+          </a:p>
+          <a:p>
+            <a:pPr>
+              <a:spcBef>
+                <a:spcPts val="1200"/>
+              </a:spcBef>
+            </a:pPr>
+            <a:r>
+              <a:rPr sz="1600" b="0">
+                <a:solidFill>
+                  <a:srgbClr val="6A7264"/>
+                </a:solidFill>
+                <a:latin typeface="Arial"/>
+              </a:rPr>
+              <a:t>Make the story shared: clear as-of, named gaps, and a path Finance and HR can both run.</a:t>
             </a:r>
           </a:p>
         </p:txBody>
@@ -8104,7 +8337,7 @@
                 </a:solidFill>
                 <a:latin typeface="Arial"/>
               </a:rPr>
-              <a:t>Live prototype in README  ·  Next: 5 interviews + one close pilot</a:t>
+              <a:t>Live prototype in README  ·  BambooHR interview case study</a:t>
             </a:r>
           </a:p>
         </p:txBody>
@@ -8426,7 +8659,7 @@
         <p:spPr>
           <a:xfrm>
             <a:off x="960120" y="3108960"/>
-            <a:ext cx="2926080" cy="2011680"/>
+            <a:ext cx="2926080" cy="1246495"/>
           </a:xfrm>
           <a:prstGeom prst="rect">
             <a:avLst/>
@@ -8447,7 +8680,25 @@
                 </a:solidFill>
                 <a:latin typeface="Arial"/>
               </a:rPr>
-              <a:t>Approved plan, working plan, and filled headcount live in different tabs — often only one Finance owner can rebuild the story.</a:t>
+              <a:t>Approved plan, working plan, and filled headcount live in different tabs</a:t>
+            </a:r>
+            <a:r>
+              <a:rPr lang="en-US" sz="1500" b="0" dirty="0">
+                <a:solidFill>
+                  <a:srgbClr val="6A7264"/>
+                </a:solidFill>
+                <a:latin typeface="Arial"/>
+              </a:rPr>
+              <a:t>, </a:t>
+            </a:r>
+            <a:r>
+              <a:rPr sz="1500" b="0" dirty="0">
+                <a:solidFill>
+                  <a:srgbClr val="6A7264"/>
+                </a:solidFill>
+                <a:latin typeface="Arial"/>
+              </a:rPr>
+              <a:t> often only one Finance owner can rebuild the story.</a:t>
             </a:r>
           </a:p>
         </p:txBody>
@@ -8579,7 +8830,7 @@
         <p:spPr>
           <a:xfrm>
             <a:off x="4709160" y="3108960"/>
-            <a:ext cx="2926080" cy="2011680"/>
+            <a:ext cx="2926080" cy="1246495"/>
           </a:xfrm>
           <a:prstGeom prst="rect">
             <a:avLst/>
@@ -8600,8 +8851,77 @@
                 </a:solidFill>
                 <a:latin typeface="Arial"/>
               </a:rPr>
-              <a:t>Marketing can be −2 vs plan with no named reason — not backfilling, role closed, or a pivot to another team.</a:t>
-            </a:r>
+              <a:t>Marketing can be −2</a:t>
+            </a:r>
+            <a:r>
+              <a:rPr lang="en-US" sz="1500" b="0" dirty="0">
+                <a:solidFill>
+                  <a:srgbClr val="6A7264"/>
+                </a:solidFill>
+                <a:latin typeface="Arial"/>
+              </a:rPr>
+              <a:t> headcount </a:t>
+            </a:r>
+            <a:r>
+              <a:rPr sz="1500" b="0" dirty="0">
+                <a:solidFill>
+                  <a:srgbClr val="6A7264"/>
+                </a:solidFill>
+                <a:latin typeface="Arial"/>
+              </a:rPr>
+              <a:t> vs plan</a:t>
+            </a:r>
+            <a:r>
+              <a:rPr lang="en-US" sz="1500" b="0" dirty="0">
+                <a:solidFill>
+                  <a:srgbClr val="6A7264"/>
+                </a:solidFill>
+                <a:latin typeface="Arial"/>
+              </a:rPr>
+              <a:t>ned headcount</a:t>
+            </a:r>
+            <a:r>
+              <a:rPr sz="1500" b="0" dirty="0">
+                <a:solidFill>
+                  <a:srgbClr val="6A7264"/>
+                </a:solidFill>
+                <a:latin typeface="Arial"/>
+              </a:rPr>
+              <a:t> with no named reason</a:t>
+            </a:r>
+            <a:r>
+              <a:rPr lang="en-US" sz="1500" b="0" dirty="0">
+                <a:solidFill>
+                  <a:srgbClr val="6A7264"/>
+                </a:solidFill>
+                <a:latin typeface="Arial"/>
+              </a:rPr>
+              <a:t> (</a:t>
+            </a:r>
+            <a:r>
+              <a:rPr sz="1500" b="0" dirty="0">
+                <a:solidFill>
+                  <a:srgbClr val="6A7264"/>
+                </a:solidFill>
+                <a:latin typeface="Arial"/>
+              </a:rPr>
+              <a:t>not backfilling, role closed, or a pivot to another team</a:t>
+            </a:r>
+            <a:r>
+              <a:rPr lang="en-US" sz="1500" b="0" dirty="0">
+                <a:solidFill>
+                  <a:srgbClr val="6A7264"/>
+                </a:solidFill>
+                <a:latin typeface="Arial"/>
+              </a:rPr>
+              <a:t>). </a:t>
+            </a:r>
+            <a:endParaRPr sz="1500" b="0" dirty="0">
+              <a:solidFill>
+                <a:srgbClr val="6A7264"/>
+              </a:solidFill>
+              <a:latin typeface="Arial"/>
+            </a:endParaRPr>
           </a:p>
         </p:txBody>
       </p:sp>
@@ -8732,7 +9052,7 @@
         <p:spPr>
           <a:xfrm>
             <a:off x="8458199" y="3108960"/>
-            <a:ext cx="2926080" cy="2011680"/>
+            <a:ext cx="2926080" cy="1246495"/>
           </a:xfrm>
           <a:prstGeom prst="rect">
             <a:avLst/>
@@ -8747,13 +9067,31 @@
           <a:p>
             <a:pPr algn="l"/>
             <a:r>
-              <a:rPr sz="1500" b="0">
+              <a:rPr sz="1500" b="0" dirty="0">
                 <a:solidFill>
                   <a:srgbClr val="6A7264"/>
                 </a:solidFill>
                 <a:latin typeface="Arial"/>
               </a:rPr>
-              <a:t>Is this as of today or as of month-end close? Without a trusted as-of, every recon rebuilds trust from scratch.</a:t>
+              <a:t>Is this as of today or as of month-end close? Without a trusted as-of, every recon</a:t>
+            </a:r>
+            <a:r>
+              <a:rPr lang="en-US" sz="1500" b="0" dirty="0">
+                <a:solidFill>
+                  <a:srgbClr val="6A7264"/>
+                </a:solidFill>
+                <a:latin typeface="Arial"/>
+              </a:rPr>
+              <a:t>ciliation</a:t>
+            </a:r>
+            <a:r>
+              <a:rPr sz="1500" b="0" dirty="0">
+                <a:solidFill>
+                  <a:srgbClr val="6A7264"/>
+                </a:solidFill>
+                <a:latin typeface="Arial"/>
+              </a:rPr>
+              <a:t> rebuilds trust from scratch.</a:t>
             </a:r>
           </a:p>
         </p:txBody>
@@ -9578,7 +9916,7 @@
         <p:spPr>
           <a:xfrm>
             <a:off x="3200400" y="4937759"/>
-            <a:ext cx="4846320" cy="640080"/>
+            <a:ext cx="4846320" cy="553998"/>
           </a:xfrm>
           <a:prstGeom prst="rect">
             <a:avLst/>
@@ -9593,13 +9931,31 @@
           <a:p>
             <a:pPr algn="l"/>
             <a:r>
-              <a:rPr sz="1500" b="0">
+              <a:rPr sz="1500" b="0" dirty="0">
                 <a:solidFill>
                   <a:srgbClr val="1B1F17"/>
                 </a:solidFill>
                 <a:latin typeface="Arial"/>
               </a:rPr>
-              <a:t>Trust the as-of date and named drivers — even if the FP&amp;A owner is out</a:t>
+              <a:t>Trust the as-of date and named drivers</a:t>
+            </a:r>
+            <a:r>
+              <a:rPr lang="en-US" sz="1500" b="0" dirty="0">
+                <a:solidFill>
+                  <a:srgbClr val="1B1F17"/>
+                </a:solidFill>
+                <a:latin typeface="Arial"/>
+              </a:rPr>
+              <a:t>, </a:t>
+            </a:r>
+            <a:r>
+              <a:rPr sz="1500" b="0" dirty="0">
+                <a:solidFill>
+                  <a:srgbClr val="1B1F17"/>
+                </a:solidFill>
+                <a:latin typeface="Arial"/>
+              </a:rPr>
+              <a:t> even if the FP&amp;A owner is out</a:t>
             </a:r>
           </a:p>
         </p:txBody>
@@ -9635,24 +9991,6 @@
                 <a:latin typeface="Arial"/>
               </a:rPr>
               <a:t>Business continuity · decisions on people cost, not one person’s spreadsheet</a:t>
-            </a:r>
-            <a:r>
-              <a:rPr lang="en-US" sz="1400" b="1" dirty="0">
-                <a:solidFill>
-                  <a:srgbClr val="4F8F12"/>
-                </a:solidFill>
-                <a:latin typeface="Arial"/>
-              </a:rPr>
-              <a:t/>
-            </a:r>
-            <a:r>
-              <a:rPr sz="1400" b="1" dirty="0">
-                <a:solidFill>
-                  <a:srgbClr val="4F8F12"/>
-                </a:solidFill>
-                <a:latin typeface="Arial"/>
-              </a:rPr>
-              <a:t/>
             </a:r>
           </a:p>
         </p:txBody>
@@ -10626,14 +10964,20 @@
           <a:p>
             <a:pPr algn="l"/>
             <a:r>
-              <a:rPr sz="2600" b="1">
+              <a:rPr lang="en-US" sz="2600" b="1" dirty="0">
                 <a:solidFill>
                   <a:srgbClr val="1B1F17"/>
                 </a:solidFill>
                 <a:latin typeface="Arial"/>
               </a:rPr>
-              <a:t>A multi-tab workbook only one Finance owner can truly navigate</a:t>
-            </a:r>
+              <a:t>Spreadsheet that only the FP&amp;A leader can follow</a:t>
+            </a:r>
+            <a:endParaRPr sz="2600" b="1" dirty="0">
+              <a:solidFill>
+                <a:srgbClr val="1B1F17"/>
+              </a:solidFill>
+              <a:latin typeface="Arial"/>
+            </a:endParaRPr>
           </a:p>
         </p:txBody>
       </p:sp>
@@ -10667,7 +11011,7 @@
                 </a:solidFill>
                 <a:latin typeface="Arial"/>
               </a:rPr>
-              <a:t>Fictional Northline data — </a:t>
+              <a:t>Fictional Northline data</a:t>
             </a:r>
             <a:r>
               <a:rPr lang="en-US" sz="1500" b="0" dirty="0">
@@ -10676,7 +11020,7 @@
                 </a:solidFill>
                 <a:latin typeface="Arial"/>
               </a:rPr>
-              <a:t>This is a real spreadsheet from a Head of Finance but with numbers and roles changed to protect confidentiality </a:t>
+              <a:t>: This is a real spreadsheet from a Head of Finance but with numbers and roles changed to protect confidentiality </a:t>
             </a:r>
             <a:endParaRPr sz="1500" b="0" dirty="0">
               <a:solidFill>
@@ -11038,13 +11382,31 @@
           <a:p>
             <a:pPr algn="l"/>
             <a:r>
-              <a:rPr sz="2000" b="0">
+              <a:rPr sz="2000" b="0" dirty="0">
                 <a:solidFill>
                   <a:srgbClr val="1B1F17"/>
                 </a:solidFill>
                 <a:latin typeface="Arial"/>
               </a:rPr>
-              <a:t>“Reconciliation is critical, but the presentation tools are complicated and nobody understands them”</a:t>
+              <a:t>“Reconciliation is critical, but the presentation tools are </a:t>
+            </a:r>
+            <a:r>
+              <a:rPr lang="en-US" sz="2000" b="0" dirty="0">
+                <a:solidFill>
+                  <a:srgbClr val="1B1F17"/>
+                </a:solidFill>
+                <a:latin typeface="Arial"/>
+              </a:rPr>
+              <a:t>complicated,</a:t>
+            </a:r>
+            <a:r>
+              <a:rPr sz="2000" b="0" dirty="0">
+                <a:solidFill>
+                  <a:srgbClr val="1B1F17"/>
+                </a:solidFill>
+                <a:latin typeface="Arial"/>
+              </a:rPr>
+              <a:t> and nobody understands them”</a:t>
             </a:r>
           </a:p>
           <a:p>
@@ -11054,7 +11416,7 @@
               </a:spcBef>
             </a:pPr>
             <a:r>
-              <a:rPr sz="1400" b="1">
+              <a:rPr sz="1400" b="1" dirty="0">
                 <a:solidFill>
                   <a:srgbClr val="4F8F12"/>
                 </a:solidFill>
@@ -11137,7 +11499,7 @@
           <a:p>
             <a:pPr algn="l"/>
             <a:r>
-              <a:rPr sz="2000" b="0">
+              <a:rPr sz="2000" b="0" dirty="0">
                 <a:solidFill>
                   <a:srgbClr val="1B1F17"/>
                 </a:solidFill>
@@ -11153,7 +11515,7 @@
               </a:spcBef>
             </a:pPr>
             <a:r>
-              <a:rPr sz="1400" b="1">
+              <a:rPr sz="1400" b="1" dirty="0">
                 <a:solidFill>
                   <a:srgbClr val="4F8F12"/>
                 </a:solidFill>
@@ -11276,6 +11638,7 @@
           <a:lstStyle/>
           <a:p>
             <a:pPr algn="ctr"/>
+            <a:endParaRPr/>
           </a:p>
         </p:txBody>
       </p:sp>
@@ -11288,21 +11651,21 @@
         <p:spPr>
           <a:xfrm>
             <a:off x="1051560" y="3172968"/>
-            <a:ext cx="10241280" cy="1097280"/>
-          </a:xfrm>
-          <a:prstGeom prst="rect">
-            <a:avLst/>
-          </a:prstGeom>
-          <a:noFill/>
-        </p:spPr>
-        <p:txBody>
-          <a:bodyPr wrap="square">
-            <a:spAutoFit/>
-          </a:bodyPr>
-          <a:lstStyle/>
-          <a:p>
-            <a:r>
-              <a:rPr sz="1700" b="0">
+            <a:ext cx="10241280" cy="1036181"/>
+          </a:xfrm>
+          <a:prstGeom prst="rect">
+            <a:avLst/>
+          </a:prstGeom>
+          <a:noFill/>
+        </p:spPr>
+        <p:txBody>
+          <a:bodyPr wrap="square">
+            <a:spAutoFit/>
+          </a:bodyPr>
+          <a:lstStyle/>
+          <a:p>
+            <a:r>
+              <a:rPr sz="2000" b="0" dirty="0">
                 <a:solidFill>
                   <a:srgbClr val="1B1F17"/>
                 </a:solidFill>
@@ -11318,13 +11681,31 @@
               </a:spcBef>
             </a:pPr>
             <a:r>
-              <a:rPr sz="1300" b="1">
+              <a:rPr sz="1300" b="1" dirty="0">
                 <a:solidFill>
                   <a:srgbClr val="4F8F12"/>
                 </a:solidFill>
                 <a:latin typeface="Arial"/>
               </a:rPr>
-              <a:t>— Head of Finance  ·  Key-person / bus-factor risk</a:t>
+              <a:t>— Head of Finance  ·  Key-person / bus</a:t>
+            </a:r>
+            <a:r>
+              <a:rPr lang="en-US" sz="1300" b="1" dirty="0">
+                <a:solidFill>
+                  <a:srgbClr val="4F8F12"/>
+                </a:solidFill>
+                <a:latin typeface="Arial"/>
+              </a:rPr>
+              <a:t>iness</a:t>
+            </a:r>
+            <a:r>
+              <a:rPr sz="1300" b="1" dirty="0">
+                <a:solidFill>
+                  <a:srgbClr val="4F8F12"/>
+                </a:solidFill>
+                <a:latin typeface="Arial"/>
+              </a:rPr>
+              <a:t>-factor risk</a:t>
             </a:r>
           </a:p>
         </p:txBody>
@@ -13497,7 +13878,7 @@
                 </a:solidFill>
                 <a:latin typeface="Arial"/>
               </a:rPr>
-              <a:t>We support one another in all areas</a:t>
+              <a:t>How a strong PM partners with each team — not a RACI of their jobs</a:t>
             </a:r>
             <a:endParaRPr sz="1500" b="0" dirty="0">
               <a:solidFill>
@@ -13621,7 +14002,7 @@
                 </a:solidFill>
                 <a:latin typeface="Arial"/>
               </a:rPr>
-              <a:t>Frame the problem, cut scope, keep the decision log. Protect the 30-second story.</a:t>
+              <a:t>I own the problem statement and the cuts. I keep a visible decision log so Engineering and Design never guess what “done” means.</a:t>
             </a:r>
           </a:p>
         </p:txBody>
@@ -13739,7 +14120,7 @@
                 </a:solidFill>
                 <a:latin typeface="Arial"/>
               </a:rPr>
-              <a:t>Define approved plan vs working plan vs filled. Validate as-of rules and variance language.</a:t>
+              <a:t>I sit in their close ritual. I learn their words — approved plan, working plan, filled — and pressure-test every screen against a real recon week.</a:t>
             </a:r>
           </a:p>
         </p:txBody>
@@ -13857,7 +14238,7 @@
                 </a:solidFill>
                 <a:latin typeface="Arial"/>
               </a:rPr>
-              <a:t>Own disposition definitions (backfill, not backfilling, pivot) and the approval path.</a:t>
+              <a:t>I co-design dispositions inside HR’s flow, not as a Finance bolt-on. If they won’t tag a Tuesday attrition, the product failed.</a:t>
             </a:r>
           </a:p>
         </p:txBody>
@@ -13975,7 +14356,7 @@
                 </a:solidFill>
                 <a:latin typeface="Arial"/>
               </a:rPr>
-              <a:t>Comprehension first. Kill jargon. Test that a new user can read the gap in one pass.</a:t>
+              <a:t>I pair early on the 30-second test: can a first-time user explain the gap? If not, we redesign before we add features.</a:t>
             </a:r>
           </a:p>
         </p:txBody>
@@ -14093,7 +14474,7 @@
                 </a:solidFill>
                 <a:latin typeface="Arial"/>
               </a:rPr>
-              <a:t>Source of truth, audit trail, and what can be automated vs what must stay a manual update.</a:t>
+              <a:t>I negotiate automation vs manual update with them. We agree source of truth, audit, and what’s intentionally human — before we write tickets.</a:t>
             </a:r>
           </a:p>
         </p:txBody>
@@ -14211,7 +14592,7 @@
                 </a:solidFill>
                 <a:latin typeface="Arial"/>
               </a:rPr>
-              <a:t>How customers adopt at close: glossary, migration from spreadsheets, pilot success criteria.</a:t>
+              <a:t>I pull them in before GA. Spreadsheet migration, glossary, and pilot success criteria are product work — not a surprise for support.</a:t>
             </a:r>
           </a:p>
         </p:txBody>

</xml_diff>

<commit_message>
Clean up closing-slide takeaway spacing.
</commit_message>
<xml_diff>
--- a/deck/Headcount_Control_Tower_Case_Study.pptx
+++ b/deck/Headcount_Control_Tower_Case_Study.pptx
@@ -8230,7 +8230,11 @@
           </a:bodyPr>
           <a:lstStyle/>
           <a:p>
-            <a:pPr algn="l"/>
+            <a:pPr algn="l">
+              <a:spcBef>
+                <a:spcPts val="0"/>
+              </a:spcBef>
+            </a:pPr>
             <a:r>
               <a:rPr sz="1400" b="1">
                 <a:solidFill>
@@ -8267,6 +8271,38 @@
               <a:rPr sz="1600" b="1">
                 <a:solidFill>
                   <a:srgbClr val="4F8F12"/>
+                </a:solidFill>
+                <a:latin typeface="Arial"/>
+              </a:rPr>
+              <a:t/>
+            </a:r>
+          </a:p>
+          <a:p>
+            <a:pPr>
+              <a:spcBef>
+                <a:spcPts val="1000"/>
+              </a:spcBef>
+            </a:pPr>
+            <a:r>
+              <a:rPr sz="2200" b="1">
+                <a:solidFill>
+                  <a:srgbClr val="1B1F17"/>
+                </a:solidFill>
+                <a:latin typeface="Arial"/>
+              </a:rPr>
+              <a:t/>
+            </a:r>
+          </a:p>
+          <a:p>
+            <a:pPr>
+              <a:spcBef>
+                <a:spcPts val="1200"/>
+              </a:spcBef>
+            </a:pPr>
+            <a:r>
+              <a:rPr sz="1600" b="0">
+                <a:solidFill>
+                  <a:srgbClr val="6A7264"/>
                 </a:solidFill>
                 <a:latin typeface="Arial"/>
               </a:rPr>

</xml_diff>

<commit_message>
Fix closing-slide takeaway formatting.
</commit_message>
<xml_diff>
--- a/deck/Headcount_Control_Tower_Case_Study.pptx
+++ b/deck/Headcount_Control_Tower_Case_Study.pptx
@@ -8210,7 +8210,42 @@
       </p:sp>
       <p:sp>
         <p:nvSpPr>
-          <p:cNvPr id="5" name="TextBox 4"/>
+          <p:cNvPr id="6" name="TextBox 5"/>
+          <p:cNvSpPr txBox="1"/>
+          <p:nvPr/>
+        </p:nvSpPr>
+        <p:spPr>
+          <a:xfrm>
+            <a:off x="822960" y="5669280"/>
+            <a:ext cx="10058400" cy="365760"/>
+          </a:xfrm>
+          <a:prstGeom prst="rect">
+            <a:avLst/>
+          </a:prstGeom>
+          <a:noFill/>
+        </p:spPr>
+        <p:txBody>
+          <a:bodyPr wrap="square">
+            <a:spAutoFit/>
+          </a:bodyPr>
+          <a:lstStyle/>
+          <a:p>
+            <a:pPr algn="l"/>
+            <a:r>
+              <a:rPr sz="1400" b="0">
+                <a:solidFill>
+                  <a:srgbClr val="6A7264"/>
+                </a:solidFill>
+                <a:latin typeface="Arial"/>
+              </a:rPr>
+              <a:t>Live prototype in README  ·  BambooHR interview case study</a:t>
+            </a:r>
+          </a:p>
+        </p:txBody>
+      </p:sp>
+      <p:sp>
+        <p:nvSpPr>
+          <p:cNvPr id="7" name="TextBox 6"/>
           <p:cNvSpPr txBox="1"/>
           <p:nvPr/>
         </p:nvSpPr>
@@ -8230,7 +8265,7 @@
           </a:bodyPr>
           <a:lstStyle/>
           <a:p>
-            <a:pPr algn="l">
+            <a:pPr>
               <a:spcBef>
                 <a:spcPts val="0"/>
               </a:spcBef>
@@ -8246,51 +8281,19 @@
             </a:r>
           </a:p>
           <a:p>
-            <a:pPr algn="l">
+            <a:pPr>
               <a:spcBef>
-                <a:spcPts val="1000"/>
+                <a:spcPts val="1400"/>
               </a:spcBef>
             </a:pPr>
             <a:r>
-              <a:rPr sz="1600" b="0">
+              <a:rPr sz="2200" b="1">
                 <a:solidFill>
                   <a:srgbClr val="1B1F17"/>
                 </a:solidFill>
                 <a:latin typeface="Arial"/>
               </a:rPr>
-              <a:t/>
-            </a:r>
-          </a:p>
-          <a:p>
-            <a:pPr algn="l">
-              <a:spcBef>
-                <a:spcPts val="1000"/>
-              </a:spcBef>
-            </a:pPr>
-            <a:r>
-              <a:rPr sz="1600" b="1">
-                <a:solidFill>
-                  <a:srgbClr val="4F8F12"/>
-                </a:solidFill>
-                <a:latin typeface="Arial"/>
-              </a:rPr>
-              <a:t/>
-            </a:r>
-          </a:p>
-          <a:p>
-            <a:pPr>
-              <a:spcBef>
-                <a:spcPts val="1000"/>
-              </a:spcBef>
-            </a:pPr>
-            <a:r>
-              <a:rPr sz="2200" b="1">
-                <a:solidFill>
-                  <a:srgbClr val="1B1F17"/>
-                </a:solidFill>
-                <a:latin typeface="Arial"/>
-              </a:rPr>
-              <a:t/>
+              <a:t>Headcount recon shouldn’t live in one person’s head — or one spreadsheet.</a:t>
             </a:r>
           </a:p>
           <a:p>
@@ -8306,74 +8309,7 @@
                 </a:solidFill>
                 <a:latin typeface="Arial"/>
               </a:rPr>
-              <a:t/>
-            </a:r>
-          </a:p>
-          <a:p>
-            <a:pPr>
-              <a:spcBef>
-                <a:spcPts val="1000"/>
-              </a:spcBef>
-            </a:pPr>
-            <a:r>
-              <a:rPr sz="2200" b="1">
-                <a:solidFill>
-                  <a:srgbClr val="1B1F17"/>
-                </a:solidFill>
-                <a:latin typeface="Arial"/>
-              </a:rPr>
-              <a:t>Headcount recon shouldn’t live in one person’s head — or one spreadsheet.</a:t>
-            </a:r>
-          </a:p>
-          <a:p>
-            <a:pPr>
-              <a:spcBef>
-                <a:spcPts val="1200"/>
-              </a:spcBef>
-            </a:pPr>
-            <a:r>
-              <a:rPr sz="1600" b="0">
-                <a:solidFill>
-                  <a:srgbClr val="6A7264"/>
-                </a:solidFill>
-                <a:latin typeface="Arial"/>
-              </a:rPr>
               <a:t>Make the story shared: clear as-of, named gaps, and a path Finance and HR can both run.</a:t>
-            </a:r>
-          </a:p>
-        </p:txBody>
-      </p:sp>
-      <p:sp>
-        <p:nvSpPr>
-          <p:cNvPr id="6" name="TextBox 5"/>
-          <p:cNvSpPr txBox="1"/>
-          <p:nvPr/>
-        </p:nvSpPr>
-        <p:spPr>
-          <a:xfrm>
-            <a:off x="822960" y="5669280"/>
-            <a:ext cx="10058400" cy="365760"/>
-          </a:xfrm>
-          <a:prstGeom prst="rect">
-            <a:avLst/>
-          </a:prstGeom>
-          <a:noFill/>
-        </p:spPr>
-        <p:txBody>
-          <a:bodyPr wrap="square">
-            <a:spAutoFit/>
-          </a:bodyPr>
-          <a:lstStyle/>
-          <a:p>
-            <a:pPr algn="l"/>
-            <a:r>
-              <a:rPr sz="1400" b="0">
-                <a:solidFill>
-                  <a:srgbClr val="6A7264"/>
-                </a:solidFill>
-                <a:latin typeface="Arial"/>
-              </a:rPr>
-              <a:t>Live prototype in README  ·  BambooHR interview case study</a:t>
             </a:r>
           </a:p>
         </p:txBody>

</xml_diff>

<commit_message>
Simplify the Who Benefits slide to one clear green benefit per role.
</commit_message>
<xml_diff>
--- a/deck/Headcount_Control_Tower_Case_Study.pptx
+++ b/deck/Headcount_Control_Tower_Case_Study.pptx
@@ -5,24 +5,24 @@
     <p:sldMasterId id="2147483648" r:id="rId1"/>
   </p:sldMasterIdLst>
   <p:notesMasterIdLst>
-    <p:notesMasterId r:id="rId16"/>
+    <p:notesMasterId r:id="rId17"/>
   </p:notesMasterIdLst>
   <p:sldIdLst>
     <p:sldId id="256" r:id="rId2"/>
-    <p:sldId id="270" r:id="rId21"/>
-    <p:sldId id="257" r:id="rId3"/>
-    <p:sldId id="258" r:id="rId4"/>
-    <p:sldId id="259" r:id="rId5"/>
-    <p:sldId id="260" r:id="rId6"/>
-    <p:sldId id="261" r:id="rId7"/>
-    <p:sldId id="262" r:id="rId8"/>
-    <p:sldId id="263" r:id="rId9"/>
-    <p:sldId id="264" r:id="rId10"/>
-    <p:sldId id="265" r:id="rId11"/>
-    <p:sldId id="266" r:id="rId12"/>
-    <p:sldId id="267" r:id="rId13"/>
-    <p:sldId id="268" r:id="rId14"/>
-    <p:sldId id="269" r:id="rId15"/>
+    <p:sldId id="270" r:id="rId3"/>
+    <p:sldId id="257" r:id="rId4"/>
+    <p:sldId id="258" r:id="rId5"/>
+    <p:sldId id="259" r:id="rId6"/>
+    <p:sldId id="260" r:id="rId7"/>
+    <p:sldId id="261" r:id="rId8"/>
+    <p:sldId id="262" r:id="rId9"/>
+    <p:sldId id="263" r:id="rId10"/>
+    <p:sldId id="264" r:id="rId11"/>
+    <p:sldId id="265" r:id="rId12"/>
+    <p:sldId id="266" r:id="rId13"/>
+    <p:sldId id="267" r:id="rId14"/>
+    <p:sldId id="268" r:id="rId15"/>
+    <p:sldId id="269" r:id="rId16"/>
   </p:sldIdLst>
   <p:sldSz cx="12192000" cy="6858000"/>
   <p:notesSz cx="6858000" cy="9144000"/>
@@ -380,7 +380,7 @@
           <a:lstStyle/>
           <a:p>
             <a:r>
-              <a:t>Honesty: one deep signal + artifact now; structured interviews before scale.</a:t>
+              <a:t>Speak as a PM operating model: sit with Finance, co-design with HR, pair with Design on comprehension, negotiate with Eng on automation boundaries, and bring Implementation in before GA.</a:t>
             </a:r>
           </a:p>
         </p:txBody>
@@ -450,7 +450,7 @@
           <a:lstStyle/>
           <a:p>
             <a:r>
-              <a:t>Partner feedback drove cuts: contractors out; named Marketing −2; pivots; July close vs viewing date; manual update.</a:t>
+              <a:t>Honesty: one deep signal + artifact now; structured interviews before scale.</a:t>
             </a:r>
           </a:p>
         </p:txBody>
@@ -520,7 +520,7 @@
           <a:lstStyle/>
           <a:p>
             <a:r>
-              <a:t>North star: time to understand headcount at a given close date.</a:t>
+              <a:t>Partner feedback drove cuts: contractors out; named Marketing −2; pivots; July close vs viewing date; manual update.</a:t>
             </a:r>
           </a:p>
         </p:txBody>
@@ -590,7 +590,7 @@
           <a:lstStyle/>
           <a:p>
             <a:r>
-              <a:t>Stay humble on ROI. Point back to market recon-time evidence + partner’s lived spreadsheet pain.</a:t>
+              <a:t>North star: time to understand headcount at a given close date.</a:t>
             </a:r>
           </a:p>
         </p:txBody>
@@ -660,7 +660,7 @@
           <a:lstStyle/>
           <a:p>
             <a:r>
-              <a:t>End on the bus-factor quote. Takeaway: resilience and shared understanding, not only speed. Offer the live prototype.</a:t>
+              <a:t>Stay humble on ROI. Point back to market recon-time evidence + partner’s lived spreadsheet pain.</a:t>
             </a:r>
           </a:p>
         </p:txBody>
@@ -686,7 +686,7 @@
 </file>
 
 <file path=ppt/notesSlides/notesSlide15.xml><?xml version="1.0" encoding="utf-8"?>
-<p:notes xmlns:a="http://schemas.openxmlformats.org/drawingml/2006/main" xmlns:p="http://schemas.openxmlformats.org/presentationml/2006/main" xmlns:r="http://schemas.openxmlformats.org/officeDocument/2006/relationships">
+<p:notes xmlns:a="http://schemas.openxmlformats.org/drawingml/2006/main" xmlns:r="http://schemas.openxmlformats.org/officeDocument/2006/relationships" xmlns:p="http://schemas.openxmlformats.org/presentationml/2006/main">
   <p:cSld>
     <p:spTree>
       <p:nvGrpSpPr>
@@ -702,6 +702,51 @@
           <a:chExt cx="0" cy="0"/>
         </a:xfrm>
       </p:grpSpPr>
+      <p:sp>
+        <p:nvSpPr>
+          <p:cNvPr id="2" name="Slide Image Placeholder 1"/>
+          <p:cNvSpPr>
+            <a:spLocks noGrp="1" noRot="1" noChangeAspect="1"/>
+          </p:cNvSpPr>
+          <p:nvPr>
+            <p:ph type="sldImg" idx="2"/>
+          </p:nvPr>
+        </p:nvSpPr>
+        <p:spPr/>
+      </p:sp>
+      <p:sp>
+        <p:nvSpPr>
+          <p:cNvPr id="3" name="Notes Placeholder 2"/>
+          <p:cNvSpPr>
+            <a:spLocks noGrp="1"/>
+          </p:cNvSpPr>
+          <p:nvPr>
+            <p:ph type="body" sz="quarter" idx="3"/>
+          </p:nvPr>
+        </p:nvSpPr>
+        <p:spPr/>
+        <p:txBody>
+          <a:bodyPr/>
+          <a:lstStyle/>
+          <a:p>
+            <a:r>
+              <a:t>End on the bus-factor quote. Takeaway: resilience and shared understanding, not only speed. Offer the live prototype.</a:t>
+            </a:r>
+          </a:p>
+        </p:txBody>
+      </p:sp>
+      <p:sp>
+        <p:nvSpPr>
+          <p:cNvPr id="4" name="Slide Number Placeholder 3"/>
+          <p:cNvSpPr>
+            <a:spLocks noGrp="1"/>
+          </p:cNvSpPr>
+          <p:nvPr>
+            <p:ph type="sldNum" sz="quarter" idx="5"/>
+          </p:nvPr>
+        </p:nvSpPr>
+        <p:spPr/>
+      </p:sp>
     </p:spTree>
   </p:cSld>
   <p:clrMapOvr>
@@ -727,51 +772,6 @@
           <a:chExt cx="0" cy="0"/>
         </a:xfrm>
       </p:grpSpPr>
-      <p:sp>
-        <p:nvSpPr>
-          <p:cNvPr id="2" name="Slide Image Placeholder 1"/>
-          <p:cNvSpPr>
-            <a:spLocks noGrp="1" noRot="1" noChangeAspect="1"/>
-          </p:cNvSpPr>
-          <p:nvPr>
-            <p:ph type="sldImg" idx="2"/>
-          </p:nvPr>
-        </p:nvSpPr>
-        <p:spPr/>
-      </p:sp>
-      <p:sp>
-        <p:nvSpPr>
-          <p:cNvPr id="3" name="Notes Placeholder 2"/>
-          <p:cNvSpPr>
-            <a:spLocks noGrp="1"/>
-          </p:cNvSpPr>
-          <p:nvPr>
-            <p:ph type="body" sz="quarter" idx="3"/>
-          </p:nvPr>
-        </p:nvSpPr>
-        <p:spPr/>
-        <p:txBody>
-          <a:bodyPr/>
-          <a:lstStyle/>
-          <a:p>
-            <a:r>
-              <a:t>Say this out loud: we are solving “make headcount recon understandable,” not “collect more HR data.” Rooted in a real Utah Head of Finance workflow and follow-up review.</a:t>
-            </a:r>
-          </a:p>
-        </p:txBody>
-      </p:sp>
-      <p:sp>
-        <p:nvSpPr>
-          <p:cNvPr id="4" name="Slide Number Placeholder 3"/>
-          <p:cNvSpPr>
-            <a:spLocks noGrp="1"/>
-          </p:cNvSpPr>
-          <p:nvPr>
-            <p:ph type="sldNum" sz="quarter" idx="5"/>
-          </p:nvPr>
-        </p:nvSpPr>
-        <p:spPr/>
-      </p:sp>
     </p:spTree>
   </p:cSld>
   <p:clrMapOvr>
@@ -825,7 +825,7 @@
           <a:lstStyle/>
           <a:p>
             <a:r>
-              <a:t>Client why = time, trust, shared language. Tie every prototype feature back to one of these rows.</a:t>
+              <a:t>Say this out loud: we are solving “make headcount recon understandable,” not “collect more HR data.” Rooted in a real Utah Head of Finance workflow and follow-up review.</a:t>
             </a:r>
           </a:p>
         </p:txBody>
@@ -895,7 +895,7 @@
           <a:lstStyle/>
           <a:p>
             <a:r>
-              <a:t>BambooHR why = GTM into Finance + stickiness of the close ritual. Quote is primary research — treat as directional, not a win-rate claim.</a:t>
+              <a:t>Client why = time, trust, shared language. Tie every prototype feature back to one of these rows.</a:t>
             </a:r>
           </a:p>
         </p:txBody>
@@ -965,7 +965,7 @@
           <a:lstStyle/>
           <a:p>
             <a:r>
-              <a:t>Emphasize: proprietary contact data was scrubbed. Structure is the point — 4 tabs, dense role rows, monthly columns, formulas. This is why “presentation tools are complicated and nobody understands them.”</a:t>
+              <a:t>BambooHR why = GTM into Finance + stickiness of the close ritual. Quote is primary research — treat as directional, not a win-rate claim.</a:t>
             </a:r>
           </a:p>
         </p:txBody>
@@ -1035,7 +1035,7 @@
           <a:lstStyle/>
           <a:p>
             <a:r>
-              <a:t>Lead with the bus-factor quote after the comprehension quote. Problem is not only time — institutional knowledge concentrated in one FP&amp;A owner. Product value = shared story so the company is not doomed if that person is out.</a:t>
+              <a:t>Emphasize: proprietary contact data was scrubbed. Structure is the point — 4 tabs, dense role rows, monthly columns, formulas. This is why “presentation tools are complicated and nobody understands them.”</a:t>
             </a:r>
           </a:p>
         </p:txBody>
@@ -1105,7 +1105,7 @@
           <a:lstStyle/>
           <a:p>
             <a:r>
-              <a:t>Prefer cohesion + recon-time stats. Cite carefully: Gartner via Kinnect; IJIRMPS for 14→8 days and 45% recon-time cut; PwC 25% discrepancy. Also available: Workday customer claim 60% less manual recon / 50% faster close — use only if you want vendor-sourced color.</a:t>
+              <a:t>Lead with the bus-factor quote after the comprehension quote. Problem is not only time — institutional knowledge concentrated in one FP&amp;A owner. Product value = shared story so the company is not doomed if that person is out.</a:t>
             </a:r>
           </a:p>
         </p:txBody>
@@ -1175,7 +1175,7 @@
           <a:lstStyle/>
           <a:p>
             <a:r>
-              <a:t>AI helped generate; human kept five and mapped each to a UI test.</a:t>
+              <a:t>Prefer cohesion + recon-time stats. Cite carefully: Gartner via Kinnect; IJIRMPS for 14→8 days and 45% recon-time cut; PwC 25% discrepancy. Also available: Workday customer claim 60% less manual recon / 50% faster close — use only if you want vendor-sourced color.</a:t>
             </a:r>
           </a:p>
         </p:txBody>
@@ -1245,7 +1245,7 @@
           <a:lstStyle/>
           <a:p>
             <a:r>
-              <a:t>Speak as a PM operating model: sit with Finance, co-design with HR, pair with Design on comprehension, negotiate with Eng on automation boundaries, and bring Implementation in before GA.</a:t>
+              <a:t>AI helped generate; human kept five and mapped each to a UI test.</a:t>
             </a:r>
           </a:p>
         </p:txBody>
@@ -9433,7 +9433,7 @@
 </file>
 
 <file path=ppt/slides/slide2.xml><?xml version="1.0" encoding="utf-8"?>
-<p:sld xmlns:a="http://schemas.openxmlformats.org/drawingml/2006/main" xmlns:p="http://schemas.openxmlformats.org/presentationml/2006/main" xmlns:r="http://schemas.openxmlformats.org/officeDocument/2006/relationships">
+<p:sld xmlns:a="http://schemas.openxmlformats.org/drawingml/2006/main" xmlns:r="http://schemas.openxmlformats.org/officeDocument/2006/relationships" xmlns:p="http://schemas.openxmlformats.org/presentationml/2006/main">
   <p:cSld>
     <p:spTree>
       <p:nvGrpSpPr>
@@ -9441,7 +9441,14 @@
         <p:cNvGrpSpPr/>
         <p:nvPr/>
       </p:nvGrpSpPr>
-      <p:grpSpPr/>
+      <p:grpSpPr>
+        <a:xfrm>
+          <a:off x="0" y="0"/>
+          <a:ext cx="0" cy="0"/>
+          <a:chOff x="0" y="0"/>
+          <a:chExt cx="0" cy="0"/>
+        </a:xfrm>
+      </p:grpSpPr>
       <p:sp>
         <p:nvSpPr>
           <p:cNvPr id="2" name="Rectangle 1"/>
@@ -9482,6 +9489,7 @@
           <a:lstStyle/>
           <a:p>
             <a:pPr algn="ctr"/>
+            <a:endParaRPr/>
           </a:p>
         </p:txBody>
       </p:sp>
@@ -9494,7 +9502,7 @@
           <p:nvPr/>
         </p:nvPicPr>
         <p:blipFill>
-          <a:blip r:embed="rId2"/>
+          <a:blip r:embed="rId3"/>
           <a:stretch>
             <a:fillRect/>
           </a:stretch>
@@ -9576,14 +9584,20 @@
               </a:spcBef>
             </a:pPr>
             <a:r>
-              <a:rPr sz="2600" b="1">
+              <a:rPr lang="en-US" sz="2600" b="1" dirty="0">
                 <a:solidFill>
                   <a:srgbClr val="1B1F17"/>
                 </a:solidFill>
                 <a:latin typeface="Arial"/>
               </a:rPr>
-              <a:t>What headcount reconciliation is</a:t>
-            </a:r>
+              <a:t>What is Headcount Reconciliation? </a:t>
+            </a:r>
+            <a:endParaRPr sz="2600" b="1" dirty="0">
+              <a:solidFill>
+                <a:srgbClr val="1B1F17"/>
+              </a:solidFill>
+              <a:latin typeface="Arial"/>
+            </a:endParaRPr>
           </a:p>
         </p:txBody>
       </p:sp>
@@ -9615,7 +9629,7 @@
               </a:spcBef>
             </a:pPr>
             <a:r>
-              <a:rPr sz="1500" b="0">
+              <a:rPr sz="1500" b="0" dirty="0">
                 <a:solidFill>
                   <a:srgbClr val="6A7264"/>
                 </a:solidFill>
@@ -9668,6 +9682,7 @@
           <a:lstStyle/>
           <a:p>
             <a:pPr algn="ctr"/>
+            <a:endParaRPr/>
           </a:p>
         </p:txBody>
       </p:sp>
@@ -9679,35 +9694,19 @@
         </p:nvSpPr>
         <p:spPr>
           <a:xfrm>
-            <a:off x="1005840" y="1737360"/>
-            <a:ext cx="10332720" cy="1371600"/>
-          </a:xfrm>
-          <a:prstGeom prst="rect">
-            <a:avLst/>
-          </a:prstGeom>
-          <a:noFill/>
-        </p:spPr>
-        <p:txBody>
-          <a:bodyPr wrap="square">
-            <a:spAutoFit/>
-          </a:bodyPr>
-          <a:lstStyle/>
-          <a:p>
-            <a:pPr>
-              <a:spcBef>
-                <a:spcPts val="0"/>
-              </a:spcBef>
-            </a:pPr>
-            <a:r>
-              <a:rPr sz="1300" b="1">
-                <a:solidFill>
-                  <a:srgbClr val="4F8F12"/>
-                </a:solidFill>
-                <a:latin typeface="Arial"/>
-              </a:rPr>
-              <a:t>In plain terms</a:t>
-            </a:r>
-          </a:p>
+            <a:off x="1005840" y="2032641"/>
+            <a:ext cx="10332720" cy="707886"/>
+          </a:xfrm>
+          <a:prstGeom prst="rect">
+            <a:avLst/>
+          </a:prstGeom>
+          <a:noFill/>
+        </p:spPr>
+        <p:txBody>
+          <a:bodyPr wrap="square">
+            <a:spAutoFit/>
+          </a:bodyPr>
+          <a:lstStyle/>
           <a:p>
             <a:pPr>
               <a:spcBef>
@@ -9715,13 +9714,31 @@
               </a:spcBef>
             </a:pPr>
             <a:r>
-              <a:rPr sz="2000" b="0">
+              <a:rPr sz="2000" b="0" dirty="0">
                 <a:solidFill>
                   <a:srgbClr val="1B1F17"/>
                 </a:solidFill>
                 <a:latin typeface="Arial"/>
               </a:rPr>
-              <a:t>Headcount reconciliation is comparing the hiring plan leadership approved to the people actually in roles — and explaining any difference.</a:t>
+              <a:t>Headcount reconciliation is comparing the hiring plan leadership approved to the people actually in roles</a:t>
+            </a:r>
+            <a:r>
+              <a:rPr lang="en-US" sz="2000" b="0" dirty="0">
+                <a:solidFill>
+                  <a:srgbClr val="1B1F17"/>
+                </a:solidFill>
+                <a:latin typeface="Arial"/>
+              </a:rPr>
+              <a:t>,</a:t>
+            </a:r>
+            <a:r>
+              <a:rPr sz="2000" b="0" dirty="0">
+                <a:solidFill>
+                  <a:srgbClr val="1B1F17"/>
+                </a:solidFill>
+                <a:latin typeface="Arial"/>
+              </a:rPr>
+              <a:t> and explaining any difference.</a:t>
             </a:r>
           </a:p>
         </p:txBody>
@@ -9770,6 +9787,7 @@
           <a:lstStyle/>
           <a:p>
             <a:pPr algn="ctr"/>
+            <a:endParaRPr/>
           </a:p>
         </p:txBody>
       </p:sp>
@@ -9821,7 +9839,7 @@
         <p:spPr>
           <a:xfrm>
             <a:off x="960120" y="4343400"/>
-            <a:ext cx="2971800" cy="1280160"/>
+            <a:ext cx="2971800" cy="738664"/>
           </a:xfrm>
           <a:prstGeom prst="rect">
             <a:avLst/>
@@ -9840,13 +9858,31 @@
               </a:spcBef>
             </a:pPr>
             <a:r>
-              <a:rPr sz="1400" b="0">
+              <a:rPr sz="1400" b="0" dirty="0">
                 <a:solidFill>
                   <a:srgbClr val="6A7264"/>
                 </a:solidFill>
                 <a:latin typeface="Arial"/>
               </a:rPr>
-              <a:t>How many people the company said it would hire or keep — usually locked with the budget.</a:t>
+              <a:t>How many people the company said it would hire or keep</a:t>
+            </a:r>
+            <a:r>
+              <a:rPr lang="en-US" sz="1400" b="0" dirty="0">
+                <a:solidFill>
+                  <a:srgbClr val="6A7264"/>
+                </a:solidFill>
+                <a:latin typeface="Arial"/>
+              </a:rPr>
+              <a:t>, </a:t>
+            </a:r>
+            <a:r>
+              <a:rPr sz="1400" b="0" dirty="0">
+                <a:solidFill>
+                  <a:srgbClr val="6A7264"/>
+                </a:solidFill>
+                <a:latin typeface="Arial"/>
+              </a:rPr>
+              <a:t> usually locked with the budget.</a:t>
             </a:r>
           </a:p>
         </p:txBody>
@@ -9895,6 +9931,7 @@
           <a:lstStyle/>
           <a:p>
             <a:pPr algn="ctr"/>
+            <a:endParaRPr/>
           </a:p>
         </p:txBody>
       </p:sp>
@@ -10020,6 +10057,7 @@
           <a:lstStyle/>
           <a:p>
             <a:pPr algn="ctr"/>
+            <a:endParaRPr/>
           </a:p>
         </p:txBody>
       </p:sp>
@@ -10032,7 +10070,7 @@
         <p:spPr>
           <a:xfrm>
             <a:off x="8458200" y="3840480"/>
-            <a:ext cx="2971800" cy="411480"/>
+            <a:ext cx="2971800" cy="369332"/>
           </a:xfrm>
           <a:prstGeom prst="rect">
             <a:avLst/>
@@ -10051,7 +10089,7 @@
               </a:spcBef>
             </a:pPr>
             <a:r>
-              <a:rPr sz="1800" b="1">
+              <a:rPr sz="1800" b="1" dirty="0">
                 <a:solidFill>
                   <a:srgbClr val="1B1F17"/>
                 </a:solidFill>
@@ -10059,6 +10097,21 @@
               </a:rPr>
               <a:t>The recon</a:t>
             </a:r>
+            <a:r>
+              <a:rPr lang="en-US" sz="1800" b="1" dirty="0">
+                <a:solidFill>
+                  <a:srgbClr val="1B1F17"/>
+                </a:solidFill>
+                <a:latin typeface="Arial"/>
+              </a:rPr>
+              <a:t>ciliation</a:t>
+            </a:r>
+            <a:endParaRPr sz="1800" b="1" dirty="0">
+              <a:solidFill>
+                <a:srgbClr val="1B1F17"/>
+              </a:solidFill>
+              <a:latin typeface="Arial"/>
+            </a:endParaRPr>
           </a:p>
         </p:txBody>
       </p:sp>
@@ -10110,7 +10163,7 @@
         <p:spPr>
           <a:xfrm>
             <a:off x="685800" y="6080760"/>
-            <a:ext cx="10972800" cy="365760"/>
+            <a:ext cx="10972800" cy="307777"/>
           </a:xfrm>
           <a:prstGeom prst="rect">
             <a:avLst/>
@@ -10129,13 +10182,31 @@
               </a:spcBef>
             </a:pPr>
             <a:r>
-              <a:rPr sz="1400" b="0">
+              <a:rPr sz="1400" b="0" dirty="0">
                 <a:solidFill>
                   <a:srgbClr val="1B1F17"/>
                 </a:solidFill>
                 <a:latin typeface="Arial"/>
               </a:rPr>
-              <a:t>Why it matters: people are usually the largest operating cost — so this number drives hiring, budget, and board conversations.</a:t>
+              <a:t>Why it matters: people are usually the largest operating cost</a:t>
+            </a:r>
+            <a:r>
+              <a:rPr lang="en-US" sz="1400" b="0" dirty="0">
+                <a:solidFill>
+                  <a:srgbClr val="1B1F17"/>
+                </a:solidFill>
+                <a:latin typeface="Arial"/>
+              </a:rPr>
+              <a:t>,</a:t>
+            </a:r>
+            <a:r>
+              <a:rPr sz="1400" b="0" dirty="0">
+                <a:solidFill>
+                  <a:srgbClr val="1B1F17"/>
+                </a:solidFill>
+                <a:latin typeface="Arial"/>
+              </a:rPr>
+              <a:t> so this number drives hiring, budget, and board conversations.</a:t>
             </a:r>
           </a:p>
         </p:txBody>
@@ -10531,7 +10602,7 @@
         <p:spPr>
           <a:xfrm>
             <a:off x="960120" y="3108960"/>
-            <a:ext cx="2926080" cy="1246495"/>
+            <a:ext cx="2926080" cy="1477328"/>
           </a:xfrm>
           <a:prstGeom prst="rect">
             <a:avLst/>
@@ -10570,8 +10641,23 @@
                 </a:solidFill>
                 <a:latin typeface="Arial"/>
               </a:rPr>
-              <a:t> often only one Finance owner can rebuild the story.</a:t>
-            </a:r>
+              <a:t>often only one Finance owner can rebuild the story.</a:t>
+            </a:r>
+            <a:r>
+              <a:rPr lang="en-US" sz="1500" b="0" dirty="0">
+                <a:solidFill>
+                  <a:srgbClr val="6A7264"/>
+                </a:solidFill>
+                <a:latin typeface="Arial"/>
+              </a:rPr>
+              <a:t> HR and Finance often have different numbers. </a:t>
+            </a:r>
+            <a:endParaRPr sz="1500" b="0" dirty="0">
+              <a:solidFill>
+                <a:srgbClr val="6A7264"/>
+              </a:solidFill>
+              <a:latin typeface="Arial"/>
+            </a:endParaRPr>
           </a:p>
         </p:txBody>
       </p:sp>
@@ -10904,7 +10990,7 @@
           <a:p>
             <a:pPr algn="l"/>
             <a:r>
-              <a:rPr sz="2000" b="1">
+              <a:rPr sz="2000" b="1" dirty="0">
                 <a:solidFill>
                   <a:srgbClr val="1B1F17"/>
                 </a:solidFill>
@@ -11140,7 +11226,7 @@
         <p:spPr>
           <a:xfrm>
             <a:off x="2331720" y="228600"/>
-            <a:ext cx="9144000" cy="228600"/>
+            <a:ext cx="9144000" cy="261610"/>
           </a:xfrm>
           <a:prstGeom prst="rect">
             <a:avLst/>
@@ -11155,14 +11241,29 @@
           <a:p>
             <a:pPr algn="l"/>
             <a:r>
-              <a:rPr sz="1100" b="1">
+              <a:rPr sz="1100" b="1" dirty="0">
                 <a:solidFill>
                   <a:srgbClr val="4F8F12"/>
                 </a:solidFill>
                 <a:latin typeface="Arial"/>
               </a:rPr>
-              <a:t>WHY THIS HELPS CLIENTS</a:t>
-            </a:r>
+              <a:t>W</a:t>
+            </a:r>
+            <a:r>
+              <a:rPr lang="en-US" sz="1100" b="1" dirty="0">
+                <a:solidFill>
+                  <a:srgbClr val="4F8F12"/>
+                </a:solidFill>
+                <a:latin typeface="Arial"/>
+              </a:rPr>
+              <a:t>HO BENEFITS</a:t>
+            </a:r>
+            <a:endParaRPr sz="1100" b="1" dirty="0">
+              <a:solidFill>
+                <a:srgbClr val="4F8F12"/>
+              </a:solidFill>
+              <a:latin typeface="Arial"/>
+            </a:endParaRPr>
           </a:p>
         </p:txBody>
       </p:sp>
@@ -11210,159 +11311,6 @@
         <p:spPr>
           <a:xfrm>
             <a:off x="685800" y="1463040"/>
-            <a:ext cx="2286000" cy="960120"/>
-          </a:xfrm>
-          <a:prstGeom prst="roundRect">
-            <a:avLst>
-              <a:gd name="adj" fmla="val 6000"/>
-            </a:avLst>
-          </a:prstGeom>
-          <a:solidFill>
-            <a:srgbClr val="F3F8EA"/>
-          </a:solidFill>
-          <a:ln>
-            <a:solidFill>
-              <a:srgbClr val="E6EAE1"/>
-            </a:solidFill>
-          </a:ln>
-        </p:spPr>
-        <p:style>
-          <a:lnRef idx="1">
-            <a:schemeClr val="accent1"/>
-          </a:lnRef>
-          <a:fillRef idx="3">
-            <a:schemeClr val="accent1"/>
-          </a:fillRef>
-          <a:effectRef idx="2">
-            <a:schemeClr val="accent1"/>
-          </a:effectRef>
-          <a:fontRef idx="minor">
-            <a:schemeClr val="lt1"/>
-          </a:fontRef>
-        </p:style>
-        <p:txBody>
-          <a:bodyPr rtlCol="0" anchor="ctr"/>
-          <a:lstStyle/>
-          <a:p>
-            <a:pPr algn="ctr"/>
-            <a:endParaRPr/>
-          </a:p>
-        </p:txBody>
-      </p:sp>
-      <p:sp>
-        <p:nvSpPr>
-          <p:cNvPr id="7" name="TextBox 6"/>
-          <p:cNvSpPr txBox="1"/>
-          <p:nvPr/>
-        </p:nvSpPr>
-        <p:spPr>
-          <a:xfrm>
-            <a:off x="868680" y="1737360"/>
-            <a:ext cx="1920240" cy="411480"/>
-          </a:xfrm>
-          <a:prstGeom prst="rect">
-            <a:avLst/>
-          </a:prstGeom>
-          <a:noFill/>
-        </p:spPr>
-        <p:txBody>
-          <a:bodyPr wrap="square">
-            <a:spAutoFit/>
-          </a:bodyPr>
-          <a:lstStyle/>
-          <a:p>
-            <a:pPr algn="l"/>
-            <a:r>
-              <a:rPr sz="1600" b="1">
-                <a:solidFill>
-                  <a:srgbClr val="1B1F17"/>
-                </a:solidFill>
-                <a:latin typeface="Arial"/>
-              </a:rPr>
-              <a:t>Finance</a:t>
-            </a:r>
-          </a:p>
-        </p:txBody>
-      </p:sp>
-      <p:sp>
-        <p:nvSpPr>
-          <p:cNvPr id="8" name="TextBox 7"/>
-          <p:cNvSpPr txBox="1"/>
-          <p:nvPr/>
-        </p:nvSpPr>
-        <p:spPr>
-          <a:xfrm>
-            <a:off x="3200400" y="1645920"/>
-            <a:ext cx="4846320" cy="640080"/>
-          </a:xfrm>
-          <a:prstGeom prst="rect">
-            <a:avLst/>
-          </a:prstGeom>
-          <a:noFill/>
-        </p:spPr>
-        <p:txBody>
-          <a:bodyPr wrap="square">
-            <a:spAutoFit/>
-          </a:bodyPr>
-          <a:lstStyle/>
-          <a:p>
-            <a:pPr algn="l"/>
-            <a:r>
-              <a:rPr sz="1500" b="0">
-                <a:solidFill>
-                  <a:srgbClr val="1B1F17"/>
-                </a:solidFill>
-                <a:latin typeface="Arial"/>
-              </a:rPr>
-              <a:t>Answer “where are we vs the approved hiring plan?” in one view</a:t>
-            </a:r>
-          </a:p>
-        </p:txBody>
-      </p:sp>
-      <p:sp>
-        <p:nvSpPr>
-          <p:cNvPr id="9" name="TextBox 8"/>
-          <p:cNvSpPr txBox="1"/>
-          <p:nvPr/>
-        </p:nvSpPr>
-        <p:spPr>
-          <a:xfrm>
-            <a:off x="8138160" y="1645920"/>
-            <a:ext cx="3383280" cy="640080"/>
-          </a:xfrm>
-          <a:prstGeom prst="rect">
-            <a:avLst/>
-          </a:prstGeom>
-          <a:noFill/>
-        </p:spPr>
-        <p:txBody>
-          <a:bodyPr wrap="square">
-            <a:spAutoFit/>
-          </a:bodyPr>
-          <a:lstStyle/>
-          <a:p>
-            <a:pPr algn="l"/>
-            <a:r>
-              <a:rPr sz="1400" b="1">
-                <a:solidFill>
-                  <a:srgbClr val="4F8F12"/>
-                </a:solidFill>
-                <a:latin typeface="Arial"/>
-              </a:rPr>
-              <a:t>Fewer recon threads · board-ready variance · knowledge not trapped in one person</a:t>
-            </a:r>
-          </a:p>
-        </p:txBody>
-      </p:sp>
-      <p:sp>
-        <p:nvSpPr>
-          <p:cNvPr id="10" name="Rounded Rectangle 9"/>
-          <p:cNvSpPr/>
-          <p:nvPr/>
-        </p:nvSpPr>
-        <p:spPr>
-          <a:xfrm>
-            <a:off x="685800" y="2560320"/>
             <a:ext cx="2286000" cy="960120"/>
           </a:xfrm>
           <a:prstGeom prst="roundRect">
@@ -11404,313 +11352,17 @@
       </p:sp>
       <p:sp>
         <p:nvSpPr>
-          <p:cNvPr id="11" name="TextBox 10"/>
-          <p:cNvSpPr txBox="1"/>
-          <p:nvPr/>
-        </p:nvSpPr>
-        <p:spPr>
-          <a:xfrm>
-            <a:off x="868680" y="2834640"/>
+          <p:cNvPr id="7" name="TextBox 6"/>
+          <p:cNvSpPr txBox="1"/>
+          <p:nvPr/>
+        </p:nvSpPr>
+        <p:spPr>
+          <a:xfrm>
+            <a:off x="868680" y="1737360"/>
             <a:ext cx="1920240" cy="411480"/>
           </a:xfrm>
           <a:prstGeom prst="rect">
             <a:avLst/>
-          </a:prstGeom>
-          <a:noFill/>
-        </p:spPr>
-        <p:txBody>
-          <a:bodyPr wrap="square">
-            <a:spAutoFit/>
-          </a:bodyPr>
-          <a:lstStyle/>
-          <a:p>
-            <a:pPr algn="l"/>
-            <a:r>
-              <a:rPr sz="1600" b="1">
-                <a:solidFill>
-                  <a:srgbClr val="1B1F17"/>
-                </a:solidFill>
-                <a:latin typeface="Arial"/>
-              </a:rPr>
-              <a:t>HR</a:t>
-            </a:r>
-          </a:p>
-        </p:txBody>
-      </p:sp>
-      <p:sp>
-        <p:nvSpPr>
-          <p:cNvPr id="12" name="TextBox 11"/>
-          <p:cNvSpPr txBox="1"/>
-          <p:nvPr/>
-        </p:nvSpPr>
-        <p:spPr>
-          <a:xfrm>
-            <a:off x="3200400" y="2743200"/>
-            <a:ext cx="4846320" cy="553998"/>
-          </a:xfrm>
-          <a:prstGeom prst="rect">
-            <a:avLst/>
-          </a:prstGeom>
-          <a:noFill/>
-        </p:spPr>
-        <p:txBody>
-          <a:bodyPr wrap="square">
-            <a:spAutoFit/>
-          </a:bodyPr>
-          <a:lstStyle/>
-          <a:p>
-            <a:pPr algn="l"/>
-            <a:r>
-              <a:rPr sz="1500" b="0" dirty="0">
-                <a:solidFill>
-                  <a:srgbClr val="1B1F17"/>
-                </a:solidFill>
-                <a:latin typeface="Arial"/>
-              </a:rPr>
-              <a:t>Log backfill / not backfilling / pivot once</a:t>
-            </a:r>
-            <a:r>
-              <a:rPr lang="en-US" sz="1500" b="0" dirty="0">
-                <a:solidFill>
-                  <a:srgbClr val="1B1F17"/>
-                </a:solidFill>
-                <a:latin typeface="Arial"/>
-              </a:rPr>
-              <a:t>,</a:t>
-            </a:r>
-            <a:r>
-              <a:rPr sz="1500" b="0" dirty="0">
-                <a:solidFill>
-                  <a:srgbClr val="1B1F17"/>
-                </a:solidFill>
-                <a:latin typeface="Arial"/>
-              </a:rPr>
-              <a:t> Finance sees it instantly</a:t>
-            </a:r>
-          </a:p>
-        </p:txBody>
-      </p:sp>
-      <p:sp>
-        <p:nvSpPr>
-          <p:cNvPr id="13" name="TextBox 12"/>
-          <p:cNvSpPr txBox="1"/>
-          <p:nvPr/>
-        </p:nvSpPr>
-        <p:spPr>
-          <a:xfrm>
-            <a:off x="8138160" y="2743200"/>
-            <a:ext cx="3383280" cy="640080"/>
-          </a:xfrm>
-          <a:prstGeom prst="rect">
-            <a:avLst/>
-          </a:prstGeom>
-          <a:noFill/>
-        </p:spPr>
-        <p:txBody>
-          <a:bodyPr wrap="square">
-            <a:spAutoFit/>
-          </a:bodyPr>
-          <a:lstStyle/>
-          <a:p>
-            <a:pPr algn="l"/>
-            <a:r>
-              <a:rPr sz="1400" b="1">
-                <a:solidFill>
-                  <a:srgbClr val="4F8F12"/>
-                </a:solidFill>
-                <a:latin typeface="Arial"/>
-              </a:rPr>
-              <a:t>Less spreadsheet ping-pong · clearer hiring priorities</a:t>
-            </a:r>
-          </a:p>
-        </p:txBody>
-      </p:sp>
-      <p:sp>
-        <p:nvSpPr>
-          <p:cNvPr id="14" name="Rounded Rectangle 13"/>
-          <p:cNvSpPr/>
-          <p:nvPr/>
-        </p:nvSpPr>
-        <p:spPr>
-          <a:xfrm>
-            <a:off x="685800" y="3657600"/>
-            <a:ext cx="2286000" cy="960120"/>
-          </a:xfrm>
-          <a:prstGeom prst="roundRect">
-            <a:avLst>
-              <a:gd name="adj" fmla="val 6000"/>
-            </a:avLst>
-          </a:prstGeom>
-          <a:solidFill>
-            <a:srgbClr val="F3F8EA"/>
-          </a:solidFill>
-          <a:ln>
-            <a:solidFill>
-              <a:srgbClr val="E6EAE1"/>
-            </a:solidFill>
-          </a:ln>
-        </p:spPr>
-        <p:style>
-          <a:lnRef idx="1">
-            <a:schemeClr val="accent1"/>
-          </a:lnRef>
-          <a:fillRef idx="3">
-            <a:schemeClr val="accent1"/>
-          </a:fillRef>
-          <a:effectRef idx="2">
-            <a:schemeClr val="accent1"/>
-          </a:effectRef>
-          <a:fontRef idx="minor">
-            <a:schemeClr val="lt1"/>
-          </a:fontRef>
-        </p:style>
-        <p:txBody>
-          <a:bodyPr rtlCol="0" anchor="ctr"/>
-          <a:lstStyle/>
-          <a:p>
-            <a:pPr algn="ctr"/>
-            <a:endParaRPr/>
-          </a:p>
-        </p:txBody>
-      </p:sp>
-      <p:sp>
-        <p:nvSpPr>
-          <p:cNvPr id="15" name="TextBox 14"/>
-          <p:cNvSpPr txBox="1"/>
-          <p:nvPr/>
-        </p:nvSpPr>
-        <p:spPr>
-          <a:xfrm>
-            <a:off x="868680" y="3931920"/>
-            <a:ext cx="1920240" cy="411480"/>
-          </a:xfrm>
-          <a:prstGeom prst="rect">
-            <a:avLst/>
-          </a:prstGeom>
-          <a:noFill/>
-        </p:spPr>
-        <p:txBody>
-          <a:bodyPr wrap="square">
-            <a:spAutoFit/>
-          </a:bodyPr>
-          <a:lstStyle/>
-          <a:p>
-            <a:pPr algn="l"/>
-            <a:r>
-              <a:rPr sz="1600" b="1">
-                <a:solidFill>
-                  <a:srgbClr val="1B1F17"/>
-                </a:solidFill>
-                <a:latin typeface="Arial"/>
-              </a:rPr>
-              <a:t>Managers</a:t>
-            </a:r>
-          </a:p>
-        </p:txBody>
-      </p:sp>
-      <p:sp>
-        <p:nvSpPr>
-          <p:cNvPr id="16" name="TextBox 15"/>
-          <p:cNvSpPr txBox="1"/>
-          <p:nvPr/>
-        </p:nvSpPr>
-        <p:spPr>
-          <a:xfrm>
-            <a:off x="3200400" y="3840480"/>
-            <a:ext cx="4846320" cy="640080"/>
-          </a:xfrm>
-          <a:prstGeom prst="rect">
-            <a:avLst/>
-          </a:prstGeom>
-          <a:noFill/>
-        </p:spPr>
-        <p:txBody>
-          <a:bodyPr wrap="square">
-            <a:spAutoFit/>
-          </a:bodyPr>
-          <a:lstStyle/>
-          <a:p>
-            <a:pPr algn="l"/>
-            <a:r>
-              <a:rPr sz="1500" b="0">
-                <a:solidFill>
-                  <a:srgbClr val="1B1F17"/>
-                </a:solidFill>
-                <a:latin typeface="Arial"/>
-              </a:rPr>
-              <a:t>See request status without chasing HR or FP&amp;A</a:t>
-            </a:r>
-          </a:p>
-        </p:txBody>
-      </p:sp>
-      <p:sp>
-        <p:nvSpPr>
-          <p:cNvPr id="17" name="TextBox 16"/>
-          <p:cNvSpPr txBox="1"/>
-          <p:nvPr/>
-        </p:nvSpPr>
-        <p:spPr>
-          <a:xfrm>
-            <a:off x="8138160" y="3840480"/>
-            <a:ext cx="3383280" cy="523220"/>
-          </a:xfrm>
-          <a:prstGeom prst="rect">
-            <a:avLst/>
-          </a:prstGeom>
-          <a:noFill/>
-        </p:spPr>
-        <p:txBody>
-          <a:bodyPr wrap="square">
-            <a:spAutoFit/>
-          </a:bodyPr>
-          <a:lstStyle/>
-          <a:p>
-            <a:pPr algn="l"/>
-            <a:r>
-              <a:rPr sz="1400" b="1" dirty="0">
-                <a:solidFill>
-                  <a:srgbClr val="4F8F12"/>
-                </a:solidFill>
-                <a:latin typeface="Arial"/>
-              </a:rPr>
-              <a:t>Less tribal knowledge · fewer stalled req</a:t>
-            </a:r>
-            <a:r>
-              <a:rPr lang="en-US" sz="1400" b="1" dirty="0">
-                <a:solidFill>
-                  <a:srgbClr val="4F8F12"/>
-                </a:solidFill>
-                <a:latin typeface="Arial"/>
-              </a:rPr>
-              <a:t>uirement</a:t>
-            </a:r>
-            <a:r>
-              <a:rPr sz="1400" b="1" dirty="0">
-                <a:solidFill>
-                  <a:srgbClr val="4F8F12"/>
-                </a:solidFill>
-                <a:latin typeface="Arial"/>
-              </a:rPr>
-              <a:t>s</a:t>
-            </a:r>
-          </a:p>
-        </p:txBody>
-      </p:sp>
-      <p:sp>
-        <p:nvSpPr>
-          <p:cNvPr id="18" name="Rounded Rectangle 17"/>
-          <p:cNvSpPr/>
-          <p:nvPr/>
-        </p:nvSpPr>
-        <p:spPr>
-          <a:xfrm>
-            <a:off x="685800" y="4754879"/>
-            <a:ext cx="2286000" cy="960120"/>
-          </a:xfrm>
-          <a:prstGeom prst="roundRect">
-            <a:avLst>
-              <a:gd name="adj" fmla="val 6000"/>
-            </a:avLst>
           </a:prstGeom>
           <a:solidFill>
             <a:srgbClr val="FFFFFF"/>
@@ -11721,6 +11373,50 @@
             </a:solidFill>
           </a:ln>
         </p:spPr>
+        <p:txBody>
+          <a:bodyPr wrap="square">
+            <a:spAutoFit/>
+          </a:bodyPr>
+          <a:lstStyle/>
+          <a:p>
+            <a:pPr algn="l"/>
+            <a:r>
+              <a:rPr sz="1600" b="1">
+                <a:solidFill>
+                  <a:srgbClr val="1B1F17"/>
+                </a:solidFill>
+                <a:latin typeface="Arial"/>
+              </a:rPr>
+              <a:t>Finance</a:t>
+            </a:r>
+          </a:p>
+        </p:txBody>
+      </p:sp>
+      <p:sp>
+        <p:nvSpPr>
+          <p:cNvPr id="10" name="Rounded Rectangle 9"/>
+          <p:cNvSpPr/>
+          <p:nvPr/>
+        </p:nvSpPr>
+        <p:spPr>
+          <a:xfrm>
+            <a:off x="685800" y="2560320"/>
+            <a:ext cx="2286000" cy="960120"/>
+          </a:xfrm>
+          <a:prstGeom prst="roundRect">
+            <a:avLst>
+              <a:gd name="adj" fmla="val 6000"/>
+            </a:avLst>
+          </a:prstGeom>
+          <a:solidFill>
+            <a:srgbClr val="FFFFFF"/>
+          </a:solidFill>
+          <a:ln>
+            <a:solidFill>
+              <a:srgbClr val="E6EAE1"/>
+            </a:solidFill>
+          </a:ln>
+        </p:spPr>
         <p:style>
           <a:lnRef idx="1">
             <a:schemeClr val="accent1"/>
@@ -11746,6 +11442,186 @@
       </p:sp>
       <p:sp>
         <p:nvSpPr>
+          <p:cNvPr id="11" name="TextBox 10"/>
+          <p:cNvSpPr txBox="1"/>
+          <p:nvPr/>
+        </p:nvSpPr>
+        <p:spPr>
+          <a:xfrm>
+            <a:off x="868680" y="2834640"/>
+            <a:ext cx="1920240" cy="411480"/>
+          </a:xfrm>
+          <a:prstGeom prst="rect">
+            <a:avLst/>
+          </a:prstGeom>
+          <a:solidFill>
+            <a:srgbClr val="FFFFFF"/>
+          </a:solidFill>
+          <a:ln>
+            <a:solidFill>
+              <a:srgbClr val="E6EAE1"/>
+            </a:solidFill>
+          </a:ln>
+        </p:spPr>
+        <p:txBody>
+          <a:bodyPr wrap="square">
+            <a:spAutoFit/>
+          </a:bodyPr>
+          <a:lstStyle/>
+          <a:p>
+            <a:pPr algn="l"/>
+            <a:r>
+              <a:rPr sz="1600" b="1">
+                <a:solidFill>
+                  <a:srgbClr val="1B1F17"/>
+                </a:solidFill>
+                <a:latin typeface="Arial"/>
+              </a:rPr>
+              <a:t>HR</a:t>
+            </a:r>
+          </a:p>
+        </p:txBody>
+      </p:sp>
+      <p:sp>
+        <p:nvSpPr>
+          <p:cNvPr id="14" name="Rounded Rectangle 13"/>
+          <p:cNvSpPr/>
+          <p:nvPr/>
+        </p:nvSpPr>
+        <p:spPr>
+          <a:xfrm>
+            <a:off x="685800" y="3657600"/>
+            <a:ext cx="2286000" cy="960120"/>
+          </a:xfrm>
+          <a:prstGeom prst="roundRect">
+            <a:avLst>
+              <a:gd name="adj" fmla="val 6000"/>
+            </a:avLst>
+          </a:prstGeom>
+          <a:solidFill>
+            <a:srgbClr val="FFFFFF"/>
+          </a:solidFill>
+          <a:ln>
+            <a:solidFill>
+              <a:srgbClr val="E6EAE1"/>
+            </a:solidFill>
+          </a:ln>
+        </p:spPr>
+        <p:style>
+          <a:lnRef idx="1">
+            <a:schemeClr val="accent1"/>
+          </a:lnRef>
+          <a:fillRef idx="3">
+            <a:schemeClr val="accent1"/>
+          </a:fillRef>
+          <a:effectRef idx="2">
+            <a:schemeClr val="accent1"/>
+          </a:effectRef>
+          <a:fontRef idx="minor">
+            <a:schemeClr val="lt1"/>
+          </a:fontRef>
+        </p:style>
+        <p:txBody>
+          <a:bodyPr rtlCol="0" anchor="ctr"/>
+          <a:lstStyle/>
+          <a:p>
+            <a:pPr algn="ctr"/>
+            <a:endParaRPr/>
+          </a:p>
+        </p:txBody>
+      </p:sp>
+      <p:sp>
+        <p:nvSpPr>
+          <p:cNvPr id="15" name="TextBox 14"/>
+          <p:cNvSpPr txBox="1"/>
+          <p:nvPr/>
+        </p:nvSpPr>
+        <p:spPr>
+          <a:xfrm>
+            <a:off x="868680" y="3931920"/>
+            <a:ext cx="1920240" cy="411480"/>
+          </a:xfrm>
+          <a:prstGeom prst="rect">
+            <a:avLst/>
+          </a:prstGeom>
+          <a:solidFill>
+            <a:srgbClr val="FFFFFF"/>
+          </a:solidFill>
+          <a:ln>
+            <a:solidFill>
+              <a:srgbClr val="E6EAE1"/>
+            </a:solidFill>
+          </a:ln>
+        </p:spPr>
+        <p:txBody>
+          <a:bodyPr wrap="square">
+            <a:spAutoFit/>
+          </a:bodyPr>
+          <a:lstStyle/>
+          <a:p>
+            <a:pPr algn="l"/>
+            <a:r>
+              <a:rPr sz="1600" b="1">
+                <a:solidFill>
+                  <a:srgbClr val="1B1F17"/>
+                </a:solidFill>
+                <a:latin typeface="Arial"/>
+              </a:rPr>
+              <a:t>Managers</a:t>
+            </a:r>
+          </a:p>
+        </p:txBody>
+      </p:sp>
+      <p:sp>
+        <p:nvSpPr>
+          <p:cNvPr id="18" name="Rounded Rectangle 17"/>
+          <p:cNvSpPr/>
+          <p:nvPr/>
+        </p:nvSpPr>
+        <p:spPr>
+          <a:xfrm>
+            <a:off x="685800" y="4754879"/>
+            <a:ext cx="2286000" cy="960120"/>
+          </a:xfrm>
+          <a:prstGeom prst="roundRect">
+            <a:avLst>
+              <a:gd name="adj" fmla="val 6000"/>
+            </a:avLst>
+          </a:prstGeom>
+          <a:solidFill>
+            <a:srgbClr val="FFFFFF"/>
+          </a:solidFill>
+          <a:ln>
+            <a:solidFill>
+              <a:srgbClr val="E6EAE1"/>
+            </a:solidFill>
+          </a:ln>
+        </p:spPr>
+        <p:style>
+          <a:lnRef idx="1">
+            <a:schemeClr val="accent1"/>
+          </a:lnRef>
+          <a:fillRef idx="3">
+            <a:schemeClr val="accent1"/>
+          </a:fillRef>
+          <a:effectRef idx="2">
+            <a:schemeClr val="accent1"/>
+          </a:effectRef>
+          <a:fontRef idx="minor">
+            <a:schemeClr val="lt1"/>
+          </a:fontRef>
+        </p:style>
+        <p:txBody>
+          <a:bodyPr rtlCol="0" anchor="ctr"/>
+          <a:lstStyle/>
+          <a:p>
+            <a:pPr algn="ctr"/>
+            <a:endParaRPr/>
+          </a:p>
+        </p:txBody>
+      </p:sp>
+      <p:sp>
+        <p:nvSpPr>
           <p:cNvPr id="19" name="TextBox 18"/>
           <p:cNvSpPr txBox="1"/>
           <p:nvPr/>
@@ -11758,7 +11634,14 @@
           <a:prstGeom prst="rect">
             <a:avLst/>
           </a:prstGeom>
-          <a:noFill/>
+          <a:solidFill>
+            <a:srgbClr val="FFFFFF"/>
+          </a:solidFill>
+          <a:ln>
+            <a:solidFill>
+              <a:srgbClr val="E6EAE1"/>
+            </a:solidFill>
+          </a:ln>
         </p:spPr>
         <p:txBody>
           <a:bodyPr wrap="square">
@@ -11775,94 +11658,6 @@
                 <a:latin typeface="Arial"/>
               </a:rPr>
               <a:t>Leadership</a:t>
-            </a:r>
-          </a:p>
-        </p:txBody>
-      </p:sp>
-      <p:sp>
-        <p:nvSpPr>
-          <p:cNvPr id="20" name="TextBox 19"/>
-          <p:cNvSpPr txBox="1"/>
-          <p:nvPr/>
-        </p:nvSpPr>
-        <p:spPr>
-          <a:xfrm>
-            <a:off x="3200400" y="4937759"/>
-            <a:ext cx="4846320" cy="553998"/>
-          </a:xfrm>
-          <a:prstGeom prst="rect">
-            <a:avLst/>
-          </a:prstGeom>
-          <a:noFill/>
-        </p:spPr>
-        <p:txBody>
-          <a:bodyPr wrap="square">
-            <a:spAutoFit/>
-          </a:bodyPr>
-          <a:lstStyle/>
-          <a:p>
-            <a:pPr algn="l"/>
-            <a:r>
-              <a:rPr sz="1500" b="0" dirty="0">
-                <a:solidFill>
-                  <a:srgbClr val="1B1F17"/>
-                </a:solidFill>
-                <a:latin typeface="Arial"/>
-              </a:rPr>
-              <a:t>Trust the as-of date and named drivers</a:t>
-            </a:r>
-            <a:r>
-              <a:rPr lang="en-US" sz="1500" b="0" dirty="0">
-                <a:solidFill>
-                  <a:srgbClr val="1B1F17"/>
-                </a:solidFill>
-                <a:latin typeface="Arial"/>
-              </a:rPr>
-              <a:t>, </a:t>
-            </a:r>
-            <a:r>
-              <a:rPr sz="1500" b="0" dirty="0">
-                <a:solidFill>
-                  <a:srgbClr val="1B1F17"/>
-                </a:solidFill>
-                <a:latin typeface="Arial"/>
-              </a:rPr>
-              <a:t> even if the FP&amp;A owner is out</a:t>
-            </a:r>
-          </a:p>
-        </p:txBody>
-      </p:sp>
-      <p:sp>
-        <p:nvSpPr>
-          <p:cNvPr id="21" name="TextBox 20"/>
-          <p:cNvSpPr txBox="1"/>
-          <p:nvPr/>
-        </p:nvSpPr>
-        <p:spPr>
-          <a:xfrm>
-            <a:off x="8138160" y="4937759"/>
-            <a:ext cx="3383280" cy="523220"/>
-          </a:xfrm>
-          <a:prstGeom prst="rect">
-            <a:avLst/>
-          </a:prstGeom>
-          <a:noFill/>
-        </p:spPr>
-        <p:txBody>
-          <a:bodyPr wrap="square">
-            <a:spAutoFit/>
-          </a:bodyPr>
-          <a:lstStyle/>
-          <a:p>
-            <a:pPr algn="l"/>
-            <a:r>
-              <a:rPr sz="1400" b="1" dirty="0">
-                <a:solidFill>
-                  <a:srgbClr val="4F8F12"/>
-                </a:solidFill>
-                <a:latin typeface="Arial"/>
-              </a:rPr>
-              <a:t>Business continuity · decisions on people cost, not one person’s spreadsheet</a:t>
             </a:r>
           </a:p>
         </p:txBody>
@@ -11933,6 +11728,178 @@
                 <a:latin typeface="Arial"/>
               </a:rPr>
               <a:t>4/15</a:t>
+            </a:r>
+          </a:p>
+        </p:txBody>
+      </p:sp>
+      <p:sp>
+        <p:nvSpPr>
+          <p:cNvPr id="24" name="TextBox 23"/>
+          <p:cNvSpPr txBox="1"/>
+          <p:nvPr/>
+        </p:nvSpPr>
+        <p:spPr>
+          <a:xfrm>
+            <a:off x="3200400" y="1645919"/>
+            <a:ext cx="8229600" cy="640080"/>
+          </a:xfrm>
+          <a:prstGeom prst="rect">
+            <a:avLst/>
+          </a:prstGeom>
+          <a:noFill/>
+        </p:spPr>
+        <p:txBody>
+          <a:bodyPr wrap="square">
+            <a:spAutoFit/>
+          </a:bodyPr>
+          <a:lstStyle/>
+          <a:p>
+            <a:r>
+              <a:rPr sz="1500" b="1">
+                <a:solidFill>
+                  <a:srgbClr val="4F8F12"/>
+                </a:solidFill>
+                <a:latin typeface="Arial"/>
+              </a:rPr>
+              <a:t>Benefit: </a:t>
+            </a:r>
+            <a:r>
+              <a:rPr sz="1500" b="0">
+                <a:solidFill>
+                  <a:srgbClr val="4F8F12"/>
+                </a:solidFill>
+                <a:latin typeface="Arial"/>
+              </a:rPr>
+              <a:t>A headcount number they can trust at close — and that isn’t locked in one person’s head.</a:t>
+            </a:r>
+          </a:p>
+        </p:txBody>
+      </p:sp>
+      <p:sp>
+        <p:nvSpPr>
+          <p:cNvPr id="25" name="TextBox 24"/>
+          <p:cNvSpPr txBox="1"/>
+          <p:nvPr/>
+        </p:nvSpPr>
+        <p:spPr>
+          <a:xfrm>
+            <a:off x="3200400" y="2743200"/>
+            <a:ext cx="8229600" cy="640080"/>
+          </a:xfrm>
+          <a:prstGeom prst="rect">
+            <a:avLst/>
+          </a:prstGeom>
+          <a:noFill/>
+        </p:spPr>
+        <p:txBody>
+          <a:bodyPr wrap="square">
+            <a:spAutoFit/>
+          </a:bodyPr>
+          <a:lstStyle/>
+          <a:p>
+            <a:r>
+              <a:rPr sz="1500" b="1">
+                <a:solidFill>
+                  <a:srgbClr val="4F8F12"/>
+                </a:solidFill>
+                <a:latin typeface="Arial"/>
+              </a:rPr>
+              <a:t>Benefit: </a:t>
+            </a:r>
+            <a:r>
+              <a:rPr sz="1500" b="0">
+                <a:solidFill>
+                  <a:srgbClr val="4F8F12"/>
+                </a:solidFill>
+                <a:latin typeface="Arial"/>
+              </a:rPr>
+              <a:t>Real alignment with Finance on every hire and departure — without spreadsheet ping-pong.</a:t>
+            </a:r>
+          </a:p>
+        </p:txBody>
+      </p:sp>
+      <p:sp>
+        <p:nvSpPr>
+          <p:cNvPr id="26" name="TextBox 25"/>
+          <p:cNvSpPr txBox="1"/>
+          <p:nvPr/>
+        </p:nvSpPr>
+        <p:spPr>
+          <a:xfrm>
+            <a:off x="3200400" y="3840480"/>
+            <a:ext cx="8229600" cy="640080"/>
+          </a:xfrm>
+          <a:prstGeom prst="rect">
+            <a:avLst/>
+          </a:prstGeom>
+          <a:noFill/>
+        </p:spPr>
+        <p:txBody>
+          <a:bodyPr wrap="square">
+            <a:spAutoFit/>
+          </a:bodyPr>
+          <a:lstStyle/>
+          <a:p>
+            <a:r>
+              <a:rPr sz="1500" b="1">
+                <a:solidFill>
+                  <a:srgbClr val="4F8F12"/>
+                </a:solidFill>
+                <a:latin typeface="Arial"/>
+              </a:rPr>
+              <a:t>Benefit: </a:t>
+            </a:r>
+            <a:r>
+              <a:rPr sz="1500" b="0">
+                <a:solidFill>
+                  <a:srgbClr val="4F8F12"/>
+                </a:solidFill>
+                <a:latin typeface="Arial"/>
+              </a:rPr>
+              <a:t>Clear visibility into whether their hiring request is moving — without chasing people.</a:t>
+            </a:r>
+          </a:p>
+        </p:txBody>
+      </p:sp>
+      <p:sp>
+        <p:nvSpPr>
+          <p:cNvPr id="27" name="TextBox 26"/>
+          <p:cNvSpPr txBox="1"/>
+          <p:nvPr/>
+        </p:nvSpPr>
+        <p:spPr>
+          <a:xfrm>
+            <a:off x="3200400" y="4937759"/>
+            <a:ext cx="8229600" cy="640080"/>
+          </a:xfrm>
+          <a:prstGeom prst="rect">
+            <a:avLst/>
+          </a:prstGeom>
+          <a:noFill/>
+        </p:spPr>
+        <p:txBody>
+          <a:bodyPr wrap="square">
+            <a:spAutoFit/>
+          </a:bodyPr>
+          <a:lstStyle/>
+          <a:p>
+            <a:r>
+              <a:rPr sz="1500" b="1">
+                <a:solidFill>
+                  <a:srgbClr val="4F8F12"/>
+                </a:solidFill>
+                <a:latin typeface="Arial"/>
+              </a:rPr>
+              <a:t>Benefit: </a:t>
+            </a:r>
+            <a:r>
+              <a:rPr sz="1500" b="0">
+                <a:solidFill>
+                  <a:srgbClr val="4F8F12"/>
+                </a:solidFill>
+                <a:latin typeface="Arial"/>
+              </a:rPr>
+              <a:t>Confidence the people story holds up for the board — even if a key FP&amp;A owner is out.</a:t>
             </a:r>
           </a:p>
         </p:txBody>

</xml_diff>

<commit_message>
Simplify the Hypotheses slide to one clear green benefit per hypothesis.
</commit_message>
<xml_diff>
--- a/deck/Headcount_Control_Tower_Case_Study.pptx
+++ b/deck/Headcount_Control_Tower_Case_Study.pptx
@@ -4502,6 +4502,47 @@
           </a:p>
         </p:txBody>
       </p:sp>
+      <p:sp>
+        <p:nvSpPr>
+          <p:cNvPr id="7" name="TextBox 6">
+            <a:extLst>
+              <a:ext uri="{FF2B5EF4-FFF2-40B4-BE49-F238E27FC236}">
+                <a16:creationId xmlns:a16="http://schemas.microsoft.com/office/drawing/2014/main" id="{4BCCBFDE-C82F-5728-A64E-663B5BD26A48}"/>
+              </a:ext>
+            </a:extLst>
+          </p:cNvPr>
+          <p:cNvSpPr txBox="1"/>
+          <p:nvPr/>
+        </p:nvSpPr>
+        <p:spPr>
+          <a:xfrm>
+            <a:off x="685800" y="6537960"/>
+            <a:ext cx="9144000" cy="228600"/>
+          </a:xfrm>
+          <a:prstGeom prst="rect">
+            <a:avLst/>
+          </a:prstGeom>
+          <a:noFill/>
+        </p:spPr>
+        <p:txBody>
+          <a:bodyPr wrap="square">
+            <a:spAutoFit/>
+          </a:bodyPr>
+          <a:lstStyle/>
+          <a:p>
+            <a:pPr algn="l"/>
+            <a:r>
+              <a:rPr sz="1100" b="0" dirty="0">
+                <a:solidFill>
+                  <a:srgbClr val="6A7264"/>
+                </a:solidFill>
+                <a:latin typeface="Arial"/>
+              </a:rPr>
+              <a:t>BambooHR interview case study</a:t>
+            </a:r>
+          </a:p>
+        </p:txBody>
+      </p:sp>
     </p:spTree>
   </p:cSld>
   <p:clrMapOvr>
@@ -6009,7 +6050,7 @@
         <p:spPr>
           <a:xfrm>
             <a:off x="6629400" y="1783080"/>
-            <a:ext cx="4663440" cy="365760"/>
+            <a:ext cx="4663440" cy="307777"/>
           </a:xfrm>
           <a:prstGeom prst="rect">
             <a:avLst/>
@@ -6024,7 +6065,7 @@
           <a:p>
             <a:pPr algn="l"/>
             <a:r>
-              <a:rPr sz="1400" b="1">
+              <a:rPr sz="1400" b="1" dirty="0">
                 <a:solidFill>
                   <a:srgbClr val="4F8F12"/>
                 </a:solidFill>
@@ -6032,6 +6073,21 @@
               </a:rPr>
               <a:t>Next five interviews</a:t>
             </a:r>
+            <a:r>
+              <a:rPr lang="en-US" sz="1400" b="1" dirty="0">
+                <a:solidFill>
+                  <a:srgbClr val="4F8F12"/>
+                </a:solidFill>
+                <a:latin typeface="Arial"/>
+              </a:rPr>
+              <a:t> (more to follow)</a:t>
+            </a:r>
+            <a:endParaRPr sz="1400" b="1" dirty="0">
+              <a:solidFill>
+                <a:srgbClr val="4F8F12"/>
+              </a:solidFill>
+              <a:latin typeface="Arial"/>
+            </a:endParaRPr>
           </a:p>
         </p:txBody>
       </p:sp>
@@ -7264,7 +7320,7 @@
         <p:spPr>
           <a:xfrm>
             <a:off x="914400" y="1828800"/>
-            <a:ext cx="3063240" cy="640080"/>
+            <a:ext cx="3063240" cy="553998"/>
           </a:xfrm>
           <a:prstGeom prst="rect">
             <a:avLst/>
@@ -7279,13 +7335,31 @@
           <a:p>
             <a:pPr algn="l"/>
             <a:r>
-              <a:rPr sz="1500" b="1">
+              <a:rPr sz="1500" b="1" dirty="0">
                 <a:solidFill>
                   <a:srgbClr val="1B1F17"/>
                 </a:solidFill>
                 <a:latin typeface="Arial"/>
               </a:rPr>
-              <a:t>Time to understand HC @ close date</a:t>
+              <a:t>Time to understand H</a:t>
+            </a:r>
+            <a:r>
+              <a:rPr lang="en-US" sz="1500" b="1" dirty="0">
+                <a:solidFill>
+                  <a:srgbClr val="1B1F17"/>
+                </a:solidFill>
+                <a:latin typeface="Arial"/>
+              </a:rPr>
+              <a:t>eadcount</a:t>
+            </a:r>
+            <a:r>
+              <a:rPr sz="1500" b="1" dirty="0">
+                <a:solidFill>
+                  <a:srgbClr val="1B1F17"/>
+                </a:solidFill>
+                <a:latin typeface="Arial"/>
+              </a:rPr>
+              <a:t> @ close date</a:t>
             </a:r>
           </a:p>
         </p:txBody>
@@ -7461,7 +7535,7 @@
         <p:spPr>
           <a:xfrm>
             <a:off x="4663440" y="1828800"/>
-            <a:ext cx="3063240" cy="640080"/>
+            <a:ext cx="3063240" cy="323165"/>
           </a:xfrm>
           <a:prstGeom prst="rect">
             <a:avLst/>
@@ -7476,13 +7550,13 @@
           <a:p>
             <a:pPr algn="l"/>
             <a:r>
-              <a:rPr sz="1500" b="1">
+              <a:rPr sz="1500" b="1" dirty="0">
                 <a:solidFill>
                   <a:srgbClr val="1B1F17"/>
                 </a:solidFill>
                 <a:latin typeface="Arial"/>
               </a:rPr>
-              <a:t>Month-end recon time</a:t>
+              <a:t>Month-end reconciliation time</a:t>
             </a:r>
           </a:p>
         </p:txBody>
@@ -9258,7 +9332,7 @@
         <p:spPr>
           <a:xfrm>
             <a:off x="822960" y="2369735"/>
-            <a:ext cx="10645140" cy="2734082"/>
+            <a:ext cx="10645140" cy="3349635"/>
           </a:xfrm>
           <a:prstGeom prst="rect">
             <a:avLst/>
@@ -9344,7 +9418,16 @@
                 </a:solidFill>
                 <a:latin typeface="Arial"/>
               </a:rPr>
-              <a:t> We can solve this.</a:t>
+              <a:t> With our “Headcount Control Tower” </a:t>
+            </a:r>
+            <a:r>
+              <a:rPr lang="en-US" sz="4000" b="1">
+                <a:solidFill>
+                  <a:srgbClr val="1B1F17"/>
+                </a:solidFill>
+                <a:latin typeface="Arial"/>
+              </a:rPr>
+              <a:t>we can fix this.</a:t>
             </a:r>
             <a:endParaRPr sz="4000" b="1" dirty="0">
               <a:solidFill>
@@ -11291,14 +11374,20 @@
           <a:p>
             <a:pPr algn="l"/>
             <a:r>
-              <a:rPr sz="2600" b="1">
+              <a:rPr lang="en-US" sz="2600" b="1" dirty="0">
                 <a:solidFill>
                   <a:srgbClr val="1B1F17"/>
                 </a:solidFill>
                 <a:latin typeface="Arial"/>
               </a:rPr>
-              <a:t>When Finance and HR share one headcount story, the business moves faster.</a:t>
-            </a:r>
+              <a:t>With one system, everyone benefits</a:t>
+            </a:r>
+            <a:endParaRPr sz="2600" b="1" dirty="0">
+              <a:solidFill>
+                <a:srgbClr val="1B1F17"/>
+              </a:solidFill>
+              <a:latin typeface="Arial"/>
+            </a:endParaRPr>
           </a:p>
         </p:txBody>
       </p:sp>
@@ -11369,7 +11458,7 @@
           </a:solidFill>
           <a:ln>
             <a:solidFill>
-              <a:srgbClr val="E6EAE1"/>
+              <a:srgbClr val="92D050"/>
             </a:solidFill>
           </a:ln>
         </p:spPr>
@@ -11459,7 +11548,7 @@
           </a:solidFill>
           <a:ln>
             <a:solidFill>
-              <a:srgbClr val="E6EAE1"/>
+              <a:srgbClr val="92D050"/>
             </a:solidFill>
           </a:ln>
         </p:spPr>
@@ -11549,7 +11638,7 @@
           </a:solidFill>
           <a:ln>
             <a:solidFill>
-              <a:srgbClr val="E6EAE1"/>
+              <a:srgbClr val="92D050"/>
             </a:solidFill>
           </a:ln>
         </p:spPr>
@@ -11639,7 +11728,7 @@
           </a:solidFill>
           <a:ln>
             <a:solidFill>
-              <a:srgbClr val="E6EAE1"/>
+              <a:srgbClr val="92D050"/>
             </a:solidFill>
           </a:ln>
         </p:spPr>
@@ -11741,21 +11830,21 @@
         <p:spPr>
           <a:xfrm>
             <a:off x="3200400" y="1645919"/>
-            <a:ext cx="8229600" cy="640080"/>
-          </a:xfrm>
-          <a:prstGeom prst="rect">
-            <a:avLst/>
-          </a:prstGeom>
-          <a:noFill/>
-        </p:spPr>
-        <p:txBody>
-          <a:bodyPr wrap="square">
-            <a:spAutoFit/>
-          </a:bodyPr>
-          <a:lstStyle/>
-          <a:p>
-            <a:r>
-              <a:rPr sz="1500" b="1">
+            <a:ext cx="8229600" cy="553998"/>
+          </a:xfrm>
+          <a:prstGeom prst="rect">
+            <a:avLst/>
+          </a:prstGeom>
+          <a:noFill/>
+        </p:spPr>
+        <p:txBody>
+          <a:bodyPr wrap="square">
+            <a:spAutoFit/>
+          </a:bodyPr>
+          <a:lstStyle/>
+          <a:p>
+            <a:r>
+              <a:rPr sz="1500" b="1" dirty="0">
                 <a:solidFill>
                   <a:srgbClr val="4F8F12"/>
                 </a:solidFill>
@@ -11764,13 +11853,31 @@
               <a:t>Benefit: </a:t>
             </a:r>
             <a:r>
-              <a:rPr sz="1500" b="0">
+              <a:rPr sz="1500" b="0" dirty="0">
                 <a:solidFill>
                   <a:srgbClr val="4F8F12"/>
                 </a:solidFill>
                 <a:latin typeface="Arial"/>
               </a:rPr>
-              <a:t>A headcount number they can trust at close — and that isn’t locked in one person’s head.</a:t>
+              <a:t>A headcount number they can trust at close</a:t>
+            </a:r>
+            <a:r>
+              <a:rPr lang="en-US" sz="1500" b="0" dirty="0">
+                <a:solidFill>
+                  <a:srgbClr val="4F8F12"/>
+                </a:solidFill>
+                <a:latin typeface="Arial"/>
+              </a:rPr>
+              <a:t>,</a:t>
+            </a:r>
+            <a:r>
+              <a:rPr sz="1500" b="0" dirty="0">
+                <a:solidFill>
+                  <a:srgbClr val="4F8F12"/>
+                </a:solidFill>
+                <a:latin typeface="Arial"/>
+              </a:rPr>
+              <a:t> and that isn’t locked in one person’s head.</a:t>
             </a:r>
           </a:p>
         </p:txBody>
@@ -11784,21 +11891,21 @@
         <p:spPr>
           <a:xfrm>
             <a:off x="3200400" y="2743200"/>
-            <a:ext cx="8229600" cy="640080"/>
-          </a:xfrm>
-          <a:prstGeom prst="rect">
-            <a:avLst/>
-          </a:prstGeom>
-          <a:noFill/>
-        </p:spPr>
-        <p:txBody>
-          <a:bodyPr wrap="square">
-            <a:spAutoFit/>
-          </a:bodyPr>
-          <a:lstStyle/>
-          <a:p>
-            <a:r>
-              <a:rPr sz="1500" b="1">
+            <a:ext cx="8229600" cy="553998"/>
+          </a:xfrm>
+          <a:prstGeom prst="rect">
+            <a:avLst/>
+          </a:prstGeom>
+          <a:noFill/>
+        </p:spPr>
+        <p:txBody>
+          <a:bodyPr wrap="square">
+            <a:spAutoFit/>
+          </a:bodyPr>
+          <a:lstStyle/>
+          <a:p>
+            <a:r>
+              <a:rPr sz="1500" b="1" dirty="0">
                 <a:solidFill>
                   <a:srgbClr val="4F8F12"/>
                 </a:solidFill>
@@ -11807,13 +11914,31 @@
               <a:t>Benefit: </a:t>
             </a:r>
             <a:r>
-              <a:rPr sz="1500" b="0">
+              <a:rPr sz="1500" b="0" dirty="0">
                 <a:solidFill>
                   <a:srgbClr val="4F8F12"/>
                 </a:solidFill>
                 <a:latin typeface="Arial"/>
               </a:rPr>
-              <a:t>Real alignment with Finance on every hire and departure — without spreadsheet ping-pong.</a:t>
+              <a:t>Real alignment with Finance on every hire and departure</a:t>
+            </a:r>
+            <a:r>
+              <a:rPr lang="en-US" sz="1500" b="0" dirty="0">
+                <a:solidFill>
+                  <a:srgbClr val="4F8F12"/>
+                </a:solidFill>
+                <a:latin typeface="Arial"/>
+              </a:rPr>
+              <a:t>, </a:t>
+            </a:r>
+            <a:r>
+              <a:rPr sz="1500" b="0" dirty="0">
+                <a:solidFill>
+                  <a:srgbClr val="4F8F12"/>
+                </a:solidFill>
+                <a:latin typeface="Arial"/>
+              </a:rPr>
+              <a:t> without spreadsheet ping-pong.</a:t>
             </a:r>
           </a:p>
         </p:txBody>
@@ -11827,21 +11952,21 @@
         <p:spPr>
           <a:xfrm>
             <a:off x="3200400" y="3840480"/>
-            <a:ext cx="8229600" cy="640080"/>
-          </a:xfrm>
-          <a:prstGeom prst="rect">
-            <a:avLst/>
-          </a:prstGeom>
-          <a:noFill/>
-        </p:spPr>
-        <p:txBody>
-          <a:bodyPr wrap="square">
-            <a:spAutoFit/>
-          </a:bodyPr>
-          <a:lstStyle/>
-          <a:p>
-            <a:r>
-              <a:rPr sz="1500" b="1">
+            <a:ext cx="8229600" cy="323165"/>
+          </a:xfrm>
+          <a:prstGeom prst="rect">
+            <a:avLst/>
+          </a:prstGeom>
+          <a:noFill/>
+        </p:spPr>
+        <p:txBody>
+          <a:bodyPr wrap="square">
+            <a:spAutoFit/>
+          </a:bodyPr>
+          <a:lstStyle/>
+          <a:p>
+            <a:r>
+              <a:rPr sz="1500" b="1" dirty="0">
                 <a:solidFill>
                   <a:srgbClr val="4F8F12"/>
                 </a:solidFill>
@@ -11850,13 +11975,31 @@
               <a:t>Benefit: </a:t>
             </a:r>
             <a:r>
-              <a:rPr sz="1500" b="0">
+              <a:rPr sz="1500" b="0" dirty="0">
                 <a:solidFill>
                   <a:srgbClr val="4F8F12"/>
                 </a:solidFill>
                 <a:latin typeface="Arial"/>
               </a:rPr>
-              <a:t>Clear visibility into whether their hiring request is moving — without chasing people.</a:t>
+              <a:t>Clear visibility into whether their hiring request is moving</a:t>
+            </a:r>
+            <a:r>
+              <a:rPr lang="en-US" sz="1500" b="0" dirty="0">
+                <a:solidFill>
+                  <a:srgbClr val="4F8F12"/>
+                </a:solidFill>
+                <a:latin typeface="Arial"/>
+              </a:rPr>
+              <a:t>,</a:t>
+            </a:r>
+            <a:r>
+              <a:rPr sz="1500" b="0" dirty="0">
+                <a:solidFill>
+                  <a:srgbClr val="4F8F12"/>
+                </a:solidFill>
+                <a:latin typeface="Arial"/>
+              </a:rPr>
+              <a:t> without chasing people.</a:t>
             </a:r>
           </a:p>
         </p:txBody>
@@ -11870,21 +12013,21 @@
         <p:spPr>
           <a:xfrm>
             <a:off x="3200400" y="4937759"/>
-            <a:ext cx="8229600" cy="640080"/>
-          </a:xfrm>
-          <a:prstGeom prst="rect">
-            <a:avLst/>
-          </a:prstGeom>
-          <a:noFill/>
-        </p:spPr>
-        <p:txBody>
-          <a:bodyPr wrap="square">
-            <a:spAutoFit/>
-          </a:bodyPr>
-          <a:lstStyle/>
-          <a:p>
-            <a:r>
-              <a:rPr sz="1500" b="1">
+            <a:ext cx="8229600" cy="323165"/>
+          </a:xfrm>
+          <a:prstGeom prst="rect">
+            <a:avLst/>
+          </a:prstGeom>
+          <a:noFill/>
+        </p:spPr>
+        <p:txBody>
+          <a:bodyPr wrap="square">
+            <a:spAutoFit/>
+          </a:bodyPr>
+          <a:lstStyle/>
+          <a:p>
+            <a:r>
+              <a:rPr sz="1500" b="1" dirty="0">
                 <a:solidFill>
                   <a:srgbClr val="4F8F12"/>
                 </a:solidFill>
@@ -11893,13 +12036,31 @@
               <a:t>Benefit: </a:t>
             </a:r>
             <a:r>
-              <a:rPr sz="1500" b="0">
+              <a:rPr sz="1500" b="0" dirty="0">
                 <a:solidFill>
                   <a:srgbClr val="4F8F12"/>
                 </a:solidFill>
                 <a:latin typeface="Arial"/>
               </a:rPr>
-              <a:t>Confidence the people story holds up for the board — even if a key FP&amp;A owner is out.</a:t>
+              <a:t>Confidence the people story holds up for the board</a:t>
+            </a:r>
+            <a:r>
+              <a:rPr lang="en-US" sz="1500" b="0" dirty="0">
+                <a:solidFill>
+                  <a:srgbClr val="4F8F12"/>
+                </a:solidFill>
+                <a:latin typeface="Arial"/>
+              </a:rPr>
+              <a:t>,</a:t>
+            </a:r>
+            <a:r>
+              <a:rPr sz="1500" b="0" dirty="0">
+                <a:solidFill>
+                  <a:srgbClr val="4F8F12"/>
+                </a:solidFill>
+                <a:latin typeface="Arial"/>
+              </a:rPr>
+              <a:t> even if a key FP&amp;A owner is out.</a:t>
             </a:r>
           </a:p>
         </p:txBody>
@@ -12006,7 +12167,7 @@
         <p:spPr>
           <a:xfrm>
             <a:off x="2331720" y="228600"/>
-            <a:ext cx="9144000" cy="228600"/>
+            <a:ext cx="9144000" cy="261610"/>
           </a:xfrm>
           <a:prstGeom prst="rect">
             <a:avLst/>
@@ -12021,14 +12182,20 @@
           <a:p>
             <a:pPr algn="l"/>
             <a:r>
-              <a:rPr sz="1100" b="1">
+              <a:rPr lang="en-US" sz="1100" b="1" dirty="0">
                 <a:solidFill>
                   <a:srgbClr val="4F8F12"/>
                 </a:solidFill>
                 <a:latin typeface="Arial"/>
               </a:rPr>
-              <a:t>WHY THIS HELPS BAMBOOHR</a:t>
-            </a:r>
+              <a:t>BUSINESS BENEFIT</a:t>
+            </a:r>
+            <a:endParaRPr sz="1100" b="1" dirty="0">
+              <a:solidFill>
+                <a:srgbClr val="4F8F12"/>
+              </a:solidFill>
+              <a:latin typeface="Arial"/>
+            </a:endParaRPr>
           </a:p>
         </p:txBody>
       </p:sp>
@@ -12829,7 +12996,7 @@
         <p:spPr>
           <a:xfrm>
             <a:off x="2331720" y="866001"/>
-            <a:ext cx="9726930" cy="553998"/>
+            <a:ext cx="9726930" cy="276999"/>
           </a:xfrm>
           <a:prstGeom prst="rect">
             <a:avLst/>
@@ -12844,7 +13011,7 @@
           <a:p>
             <a:pPr algn="l"/>
             <a:r>
-              <a:rPr sz="1500" b="0" dirty="0">
+              <a:rPr sz="1200" b="0" dirty="0">
                 <a:solidFill>
                   <a:srgbClr val="6A7264"/>
                 </a:solidFill>
@@ -12853,7 +13020,7 @@
               <a:t>Fictional Northline data</a:t>
             </a:r>
             <a:r>
-              <a:rPr lang="en-US" sz="1500" b="0" dirty="0">
+              <a:rPr lang="en-US" sz="1200" b="0" dirty="0">
                 <a:solidFill>
                   <a:srgbClr val="6A7264"/>
                 </a:solidFill>
@@ -12861,7 +13028,7 @@
               </a:rPr>
               <a:t>: This is a real spreadsheet from a Head of Finance but with numbers and roles changed to protect confidentiality </a:t>
             </a:r>
-            <a:endParaRPr sz="1500" b="0" dirty="0">
+            <a:endParaRPr sz="1200" b="0" dirty="0">
               <a:solidFill>
                 <a:srgbClr val="6A7264"/>
               </a:solidFill>
@@ -12918,7 +13085,7 @@
           <a:p>
             <a:pPr algn="l"/>
             <a:r>
-              <a:rPr sz="1100" b="0">
+              <a:rPr sz="1100" b="0" dirty="0">
                 <a:solidFill>
                   <a:srgbClr val="6A7264"/>
                 </a:solidFill>
@@ -13066,7 +13233,7 @@
         <p:spPr>
           <a:xfrm>
             <a:off x="2331720" y="228600"/>
-            <a:ext cx="9144000" cy="228600"/>
+            <a:ext cx="9144000" cy="261610"/>
           </a:xfrm>
           <a:prstGeom prst="rect">
             <a:avLst/>
@@ -13081,7 +13248,7 @@
           <a:p>
             <a:pPr algn="l"/>
             <a:r>
-              <a:rPr sz="1100" b="1">
+              <a:rPr sz="1100" b="1" dirty="0">
                 <a:solidFill>
                   <a:srgbClr val="4F8F12"/>
                 </a:solidFill>
@@ -13089,6 +13256,21 @@
               </a:rPr>
               <a:t>EVIDENCE</a:t>
             </a:r>
+            <a:r>
+              <a:rPr lang="en-US" sz="1100" b="1" dirty="0">
+                <a:solidFill>
+                  <a:srgbClr val="4F8F12"/>
+                </a:solidFill>
+                <a:latin typeface="Arial"/>
+              </a:rPr>
+              <a:t> – REASONS TO BELIEVE</a:t>
+            </a:r>
+            <a:endParaRPr sz="1100" b="1" dirty="0">
+              <a:solidFill>
+                <a:srgbClr val="4F8F12"/>
+              </a:solidFill>
+              <a:latin typeface="Arial"/>
+            </a:endParaRPr>
           </a:p>
         </p:txBody>
       </p:sp>
@@ -13651,29 +13833,37 @@
         <p:spPr>
           <a:xfrm>
             <a:off x="2331720" y="228600"/>
-            <a:ext cx="9144000" cy="228600"/>
-          </a:xfrm>
-          <a:prstGeom prst="rect">
-            <a:avLst/>
-          </a:prstGeom>
-          <a:noFill/>
-        </p:spPr>
-        <p:txBody>
-          <a:bodyPr wrap="square">
-            <a:spAutoFit/>
-          </a:bodyPr>
-          <a:lstStyle/>
+            <a:ext cx="9144000" cy="430887"/>
+          </a:xfrm>
+          <a:prstGeom prst="rect">
+            <a:avLst/>
+          </a:prstGeom>
+          <a:noFill/>
+        </p:spPr>
+        <p:txBody>
+          <a:bodyPr wrap="square">
+            <a:spAutoFit/>
+          </a:bodyPr>
+          <a:lstStyle/>
+          <a:p>
+            <a:r>
+              <a:rPr lang="en-US" sz="1100" b="1" dirty="0">
+                <a:solidFill>
+                  <a:srgbClr val="4F8F12"/>
+                </a:solidFill>
+                <a:latin typeface="Arial"/>
+              </a:rPr>
+              <a:t>EVIDENCE – REASONS TO BELIEVE</a:t>
+            </a:r>
+          </a:p>
           <a:p>
             <a:pPr algn="l"/>
-            <a:r>
-              <a:rPr sz="1100" b="1">
-                <a:solidFill>
-                  <a:srgbClr val="4F8F12"/>
-                </a:solidFill>
-                <a:latin typeface="Arial"/>
-              </a:rPr>
-              <a:t>EVIDENCE</a:t>
-            </a:r>
+            <a:endParaRPr sz="1100" b="1" dirty="0">
+              <a:solidFill>
+                <a:srgbClr val="4F8F12"/>
+              </a:solidFill>
+              <a:latin typeface="Arial"/>
+            </a:endParaRPr>
           </a:p>
         </p:txBody>
       </p:sp>
@@ -13716,7 +13906,7 @@
                 </a:solidFill>
                 <a:latin typeface="Arial"/>
               </a:rPr>
-              <a:t>Research</a:t>
+              <a:t>Research:</a:t>
             </a:r>
             <a:r>
               <a:rPr sz="2600" b="1" dirty="0">
@@ -13725,7 +13915,7 @@
                 </a:solidFill>
                 <a:latin typeface="Arial"/>
               </a:rPr>
-              <a:t> — HR and Finance still don’t share one headcount system</a:t>
+              <a:t> HR and Finance still don’t share one headcount system</a:t>
             </a:r>
           </a:p>
         </p:txBody>
@@ -14561,76 +14751,6 @@
       </p:sp>
       <p:sp>
         <p:nvSpPr>
-          <p:cNvPr id="9" name="TextBox 8"/>
-          <p:cNvSpPr txBox="1"/>
-          <p:nvPr/>
-        </p:nvSpPr>
-        <p:spPr>
-          <a:xfrm>
-            <a:off x="5120640" y="1508760"/>
-            <a:ext cx="3474720" cy="548640"/>
-          </a:xfrm>
-          <a:prstGeom prst="rect">
-            <a:avLst/>
-          </a:prstGeom>
-          <a:noFill/>
-        </p:spPr>
-        <p:txBody>
-          <a:bodyPr wrap="square">
-            <a:spAutoFit/>
-          </a:bodyPr>
-          <a:lstStyle/>
-          <a:p>
-            <a:pPr algn="l"/>
-            <a:r>
-              <a:rPr sz="1400" b="0">
-                <a:solidFill>
-                  <a:srgbClr val="6A7264"/>
-                </a:solidFill>
-                <a:latin typeface="Arial"/>
-              </a:rPr>
-              <a:t>Multi-tab recon exceeds working memory</a:t>
-            </a:r>
-          </a:p>
-        </p:txBody>
-      </p:sp>
-      <p:sp>
-        <p:nvSpPr>
-          <p:cNvPr id="10" name="TextBox 9"/>
-          <p:cNvSpPr txBox="1"/>
-          <p:nvPr/>
-        </p:nvSpPr>
-        <p:spPr>
-          <a:xfrm>
-            <a:off x="8686800" y="1508760"/>
-            <a:ext cx="2926080" cy="548640"/>
-          </a:xfrm>
-          <a:prstGeom prst="rect">
-            <a:avLst/>
-          </a:prstGeom>
-          <a:noFill/>
-        </p:spPr>
-        <p:txBody>
-          <a:bodyPr wrap="square">
-            <a:spAutoFit/>
-          </a:bodyPr>
-          <a:lstStyle/>
-          <a:p>
-            <a:pPr algn="l"/>
-            <a:r>
-              <a:rPr sz="1400" b="1">
-                <a:solidFill>
-                  <a:srgbClr val="4F8F12"/>
-                </a:solidFill>
-                <a:latin typeface="Arial"/>
-              </a:rPr>
-              <a:t>Story + named gap drivers</a:t>
-            </a:r>
-          </a:p>
-        </p:txBody>
-      </p:sp>
-      <p:sp>
-        <p:nvSpPr>
           <p:cNvPr id="11" name="Rounded Rectangle 10"/>
           <p:cNvSpPr/>
           <p:nvPr/>
@@ -14747,76 +14867,6 @@
       </p:sp>
       <p:sp>
         <p:nvSpPr>
-          <p:cNvPr id="14" name="TextBox 13"/>
-          <p:cNvSpPr txBox="1"/>
-          <p:nvPr/>
-        </p:nvSpPr>
-        <p:spPr>
-          <a:xfrm>
-            <a:off x="5120640" y="2377440"/>
-            <a:ext cx="3474720" cy="548640"/>
-          </a:xfrm>
-          <a:prstGeom prst="rect">
-            <a:avLst/>
-          </a:prstGeom>
-          <a:noFill/>
-        </p:spPr>
-        <p:txBody>
-          <a:bodyPr wrap="square">
-            <a:spAutoFit/>
-          </a:bodyPr>
-          <a:lstStyle/>
-          <a:p>
-            <a:pPr algn="l"/>
-            <a:r>
-              <a:rPr sz="1400" b="0">
-                <a:solidFill>
-                  <a:srgbClr val="6A7264"/>
-                </a:solidFill>
-                <a:latin typeface="Arial"/>
-              </a:rPr>
-              <a:t>Backfill / not backfilling / pivot undefined</a:t>
-            </a:r>
-          </a:p>
-        </p:txBody>
-      </p:sp>
-      <p:sp>
-        <p:nvSpPr>
-          <p:cNvPr id="15" name="TextBox 14"/>
-          <p:cNvSpPr txBox="1"/>
-          <p:nvPr/>
-        </p:nvSpPr>
-        <p:spPr>
-          <a:xfrm>
-            <a:off x="8686800" y="2377440"/>
-            <a:ext cx="2926080" cy="548640"/>
-          </a:xfrm>
-          <a:prstGeom prst="rect">
-            <a:avLst/>
-          </a:prstGeom>
-          <a:noFill/>
-        </p:spPr>
-        <p:txBody>
-          <a:bodyPr wrap="square">
-            <a:spAutoFit/>
-          </a:bodyPr>
-          <a:lstStyle/>
-          <a:p>
-            <a:pPr algn="l"/>
-            <a:r>
-              <a:rPr sz="1400" b="1">
-                <a:solidFill>
-                  <a:srgbClr val="4F8F12"/>
-                </a:solidFill>
-                <a:latin typeface="Arial"/>
-              </a:rPr>
-              <a:t>Shared disposition tags</a:t>
-            </a:r>
-          </a:p>
-        </p:txBody>
-      </p:sp>
-      <p:sp>
-        <p:nvSpPr>
           <p:cNvPr id="16" name="Rounded Rectangle 15"/>
           <p:cNvSpPr/>
           <p:nvPr/>
@@ -14933,106 +14983,6 @@
       </p:sp>
       <p:sp>
         <p:nvSpPr>
-          <p:cNvPr id="19" name="TextBox 18"/>
-          <p:cNvSpPr txBox="1"/>
-          <p:nvPr/>
-        </p:nvSpPr>
-        <p:spPr>
-          <a:xfrm>
-            <a:off x="5120640" y="3246120"/>
-            <a:ext cx="3474720" cy="523220"/>
-          </a:xfrm>
-          <a:prstGeom prst="rect">
-            <a:avLst/>
-          </a:prstGeom>
-          <a:noFill/>
-        </p:spPr>
-        <p:txBody>
-          <a:bodyPr wrap="square">
-            <a:spAutoFit/>
-          </a:bodyPr>
-          <a:lstStyle/>
-          <a:p>
-            <a:pPr algn="l"/>
-            <a:r>
-              <a:rPr sz="1400" b="0" dirty="0">
-                <a:solidFill>
-                  <a:srgbClr val="6A7264"/>
-                </a:solidFill>
-                <a:latin typeface="Arial"/>
-              </a:rPr>
-              <a:t>Mid-cycle changes live only in spreadsheets</a:t>
-            </a:r>
-            <a:r>
-              <a:rPr lang="en-US" sz="1400" b="0" dirty="0">
-                <a:solidFill>
-                  <a:srgbClr val="6A7264"/>
-                </a:solidFill>
-                <a:latin typeface="Arial"/>
-              </a:rPr>
-              <a:t> an not accessible </a:t>
-            </a:r>
-            <a:endParaRPr sz="1400" b="0" dirty="0">
-              <a:solidFill>
-                <a:srgbClr val="6A7264"/>
-              </a:solidFill>
-              <a:latin typeface="Arial"/>
-            </a:endParaRPr>
-          </a:p>
-        </p:txBody>
-      </p:sp>
-      <p:sp>
-        <p:nvSpPr>
-          <p:cNvPr id="20" name="TextBox 19"/>
-          <p:cNvSpPr txBox="1"/>
-          <p:nvPr/>
-        </p:nvSpPr>
-        <p:spPr>
-          <a:xfrm>
-            <a:off x="8686800" y="3246120"/>
-            <a:ext cx="2926080" cy="307777"/>
-          </a:xfrm>
-          <a:prstGeom prst="rect">
-            <a:avLst/>
-          </a:prstGeom>
-          <a:noFill/>
-        </p:spPr>
-        <p:txBody>
-          <a:bodyPr wrap="square">
-            <a:spAutoFit/>
-          </a:bodyPr>
-          <a:lstStyle/>
-          <a:p>
-            <a:pPr algn="l"/>
-            <a:r>
-              <a:rPr sz="1400" b="1" dirty="0">
-                <a:solidFill>
-                  <a:srgbClr val="4F8F12"/>
-                </a:solidFill>
-                <a:latin typeface="Arial"/>
-              </a:rPr>
-              <a:t>Manual update</a:t>
-            </a:r>
-            <a:r>
-              <a:rPr lang="en-US" sz="1400" b="1" dirty="0">
-                <a:solidFill>
-                  <a:srgbClr val="4F8F12"/>
-                </a:solidFill>
-                <a:latin typeface="Arial"/>
-              </a:rPr>
-              <a:t>s required</a:t>
-            </a:r>
-            <a:endParaRPr sz="1400" b="1" dirty="0">
-              <a:solidFill>
-                <a:srgbClr val="4F8F12"/>
-              </a:solidFill>
-              <a:latin typeface="Arial"/>
-            </a:endParaRPr>
-          </a:p>
-        </p:txBody>
-      </p:sp>
-      <p:sp>
-        <p:nvSpPr>
           <p:cNvPr id="21" name="Rounded Rectangle 20"/>
           <p:cNvSpPr/>
           <p:nvPr/>
@@ -15149,91 +15099,6 @@
       </p:sp>
       <p:sp>
         <p:nvSpPr>
-          <p:cNvPr id="24" name="TextBox 23"/>
-          <p:cNvSpPr txBox="1"/>
-          <p:nvPr/>
-        </p:nvSpPr>
-        <p:spPr>
-          <a:xfrm>
-            <a:off x="5120640" y="4114799"/>
-            <a:ext cx="3474720" cy="548640"/>
-          </a:xfrm>
-          <a:prstGeom prst="rect">
-            <a:avLst/>
-          </a:prstGeom>
-          <a:noFill/>
-        </p:spPr>
-        <p:txBody>
-          <a:bodyPr wrap="square">
-            <a:spAutoFit/>
-          </a:bodyPr>
-          <a:lstStyle/>
-          <a:p>
-            <a:pPr algn="l"/>
-            <a:r>
-              <a:rPr sz="1400" b="0">
-                <a:solidFill>
-                  <a:srgbClr val="6A7264"/>
-                </a:solidFill>
-                <a:latin typeface="Arial"/>
-              </a:rPr>
-              <a:t>Today vs close date confused</a:t>
-            </a:r>
-          </a:p>
-        </p:txBody>
-      </p:sp>
-      <p:sp>
-        <p:nvSpPr>
-          <p:cNvPr id="25" name="TextBox 24"/>
-          <p:cNvSpPr txBox="1"/>
-          <p:nvPr/>
-        </p:nvSpPr>
-        <p:spPr>
-          <a:xfrm>
-            <a:off x="8686800" y="4114799"/>
-            <a:ext cx="2926080" cy="523220"/>
-          </a:xfrm>
-          <a:prstGeom prst="rect">
-            <a:avLst/>
-          </a:prstGeom>
-          <a:noFill/>
-        </p:spPr>
-        <p:txBody>
-          <a:bodyPr wrap="square">
-            <a:spAutoFit/>
-          </a:bodyPr>
-          <a:lstStyle/>
-          <a:p>
-            <a:pPr algn="l"/>
-            <a:r>
-              <a:rPr sz="1400" b="1" dirty="0">
-                <a:solidFill>
-                  <a:srgbClr val="4F8F12"/>
-                </a:solidFill>
-                <a:latin typeface="Arial"/>
-              </a:rPr>
-              <a:t>Explicit </a:t>
-            </a:r>
-            <a:r>
-              <a:rPr lang="en-US" sz="1400" b="1" dirty="0">
-                <a:solidFill>
-                  <a:srgbClr val="4F8F12"/>
-                </a:solidFill>
-                <a:latin typeface="Arial"/>
-              </a:rPr>
-              <a:t>as-of dates / real time data</a:t>
-            </a:r>
-            <a:endParaRPr sz="1400" b="1" dirty="0">
-              <a:solidFill>
-                <a:srgbClr val="4F8F12"/>
-              </a:solidFill>
-              <a:latin typeface="Arial"/>
-            </a:endParaRPr>
-          </a:p>
-        </p:txBody>
-      </p:sp>
-      <p:sp>
-        <p:nvSpPr>
           <p:cNvPr id="26" name="Rounded Rectangle 25"/>
           <p:cNvSpPr/>
           <p:nvPr/>
@@ -15374,76 +15239,6 @@
       </p:sp>
       <p:sp>
         <p:nvSpPr>
-          <p:cNvPr id="29" name="TextBox 28"/>
-          <p:cNvSpPr txBox="1"/>
-          <p:nvPr/>
-        </p:nvSpPr>
-        <p:spPr>
-          <a:xfrm>
-            <a:off x="5120640" y="4983480"/>
-            <a:ext cx="3474720" cy="548640"/>
-          </a:xfrm>
-          <a:prstGeom prst="rect">
-            <a:avLst/>
-          </a:prstGeom>
-          <a:noFill/>
-        </p:spPr>
-        <p:txBody>
-          <a:bodyPr wrap="square">
-            <a:spAutoFit/>
-          </a:bodyPr>
-          <a:lstStyle/>
-          <a:p>
-            <a:pPr algn="l"/>
-            <a:r>
-              <a:rPr sz="1400" b="0">
-                <a:solidFill>
-                  <a:srgbClr val="6A7264"/>
-                </a:solidFill>
-                <a:latin typeface="Arial"/>
-              </a:rPr>
-              <a:t>Grids serve authors, not leaders</a:t>
-            </a:r>
-          </a:p>
-        </p:txBody>
-      </p:sp>
-      <p:sp>
-        <p:nvSpPr>
-          <p:cNvPr id="30" name="TextBox 29"/>
-          <p:cNvSpPr txBox="1"/>
-          <p:nvPr/>
-        </p:nvSpPr>
-        <p:spPr>
-          <a:xfrm>
-            <a:off x="8686800" y="4983480"/>
-            <a:ext cx="2926080" cy="548640"/>
-          </a:xfrm>
-          <a:prstGeom prst="rect">
-            <a:avLst/>
-          </a:prstGeom>
-          <a:noFill/>
-        </p:spPr>
-        <p:txBody>
-          <a:bodyPr wrap="square">
-            <a:spAutoFit/>
-          </a:bodyPr>
-          <a:lstStyle/>
-          <a:p>
-            <a:pPr algn="l"/>
-            <a:r>
-              <a:rPr sz="1400" b="1">
-                <a:solidFill>
-                  <a:srgbClr val="4F8F12"/>
-                </a:solidFill>
-                <a:latin typeface="Arial"/>
-              </a:rPr>
-              <a:t>Bridge tells the story first</a:t>
-            </a:r>
-          </a:p>
-        </p:txBody>
-      </p:sp>
-      <p:sp>
-        <p:nvSpPr>
           <p:cNvPr id="31" name="TextBox 30"/>
           <p:cNvSpPr txBox="1"/>
           <p:nvPr/>
@@ -15508,6 +15303,221 @@
                 <a:latin typeface="Arial"/>
               </a:rPr>
               <a:t>9/15</a:t>
+            </a:r>
+          </a:p>
+        </p:txBody>
+      </p:sp>
+      <p:sp>
+        <p:nvSpPr>
+          <p:cNvPr id="33" name="TextBox 32"/>
+          <p:cNvSpPr txBox="1"/>
+          <p:nvPr/>
+        </p:nvSpPr>
+        <p:spPr>
+          <a:xfrm>
+            <a:off x="4937760" y="1508760"/>
+            <a:ext cx="6583680" cy="640080"/>
+          </a:xfrm>
+          <a:prstGeom prst="rect">
+            <a:avLst/>
+          </a:prstGeom>
+          <a:noFill/>
+        </p:spPr>
+        <p:txBody>
+          <a:bodyPr wrap="square">
+            <a:spAutoFit/>
+          </a:bodyPr>
+          <a:lstStyle/>
+          <a:p>
+            <a:r>
+              <a:rPr sz="1400" b="1">
+                <a:solidFill>
+                  <a:srgbClr val="4F8F12"/>
+                </a:solidFill>
+                <a:latin typeface="Arial"/>
+              </a:rPr>
+              <a:t>Benefit: </a:t>
+            </a:r>
+            <a:r>
+              <a:rPr sz="1400" b="0">
+                <a:solidFill>
+                  <a:srgbClr val="4F8F12"/>
+                </a:solidFill>
+                <a:latin typeface="Arial"/>
+              </a:rPr>
+              <a:t>Leaders can follow the recon without a specialist walking them through the tabs.</a:t>
+            </a:r>
+          </a:p>
+        </p:txBody>
+      </p:sp>
+      <p:sp>
+        <p:nvSpPr>
+          <p:cNvPr id="34" name="TextBox 33"/>
+          <p:cNvSpPr txBox="1"/>
+          <p:nvPr/>
+        </p:nvSpPr>
+        <p:spPr>
+          <a:xfrm>
+            <a:off x="4937760" y="2377440"/>
+            <a:ext cx="6583680" cy="640080"/>
+          </a:xfrm>
+          <a:prstGeom prst="rect">
+            <a:avLst/>
+          </a:prstGeom>
+          <a:noFill/>
+        </p:spPr>
+        <p:txBody>
+          <a:bodyPr wrap="square">
+            <a:spAutoFit/>
+          </a:bodyPr>
+          <a:lstStyle/>
+          <a:p>
+            <a:r>
+              <a:rPr sz="1400" b="1">
+                <a:solidFill>
+                  <a:srgbClr val="4F8F12"/>
+                </a:solidFill>
+                <a:latin typeface="Arial"/>
+              </a:rPr>
+              <a:t>Benefit: </a:t>
+            </a:r>
+            <a:r>
+              <a:rPr sz="1400" b="0">
+                <a:solidFill>
+                  <a:srgbClr val="4F8F12"/>
+                </a:solidFill>
+                <a:latin typeface="Arial"/>
+              </a:rPr>
+              <a:t>Finance and HR mean the same thing when they say backfill, not backfilling, or pivot.</a:t>
+            </a:r>
+          </a:p>
+        </p:txBody>
+      </p:sp>
+      <p:sp>
+        <p:nvSpPr>
+          <p:cNvPr id="35" name="TextBox 34"/>
+          <p:cNvSpPr txBox="1"/>
+          <p:nvPr/>
+        </p:nvSpPr>
+        <p:spPr>
+          <a:xfrm>
+            <a:off x="4937760" y="3246120"/>
+            <a:ext cx="6583680" cy="640080"/>
+          </a:xfrm>
+          <a:prstGeom prst="rect">
+            <a:avLst/>
+          </a:prstGeom>
+          <a:noFill/>
+        </p:spPr>
+        <p:txBody>
+          <a:bodyPr wrap="square">
+            <a:spAutoFit/>
+          </a:bodyPr>
+          <a:lstStyle/>
+          <a:p>
+            <a:r>
+              <a:rPr sz="1400" b="1">
+                <a:solidFill>
+                  <a:srgbClr val="4F8F12"/>
+                </a:solidFill>
+                <a:latin typeface="Arial"/>
+              </a:rPr>
+              <a:t>Benefit: </a:t>
+            </a:r>
+            <a:r>
+              <a:rPr sz="1400" b="0">
+                <a:solidFill>
+                  <a:srgbClr val="4F8F12"/>
+                </a:solidFill>
+                <a:latin typeface="Arial"/>
+              </a:rPr>
+              <a:t>Mid-cycle changes don’t disappear into one person’s spreadsheet.</a:t>
+            </a:r>
+          </a:p>
+        </p:txBody>
+      </p:sp>
+      <p:sp>
+        <p:nvSpPr>
+          <p:cNvPr id="36" name="TextBox 35"/>
+          <p:cNvSpPr txBox="1"/>
+          <p:nvPr/>
+        </p:nvSpPr>
+        <p:spPr>
+          <a:xfrm>
+            <a:off x="4937760" y="4114799"/>
+            <a:ext cx="6583680" cy="640080"/>
+          </a:xfrm>
+          <a:prstGeom prst="rect">
+            <a:avLst/>
+          </a:prstGeom>
+          <a:noFill/>
+        </p:spPr>
+        <p:txBody>
+          <a:bodyPr wrap="square">
+            <a:spAutoFit/>
+          </a:bodyPr>
+          <a:lstStyle/>
+          <a:p>
+            <a:r>
+              <a:rPr sz="1400" b="1">
+                <a:solidFill>
+                  <a:srgbClr val="4F8F12"/>
+                </a:solidFill>
+                <a:latin typeface="Arial"/>
+              </a:rPr>
+              <a:t>Benefit: </a:t>
+            </a:r>
+            <a:r>
+              <a:rPr sz="1400" b="0">
+                <a:solidFill>
+                  <a:srgbClr val="4F8F12"/>
+                </a:solidFill>
+                <a:latin typeface="Arial"/>
+              </a:rPr>
+              <a:t>Everyone knows whether the number is as of close — or as of today.</a:t>
+            </a:r>
+          </a:p>
+        </p:txBody>
+      </p:sp>
+      <p:sp>
+        <p:nvSpPr>
+          <p:cNvPr id="37" name="TextBox 36"/>
+          <p:cNvSpPr txBox="1"/>
+          <p:nvPr/>
+        </p:nvSpPr>
+        <p:spPr>
+          <a:xfrm>
+            <a:off x="4937760" y="4983480"/>
+            <a:ext cx="6583680" cy="640080"/>
+          </a:xfrm>
+          <a:prstGeom prst="rect">
+            <a:avLst/>
+          </a:prstGeom>
+          <a:noFill/>
+        </p:spPr>
+        <p:txBody>
+          <a:bodyPr wrap="square">
+            <a:spAutoFit/>
+          </a:bodyPr>
+          <a:lstStyle/>
+          <a:p>
+            <a:r>
+              <a:rPr sz="1400" b="1">
+                <a:solidFill>
+                  <a:srgbClr val="4F8F12"/>
+                </a:solidFill>
+                <a:latin typeface="Arial"/>
+              </a:rPr>
+              <a:t>Benefit: </a:t>
+            </a:r>
+            <a:r>
+              <a:rPr sz="1400" b="0">
+                <a:solidFill>
+                  <a:srgbClr val="4F8F12"/>
+                </a:solidFill>
+                <a:latin typeface="Arial"/>
+              </a:rPr>
+              <a:t>The gap is readable in one pass — not buried in a grid for authors.</a:t>
             </a:r>
           </a:p>
         </p:txBody>

</xml_diff>

<commit_message>
Add a prototype Feature → Benefit slide after Iterations.
</commit_message>
<xml_diff>
--- a/deck/Headcount_Control_Tower_Case_Study.pptx
+++ b/deck/Headcount_Control_Tower_Case_Study.pptx
@@ -20,6 +20,7 @@
     <p:sldId id="264" r:id="rId11"/>
     <p:sldId id="265" r:id="rId12"/>
     <p:sldId id="266" r:id="rId13"/>
+    <p:sldId id="271" r:id="rId22"/>
     <p:sldId id="267" r:id="rId14"/>
     <p:sldId id="268" r:id="rId15"/>
     <p:sldId id="269" r:id="rId16"/>
@@ -747,6 +748,31 @@
         </p:nvSpPr>
         <p:spPr/>
       </p:sp>
+    </p:spTree>
+  </p:cSld>
+  <p:clrMapOvr>
+    <a:masterClrMapping/>
+  </p:clrMapOvr>
+</p:notes>
+</file>
+
+<file path=ppt/notesSlides/notesSlide16.xml><?xml version="1.0" encoding="utf-8"?>
+<p:notes xmlns:a="http://schemas.openxmlformats.org/drawingml/2006/main" xmlns:p="http://schemas.openxmlformats.org/presentationml/2006/main" xmlns:r="http://schemas.openxmlformats.org/officeDocument/2006/relationships">
+  <p:cSld>
+    <p:spTree>
+      <p:nvGrpSpPr>
+        <p:cNvPr id="1" name=""/>
+        <p:cNvGrpSpPr/>
+        <p:nvPr/>
+      </p:nvGrpSpPr>
+      <p:grpSpPr>
+        <a:xfrm>
+          <a:off x="0" y="0"/>
+          <a:ext cx="0" cy="0"/>
+          <a:chOff x="0" y="0"/>
+          <a:chExt cx="0" cy="0"/>
+        </a:xfrm>
+      </p:grpSpPr>
     </p:spTree>
   </p:cSld>
   <p:clrMapOvr>
@@ -5604,7 +5630,7 @@
                 </a:solidFill>
                 <a:latin typeface="Arial"/>
               </a:rPr>
-              <a:t>10/15</a:t>
+              <a:t>10/16</a:t>
             </a:r>
           </a:p>
         </p:txBody>
@@ -6377,7 +6403,7 @@
                 </a:solidFill>
                 <a:latin typeface="Arial"/>
               </a:rPr>
-              <a:t>11/15</a:t>
+              <a:t>11/16</a:t>
             </a:r>
           </a:p>
         </p:txBody>
@@ -7036,7 +7062,7 @@
                 </a:solidFill>
                 <a:latin typeface="Arial"/>
               </a:rPr>
-              <a:t>12/15</a:t>
+              <a:t>12/16</a:t>
             </a:r>
           </a:p>
         </p:txBody>
@@ -8484,7 +8510,7 @@
                 </a:solidFill>
                 <a:latin typeface="Arial"/>
               </a:rPr>
-              <a:t>13/15</a:t>
+              <a:t>14/16</a:t>
             </a:r>
           </a:p>
         </p:txBody>
@@ -9225,7 +9251,7 @@
                 </a:solidFill>
                 <a:latin typeface="Arial"/>
               </a:rPr>
-              <a:t>14/15</a:t>
+              <a:t>15/16</a:t>
             </a:r>
           </a:p>
         </p:txBody>
@@ -9462,13 +9488,13 @@
           <a:p>
             <a:pPr algn="r"/>
             <a:r>
-              <a:rPr sz="1100">
+              <a:rPr sz="1100" b="0">
                 <a:solidFill>
                   <a:srgbClr val="6A7264"/>
                 </a:solidFill>
                 <a:latin typeface="Arial"/>
               </a:rPr>
-              <a:t>15/15</a:t>
+              <a:t>16/16</a:t>
             </a:r>
           </a:p>
         </p:txBody>
@@ -9503,6 +9529,1314 @@
                 <a:latin typeface="Arial"/>
               </a:rPr>
               <a:t>BambooHR interview case study</a:t>
+            </a:r>
+          </a:p>
+        </p:txBody>
+      </p:sp>
+    </p:spTree>
+  </p:cSld>
+  <p:clrMapOvr>
+    <a:masterClrMapping/>
+  </p:clrMapOvr>
+</p:sld>
+</file>
+
+<file path=ppt/slides/slide16.xml><?xml version="1.0" encoding="utf-8"?>
+<p:sld xmlns:a="http://schemas.openxmlformats.org/drawingml/2006/main" xmlns:p="http://schemas.openxmlformats.org/presentationml/2006/main" xmlns:r="http://schemas.openxmlformats.org/officeDocument/2006/relationships">
+  <p:cSld>
+    <p:spTree>
+      <p:nvGrpSpPr>
+        <p:cNvPr id="1" name=""/>
+        <p:cNvGrpSpPr/>
+        <p:nvPr/>
+      </p:nvGrpSpPr>
+      <p:grpSpPr/>
+      <p:sp>
+        <p:nvSpPr>
+          <p:cNvPr id="2" name="Rectangle 1"/>
+          <p:cNvSpPr/>
+          <p:nvPr/>
+        </p:nvSpPr>
+        <p:spPr>
+          <a:xfrm>
+            <a:off x="0" y="0"/>
+            <a:ext cx="12191695" cy="54864"/>
+          </a:xfrm>
+          <a:prstGeom prst="rect">
+            <a:avLst/>
+          </a:prstGeom>
+          <a:solidFill>
+            <a:srgbClr val="73C41D"/>
+          </a:solidFill>
+          <a:ln>
+            <a:noFill/>
+          </a:ln>
+        </p:spPr>
+        <p:style>
+          <a:lnRef idx="1">
+            <a:schemeClr val="accent1"/>
+          </a:lnRef>
+          <a:fillRef idx="3">
+            <a:schemeClr val="accent1"/>
+          </a:fillRef>
+          <a:effectRef idx="2">
+            <a:schemeClr val="accent1"/>
+          </a:effectRef>
+          <a:fontRef idx="minor">
+            <a:schemeClr val="lt1"/>
+          </a:fontRef>
+        </p:style>
+        <p:txBody>
+          <a:bodyPr rtlCol="0" anchor="ctr"/>
+          <a:lstStyle/>
+          <a:p>
+            <a:pPr algn="ctr"/>
+          </a:p>
+        </p:txBody>
+      </p:sp>
+      <p:pic>
+        <p:nvPicPr>
+          <p:cNvPr id="3" name="Picture 2" descr="image.png"/>
+          <p:cNvPicPr>
+            <a:picLocks noChangeAspect="1"/>
+          </p:cNvPicPr>
+          <p:nvPr/>
+        </p:nvPicPr>
+        <p:blipFill>
+          <a:blip r:embed="rId2"/>
+          <a:stretch>
+            <a:fillRect/>
+          </a:stretch>
+        </p:blipFill>
+        <p:spPr>
+          <a:xfrm>
+            <a:off x="685800" y="256032"/>
+            <a:ext cx="1417320" cy="304174"/>
+          </a:xfrm>
+          <a:prstGeom prst="rect">
+            <a:avLst/>
+          </a:prstGeom>
+        </p:spPr>
+      </p:pic>
+      <p:sp>
+        <p:nvSpPr>
+          <p:cNvPr id="4" name="TextBox 3"/>
+          <p:cNvSpPr txBox="1"/>
+          <p:nvPr/>
+        </p:nvSpPr>
+        <p:spPr>
+          <a:xfrm>
+            <a:off x="2331720" y="228600"/>
+            <a:ext cx="9144000" cy="228600"/>
+          </a:xfrm>
+          <a:prstGeom prst="rect">
+            <a:avLst/>
+          </a:prstGeom>
+          <a:noFill/>
+        </p:spPr>
+        <p:txBody>
+          <a:bodyPr wrap="square">
+            <a:spAutoFit/>
+          </a:bodyPr>
+          <a:lstStyle/>
+          <a:p>
+            <a:pPr>
+              <a:spcBef>
+                <a:spcPts val="0"/>
+              </a:spcBef>
+            </a:pPr>
+            <a:r>
+              <a:rPr sz="1100" b="1">
+                <a:solidFill>
+                  <a:srgbClr val="4F8F12"/>
+                </a:solidFill>
+                <a:latin typeface="Arial"/>
+              </a:rPr>
+              <a:t>THE PROTOTYPE</a:t>
+            </a:r>
+          </a:p>
+        </p:txBody>
+      </p:sp>
+      <p:sp>
+        <p:nvSpPr>
+          <p:cNvPr id="5" name="TextBox 4"/>
+          <p:cNvSpPr txBox="1"/>
+          <p:nvPr/>
+        </p:nvSpPr>
+        <p:spPr>
+          <a:xfrm>
+            <a:off x="2331720" y="457200"/>
+            <a:ext cx="9326880" cy="457200"/>
+          </a:xfrm>
+          <a:prstGeom prst="rect">
+            <a:avLst/>
+          </a:prstGeom>
+          <a:noFill/>
+        </p:spPr>
+        <p:txBody>
+          <a:bodyPr wrap="square">
+            <a:spAutoFit/>
+          </a:bodyPr>
+          <a:lstStyle/>
+          <a:p>
+            <a:pPr>
+              <a:spcBef>
+                <a:spcPts val="0"/>
+              </a:spcBef>
+            </a:pPr>
+            <a:r>
+              <a:rPr sz="2600" b="1">
+                <a:solidFill>
+                  <a:srgbClr val="1B1F17"/>
+                </a:solidFill>
+                <a:latin typeface="Arial"/>
+              </a:rPr>
+              <a:t>What we built — and why</a:t>
+            </a:r>
+          </a:p>
+        </p:txBody>
+      </p:sp>
+      <p:sp>
+        <p:nvSpPr>
+          <p:cNvPr id="6" name="TextBox 5"/>
+          <p:cNvSpPr txBox="1"/>
+          <p:nvPr/>
+        </p:nvSpPr>
+        <p:spPr>
+          <a:xfrm>
+            <a:off x="2331720" y="960120"/>
+            <a:ext cx="9326880" cy="320040"/>
+          </a:xfrm>
+          <a:prstGeom prst="rect">
+            <a:avLst/>
+          </a:prstGeom>
+          <a:noFill/>
+        </p:spPr>
+        <p:txBody>
+          <a:bodyPr wrap="square">
+            <a:spAutoFit/>
+          </a:bodyPr>
+          <a:lstStyle/>
+          <a:p>
+            <a:pPr>
+              <a:spcBef>
+                <a:spcPts val="0"/>
+              </a:spcBef>
+            </a:pPr>
+            <a:r>
+              <a:rPr sz="1500" b="0">
+                <a:solidFill>
+                  <a:srgbClr val="6A7264"/>
+                </a:solidFill>
+                <a:latin typeface="Arial"/>
+              </a:rPr>
+              <a:t>Each feature maps to a clear benefit for Finance and HR.</a:t>
+            </a:r>
+          </a:p>
+        </p:txBody>
+      </p:sp>
+      <p:sp>
+        <p:nvSpPr>
+          <p:cNvPr id="7" name="Rounded Rectangle 6"/>
+          <p:cNvSpPr/>
+          <p:nvPr/>
+        </p:nvSpPr>
+        <p:spPr>
+          <a:xfrm>
+            <a:off x="685800" y="1417320"/>
+            <a:ext cx="5440680" cy="1371600"/>
+          </a:xfrm>
+          <a:prstGeom prst="roundRect">
+            <a:avLst>
+              <a:gd name="adj" fmla="val 6000"/>
+            </a:avLst>
+          </a:prstGeom>
+          <a:solidFill>
+            <a:srgbClr val="FFFFFF"/>
+          </a:solidFill>
+          <a:ln>
+            <a:solidFill>
+              <a:srgbClr val="E6EAE1"/>
+            </a:solidFill>
+          </a:ln>
+        </p:spPr>
+        <p:style>
+          <a:lnRef idx="1">
+            <a:schemeClr val="accent1"/>
+          </a:lnRef>
+          <a:fillRef idx="3">
+            <a:schemeClr val="accent1"/>
+          </a:fillRef>
+          <a:effectRef idx="2">
+            <a:schemeClr val="accent1"/>
+          </a:effectRef>
+          <a:fontRef idx="minor">
+            <a:schemeClr val="lt1"/>
+          </a:fontRef>
+        </p:style>
+        <p:txBody>
+          <a:bodyPr rtlCol="0" anchor="ctr"/>
+          <a:lstStyle/>
+          <a:p>
+            <a:pPr algn="ctr"/>
+          </a:p>
+        </p:txBody>
+      </p:sp>
+      <p:sp>
+        <p:nvSpPr>
+          <p:cNvPr id="8" name="Rectangle 7"/>
+          <p:cNvSpPr/>
+          <p:nvPr/>
+        </p:nvSpPr>
+        <p:spPr>
+          <a:xfrm>
+            <a:off x="685800" y="1417320"/>
+            <a:ext cx="73152" cy="1371600"/>
+          </a:xfrm>
+          <a:prstGeom prst="rect">
+            <a:avLst/>
+          </a:prstGeom>
+          <a:solidFill>
+            <a:srgbClr val="73C41D"/>
+          </a:solidFill>
+          <a:ln>
+            <a:noFill/>
+          </a:ln>
+        </p:spPr>
+        <p:style>
+          <a:lnRef idx="1">
+            <a:schemeClr val="accent1"/>
+          </a:lnRef>
+          <a:fillRef idx="3">
+            <a:schemeClr val="accent1"/>
+          </a:fillRef>
+          <a:effectRef idx="2">
+            <a:schemeClr val="accent1"/>
+          </a:effectRef>
+          <a:fontRef idx="minor">
+            <a:schemeClr val="lt1"/>
+          </a:fontRef>
+        </p:style>
+        <p:txBody>
+          <a:bodyPr rtlCol="0" anchor="ctr"/>
+          <a:lstStyle/>
+          <a:p>
+            <a:pPr algn="ctr"/>
+          </a:p>
+        </p:txBody>
+      </p:sp>
+      <p:sp>
+        <p:nvSpPr>
+          <p:cNvPr id="9" name="TextBox 8"/>
+          <p:cNvSpPr txBox="1"/>
+          <p:nvPr/>
+        </p:nvSpPr>
+        <p:spPr>
+          <a:xfrm>
+            <a:off x="960120" y="1645920"/>
+            <a:ext cx="4937760" cy="365760"/>
+          </a:xfrm>
+          <a:prstGeom prst="rect">
+            <a:avLst/>
+          </a:prstGeom>
+          <a:noFill/>
+        </p:spPr>
+        <p:txBody>
+          <a:bodyPr wrap="square">
+            <a:spAutoFit/>
+          </a:bodyPr>
+          <a:lstStyle/>
+          <a:p>
+            <a:pPr>
+              <a:spcBef>
+                <a:spcPts val="0"/>
+              </a:spcBef>
+            </a:pPr>
+            <a:r>
+              <a:rPr sz="1600" b="1">
+                <a:solidFill>
+                  <a:srgbClr val="1B1F17"/>
+                </a:solidFill>
+                <a:latin typeface="Arial"/>
+              </a:rPr>
+              <a:t>Company story first</a:t>
+            </a:r>
+          </a:p>
+        </p:txBody>
+      </p:sp>
+      <p:sp>
+        <p:nvSpPr>
+          <p:cNvPr id="10" name="TextBox 9"/>
+          <p:cNvSpPr txBox="1"/>
+          <p:nvPr/>
+        </p:nvSpPr>
+        <p:spPr>
+          <a:xfrm>
+            <a:off x="960120" y="2057400"/>
+            <a:ext cx="4937760" cy="548640"/>
+          </a:xfrm>
+          <a:prstGeom prst="rect">
+            <a:avLst/>
+          </a:prstGeom>
+          <a:noFill/>
+        </p:spPr>
+        <p:txBody>
+          <a:bodyPr wrap="square">
+            <a:spAutoFit/>
+          </a:bodyPr>
+          <a:lstStyle/>
+          <a:p>
+            <a:r>
+              <a:rPr sz="1400" b="1">
+                <a:solidFill>
+                  <a:srgbClr val="4F8F12"/>
+                </a:solidFill>
+                <a:latin typeface="Arial"/>
+              </a:rPr>
+              <a:t>Benefit: </a:t>
+            </a:r>
+            <a:r>
+              <a:rPr sz="1400" b="0">
+                <a:solidFill>
+                  <a:srgbClr val="4F8F12"/>
+                </a:solidFill>
+                <a:latin typeface="Arial"/>
+              </a:rPr>
+              <a:t>Anyone can see plan vs filled — and what’s behind the gap — in seconds.</a:t>
+            </a:r>
+          </a:p>
+        </p:txBody>
+      </p:sp>
+      <p:sp>
+        <p:nvSpPr>
+          <p:cNvPr id="11" name="Rounded Rectangle 10"/>
+          <p:cNvSpPr/>
+          <p:nvPr/>
+        </p:nvSpPr>
+        <p:spPr>
+          <a:xfrm>
+            <a:off x="6355080" y="1417320"/>
+            <a:ext cx="5440680" cy="1371600"/>
+          </a:xfrm>
+          <a:prstGeom prst="roundRect">
+            <a:avLst>
+              <a:gd name="adj" fmla="val 6000"/>
+            </a:avLst>
+          </a:prstGeom>
+          <a:solidFill>
+            <a:srgbClr val="FFFFFF"/>
+          </a:solidFill>
+          <a:ln>
+            <a:solidFill>
+              <a:srgbClr val="E6EAE1"/>
+            </a:solidFill>
+          </a:ln>
+        </p:spPr>
+        <p:style>
+          <a:lnRef idx="1">
+            <a:schemeClr val="accent1"/>
+          </a:lnRef>
+          <a:fillRef idx="3">
+            <a:schemeClr val="accent1"/>
+          </a:fillRef>
+          <a:effectRef idx="2">
+            <a:schemeClr val="accent1"/>
+          </a:effectRef>
+          <a:fontRef idx="minor">
+            <a:schemeClr val="lt1"/>
+          </a:fontRef>
+        </p:style>
+        <p:txBody>
+          <a:bodyPr rtlCol="0" anchor="ctr"/>
+          <a:lstStyle/>
+          <a:p>
+            <a:pPr algn="ctr"/>
+          </a:p>
+        </p:txBody>
+      </p:sp>
+      <p:sp>
+        <p:nvSpPr>
+          <p:cNvPr id="12" name="Rectangle 11"/>
+          <p:cNvSpPr/>
+          <p:nvPr/>
+        </p:nvSpPr>
+        <p:spPr>
+          <a:xfrm>
+            <a:off x="6355080" y="1417320"/>
+            <a:ext cx="73152" cy="1371600"/>
+          </a:xfrm>
+          <a:prstGeom prst="rect">
+            <a:avLst/>
+          </a:prstGeom>
+          <a:solidFill>
+            <a:srgbClr val="73C41D"/>
+          </a:solidFill>
+          <a:ln>
+            <a:noFill/>
+          </a:ln>
+        </p:spPr>
+        <p:style>
+          <a:lnRef idx="1">
+            <a:schemeClr val="accent1"/>
+          </a:lnRef>
+          <a:fillRef idx="3">
+            <a:schemeClr val="accent1"/>
+          </a:fillRef>
+          <a:effectRef idx="2">
+            <a:schemeClr val="accent1"/>
+          </a:effectRef>
+          <a:fontRef idx="minor">
+            <a:schemeClr val="lt1"/>
+          </a:fontRef>
+        </p:style>
+        <p:txBody>
+          <a:bodyPr rtlCol="0" anchor="ctr"/>
+          <a:lstStyle/>
+          <a:p>
+            <a:pPr algn="ctr"/>
+          </a:p>
+        </p:txBody>
+      </p:sp>
+      <p:sp>
+        <p:nvSpPr>
+          <p:cNvPr id="13" name="TextBox 12"/>
+          <p:cNvSpPr txBox="1"/>
+          <p:nvPr/>
+        </p:nvSpPr>
+        <p:spPr>
+          <a:xfrm>
+            <a:off x="6629400" y="1645920"/>
+            <a:ext cx="4937760" cy="365760"/>
+          </a:xfrm>
+          <a:prstGeom prst="rect">
+            <a:avLst/>
+          </a:prstGeom>
+          <a:noFill/>
+        </p:spPr>
+        <p:txBody>
+          <a:bodyPr wrap="square">
+            <a:spAutoFit/>
+          </a:bodyPr>
+          <a:lstStyle/>
+          <a:p>
+            <a:pPr>
+              <a:spcBef>
+                <a:spcPts val="0"/>
+              </a:spcBef>
+            </a:pPr>
+            <a:r>
+              <a:rPr sz="1600" b="1">
+                <a:solidFill>
+                  <a:srgbClr val="1B1F17"/>
+                </a:solidFill>
+                <a:latin typeface="Arial"/>
+              </a:rPr>
+              <a:t>Clear as-of dates</a:t>
+            </a:r>
+          </a:p>
+        </p:txBody>
+      </p:sp>
+      <p:sp>
+        <p:nvSpPr>
+          <p:cNvPr id="14" name="TextBox 13"/>
+          <p:cNvSpPr txBox="1"/>
+          <p:nvPr/>
+        </p:nvSpPr>
+        <p:spPr>
+          <a:xfrm>
+            <a:off x="6629400" y="2057400"/>
+            <a:ext cx="4937760" cy="548640"/>
+          </a:xfrm>
+          <a:prstGeom prst="rect">
+            <a:avLst/>
+          </a:prstGeom>
+          <a:noFill/>
+        </p:spPr>
+        <p:txBody>
+          <a:bodyPr wrap="square">
+            <a:spAutoFit/>
+          </a:bodyPr>
+          <a:lstStyle/>
+          <a:p>
+            <a:r>
+              <a:rPr sz="1400" b="1">
+                <a:solidFill>
+                  <a:srgbClr val="4F8F12"/>
+                </a:solidFill>
+                <a:latin typeface="Arial"/>
+              </a:rPr>
+              <a:t>Benefit: </a:t>
+            </a:r>
+            <a:r>
+              <a:rPr sz="1400" b="0">
+                <a:solidFill>
+                  <a:srgbClr val="4F8F12"/>
+                </a:solidFill>
+                <a:latin typeface="Arial"/>
+              </a:rPr>
+              <a:t>No confusion between “today” and month-end close.</a:t>
+            </a:r>
+          </a:p>
+        </p:txBody>
+      </p:sp>
+      <p:sp>
+        <p:nvSpPr>
+          <p:cNvPr id="15" name="Rounded Rectangle 14"/>
+          <p:cNvSpPr/>
+          <p:nvPr/>
+        </p:nvSpPr>
+        <p:spPr>
+          <a:xfrm>
+            <a:off x="685800" y="2971800"/>
+            <a:ext cx="5440680" cy="1371600"/>
+          </a:xfrm>
+          <a:prstGeom prst="roundRect">
+            <a:avLst>
+              <a:gd name="adj" fmla="val 6000"/>
+            </a:avLst>
+          </a:prstGeom>
+          <a:solidFill>
+            <a:srgbClr val="FFFFFF"/>
+          </a:solidFill>
+          <a:ln>
+            <a:solidFill>
+              <a:srgbClr val="E6EAE1"/>
+            </a:solidFill>
+          </a:ln>
+        </p:spPr>
+        <p:style>
+          <a:lnRef idx="1">
+            <a:schemeClr val="accent1"/>
+          </a:lnRef>
+          <a:fillRef idx="3">
+            <a:schemeClr val="accent1"/>
+          </a:fillRef>
+          <a:effectRef idx="2">
+            <a:schemeClr val="accent1"/>
+          </a:effectRef>
+          <a:fontRef idx="minor">
+            <a:schemeClr val="lt1"/>
+          </a:fontRef>
+        </p:style>
+        <p:txBody>
+          <a:bodyPr rtlCol="0" anchor="ctr"/>
+          <a:lstStyle/>
+          <a:p>
+            <a:pPr algn="ctr"/>
+          </a:p>
+        </p:txBody>
+      </p:sp>
+      <p:sp>
+        <p:nvSpPr>
+          <p:cNvPr id="16" name="Rectangle 15"/>
+          <p:cNvSpPr/>
+          <p:nvPr/>
+        </p:nvSpPr>
+        <p:spPr>
+          <a:xfrm>
+            <a:off x="685800" y="2971800"/>
+            <a:ext cx="73152" cy="1371600"/>
+          </a:xfrm>
+          <a:prstGeom prst="rect">
+            <a:avLst/>
+          </a:prstGeom>
+          <a:solidFill>
+            <a:srgbClr val="73C41D"/>
+          </a:solidFill>
+          <a:ln>
+            <a:noFill/>
+          </a:ln>
+        </p:spPr>
+        <p:style>
+          <a:lnRef idx="1">
+            <a:schemeClr val="accent1"/>
+          </a:lnRef>
+          <a:fillRef idx="3">
+            <a:schemeClr val="accent1"/>
+          </a:fillRef>
+          <a:effectRef idx="2">
+            <a:schemeClr val="accent1"/>
+          </a:effectRef>
+          <a:fontRef idx="minor">
+            <a:schemeClr val="lt1"/>
+          </a:fontRef>
+        </p:style>
+        <p:txBody>
+          <a:bodyPr rtlCol="0" anchor="ctr"/>
+          <a:lstStyle/>
+          <a:p>
+            <a:pPr algn="ctr"/>
+          </a:p>
+        </p:txBody>
+      </p:sp>
+      <p:sp>
+        <p:nvSpPr>
+          <p:cNvPr id="17" name="TextBox 16"/>
+          <p:cNvSpPr txBox="1"/>
+          <p:nvPr/>
+        </p:nvSpPr>
+        <p:spPr>
+          <a:xfrm>
+            <a:off x="960120" y="3200400"/>
+            <a:ext cx="4937760" cy="365760"/>
+          </a:xfrm>
+          <a:prstGeom prst="rect">
+            <a:avLst/>
+          </a:prstGeom>
+          <a:noFill/>
+        </p:spPr>
+        <p:txBody>
+          <a:bodyPr wrap="square">
+            <a:spAutoFit/>
+          </a:bodyPr>
+          <a:lstStyle/>
+          <a:p>
+            <a:pPr>
+              <a:spcBef>
+                <a:spcPts val="0"/>
+              </a:spcBef>
+            </a:pPr>
+            <a:r>
+              <a:rPr sz="1600" b="1">
+                <a:solidFill>
+                  <a:srgbClr val="1B1F17"/>
+                </a:solidFill>
+                <a:latin typeface="Arial"/>
+              </a:rPr>
+              <a:t>Variance bridge</a:t>
+            </a:r>
+          </a:p>
+        </p:txBody>
+      </p:sp>
+      <p:sp>
+        <p:nvSpPr>
+          <p:cNvPr id="18" name="TextBox 17"/>
+          <p:cNvSpPr txBox="1"/>
+          <p:nvPr/>
+        </p:nvSpPr>
+        <p:spPr>
+          <a:xfrm>
+            <a:off x="960120" y="3611880"/>
+            <a:ext cx="4937760" cy="548640"/>
+          </a:xfrm>
+          <a:prstGeom prst="rect">
+            <a:avLst/>
+          </a:prstGeom>
+          <a:noFill/>
+        </p:spPr>
+        <p:txBody>
+          <a:bodyPr wrap="square">
+            <a:spAutoFit/>
+          </a:bodyPr>
+          <a:lstStyle/>
+          <a:p>
+            <a:r>
+              <a:rPr sz="1400" b="1">
+                <a:solidFill>
+                  <a:srgbClr val="4F8F12"/>
+                </a:solidFill>
+                <a:latin typeface="Arial"/>
+              </a:rPr>
+              <a:t>Benefit: </a:t>
+            </a:r>
+            <a:r>
+              <a:rPr sz="1400" b="0">
+                <a:solidFill>
+                  <a:srgbClr val="4F8F12"/>
+                </a:solidFill>
+                <a:latin typeface="Arial"/>
+              </a:rPr>
+              <a:t>The −2 is explained in plain steps, not buried in a grid.</a:t>
+            </a:r>
+          </a:p>
+        </p:txBody>
+      </p:sp>
+      <p:sp>
+        <p:nvSpPr>
+          <p:cNvPr id="19" name="Rounded Rectangle 18"/>
+          <p:cNvSpPr/>
+          <p:nvPr/>
+        </p:nvSpPr>
+        <p:spPr>
+          <a:xfrm>
+            <a:off x="6355080" y="2971800"/>
+            <a:ext cx="5440680" cy="1371600"/>
+          </a:xfrm>
+          <a:prstGeom prst="roundRect">
+            <a:avLst>
+              <a:gd name="adj" fmla="val 6000"/>
+            </a:avLst>
+          </a:prstGeom>
+          <a:solidFill>
+            <a:srgbClr val="FFFFFF"/>
+          </a:solidFill>
+          <a:ln>
+            <a:solidFill>
+              <a:srgbClr val="E6EAE1"/>
+            </a:solidFill>
+          </a:ln>
+        </p:spPr>
+        <p:style>
+          <a:lnRef idx="1">
+            <a:schemeClr val="accent1"/>
+          </a:lnRef>
+          <a:fillRef idx="3">
+            <a:schemeClr val="accent1"/>
+          </a:fillRef>
+          <a:effectRef idx="2">
+            <a:schemeClr val="accent1"/>
+          </a:effectRef>
+          <a:fontRef idx="minor">
+            <a:schemeClr val="lt1"/>
+          </a:fontRef>
+        </p:style>
+        <p:txBody>
+          <a:bodyPr rtlCol="0" anchor="ctr"/>
+          <a:lstStyle/>
+          <a:p>
+            <a:pPr algn="ctr"/>
+          </a:p>
+        </p:txBody>
+      </p:sp>
+      <p:sp>
+        <p:nvSpPr>
+          <p:cNvPr id="20" name="Rectangle 19"/>
+          <p:cNvSpPr/>
+          <p:nvPr/>
+        </p:nvSpPr>
+        <p:spPr>
+          <a:xfrm>
+            <a:off x="6355080" y="2971800"/>
+            <a:ext cx="73152" cy="1371600"/>
+          </a:xfrm>
+          <a:prstGeom prst="rect">
+            <a:avLst/>
+          </a:prstGeom>
+          <a:solidFill>
+            <a:srgbClr val="73C41D"/>
+          </a:solidFill>
+          <a:ln>
+            <a:noFill/>
+          </a:ln>
+        </p:spPr>
+        <p:style>
+          <a:lnRef idx="1">
+            <a:schemeClr val="accent1"/>
+          </a:lnRef>
+          <a:fillRef idx="3">
+            <a:schemeClr val="accent1"/>
+          </a:fillRef>
+          <a:effectRef idx="2">
+            <a:schemeClr val="accent1"/>
+          </a:effectRef>
+          <a:fontRef idx="minor">
+            <a:schemeClr val="lt1"/>
+          </a:fontRef>
+        </p:style>
+        <p:txBody>
+          <a:bodyPr rtlCol="0" anchor="ctr"/>
+          <a:lstStyle/>
+          <a:p>
+            <a:pPr algn="ctr"/>
+          </a:p>
+        </p:txBody>
+      </p:sp>
+      <p:sp>
+        <p:nvSpPr>
+          <p:cNvPr id="21" name="TextBox 20"/>
+          <p:cNvSpPr txBox="1"/>
+          <p:nvPr/>
+        </p:nvSpPr>
+        <p:spPr>
+          <a:xfrm>
+            <a:off x="6629400" y="3200400"/>
+            <a:ext cx="4937760" cy="365760"/>
+          </a:xfrm>
+          <a:prstGeom prst="rect">
+            <a:avLst/>
+          </a:prstGeom>
+          <a:noFill/>
+        </p:spPr>
+        <p:txBody>
+          <a:bodyPr wrap="square">
+            <a:spAutoFit/>
+          </a:bodyPr>
+          <a:lstStyle/>
+          <a:p>
+            <a:pPr>
+              <a:spcBef>
+                <a:spcPts val="0"/>
+              </a:spcBef>
+            </a:pPr>
+            <a:r>
+              <a:rPr sz="1600" b="1">
+                <a:solidFill>
+                  <a:srgbClr val="1B1F17"/>
+                </a:solidFill>
+                <a:latin typeface="Arial"/>
+              </a:rPr>
+              <a:t>Dispositions (backfill / not backfilling / pivot)</a:t>
+            </a:r>
+          </a:p>
+        </p:txBody>
+      </p:sp>
+      <p:sp>
+        <p:nvSpPr>
+          <p:cNvPr id="22" name="TextBox 21"/>
+          <p:cNvSpPr txBox="1"/>
+          <p:nvPr/>
+        </p:nvSpPr>
+        <p:spPr>
+          <a:xfrm>
+            <a:off x="6629400" y="3611880"/>
+            <a:ext cx="4937760" cy="548640"/>
+          </a:xfrm>
+          <a:prstGeom prst="rect">
+            <a:avLst/>
+          </a:prstGeom>
+          <a:noFill/>
+        </p:spPr>
+        <p:txBody>
+          <a:bodyPr wrap="square">
+            <a:spAutoFit/>
+          </a:bodyPr>
+          <a:lstStyle/>
+          <a:p>
+            <a:r>
+              <a:rPr sz="1400" b="1">
+                <a:solidFill>
+                  <a:srgbClr val="4F8F12"/>
+                </a:solidFill>
+                <a:latin typeface="Arial"/>
+              </a:rPr>
+              <a:t>Benefit: </a:t>
+            </a:r>
+            <a:r>
+              <a:rPr sz="1400" b="0">
+                <a:solidFill>
+                  <a:srgbClr val="4F8F12"/>
+                </a:solidFill>
+                <a:latin typeface="Arial"/>
+              </a:rPr>
+              <a:t>Finance and HR share one language for what happened to a role.</a:t>
+            </a:r>
+          </a:p>
+        </p:txBody>
+      </p:sp>
+      <p:sp>
+        <p:nvSpPr>
+          <p:cNvPr id="23" name="Rounded Rectangle 22"/>
+          <p:cNvSpPr/>
+          <p:nvPr/>
+        </p:nvSpPr>
+        <p:spPr>
+          <a:xfrm>
+            <a:off x="685800" y="4526280"/>
+            <a:ext cx="5440680" cy="1371600"/>
+          </a:xfrm>
+          <a:prstGeom prst="roundRect">
+            <a:avLst>
+              <a:gd name="adj" fmla="val 6000"/>
+            </a:avLst>
+          </a:prstGeom>
+          <a:solidFill>
+            <a:srgbClr val="FFFFFF"/>
+          </a:solidFill>
+          <a:ln>
+            <a:solidFill>
+              <a:srgbClr val="E6EAE1"/>
+            </a:solidFill>
+          </a:ln>
+        </p:spPr>
+        <p:style>
+          <a:lnRef idx="1">
+            <a:schemeClr val="accent1"/>
+          </a:lnRef>
+          <a:fillRef idx="3">
+            <a:schemeClr val="accent1"/>
+          </a:fillRef>
+          <a:effectRef idx="2">
+            <a:schemeClr val="accent1"/>
+          </a:effectRef>
+          <a:fontRef idx="minor">
+            <a:schemeClr val="lt1"/>
+          </a:fontRef>
+        </p:style>
+        <p:txBody>
+          <a:bodyPr rtlCol="0" anchor="ctr"/>
+          <a:lstStyle/>
+          <a:p>
+            <a:pPr algn="ctr"/>
+          </a:p>
+        </p:txBody>
+      </p:sp>
+      <p:sp>
+        <p:nvSpPr>
+          <p:cNvPr id="24" name="Rectangle 23"/>
+          <p:cNvSpPr/>
+          <p:nvPr/>
+        </p:nvSpPr>
+        <p:spPr>
+          <a:xfrm>
+            <a:off x="685800" y="4526280"/>
+            <a:ext cx="73152" cy="1371600"/>
+          </a:xfrm>
+          <a:prstGeom prst="rect">
+            <a:avLst/>
+          </a:prstGeom>
+          <a:solidFill>
+            <a:srgbClr val="73C41D"/>
+          </a:solidFill>
+          <a:ln>
+            <a:noFill/>
+          </a:ln>
+        </p:spPr>
+        <p:style>
+          <a:lnRef idx="1">
+            <a:schemeClr val="accent1"/>
+          </a:lnRef>
+          <a:fillRef idx="3">
+            <a:schemeClr val="accent1"/>
+          </a:fillRef>
+          <a:effectRef idx="2">
+            <a:schemeClr val="accent1"/>
+          </a:effectRef>
+          <a:fontRef idx="minor">
+            <a:schemeClr val="lt1"/>
+          </a:fontRef>
+        </p:style>
+        <p:txBody>
+          <a:bodyPr rtlCol="0" anchor="ctr"/>
+          <a:lstStyle/>
+          <a:p>
+            <a:pPr algn="ctr"/>
+          </a:p>
+        </p:txBody>
+      </p:sp>
+      <p:sp>
+        <p:nvSpPr>
+          <p:cNvPr id="25" name="TextBox 24"/>
+          <p:cNvSpPr txBox="1"/>
+          <p:nvPr/>
+        </p:nvSpPr>
+        <p:spPr>
+          <a:xfrm>
+            <a:off x="960120" y="4754880"/>
+            <a:ext cx="4937760" cy="365760"/>
+          </a:xfrm>
+          <a:prstGeom prst="rect">
+            <a:avLst/>
+          </a:prstGeom>
+          <a:noFill/>
+        </p:spPr>
+        <p:txBody>
+          <a:bodyPr wrap="square">
+            <a:spAutoFit/>
+          </a:bodyPr>
+          <a:lstStyle/>
+          <a:p>
+            <a:pPr>
+              <a:spcBef>
+                <a:spcPts val="0"/>
+              </a:spcBef>
+            </a:pPr>
+            <a:r>
+              <a:rPr sz="1600" b="1">
+                <a:solidFill>
+                  <a:srgbClr val="1B1F17"/>
+                </a:solidFill>
+                <a:latin typeface="Arial"/>
+              </a:rPr>
+              <a:t>Manual update</a:t>
+            </a:r>
+          </a:p>
+        </p:txBody>
+      </p:sp>
+      <p:sp>
+        <p:nvSpPr>
+          <p:cNvPr id="26" name="TextBox 25"/>
+          <p:cNvSpPr txBox="1"/>
+          <p:nvPr/>
+        </p:nvSpPr>
+        <p:spPr>
+          <a:xfrm>
+            <a:off x="960120" y="5166360"/>
+            <a:ext cx="4937760" cy="548640"/>
+          </a:xfrm>
+          <a:prstGeom prst="rect">
+            <a:avLst/>
+          </a:prstGeom>
+          <a:noFill/>
+        </p:spPr>
+        <p:txBody>
+          <a:bodyPr wrap="square">
+            <a:spAutoFit/>
+          </a:bodyPr>
+          <a:lstStyle/>
+          <a:p>
+            <a:r>
+              <a:rPr sz="1400" b="1">
+                <a:solidFill>
+                  <a:srgbClr val="4F8F12"/>
+                </a:solidFill>
+                <a:latin typeface="Arial"/>
+              </a:rPr>
+              <a:t>Benefit: </a:t>
+            </a:r>
+            <a:r>
+              <a:rPr sz="1400" b="0">
+                <a:solidFill>
+                  <a:srgbClr val="4F8F12"/>
+                </a:solidFill>
+                <a:latin typeface="Arial"/>
+              </a:rPr>
+              <a:t>Mid-cycle changes systems miss can still be logged and trusted.</a:t>
+            </a:r>
+          </a:p>
+        </p:txBody>
+      </p:sp>
+      <p:sp>
+        <p:nvSpPr>
+          <p:cNvPr id="27" name="Rounded Rectangle 26"/>
+          <p:cNvSpPr/>
+          <p:nvPr/>
+        </p:nvSpPr>
+        <p:spPr>
+          <a:xfrm>
+            <a:off x="6355080" y="4526280"/>
+            <a:ext cx="5440680" cy="1371600"/>
+          </a:xfrm>
+          <a:prstGeom prst="roundRect">
+            <a:avLst>
+              <a:gd name="adj" fmla="val 6000"/>
+            </a:avLst>
+          </a:prstGeom>
+          <a:solidFill>
+            <a:srgbClr val="FFFFFF"/>
+          </a:solidFill>
+          <a:ln>
+            <a:solidFill>
+              <a:srgbClr val="E6EAE1"/>
+            </a:solidFill>
+          </a:ln>
+        </p:spPr>
+        <p:style>
+          <a:lnRef idx="1">
+            <a:schemeClr val="accent1"/>
+          </a:lnRef>
+          <a:fillRef idx="3">
+            <a:schemeClr val="accent1"/>
+          </a:fillRef>
+          <a:effectRef idx="2">
+            <a:schemeClr val="accent1"/>
+          </a:effectRef>
+          <a:fontRef idx="minor">
+            <a:schemeClr val="lt1"/>
+          </a:fontRef>
+        </p:style>
+        <p:txBody>
+          <a:bodyPr rtlCol="0" anchor="ctr"/>
+          <a:lstStyle/>
+          <a:p>
+            <a:pPr algn="ctr"/>
+          </a:p>
+        </p:txBody>
+      </p:sp>
+      <p:sp>
+        <p:nvSpPr>
+          <p:cNvPr id="28" name="Rectangle 27"/>
+          <p:cNvSpPr/>
+          <p:nvPr/>
+        </p:nvSpPr>
+        <p:spPr>
+          <a:xfrm>
+            <a:off x="6355080" y="4526280"/>
+            <a:ext cx="73152" cy="1371600"/>
+          </a:xfrm>
+          <a:prstGeom prst="rect">
+            <a:avLst/>
+          </a:prstGeom>
+          <a:solidFill>
+            <a:srgbClr val="73C41D"/>
+          </a:solidFill>
+          <a:ln>
+            <a:noFill/>
+          </a:ln>
+        </p:spPr>
+        <p:style>
+          <a:lnRef idx="1">
+            <a:schemeClr val="accent1"/>
+          </a:lnRef>
+          <a:fillRef idx="3">
+            <a:schemeClr val="accent1"/>
+          </a:fillRef>
+          <a:effectRef idx="2">
+            <a:schemeClr val="accent1"/>
+          </a:effectRef>
+          <a:fontRef idx="minor">
+            <a:schemeClr val="lt1"/>
+          </a:fontRef>
+        </p:style>
+        <p:txBody>
+          <a:bodyPr rtlCol="0" anchor="ctr"/>
+          <a:lstStyle/>
+          <a:p>
+            <a:pPr algn="ctr"/>
+          </a:p>
+        </p:txBody>
+      </p:sp>
+      <p:sp>
+        <p:nvSpPr>
+          <p:cNvPr id="29" name="TextBox 28"/>
+          <p:cNvSpPr txBox="1"/>
+          <p:nvPr/>
+        </p:nvSpPr>
+        <p:spPr>
+          <a:xfrm>
+            <a:off x="6629400" y="4754880"/>
+            <a:ext cx="4937760" cy="365760"/>
+          </a:xfrm>
+          <a:prstGeom prst="rect">
+            <a:avLst/>
+          </a:prstGeom>
+          <a:noFill/>
+        </p:spPr>
+        <p:txBody>
+          <a:bodyPr wrap="square">
+            <a:spAutoFit/>
+          </a:bodyPr>
+          <a:lstStyle/>
+          <a:p>
+            <a:pPr>
+              <a:spcBef>
+                <a:spcPts val="0"/>
+              </a:spcBef>
+            </a:pPr>
+            <a:r>
+              <a:rPr sz="1600" b="1">
+                <a:solidFill>
+                  <a:srgbClr val="1B1F17"/>
+                </a:solidFill>
+                <a:latin typeface="Arial"/>
+              </a:rPr>
+              <a:t>Approvals + export preview</a:t>
+            </a:r>
+          </a:p>
+        </p:txBody>
+      </p:sp>
+      <p:sp>
+        <p:nvSpPr>
+          <p:cNvPr id="30" name="TextBox 29"/>
+          <p:cNvSpPr txBox="1"/>
+          <p:nvPr/>
+        </p:nvSpPr>
+        <p:spPr>
+          <a:xfrm>
+            <a:off x="6629400" y="5166360"/>
+            <a:ext cx="4937760" cy="548640"/>
+          </a:xfrm>
+          <a:prstGeom prst="rect">
+            <a:avLst/>
+          </a:prstGeom>
+          <a:noFill/>
+        </p:spPr>
+        <p:txBody>
+          <a:bodyPr wrap="square">
+            <a:spAutoFit/>
+          </a:bodyPr>
+          <a:lstStyle/>
+          <a:p>
+            <a:r>
+              <a:rPr sz="1400" b="1">
+                <a:solidFill>
+                  <a:srgbClr val="4F8F12"/>
+                </a:solidFill>
+                <a:latin typeface="Arial"/>
+              </a:rPr>
+              <a:t>Benefit: </a:t>
+            </a:r>
+            <a:r>
+              <a:rPr sz="1400" b="0">
+                <a:solidFill>
+                  <a:srgbClr val="4F8F12"/>
+                </a:solidFill>
+                <a:latin typeface="Arial"/>
+              </a:rPr>
+              <a:t>Requests and the close package live in the same story — not a separate maze.</a:t>
+            </a:r>
+          </a:p>
+        </p:txBody>
+      </p:sp>
+      <p:sp>
+        <p:nvSpPr>
+          <p:cNvPr id="31" name="TextBox 30"/>
+          <p:cNvSpPr txBox="1"/>
+          <p:nvPr/>
+        </p:nvSpPr>
+        <p:spPr>
+          <a:xfrm>
+            <a:off x="685800" y="6537960"/>
+            <a:ext cx="9144000" cy="228600"/>
+          </a:xfrm>
+          <a:prstGeom prst="rect">
+            <a:avLst/>
+          </a:prstGeom>
+          <a:noFill/>
+        </p:spPr>
+        <p:txBody>
+          <a:bodyPr wrap="square">
+            <a:spAutoFit/>
+          </a:bodyPr>
+          <a:lstStyle/>
+          <a:p>
+            <a:pPr>
+              <a:spcBef>
+                <a:spcPts val="0"/>
+              </a:spcBef>
+            </a:pPr>
+            <a:r>
+              <a:rPr sz="1100" b="0">
+                <a:solidFill>
+                  <a:srgbClr val="6A7264"/>
+                </a:solidFill>
+                <a:latin typeface="Arial"/>
+              </a:rPr>
+              <a:t>BambooHR interview case study</a:t>
+            </a:r>
+          </a:p>
+        </p:txBody>
+      </p:sp>
+      <p:sp>
+        <p:nvSpPr>
+          <p:cNvPr id="32" name="TextBox 31"/>
+          <p:cNvSpPr txBox="1"/>
+          <p:nvPr/>
+        </p:nvSpPr>
+        <p:spPr>
+          <a:xfrm>
+            <a:off x="11155680" y="6537960"/>
+            <a:ext cx="731520" cy="228600"/>
+          </a:xfrm>
+          <a:prstGeom prst="rect">
+            <a:avLst/>
+          </a:prstGeom>
+          <a:noFill/>
+        </p:spPr>
+        <p:txBody>
+          <a:bodyPr wrap="none">
+            <a:spAutoFit/>
+          </a:bodyPr>
+          <a:lstStyle/>
+          <a:p>
+            <a:pPr algn="r"/>
+            <a:r>
+              <a:rPr sz="1100" b="0">
+                <a:solidFill>
+                  <a:srgbClr val="6A7264"/>
+                </a:solidFill>
+                <a:latin typeface="Arial"/>
+              </a:rPr>
+              <a:t>13/16</a:t>
             </a:r>
           </a:p>
         </p:txBody>
@@ -10363,7 +11697,7 @@
                 </a:solidFill>
                 <a:latin typeface="Arial"/>
               </a:rPr>
-              <a:t>2/15</a:t>
+              <a:t>2/16</a:t>
             </a:r>
           </a:p>
         </p:txBody>
@@ -11202,7 +12536,7 @@
                 </a:solidFill>
                 <a:latin typeface="Arial"/>
               </a:rPr>
-              <a:t>3/15</a:t>
+              <a:t>3/16</a:t>
             </a:r>
           </a:p>
         </p:txBody>
@@ -11816,7 +13150,7 @@
                 </a:solidFill>
                 <a:latin typeface="Arial"/>
               </a:rPr>
-              <a:t>4/15</a:t>
+              <a:t>4/16</a:t>
             </a:r>
           </a:p>
         </p:txBody>
@@ -12813,7 +14147,7 @@
                 </a:solidFill>
                 <a:latin typeface="Arial"/>
               </a:rPr>
-              <a:t>5/15</a:t>
+              <a:t>5/16</a:t>
             </a:r>
           </a:p>
         </p:txBody>
@@ -13126,7 +14460,7 @@
                 </a:solidFill>
                 <a:latin typeface="Arial"/>
               </a:rPr>
-              <a:t>6/15</a:t>
+              <a:t>6/16</a:t>
             </a:r>
           </a:p>
         </p:txBody>
@@ -13612,7 +14946,7 @@
                 </a:solidFill>
                 <a:latin typeface="Arial"/>
               </a:rPr>
-              <a:t>7/15</a:t>
+              <a:t>7/16</a:t>
             </a:r>
           </a:p>
         </p:txBody>
@@ -14459,7 +15793,7 @@
                 </a:solidFill>
                 <a:latin typeface="Arial"/>
               </a:rPr>
-              <a:t>8/15</a:t>
+              <a:t>8/16</a:t>
             </a:r>
           </a:p>
         </p:txBody>
@@ -15208,32 +16542,8 @@
                 </a:solidFill>
                 <a:latin typeface="Arial"/>
               </a:rPr>
-              <a:t>Wrong default </a:t>
-            </a:r>
-            <a:r>
-              <a:rPr sz="1600" b="1" dirty="0" err="1">
-                <a:solidFill>
-                  <a:srgbClr val="1B1F17"/>
-                </a:solidFill>
-                <a:latin typeface="Arial"/>
-              </a:rPr>
-              <a:t>viz</a:t>
-            </a:r>
-            <a:r>
-              <a:rPr lang="en-US" sz="1600" b="1" dirty="0" err="1">
-                <a:solidFill>
-                  <a:srgbClr val="1B1F17"/>
-                </a:solidFill>
-                <a:latin typeface="Arial"/>
-              </a:rPr>
-              <a:t>ualization</a:t>
-            </a:r>
-            <a:endParaRPr sz="1600" b="1" dirty="0">
-              <a:solidFill>
-                <a:srgbClr val="1B1F17"/>
-              </a:solidFill>
-              <a:latin typeface="Arial"/>
-            </a:endParaRPr>
+              <a:t>Wrong default visualization</a:t>
+            </a:r>
           </a:p>
         </p:txBody>
       </p:sp>
@@ -15302,7 +16612,7 @@
                 </a:solidFill>
                 <a:latin typeface="Arial"/>
               </a:rPr>
-              <a:t>9/15</a:t>
+              <a:t>9/16</a:t>
             </a:r>
           </a:p>
         </p:txBody>
@@ -15316,36 +16626,63 @@
         <p:spPr>
           <a:xfrm>
             <a:off x="4937760" y="1508760"/>
-            <a:ext cx="6583680" cy="640080"/>
-          </a:xfrm>
-          <a:prstGeom prst="rect">
-            <a:avLst/>
-          </a:prstGeom>
-          <a:noFill/>
-        </p:spPr>
-        <p:txBody>
-          <a:bodyPr wrap="square">
-            <a:spAutoFit/>
-          </a:bodyPr>
-          <a:lstStyle/>
-          <a:p>
-            <a:r>
-              <a:rPr sz="1400" b="1">
+            <a:ext cx="6583680" cy="523220"/>
+          </a:xfrm>
+          <a:prstGeom prst="rect">
+            <a:avLst/>
+          </a:prstGeom>
+          <a:noFill/>
+        </p:spPr>
+        <p:txBody>
+          <a:bodyPr wrap="square">
+            <a:spAutoFit/>
+          </a:bodyPr>
+          <a:lstStyle/>
+          <a:p>
+            <a:r>
+              <a:rPr sz="1400" b="0" dirty="0">
                 <a:solidFill>
                   <a:srgbClr val="4F8F12"/>
                 </a:solidFill>
                 <a:latin typeface="Arial"/>
               </a:rPr>
-              <a:t>Benefit: </a:t>
-            </a:r>
-            <a:r>
-              <a:rPr sz="1400" b="0">
+              <a:t>Leaders can</a:t>
+            </a:r>
+            <a:r>
+              <a:rPr lang="en-US" sz="1400" b="0" dirty="0">
                 <a:solidFill>
                   <a:srgbClr val="4F8F12"/>
                 </a:solidFill>
                 <a:latin typeface="Arial"/>
               </a:rPr>
-              <a:t>Leaders can follow the recon without a specialist walking them through the tabs.</a:t>
+              <a:t>’t</a:t>
+            </a:r>
+            <a:r>
+              <a:rPr sz="1400" b="0" dirty="0">
+                <a:solidFill>
+                  <a:srgbClr val="4F8F12"/>
+                </a:solidFill>
+                <a:latin typeface="Arial"/>
+              </a:rPr>
+              <a:t> follow the recon</a:t>
+            </a:r>
+            <a:r>
+              <a:rPr lang="en-US" sz="1400" b="0" dirty="0">
+                <a:solidFill>
+                  <a:srgbClr val="4F8F12"/>
+                </a:solidFill>
+                <a:latin typeface="Arial"/>
+              </a:rPr>
+              <a:t>ciliation</a:t>
+            </a:r>
+            <a:r>
+              <a:rPr sz="1400" b="0" dirty="0">
+                <a:solidFill>
+                  <a:srgbClr val="4F8F12"/>
+                </a:solidFill>
+                <a:latin typeface="Arial"/>
+              </a:rPr>
+              <a:t> without a specialist walking them through the tabs.</a:t>
             </a:r>
           </a:p>
         </p:txBody>
@@ -15359,36 +16696,63 @@
         <p:spPr>
           <a:xfrm>
             <a:off x="4937760" y="2377440"/>
-            <a:ext cx="6583680" cy="640080"/>
-          </a:xfrm>
-          <a:prstGeom prst="rect">
-            <a:avLst/>
-          </a:prstGeom>
-          <a:noFill/>
-        </p:spPr>
-        <p:txBody>
-          <a:bodyPr wrap="square">
-            <a:spAutoFit/>
-          </a:bodyPr>
-          <a:lstStyle/>
-          <a:p>
-            <a:r>
-              <a:rPr sz="1400" b="1">
+            <a:ext cx="6583680" cy="523220"/>
+          </a:xfrm>
+          <a:prstGeom prst="rect">
+            <a:avLst/>
+          </a:prstGeom>
+          <a:noFill/>
+        </p:spPr>
+        <p:txBody>
+          <a:bodyPr wrap="square">
+            <a:spAutoFit/>
+          </a:bodyPr>
+          <a:lstStyle/>
+          <a:p>
+            <a:r>
+              <a:rPr sz="1400" b="0" dirty="0">
                 <a:solidFill>
                   <a:srgbClr val="4F8F12"/>
                 </a:solidFill>
                 <a:latin typeface="Arial"/>
               </a:rPr>
-              <a:t>Benefit: </a:t>
-            </a:r>
-            <a:r>
-              <a:rPr sz="1400" b="0">
+              <a:t>Finance and HR </a:t>
+            </a:r>
+            <a:r>
+              <a:rPr lang="en-US" sz="1400" b="0" dirty="0">
                 <a:solidFill>
                   <a:srgbClr val="4F8F12"/>
                 </a:solidFill>
                 <a:latin typeface="Arial"/>
               </a:rPr>
-              <a:t>Finance and HR mean the same thing when they say backfill, not backfilling, or pivot.</a:t>
+              <a:t>are on the same </a:t>
+            </a:r>
+            <a:r>
+              <a:rPr lang="en-US" sz="1400" b="0" dirty="0" err="1">
+                <a:solidFill>
+                  <a:srgbClr val="4F8F12"/>
+                </a:solidFill>
+                <a:latin typeface="Arial"/>
+              </a:rPr>
+              <a:t>terms</a:t>
+            </a:r>
+            <a:r>
+              <a:rPr sz="1400" b="0" dirty="0" err="1">
+                <a:solidFill>
+                  <a:srgbClr val="4F8F12"/>
+                </a:solidFill>
+                <a:latin typeface="Arial"/>
+              </a:rPr>
+              <a:t>when</a:t>
+            </a:r>
+            <a:r>
+              <a:rPr sz="1400" b="0" dirty="0">
+                <a:solidFill>
+                  <a:srgbClr val="4F8F12"/>
+                </a:solidFill>
+                <a:latin typeface="Arial"/>
+              </a:rPr>
+              <a:t> they say backfill, not backfilling, or pivot.</a:t>
             </a:r>
           </a:p>
         </p:txBody>
@@ -15402,36 +16766,45 @@
         <p:spPr>
           <a:xfrm>
             <a:off x="4937760" y="3246120"/>
-            <a:ext cx="6583680" cy="640080"/>
-          </a:xfrm>
-          <a:prstGeom prst="rect">
-            <a:avLst/>
-          </a:prstGeom>
-          <a:noFill/>
-        </p:spPr>
-        <p:txBody>
-          <a:bodyPr wrap="square">
-            <a:spAutoFit/>
-          </a:bodyPr>
-          <a:lstStyle/>
-          <a:p>
-            <a:r>
-              <a:rPr sz="1400" b="1">
+            <a:ext cx="6583680" cy="523220"/>
+          </a:xfrm>
+          <a:prstGeom prst="rect">
+            <a:avLst/>
+          </a:prstGeom>
+          <a:noFill/>
+        </p:spPr>
+        <p:txBody>
+          <a:bodyPr wrap="square">
+            <a:spAutoFit/>
+          </a:bodyPr>
+          <a:lstStyle/>
+          <a:p>
+            <a:r>
+              <a:rPr sz="1400" b="0" dirty="0">
                 <a:solidFill>
                   <a:srgbClr val="4F8F12"/>
                 </a:solidFill>
                 <a:latin typeface="Arial"/>
               </a:rPr>
-              <a:t>Benefit: </a:t>
-            </a:r>
-            <a:r>
-              <a:rPr sz="1400" b="0">
+              <a:t>Mid-cycle changes disappear into one person’s </a:t>
+            </a:r>
+            <a:r>
+              <a:rPr lang="en-US" sz="1400" b="0" dirty="0">
                 <a:solidFill>
                   <a:srgbClr val="4F8F12"/>
                 </a:solidFill>
                 <a:latin typeface="Arial"/>
               </a:rPr>
-              <a:t>Mid-cycle changes don’t disappear into one person’s spreadsheet.</a:t>
+              <a:t>spreadsheet or disappear completely</a:t>
+            </a:r>
+            <a:r>
+              <a:rPr sz="1400" b="0" dirty="0">
+                <a:solidFill>
+                  <a:srgbClr val="4F8F12"/>
+                </a:solidFill>
+                <a:latin typeface="Arial"/>
+              </a:rPr>
+              <a:t>.</a:t>
             </a:r>
           </a:p>
         </p:txBody>
@@ -15445,36 +16818,54 @@
         <p:spPr>
           <a:xfrm>
             <a:off x="4937760" y="4114799"/>
-            <a:ext cx="6583680" cy="640080"/>
-          </a:xfrm>
-          <a:prstGeom prst="rect">
-            <a:avLst/>
-          </a:prstGeom>
-          <a:noFill/>
-        </p:spPr>
-        <p:txBody>
-          <a:bodyPr wrap="square">
-            <a:spAutoFit/>
-          </a:bodyPr>
-          <a:lstStyle/>
-          <a:p>
-            <a:r>
-              <a:rPr sz="1400" b="1">
+            <a:ext cx="6583680" cy="307777"/>
+          </a:xfrm>
+          <a:prstGeom prst="rect">
+            <a:avLst/>
+          </a:prstGeom>
+          <a:noFill/>
+        </p:spPr>
+        <p:txBody>
+          <a:bodyPr wrap="square">
+            <a:spAutoFit/>
+          </a:bodyPr>
+          <a:lstStyle/>
+          <a:p>
+            <a:r>
+              <a:rPr lang="en-US" sz="1400" dirty="0">
                 <a:solidFill>
                   <a:srgbClr val="4F8F12"/>
                 </a:solidFill>
                 <a:latin typeface="Arial"/>
               </a:rPr>
-              <a:t>Benefit: </a:t>
-            </a:r>
-            <a:r>
-              <a:rPr sz="1400" b="0">
+              <a:t>Nobody</a:t>
+            </a:r>
+            <a:r>
+              <a:rPr sz="1400" b="0" dirty="0">
                 <a:solidFill>
                   <a:srgbClr val="4F8F12"/>
                 </a:solidFill>
                 <a:latin typeface="Arial"/>
               </a:rPr>
-              <a:t>Everyone knows whether the number is as of close — or as of today.</a:t>
+              <a:t> knows whether the number is as of close</a:t>
+            </a:r>
+            <a:r>
+              <a:rPr lang="en-US" sz="1400" b="0" dirty="0">
+                <a:solidFill>
+                  <a:srgbClr val="4F8F12"/>
+                </a:solidFill>
+                <a:latin typeface="Arial"/>
+              </a:rPr>
+              <a:t>, </a:t>
+            </a:r>
+            <a:r>
+              <a:rPr sz="1400" b="0" dirty="0">
+                <a:solidFill>
+                  <a:srgbClr val="4F8F12"/>
+                </a:solidFill>
+                <a:latin typeface="Arial"/>
+              </a:rPr>
+              <a:t>or as of today.</a:t>
             </a:r>
           </a:p>
         </p:txBody>
@@ -15488,36 +16879,81 @@
         <p:spPr>
           <a:xfrm>
             <a:off x="4937760" y="4983480"/>
-            <a:ext cx="6583680" cy="640080"/>
-          </a:xfrm>
-          <a:prstGeom prst="rect">
-            <a:avLst/>
-          </a:prstGeom>
-          <a:noFill/>
-        </p:spPr>
-        <p:txBody>
-          <a:bodyPr wrap="square">
-            <a:spAutoFit/>
-          </a:bodyPr>
-          <a:lstStyle/>
-          <a:p>
-            <a:r>
-              <a:rPr sz="1400" b="1">
+            <a:ext cx="6583680" cy="307777"/>
+          </a:xfrm>
+          <a:prstGeom prst="rect">
+            <a:avLst/>
+          </a:prstGeom>
+          <a:noFill/>
+        </p:spPr>
+        <p:txBody>
+          <a:bodyPr wrap="square">
+            <a:spAutoFit/>
+          </a:bodyPr>
+          <a:lstStyle/>
+          <a:p>
+            <a:r>
+              <a:rPr sz="1400" b="0" dirty="0">
                 <a:solidFill>
                   <a:srgbClr val="4F8F12"/>
                 </a:solidFill>
                 <a:latin typeface="Arial"/>
               </a:rPr>
-              <a:t>Benefit: </a:t>
-            </a:r>
-            <a:r>
-              <a:rPr sz="1400" b="0">
+              <a:t>The gap is</a:t>
+            </a:r>
+            <a:r>
+              <a:rPr lang="en-US" sz="1400" dirty="0">
                 <a:solidFill>
                   <a:srgbClr val="4F8F12"/>
                 </a:solidFill>
                 <a:latin typeface="Arial"/>
               </a:rPr>
-              <a:t>The gap is readable in one pass — not buried in a grid for authors.</a:t>
+              <a:t> not</a:t>
+            </a:r>
+            <a:r>
+              <a:rPr sz="1400" b="0" dirty="0">
+                <a:solidFill>
+                  <a:srgbClr val="4F8F12"/>
+                </a:solidFill>
+                <a:latin typeface="Arial"/>
+              </a:rPr>
+              <a:t> readable in one </a:t>
+            </a:r>
+            <a:r>
+              <a:rPr lang="en-US" sz="1400" b="0" dirty="0">
+                <a:solidFill>
+                  <a:srgbClr val="4F8F12"/>
+                </a:solidFill>
+                <a:latin typeface="Arial"/>
+              </a:rPr>
+              <a:t>pass;</a:t>
+            </a:r>
+            <a:r>
+              <a:rPr sz="1400" b="0" dirty="0">
+                <a:solidFill>
+                  <a:srgbClr val="4F8F12"/>
+                </a:solidFill>
+                <a:latin typeface="Arial"/>
+              </a:rPr>
+              <a:t> </a:t>
+            </a:r>
+            <a:r>
+              <a:rPr lang="en-US" sz="1400" b="0" dirty="0">
+                <a:solidFill>
+                  <a:srgbClr val="4F8F12"/>
+                </a:solidFill>
+                <a:latin typeface="Arial"/>
+              </a:rPr>
+              <a:t>it’s</a:t>
+            </a:r>
+            <a:r>
+              <a:rPr sz="1400" b="0" dirty="0">
+                <a:solidFill>
+                  <a:srgbClr val="4F8F12"/>
+                </a:solidFill>
+                <a:latin typeface="Arial"/>
+              </a:rPr>
+              <a:t> buried in a grid for authors.</a:t>
             </a:r>
           </a:p>
         </p:txBody>

</xml_diff>